<commit_message>
fix: actualiza presentacion con paleta de colores correcta
</commit_message>
<xml_diff>
--- a/docs/Sonido-Vivo (1).pptx
+++ b/docs/Sonido-Vivo (1).pptx
@@ -1,42 +1,49 @@
 
 <file path=ppt/presentation.xml><?xml version="1.0" encoding="utf-8"?>
-<p:presentation xmlns:a="http://schemas.openxmlformats.org/drawingml/2006/main" xmlns:r="http://schemas.openxmlformats.org/officeDocument/2006/relationships" xmlns:mc="http://schemas.openxmlformats.org/markup-compatibility/2006" xmlns:mv="urn:schemas-microsoft-com:mac:vml" xmlns:p="http://schemas.openxmlformats.org/presentationml/2006/main" xmlns:c="http://schemas.openxmlformats.org/drawingml/2006/chart" xmlns:dgm="http://schemas.openxmlformats.org/drawingml/2006/diagram" xmlns:o="urn:schemas-microsoft-com:office:office" xmlns:v="urn:schemas-microsoft-com:vml" xmlns:pvml="urn:schemas-microsoft-com:office:powerpoint" xmlns:com="http://schemas.openxmlformats.org/drawingml/2006/compatibility" xmlns:p14="http://schemas.microsoft.com/office/powerpoint/2010/main" xmlns:p15="http://schemas.microsoft.com/office/powerpoint/2012/main" xmlns:ahyp="http://schemas.microsoft.com/office/drawing/2018/hyperlinkcolor" autoCompressPictures="0" embedTrueTypeFonts="1" strictFirstAndLastChars="0" saveSubsetFonts="1">
+<p:presentation xmlns:a="http://schemas.openxmlformats.org/drawingml/2006/main" xmlns:r="http://schemas.openxmlformats.org/officeDocument/2006/relationships" xmlns:p="http://schemas.openxmlformats.org/presentationml/2006/main" strictFirstAndLastChars="0" embedTrueTypeFonts="1" saveSubsetFonts="1" autoCompressPictures="0">
   <p:sldMasterIdLst>
-    <p:sldMasterId id="2147483648" r:id="rId3"/>
+    <p:sldMasterId id="2147483648" r:id="rId1"/>
   </p:sldMasterIdLst>
   <p:notesMasterIdLst>
-    <p:notesMasterId r:id="rId4"/>
+    <p:notesMasterId r:id="rId12"/>
   </p:notesMasterIdLst>
   <p:sldIdLst>
-    <p:sldId id="256" r:id="rId5"/>
-    <p:sldId id="257" r:id="rId6"/>
-    <p:sldId id="258" r:id="rId7"/>
-    <p:sldId id="259" r:id="rId8"/>
-    <p:sldId id="260" r:id="rId9"/>
-    <p:sldId id="261" r:id="rId10"/>
-    <p:sldId id="262" r:id="rId11"/>
-    <p:sldId id="263" r:id="rId12"/>
-    <p:sldId id="264" r:id="rId13"/>
-    <p:sldId id="265" r:id="rId14"/>
+    <p:sldId id="256" r:id="rId2"/>
+    <p:sldId id="257" r:id="rId3"/>
+    <p:sldId id="258" r:id="rId4"/>
+    <p:sldId id="259" r:id="rId5"/>
+    <p:sldId id="260" r:id="rId6"/>
+    <p:sldId id="261" r:id="rId7"/>
+    <p:sldId id="262" r:id="rId8"/>
+    <p:sldId id="263" r:id="rId9"/>
+    <p:sldId id="264" r:id="rId10"/>
+    <p:sldId id="265" r:id="rId11"/>
   </p:sldIdLst>
-  <p:sldSz cy="6858000" cx="12192000"/>
+  <p:sldSz cx="12192000" cy="6858000"/>
   <p:notesSz cx="6858000" cy="12192000"/>
   <p:embeddedFontLst>
     <p:embeddedFont>
-      <p:font typeface="Inter"/>
-      <p:regular r:id="rId15"/>
-      <p:bold r:id="rId16"/>
-      <p:italic r:id="rId17"/>
-      <p:boldItalic r:id="rId18"/>
+      <p:font typeface="Consolas" panose="020B0609020204030204" pitchFamily="49" charset="0"/>
+      <p:regular r:id="rId13"/>
+      <p:bold r:id="rId14"/>
+      <p:italic r:id="rId15"/>
+      <p:boldItalic r:id="rId16"/>
     </p:embeddedFont>
     <p:embeddedFont>
-      <p:font typeface="Petrona"/>
-      <p:bold r:id="rId19"/>
+      <p:font typeface="Inter" panose="020B0604020202020204" charset="0"/>
+      <p:regular r:id="rId17"/>
+      <p:bold r:id="rId18"/>
+      <p:italic r:id="rId19"/>
       <p:boldItalic r:id="rId20"/>
+    </p:embeddedFont>
+    <p:embeddedFont>
+      <p:font typeface="Petrona" panose="020B0604020202020204" charset="0"/>
+      <p:bold r:id="rId21"/>
+      <p:boldItalic r:id="rId22"/>
     </p:embeddedFont>
   </p:embeddedFontLst>
   <p:defaultTextStyle>
-    <a:defPPr lvl="0" marR="0" rtl="0" algn="l">
+    <a:defPPr marR="0" lvl="0" algn="l" rtl="0">
       <a:lnSpc>
         <a:spcPct val="100000"/>
       </a:lnSpc>
@@ -47,7 +54,7 @@
         <a:spcPts val="0"/>
       </a:spcAft>
     </a:defPPr>
-    <a:lvl1pPr lvl="0" marR="0" rtl="0" algn="l">
+    <a:lvl1pPr marR="0" lvl="0" algn="l" rtl="0">
       <a:lnSpc>
         <a:spcPct val="100000"/>
       </a:lnSpc>
@@ -61,7 +68,7 @@
         <a:srgbClr val="000000"/>
       </a:buClr>
       <a:buFont typeface="Arial"/>
-      <a:defRPr b="0" i="0" spc="0" sz="1400" u="none" cap="none" strike="noStrike">
+      <a:defRPr sz="1400" b="0" i="0" u="none" strike="noStrike" cap="none" spc="0">
         <a:solidFill>
           <a:srgbClr val="000000"/>
         </a:solidFill>
@@ -71,7 +78,7 @@
         <a:sym typeface="Arial"/>
       </a:defRPr>
     </a:lvl1pPr>
-    <a:lvl2pPr lvl="1" marR="0" rtl="0" algn="l">
+    <a:lvl2pPr marR="0" lvl="1" algn="l" rtl="0">
       <a:lnSpc>
         <a:spcPct val="100000"/>
       </a:lnSpc>
@@ -85,7 +92,7 @@
         <a:srgbClr val="000000"/>
       </a:buClr>
       <a:buFont typeface="Arial"/>
-      <a:defRPr b="0" i="0" spc="0" sz="1400" u="none" cap="none" strike="noStrike">
+      <a:defRPr sz="1400" b="0" i="0" u="none" strike="noStrike" cap="none" spc="0">
         <a:solidFill>
           <a:srgbClr val="000000"/>
         </a:solidFill>
@@ -95,7 +102,7 @@
         <a:sym typeface="Arial"/>
       </a:defRPr>
     </a:lvl2pPr>
-    <a:lvl3pPr lvl="2" marR="0" rtl="0" algn="l">
+    <a:lvl3pPr marR="0" lvl="2" algn="l" rtl="0">
       <a:lnSpc>
         <a:spcPct val="100000"/>
       </a:lnSpc>
@@ -109,7 +116,7 @@
         <a:srgbClr val="000000"/>
       </a:buClr>
       <a:buFont typeface="Arial"/>
-      <a:defRPr b="0" i="0" spc="0" sz="1400" u="none" cap="none" strike="noStrike">
+      <a:defRPr sz="1400" b="0" i="0" u="none" strike="noStrike" cap="none" spc="0">
         <a:solidFill>
           <a:srgbClr val="000000"/>
         </a:solidFill>
@@ -119,7 +126,7 @@
         <a:sym typeface="Arial"/>
       </a:defRPr>
     </a:lvl3pPr>
-    <a:lvl4pPr lvl="3" marR="0" rtl="0" algn="l">
+    <a:lvl4pPr marR="0" lvl="3" algn="l" rtl="0">
       <a:lnSpc>
         <a:spcPct val="100000"/>
       </a:lnSpc>
@@ -133,7 +140,7 @@
         <a:srgbClr val="000000"/>
       </a:buClr>
       <a:buFont typeface="Arial"/>
-      <a:defRPr b="0" i="0" spc="0" sz="1400" u="none" cap="none" strike="noStrike">
+      <a:defRPr sz="1400" b="0" i="0" u="none" strike="noStrike" cap="none" spc="0">
         <a:solidFill>
           <a:srgbClr val="000000"/>
         </a:solidFill>
@@ -143,7 +150,7 @@
         <a:sym typeface="Arial"/>
       </a:defRPr>
     </a:lvl4pPr>
-    <a:lvl5pPr lvl="4" marR="0" rtl="0" algn="l">
+    <a:lvl5pPr marR="0" lvl="4" algn="l" rtl="0">
       <a:lnSpc>
         <a:spcPct val="100000"/>
       </a:lnSpc>
@@ -157,7 +164,7 @@
         <a:srgbClr val="000000"/>
       </a:buClr>
       <a:buFont typeface="Arial"/>
-      <a:defRPr b="0" i="0" spc="0" sz="1400" u="none" cap="none" strike="noStrike">
+      <a:defRPr sz="1400" b="0" i="0" u="none" strike="noStrike" cap="none" spc="0">
         <a:solidFill>
           <a:srgbClr val="000000"/>
         </a:solidFill>
@@ -167,7 +174,7 @@
         <a:sym typeface="Arial"/>
       </a:defRPr>
     </a:lvl5pPr>
-    <a:lvl6pPr lvl="5" marR="0" rtl="0" algn="l">
+    <a:lvl6pPr marR="0" lvl="5" algn="l" rtl="0">
       <a:lnSpc>
         <a:spcPct val="100000"/>
       </a:lnSpc>
@@ -181,7 +188,7 @@
         <a:srgbClr val="000000"/>
       </a:buClr>
       <a:buFont typeface="Arial"/>
-      <a:defRPr b="0" i="0" spc="0" sz="1400" u="none" cap="none" strike="noStrike">
+      <a:defRPr sz="1400" b="0" i="0" u="none" strike="noStrike" cap="none" spc="0">
         <a:solidFill>
           <a:srgbClr val="000000"/>
         </a:solidFill>
@@ -191,7 +198,7 @@
         <a:sym typeface="Arial"/>
       </a:defRPr>
     </a:lvl6pPr>
-    <a:lvl7pPr lvl="6" marR="0" rtl="0" algn="l">
+    <a:lvl7pPr marR="0" lvl="6" algn="l" rtl="0">
       <a:lnSpc>
         <a:spcPct val="100000"/>
       </a:lnSpc>
@@ -205,7 +212,7 @@
         <a:srgbClr val="000000"/>
       </a:buClr>
       <a:buFont typeface="Arial"/>
-      <a:defRPr b="0" i="0" spc="0" sz="1400" u="none" cap="none" strike="noStrike">
+      <a:defRPr sz="1400" b="0" i="0" u="none" strike="noStrike" cap="none" spc="0">
         <a:solidFill>
           <a:srgbClr val="000000"/>
         </a:solidFill>
@@ -215,7 +222,7 @@
         <a:sym typeface="Arial"/>
       </a:defRPr>
     </a:lvl7pPr>
-    <a:lvl8pPr lvl="7" marR="0" rtl="0" algn="l">
+    <a:lvl8pPr marR="0" lvl="7" algn="l" rtl="0">
       <a:lnSpc>
         <a:spcPct val="100000"/>
       </a:lnSpc>
@@ -229,7 +236,7 @@
         <a:srgbClr val="000000"/>
       </a:buClr>
       <a:buFont typeface="Arial"/>
-      <a:defRPr b="0" i="0" spc="0" sz="1400" u="none" cap="none" strike="noStrike">
+      <a:defRPr sz="1400" b="0" i="0" u="none" strike="noStrike" cap="none" spc="0">
         <a:solidFill>
           <a:srgbClr val="000000"/>
         </a:solidFill>
@@ -239,7 +246,7 @@
         <a:sym typeface="Arial"/>
       </a:defRPr>
     </a:lvl8pPr>
-    <a:lvl9pPr lvl="8" marR="0" rtl="0" algn="l">
+    <a:lvl9pPr marR="0" lvl="8" algn="l" rtl="0">
       <a:lnSpc>
         <a:spcPct val="100000"/>
       </a:lnSpc>
@@ -253,7 +260,7 @@
         <a:srgbClr val="000000"/>
       </a:buClr>
       <a:buFont typeface="Arial"/>
-      <a:defRPr b="0" i="0" spc="0" sz="1400" u="none" cap="none" strike="noStrike">
+      <a:defRPr sz="1400" b="0" i="0" u="none" strike="noStrike" cap="none" spc="0">
         <a:solidFill>
           <a:srgbClr val="000000"/>
         </a:solidFill>
@@ -266,25 +273,26 @@
   </p:defaultTextStyle>
   <p:extLst>
     <p:ext uri="GoogleSlidesCustomDataVersion2">
-      <go:slidesCustomData xmlns:go="http://customooxmlschemas.google.com/" r:id="rId21" roundtripDataSignature="AMtx7mh48V+udFt60gXffsQxkFb0dpTBtg=="/>
+      <go:slidesCustomData xmlns:go="http://customooxmlschemas.google.com/" xmlns:ahyp="http://schemas.microsoft.com/office/drawing/2018/hyperlinkcolor" xmlns:p15="http://schemas.microsoft.com/office/powerpoint/2012/main" xmlns:p14="http://schemas.microsoft.com/office/powerpoint/2010/main" xmlns:com="http://schemas.openxmlformats.org/drawingml/2006/compatibility" xmlns:pvml="urn:schemas-microsoft-com:office:powerpoint" xmlns:v="urn:schemas-microsoft-com:vml" xmlns:o="urn:schemas-microsoft-com:office:office" xmlns:dgm="http://schemas.openxmlformats.org/drawingml/2006/diagram" xmlns:c="http://schemas.openxmlformats.org/drawingml/2006/chart" xmlns:mv="urn:schemas-microsoft-com:mac:vml" xmlns:mc="http://schemas.openxmlformats.org/markup-compatibility/2006" xmlns="" r:id="rId23" roundtripDataSignature="AMtx7mh48V+udFt60gXffsQxkFb0dpTBtg=="/>
     </p:ext>
   </p:extLst>
 </p:presentation>
 </file>
 
 <file path=ppt/notesMasters/notesMaster1.xml><?xml version="1.0" encoding="utf-8"?>
-<p:notesMaster xmlns:a="http://schemas.openxmlformats.org/drawingml/2006/main" xmlns:r="http://schemas.openxmlformats.org/officeDocument/2006/relationships" xmlns:mc="http://schemas.openxmlformats.org/markup-compatibility/2006" xmlns:mv="urn:schemas-microsoft-com:mac:vml" xmlns:p="http://schemas.openxmlformats.org/presentationml/2006/main" xmlns:c="http://schemas.openxmlformats.org/drawingml/2006/chart" xmlns:dgm="http://schemas.openxmlformats.org/drawingml/2006/diagram" xmlns:o="urn:schemas-microsoft-com:office:office" xmlns:v="urn:schemas-microsoft-com:vml" xmlns:pvml="urn:schemas-microsoft-com:office:powerpoint" xmlns:com="http://schemas.openxmlformats.org/drawingml/2006/compatibility" xmlns:p14="http://schemas.microsoft.com/office/powerpoint/2010/main" xmlns:p15="http://schemas.microsoft.com/office/powerpoint/2012/main" xmlns:ahyp="http://schemas.microsoft.com/office/drawing/2018/hyperlinkcolor">
+<p:notesMaster xmlns:a="http://schemas.openxmlformats.org/drawingml/2006/main" xmlns:r="http://schemas.openxmlformats.org/officeDocument/2006/relationships" xmlns:p="http://schemas.openxmlformats.org/presentationml/2006/main">
   <p:cSld>
     <p:bg>
       <p:bgPr>
         <a:solidFill>
           <a:schemeClr val="lt1"/>
         </a:solidFill>
+        <a:effectLst/>
       </p:bgPr>
     </p:bg>
     <p:spTree>
       <p:nvGrpSpPr>
-        <p:cNvPr id="2" name="Shape 2"/>
+        <p:cNvPr id="1" name="Shape 2"/>
         <p:cNvGrpSpPr/>
         <p:nvPr/>
       </p:nvGrpSpPr>
@@ -299,9 +307,11 @@
       <p:sp>
         <p:nvSpPr>
           <p:cNvPr id="3" name="Google Shape;3;n"/>
-          <p:cNvSpPr/>
+          <p:cNvSpPr>
+            <a:spLocks noGrp="1" noRot="1" noChangeAspect="1"/>
+          </p:cNvSpPr>
           <p:nvPr>
-            <p:ph idx="2" type="sldImg"/>
+            <p:ph type="sldImg" idx="2"/>
           </p:nvPr>
         </p:nvSpPr>
         <p:spPr>
@@ -310,9 +320,13 @@
             <a:ext cx="4572225" cy="4572000"/>
           </a:xfrm>
           <a:custGeom>
-            <a:rect b="b" l="l" r="r" t="t"/>
+            <a:avLst/>
+            <a:gdLst/>
+            <a:ahLst/>
+            <a:cxnLst/>
+            <a:rect l="l" t="t" r="r" b="b"/>
             <a:pathLst>
-              <a:path extrusionOk="0" h="120000" w="120000">
+              <a:path w="120000" h="120000" extrusionOk="0">
                 <a:moveTo>
                   <a:pt x="0" y="0"/>
                 </a:moveTo>
@@ -330,23 +344,25 @@
             </a:pathLst>
           </a:custGeom>
           <a:noFill/>
-          <a:ln cap="flat" cmpd="sng" w="9525">
+          <a:ln w="9525" cap="flat" cmpd="sng">
             <a:solidFill>
               <a:srgbClr val="000000"/>
             </a:solidFill>
             <a:prstDash val="solid"/>
             <a:round/>
-            <a:headEnd len="sm" w="sm" type="none"/>
-            <a:tailEnd len="sm" w="sm" type="none"/>
+            <a:headEnd type="none" w="sm" len="sm"/>
+            <a:tailEnd type="none" w="sm" len="sm"/>
           </a:ln>
         </p:spPr>
       </p:sp>
       <p:sp>
         <p:nvSpPr>
           <p:cNvPr id="4" name="Google Shape;4;n"/>
-          <p:cNvSpPr txBox="1"/>
+          <p:cNvSpPr txBox="1">
+            <a:spLocks noGrp="1"/>
+          </p:cNvSpPr>
           <p:nvPr>
-            <p:ph idx="1" type="body"/>
+            <p:ph type="body" idx="1"/>
           </p:nvPr>
         </p:nvSpPr>
         <p:spPr>
@@ -363,11 +379,11 @@
           </a:ln>
         </p:spPr>
         <p:txBody>
-          <a:bodyPr anchorCtr="0" anchor="t" bIns="91425" lIns="91425" spcFirstLastPara="1" rIns="91425" wrap="square" tIns="91425">
+          <a:bodyPr spcFirstLastPara="1" wrap="square" lIns="91425" tIns="91425" rIns="91425" bIns="91425" anchor="t" anchorCtr="0">
             <a:noAutofit/>
           </a:bodyPr>
           <a:lstStyle>
-            <a:lvl1pPr indent="-298450" lvl="0" marL="457200">
+            <a:lvl1pPr marL="457200" lvl="0" indent="-298450">
               <a:spcBef>
                 <a:spcPts val="0"/>
               </a:spcBef>
@@ -378,7 +394,7 @@
               <a:buChar char="●"/>
               <a:defRPr sz="1100"/>
             </a:lvl1pPr>
-            <a:lvl2pPr indent="-298450" lvl="1" marL="914400">
+            <a:lvl2pPr marL="914400" lvl="1" indent="-298450">
               <a:spcBef>
                 <a:spcPts val="0"/>
               </a:spcBef>
@@ -389,7 +405,7 @@
               <a:buChar char="○"/>
               <a:defRPr sz="1100"/>
             </a:lvl2pPr>
-            <a:lvl3pPr indent="-298450" lvl="2" marL="1371600">
+            <a:lvl3pPr marL="1371600" lvl="2" indent="-298450">
               <a:spcBef>
                 <a:spcPts val="0"/>
               </a:spcBef>
@@ -400,7 +416,7 @@
               <a:buChar char="■"/>
               <a:defRPr sz="1100"/>
             </a:lvl3pPr>
-            <a:lvl4pPr indent="-298450" lvl="3" marL="1828800">
+            <a:lvl4pPr marL="1828800" lvl="3" indent="-298450">
               <a:spcBef>
                 <a:spcPts val="0"/>
               </a:spcBef>
@@ -411,7 +427,7 @@
               <a:buChar char="●"/>
               <a:defRPr sz="1100"/>
             </a:lvl4pPr>
-            <a:lvl5pPr indent="-298450" lvl="4" marL="2286000">
+            <a:lvl5pPr marL="2286000" lvl="4" indent="-298450">
               <a:spcBef>
                 <a:spcPts val="0"/>
               </a:spcBef>
@@ -422,7 +438,7 @@
               <a:buChar char="○"/>
               <a:defRPr sz="1100"/>
             </a:lvl5pPr>
-            <a:lvl6pPr indent="-298450" lvl="5" marL="2743200">
+            <a:lvl6pPr marL="2743200" lvl="5" indent="-298450">
               <a:spcBef>
                 <a:spcPts val="0"/>
               </a:spcBef>
@@ -433,7 +449,7 @@
               <a:buChar char="■"/>
               <a:defRPr sz="1100"/>
             </a:lvl6pPr>
-            <a:lvl7pPr indent="-298450" lvl="6" marL="3200400">
+            <a:lvl7pPr marL="3200400" lvl="6" indent="-298450">
               <a:spcBef>
                 <a:spcPts val="0"/>
               </a:spcBef>
@@ -444,7 +460,7 @@
               <a:buChar char="●"/>
               <a:defRPr sz="1100"/>
             </a:lvl7pPr>
-            <a:lvl8pPr indent="-298450" lvl="7" marL="3657600">
+            <a:lvl8pPr marL="3657600" lvl="7" indent="-298450">
               <a:spcBef>
                 <a:spcPts val="0"/>
               </a:spcBef>
@@ -455,7 +471,7 @@
               <a:buChar char="○"/>
               <a:defRPr sz="1100"/>
             </a:lvl8pPr>
-            <a:lvl9pPr indent="-298450" lvl="8" marL="4114800">
+            <a:lvl9pPr marL="4114800" lvl="8" indent="-298450">
               <a:spcBef>
                 <a:spcPts val="0"/>
               </a:spcBef>
@@ -467,14 +483,16 @@
               <a:defRPr sz="1100"/>
             </a:lvl9pPr>
           </a:lstStyle>
-          <a:p/>
+          <a:p>
+            <a:endParaRPr/>
+          </a:p>
         </p:txBody>
       </p:sp>
     </p:spTree>
   </p:cSld>
-  <p:clrMap accent1="accent1" accent2="accent2" accent3="accent3" accent4="accent4" accent5="accent5" accent6="accent6" bg1="lt1" bg2="dk2" tx1="dk1" tx2="lt2" folHlink="folHlink" hlink="hlink"/>
+  <p:clrMap bg1="lt1" tx1="dk1" bg2="dk2" tx2="lt2" accent1="accent1" accent2="accent2" accent3="accent3" accent4="accent4" accent5="accent5" accent6="accent6" hlink="hlink" folHlink="folHlink"/>
   <p:notesStyle>
-    <a:defPPr lvl="0" marR="0" rtl="0" algn="l">
+    <a:defPPr marR="0" lvl="0" algn="l" rtl="0">
       <a:lnSpc>
         <a:spcPct val="100000"/>
       </a:lnSpc>
@@ -485,7 +503,7 @@
         <a:spcPts val="0"/>
       </a:spcAft>
     </a:defPPr>
-    <a:lvl1pPr lvl="0" marR="0" rtl="0" algn="l">
+    <a:lvl1pPr marR="0" lvl="0" algn="l" rtl="0">
       <a:lnSpc>
         <a:spcPct val="100000"/>
       </a:lnSpc>
@@ -499,7 +517,7 @@
         <a:srgbClr val="000000"/>
       </a:buClr>
       <a:buFont typeface="Arial"/>
-      <a:defRPr b="0" i="0" spc="0" sz="1400" u="none" cap="none" strike="noStrike">
+      <a:defRPr sz="1400" b="0" i="0" u="none" strike="noStrike" cap="none" spc="0">
         <a:solidFill>
           <a:srgbClr val="000000"/>
         </a:solidFill>
@@ -509,7 +527,7 @@
         <a:sym typeface="Arial"/>
       </a:defRPr>
     </a:lvl1pPr>
-    <a:lvl2pPr lvl="1" marR="0" rtl="0" algn="l">
+    <a:lvl2pPr marR="0" lvl="1" algn="l" rtl="0">
       <a:lnSpc>
         <a:spcPct val="100000"/>
       </a:lnSpc>
@@ -523,7 +541,7 @@
         <a:srgbClr val="000000"/>
       </a:buClr>
       <a:buFont typeface="Arial"/>
-      <a:defRPr b="0" i="0" spc="0" sz="1400" u="none" cap="none" strike="noStrike">
+      <a:defRPr sz="1400" b="0" i="0" u="none" strike="noStrike" cap="none" spc="0">
         <a:solidFill>
           <a:srgbClr val="000000"/>
         </a:solidFill>
@@ -533,7 +551,7 @@
         <a:sym typeface="Arial"/>
       </a:defRPr>
     </a:lvl2pPr>
-    <a:lvl3pPr lvl="2" marR="0" rtl="0" algn="l">
+    <a:lvl3pPr marR="0" lvl="2" algn="l" rtl="0">
       <a:lnSpc>
         <a:spcPct val="100000"/>
       </a:lnSpc>
@@ -547,7 +565,7 @@
         <a:srgbClr val="000000"/>
       </a:buClr>
       <a:buFont typeface="Arial"/>
-      <a:defRPr b="0" i="0" spc="0" sz="1400" u="none" cap="none" strike="noStrike">
+      <a:defRPr sz="1400" b="0" i="0" u="none" strike="noStrike" cap="none" spc="0">
         <a:solidFill>
           <a:srgbClr val="000000"/>
         </a:solidFill>
@@ -557,7 +575,7 @@
         <a:sym typeface="Arial"/>
       </a:defRPr>
     </a:lvl3pPr>
-    <a:lvl4pPr lvl="3" marR="0" rtl="0" algn="l">
+    <a:lvl4pPr marR="0" lvl="3" algn="l" rtl="0">
       <a:lnSpc>
         <a:spcPct val="100000"/>
       </a:lnSpc>
@@ -571,7 +589,7 @@
         <a:srgbClr val="000000"/>
       </a:buClr>
       <a:buFont typeface="Arial"/>
-      <a:defRPr b="0" i="0" spc="0" sz="1400" u="none" cap="none" strike="noStrike">
+      <a:defRPr sz="1400" b="0" i="0" u="none" strike="noStrike" cap="none" spc="0">
         <a:solidFill>
           <a:srgbClr val="000000"/>
         </a:solidFill>
@@ -581,7 +599,7 @@
         <a:sym typeface="Arial"/>
       </a:defRPr>
     </a:lvl4pPr>
-    <a:lvl5pPr lvl="4" marR="0" rtl="0" algn="l">
+    <a:lvl5pPr marR="0" lvl="4" algn="l" rtl="0">
       <a:lnSpc>
         <a:spcPct val="100000"/>
       </a:lnSpc>
@@ -595,7 +613,7 @@
         <a:srgbClr val="000000"/>
       </a:buClr>
       <a:buFont typeface="Arial"/>
-      <a:defRPr b="0" i="0" spc="0" sz="1400" u="none" cap="none" strike="noStrike">
+      <a:defRPr sz="1400" b="0" i="0" u="none" strike="noStrike" cap="none" spc="0">
         <a:solidFill>
           <a:srgbClr val="000000"/>
         </a:solidFill>
@@ -605,7 +623,7 @@
         <a:sym typeface="Arial"/>
       </a:defRPr>
     </a:lvl5pPr>
-    <a:lvl6pPr lvl="5" marR="0" rtl="0" algn="l">
+    <a:lvl6pPr marR="0" lvl="5" algn="l" rtl="0">
       <a:lnSpc>
         <a:spcPct val="100000"/>
       </a:lnSpc>
@@ -619,7 +637,7 @@
         <a:srgbClr val="000000"/>
       </a:buClr>
       <a:buFont typeface="Arial"/>
-      <a:defRPr b="0" i="0" spc="0" sz="1400" u="none" cap="none" strike="noStrike">
+      <a:defRPr sz="1400" b="0" i="0" u="none" strike="noStrike" cap="none" spc="0">
         <a:solidFill>
           <a:srgbClr val="000000"/>
         </a:solidFill>
@@ -629,7 +647,7 @@
         <a:sym typeface="Arial"/>
       </a:defRPr>
     </a:lvl6pPr>
-    <a:lvl7pPr lvl="6" marR="0" rtl="0" algn="l">
+    <a:lvl7pPr marR="0" lvl="6" algn="l" rtl="0">
       <a:lnSpc>
         <a:spcPct val="100000"/>
       </a:lnSpc>
@@ -643,7 +661,7 @@
         <a:srgbClr val="000000"/>
       </a:buClr>
       <a:buFont typeface="Arial"/>
-      <a:defRPr b="0" i="0" spc="0" sz="1400" u="none" cap="none" strike="noStrike">
+      <a:defRPr sz="1400" b="0" i="0" u="none" strike="noStrike" cap="none" spc="0">
         <a:solidFill>
           <a:srgbClr val="000000"/>
         </a:solidFill>
@@ -653,7 +671,7 @@
         <a:sym typeface="Arial"/>
       </a:defRPr>
     </a:lvl7pPr>
-    <a:lvl8pPr lvl="7" marR="0" rtl="0" algn="l">
+    <a:lvl8pPr marR="0" lvl="7" algn="l" rtl="0">
       <a:lnSpc>
         <a:spcPct val="100000"/>
       </a:lnSpc>
@@ -667,7 +685,7 @@
         <a:srgbClr val="000000"/>
       </a:buClr>
       <a:buFont typeface="Arial"/>
-      <a:defRPr b="0" i="0" spc="0" sz="1400" u="none" cap="none" strike="noStrike">
+      <a:defRPr sz="1400" b="0" i="0" u="none" strike="noStrike" cap="none" spc="0">
         <a:solidFill>
           <a:srgbClr val="000000"/>
         </a:solidFill>
@@ -677,7 +695,7 @@
         <a:sym typeface="Arial"/>
       </a:defRPr>
     </a:lvl8pPr>
-    <a:lvl9pPr lvl="8" marR="0" rtl="0" algn="l">
+    <a:lvl9pPr marR="0" lvl="8" algn="l" rtl="0">
       <a:lnSpc>
         <a:spcPct val="100000"/>
       </a:lnSpc>
@@ -691,7 +709,7 @@
         <a:srgbClr val="000000"/>
       </a:buClr>
       <a:buFont typeface="Arial"/>
-      <a:defRPr b="0" i="0" spc="0" sz="1400" u="none" cap="none" strike="noStrike">
+      <a:defRPr sz="1400" b="0" i="0" u="none" strike="noStrike" cap="none" spc="0">
         <a:solidFill>
           <a:srgbClr val="000000"/>
         </a:solidFill>
@@ -706,11 +724,11 @@
 </file>
 
 <file path=ppt/notesSlides/notesSlide1.xml><?xml version="1.0" encoding="utf-8"?>
-<p:notes xmlns:a="http://schemas.openxmlformats.org/drawingml/2006/main" xmlns:r="http://schemas.openxmlformats.org/officeDocument/2006/relationships" xmlns:mc="http://schemas.openxmlformats.org/markup-compatibility/2006" xmlns:mv="urn:schemas-microsoft-com:mac:vml" xmlns:p="http://schemas.openxmlformats.org/presentationml/2006/main" xmlns:c="http://schemas.openxmlformats.org/drawingml/2006/chart" xmlns:dgm="http://schemas.openxmlformats.org/drawingml/2006/diagram" xmlns:o="urn:schemas-microsoft-com:office:office" xmlns:v="urn:schemas-microsoft-com:vml" xmlns:pvml="urn:schemas-microsoft-com:office:powerpoint" xmlns:com="http://schemas.openxmlformats.org/drawingml/2006/compatibility" xmlns:p14="http://schemas.microsoft.com/office/powerpoint/2010/main" xmlns:p15="http://schemas.microsoft.com/office/powerpoint/2012/main" xmlns:ahyp="http://schemas.microsoft.com/office/drawing/2018/hyperlinkcolor" showMasterPhAnim="0" showMasterSp="0">
+<p:notes xmlns:a="http://schemas.openxmlformats.org/drawingml/2006/main" xmlns:r="http://schemas.openxmlformats.org/officeDocument/2006/relationships" xmlns:p="http://schemas.openxmlformats.org/presentationml/2006/main" showMasterSp="0" showMasterPhAnim="0">
   <p:cSld>
     <p:spTree>
       <p:nvGrpSpPr>
-        <p:cNvPr id="11" name="Shape 11"/>
+        <p:cNvPr id="1" name="Shape 11"/>
         <p:cNvGrpSpPr/>
         <p:nvPr/>
       </p:nvGrpSpPr>
@@ -725,9 +743,11 @@
       <p:sp>
         <p:nvSpPr>
           <p:cNvPr id="12" name="Google Shape;12;p1:notes"/>
-          <p:cNvSpPr/>
+          <p:cNvSpPr>
+            <a:spLocks noGrp="1" noRot="1" noChangeAspect="1"/>
+          </p:cNvSpPr>
           <p:nvPr>
-            <p:ph idx="2" type="sldImg"/>
+            <p:ph type="sldImg" idx="2"/>
           </p:nvPr>
         </p:nvSpPr>
         <p:spPr>
@@ -736,9 +756,13 @@
             <a:ext cx="3000000" cy="3000000"/>
           </a:xfrm>
           <a:custGeom>
-            <a:rect b="b" l="l" r="r" t="t"/>
+            <a:avLst/>
+            <a:gdLst/>
+            <a:ahLst/>
+            <a:cxnLst/>
+            <a:rect l="l" t="t" r="r" b="b"/>
             <a:pathLst>
-              <a:path extrusionOk="0" h="120000" w="120000">
+              <a:path w="120000" h="120000" extrusionOk="0">
                 <a:moveTo>
                   <a:pt x="0" y="0"/>
                 </a:moveTo>
@@ -764,9 +788,11 @@
       <p:sp>
         <p:nvSpPr>
           <p:cNvPr id="13" name="Google Shape;13;p1:notes"/>
-          <p:cNvSpPr txBox="1"/>
+          <p:cNvSpPr txBox="1">
+            <a:spLocks noGrp="1"/>
+          </p:cNvSpPr>
           <p:nvPr>
-            <p:ph idx="1" type="body"/>
+            <p:ph type="body" idx="1"/>
           </p:nvPr>
         </p:nvSpPr>
         <p:spPr>
@@ -783,12 +809,12 @@
           </a:ln>
         </p:spPr>
         <p:txBody>
-          <a:bodyPr anchorCtr="0" anchor="t" bIns="45700" lIns="91425" spcFirstLastPara="1" rIns="91425" wrap="square" tIns="45700">
+          <a:bodyPr spcFirstLastPara="1" wrap="square" lIns="91425" tIns="45700" rIns="91425" bIns="45700" anchor="t" anchorCtr="0">
             <a:noAutofit/>
           </a:bodyPr>
           <a:lstStyle/>
           <a:p>
-            <a:pPr indent="0" lvl="0" marL="0" marR="0" rtl="0" algn="l">
+            <a:pPr marL="0" marR="0" lvl="0" indent="0" algn="l" rtl="0">
               <a:spcBef>
                 <a:spcPts val="0"/>
               </a:spcBef>
@@ -797,9 +823,6 @@
               </a:spcAft>
               <a:buNone/>
             </a:pPr>
-            <a:r>
-              <a:t/>
-            </a:r>
             <a:endParaRPr sz="1200">
               <a:solidFill>
                 <a:schemeClr val="dk1"/>
@@ -815,9 +838,11 @@
       <p:sp>
         <p:nvSpPr>
           <p:cNvPr id="14" name="Google Shape;14;p1:notes"/>
-          <p:cNvSpPr txBox="1"/>
+          <p:cNvSpPr txBox="1">
+            <a:spLocks noGrp="1"/>
+          </p:cNvSpPr>
           <p:nvPr>
-            <p:ph idx="12" type="sldNum"/>
+            <p:ph type="sldNum" idx="12"/>
           </p:nvPr>
         </p:nvSpPr>
         <p:spPr>
@@ -834,12 +859,12 @@
           </a:ln>
         </p:spPr>
         <p:txBody>
-          <a:bodyPr anchorCtr="0" anchor="t" bIns="45700" lIns="91425" spcFirstLastPara="1" rIns="91425" wrap="square" tIns="45700">
+          <a:bodyPr spcFirstLastPara="1" wrap="square" lIns="91425" tIns="45700" rIns="91425" bIns="45700" anchor="t" anchorCtr="0">
             <a:noAutofit/>
           </a:bodyPr>
           <a:lstStyle/>
           <a:p>
-            <a:pPr indent="0" lvl="0" marL="0" marR="0" rtl="0" algn="l">
+            <a:pPr marL="0" marR="0" lvl="0" indent="0" algn="l" rtl="0">
               <a:spcBef>
                 <a:spcPts val="0"/>
               </a:spcBef>
@@ -858,7 +883,7 @@
                 <a:cs typeface="Arial"/>
                 <a:sym typeface="Arial"/>
               </a:rPr>
-              <a:t>‹#›</a:t>
+              <a:t>1</a:t>
             </a:fld>
             <a:endParaRPr sz="1800">
               <a:solidFill>
@@ -881,11 +906,11 @@
 </file>
 
 <file path=ppt/notesSlides/notesSlide10.xml><?xml version="1.0" encoding="utf-8"?>
-<p:notes xmlns:a="http://schemas.openxmlformats.org/drawingml/2006/main" xmlns:r="http://schemas.openxmlformats.org/officeDocument/2006/relationships" xmlns:mc="http://schemas.openxmlformats.org/markup-compatibility/2006" xmlns:mv="urn:schemas-microsoft-com:mac:vml" xmlns:p="http://schemas.openxmlformats.org/presentationml/2006/main" xmlns:c="http://schemas.openxmlformats.org/drawingml/2006/chart" xmlns:dgm="http://schemas.openxmlformats.org/drawingml/2006/diagram" xmlns:o="urn:schemas-microsoft-com:office:office" xmlns:v="urn:schemas-microsoft-com:vml" xmlns:pvml="urn:schemas-microsoft-com:office:powerpoint" xmlns:com="http://schemas.openxmlformats.org/drawingml/2006/compatibility" xmlns:p14="http://schemas.microsoft.com/office/powerpoint/2010/main" xmlns:p15="http://schemas.microsoft.com/office/powerpoint/2012/main" xmlns:ahyp="http://schemas.microsoft.com/office/drawing/2018/hyperlinkcolor" showMasterPhAnim="0" showMasterSp="0">
+<p:notes xmlns:a="http://schemas.openxmlformats.org/drawingml/2006/main" xmlns:r="http://schemas.openxmlformats.org/officeDocument/2006/relationships" xmlns:p="http://schemas.openxmlformats.org/presentationml/2006/main" showMasterSp="0" showMasterPhAnim="0">
   <p:cSld>
     <p:spTree>
       <p:nvGrpSpPr>
-        <p:cNvPr id="131" name="Shape 131"/>
+        <p:cNvPr id="1" name="Shape 131"/>
         <p:cNvGrpSpPr/>
         <p:nvPr/>
       </p:nvGrpSpPr>
@@ -900,9 +925,11 @@
       <p:sp>
         <p:nvSpPr>
           <p:cNvPr id="132" name="Google Shape;132;p9:notes"/>
-          <p:cNvSpPr/>
+          <p:cNvSpPr>
+            <a:spLocks noGrp="1" noRot="1" noChangeAspect="1"/>
+          </p:cNvSpPr>
           <p:nvPr>
-            <p:ph idx="2" type="sldImg"/>
+            <p:ph type="sldImg" idx="2"/>
           </p:nvPr>
         </p:nvSpPr>
         <p:spPr>
@@ -911,9 +938,13 @@
             <a:ext cx="3000000" cy="3000000"/>
           </a:xfrm>
           <a:custGeom>
-            <a:rect b="b" l="l" r="r" t="t"/>
+            <a:avLst/>
+            <a:gdLst/>
+            <a:ahLst/>
+            <a:cxnLst/>
+            <a:rect l="l" t="t" r="r" b="b"/>
             <a:pathLst>
-              <a:path extrusionOk="0" h="120000" w="120000">
+              <a:path w="120000" h="120000" extrusionOk="0">
                 <a:moveTo>
                   <a:pt x="0" y="0"/>
                 </a:moveTo>
@@ -939,9 +970,11 @@
       <p:sp>
         <p:nvSpPr>
           <p:cNvPr id="133" name="Google Shape;133;p9:notes"/>
-          <p:cNvSpPr txBox="1"/>
+          <p:cNvSpPr txBox="1">
+            <a:spLocks noGrp="1"/>
+          </p:cNvSpPr>
           <p:nvPr>
-            <p:ph idx="1" type="body"/>
+            <p:ph type="body" idx="1"/>
           </p:nvPr>
         </p:nvSpPr>
         <p:spPr>
@@ -958,12 +991,12 @@
           </a:ln>
         </p:spPr>
         <p:txBody>
-          <a:bodyPr anchorCtr="0" anchor="t" bIns="45700" lIns="91425" spcFirstLastPara="1" rIns="91425" wrap="square" tIns="45700">
+          <a:bodyPr spcFirstLastPara="1" wrap="square" lIns="91425" tIns="45700" rIns="91425" bIns="45700" anchor="t" anchorCtr="0">
             <a:noAutofit/>
           </a:bodyPr>
           <a:lstStyle/>
           <a:p>
-            <a:pPr indent="0" lvl="0" marL="0" marR="0" rtl="0" algn="l">
+            <a:pPr marL="0" marR="0" lvl="0" indent="0" algn="l" rtl="0">
               <a:spcBef>
                 <a:spcPts val="0"/>
               </a:spcBef>
@@ -972,9 +1005,6 @@
               </a:spcAft>
               <a:buNone/>
             </a:pPr>
-            <a:r>
-              <a:t/>
-            </a:r>
             <a:endParaRPr sz="1200">
               <a:solidFill>
                 <a:schemeClr val="dk1"/>
@@ -990,9 +1020,11 @@
       <p:sp>
         <p:nvSpPr>
           <p:cNvPr id="134" name="Google Shape;134;p9:notes"/>
-          <p:cNvSpPr txBox="1"/>
+          <p:cNvSpPr txBox="1">
+            <a:spLocks noGrp="1"/>
+          </p:cNvSpPr>
           <p:nvPr>
-            <p:ph idx="12" type="sldNum"/>
+            <p:ph type="sldNum" idx="12"/>
           </p:nvPr>
         </p:nvSpPr>
         <p:spPr>
@@ -1009,12 +1041,12 @@
           </a:ln>
         </p:spPr>
         <p:txBody>
-          <a:bodyPr anchorCtr="0" anchor="t" bIns="45700" lIns="91425" spcFirstLastPara="1" rIns="91425" wrap="square" tIns="45700">
+          <a:bodyPr spcFirstLastPara="1" wrap="square" lIns="91425" tIns="45700" rIns="91425" bIns="45700" anchor="t" anchorCtr="0">
             <a:noAutofit/>
           </a:bodyPr>
           <a:lstStyle/>
           <a:p>
-            <a:pPr indent="0" lvl="0" marL="0" marR="0" rtl="0" algn="l">
+            <a:pPr marL="0" marR="0" lvl="0" indent="0" algn="l" rtl="0">
               <a:spcBef>
                 <a:spcPts val="0"/>
               </a:spcBef>
@@ -1033,7 +1065,7 @@
                 <a:cs typeface="Arial"/>
                 <a:sym typeface="Arial"/>
               </a:rPr>
-              <a:t>‹#›</a:t>
+              <a:t>10</a:t>
             </a:fld>
             <a:endParaRPr sz="1800">
               <a:solidFill>
@@ -1056,11 +1088,11 @@
 </file>
 
 <file path=ppt/notesSlides/notesSlide2.xml><?xml version="1.0" encoding="utf-8"?>
-<p:notes xmlns:a="http://schemas.openxmlformats.org/drawingml/2006/main" xmlns:r="http://schemas.openxmlformats.org/officeDocument/2006/relationships" xmlns:mc="http://schemas.openxmlformats.org/markup-compatibility/2006" xmlns:mv="urn:schemas-microsoft-com:mac:vml" xmlns:p="http://schemas.openxmlformats.org/presentationml/2006/main" xmlns:c="http://schemas.openxmlformats.org/drawingml/2006/chart" xmlns:dgm="http://schemas.openxmlformats.org/drawingml/2006/diagram" xmlns:o="urn:schemas-microsoft-com:office:office" xmlns:v="urn:schemas-microsoft-com:vml" xmlns:pvml="urn:schemas-microsoft-com:office:powerpoint" xmlns:com="http://schemas.openxmlformats.org/drawingml/2006/compatibility" xmlns:p14="http://schemas.microsoft.com/office/powerpoint/2010/main" xmlns:p15="http://schemas.microsoft.com/office/powerpoint/2012/main" xmlns:ahyp="http://schemas.microsoft.com/office/drawing/2018/hyperlinkcolor" showMasterPhAnim="0" showMasterSp="0">
+<p:notes xmlns:a="http://schemas.openxmlformats.org/drawingml/2006/main" xmlns:r="http://schemas.openxmlformats.org/officeDocument/2006/relationships" xmlns:p="http://schemas.openxmlformats.org/presentationml/2006/main" showMasterSp="0" showMasterPhAnim="0">
   <p:cSld>
     <p:spTree>
       <p:nvGrpSpPr>
-        <p:cNvPr id="20" name="Shape 20"/>
+        <p:cNvPr id="1" name="Shape 20"/>
         <p:cNvGrpSpPr/>
         <p:nvPr/>
       </p:nvGrpSpPr>
@@ -1075,9 +1107,11 @@
       <p:sp>
         <p:nvSpPr>
           <p:cNvPr id="21" name="Google Shape;21;p2:notes"/>
-          <p:cNvSpPr/>
+          <p:cNvSpPr>
+            <a:spLocks noGrp="1" noRot="1" noChangeAspect="1"/>
+          </p:cNvSpPr>
           <p:nvPr>
-            <p:ph idx="2" type="sldImg"/>
+            <p:ph type="sldImg" idx="2"/>
           </p:nvPr>
         </p:nvSpPr>
         <p:spPr>
@@ -1086,9 +1120,13 @@
             <a:ext cx="3000000" cy="3000000"/>
           </a:xfrm>
           <a:custGeom>
-            <a:rect b="b" l="l" r="r" t="t"/>
+            <a:avLst/>
+            <a:gdLst/>
+            <a:ahLst/>
+            <a:cxnLst/>
+            <a:rect l="l" t="t" r="r" b="b"/>
             <a:pathLst>
-              <a:path extrusionOk="0" h="120000" w="120000">
+              <a:path w="120000" h="120000" extrusionOk="0">
                 <a:moveTo>
                   <a:pt x="0" y="0"/>
                 </a:moveTo>
@@ -1114,9 +1152,11 @@
       <p:sp>
         <p:nvSpPr>
           <p:cNvPr id="22" name="Google Shape;22;p2:notes"/>
-          <p:cNvSpPr txBox="1"/>
+          <p:cNvSpPr txBox="1">
+            <a:spLocks noGrp="1"/>
+          </p:cNvSpPr>
           <p:nvPr>
-            <p:ph idx="1" type="body"/>
+            <p:ph type="body" idx="1"/>
           </p:nvPr>
         </p:nvSpPr>
         <p:spPr>
@@ -1133,12 +1173,12 @@
           </a:ln>
         </p:spPr>
         <p:txBody>
-          <a:bodyPr anchorCtr="0" anchor="t" bIns="45700" lIns="91425" spcFirstLastPara="1" rIns="91425" wrap="square" tIns="45700">
+          <a:bodyPr spcFirstLastPara="1" wrap="square" lIns="91425" tIns="45700" rIns="91425" bIns="45700" anchor="t" anchorCtr="0">
             <a:noAutofit/>
           </a:bodyPr>
           <a:lstStyle/>
           <a:p>
-            <a:pPr indent="0" lvl="0" marL="0" marR="0" rtl="0" algn="l">
+            <a:pPr marL="0" marR="0" lvl="0" indent="0" algn="l" rtl="0">
               <a:spcBef>
                 <a:spcPts val="0"/>
               </a:spcBef>
@@ -1147,9 +1187,6 @@
               </a:spcAft>
               <a:buNone/>
             </a:pPr>
-            <a:r>
-              <a:t/>
-            </a:r>
             <a:endParaRPr sz="1200">
               <a:solidFill>
                 <a:schemeClr val="dk1"/>
@@ -1165,9 +1202,11 @@
       <p:sp>
         <p:nvSpPr>
           <p:cNvPr id="23" name="Google Shape;23;p2:notes"/>
-          <p:cNvSpPr txBox="1"/>
+          <p:cNvSpPr txBox="1">
+            <a:spLocks noGrp="1"/>
+          </p:cNvSpPr>
           <p:nvPr>
-            <p:ph idx="12" type="sldNum"/>
+            <p:ph type="sldNum" idx="12"/>
           </p:nvPr>
         </p:nvSpPr>
         <p:spPr>
@@ -1184,12 +1223,12 @@
           </a:ln>
         </p:spPr>
         <p:txBody>
-          <a:bodyPr anchorCtr="0" anchor="t" bIns="45700" lIns="91425" spcFirstLastPara="1" rIns="91425" wrap="square" tIns="45700">
+          <a:bodyPr spcFirstLastPara="1" wrap="square" lIns="91425" tIns="45700" rIns="91425" bIns="45700" anchor="t" anchorCtr="0">
             <a:noAutofit/>
           </a:bodyPr>
           <a:lstStyle/>
           <a:p>
-            <a:pPr indent="0" lvl="0" marL="0" marR="0" rtl="0" algn="l">
+            <a:pPr marL="0" marR="0" lvl="0" indent="0" algn="l" rtl="0">
               <a:spcBef>
                 <a:spcPts val="0"/>
               </a:spcBef>
@@ -1208,7 +1247,7 @@
                 <a:cs typeface="Arial"/>
                 <a:sym typeface="Arial"/>
               </a:rPr>
-              <a:t>‹#›</a:t>
+              <a:t>2</a:t>
             </a:fld>
             <a:endParaRPr sz="1800">
               <a:solidFill>
@@ -1231,11 +1270,11 @@
 </file>
 
 <file path=ppt/notesSlides/notesSlide3.xml><?xml version="1.0" encoding="utf-8"?>
-<p:notes xmlns:a="http://schemas.openxmlformats.org/drawingml/2006/main" xmlns:r="http://schemas.openxmlformats.org/officeDocument/2006/relationships" xmlns:mc="http://schemas.openxmlformats.org/markup-compatibility/2006" xmlns:mv="urn:schemas-microsoft-com:mac:vml" xmlns:p="http://schemas.openxmlformats.org/presentationml/2006/main" xmlns:c="http://schemas.openxmlformats.org/drawingml/2006/chart" xmlns:dgm="http://schemas.openxmlformats.org/drawingml/2006/diagram" xmlns:o="urn:schemas-microsoft-com:office:office" xmlns:v="urn:schemas-microsoft-com:vml" xmlns:pvml="urn:schemas-microsoft-com:office:powerpoint" xmlns:com="http://schemas.openxmlformats.org/drawingml/2006/compatibility" xmlns:p14="http://schemas.microsoft.com/office/powerpoint/2010/main" xmlns:p15="http://schemas.microsoft.com/office/powerpoint/2012/main" xmlns:ahyp="http://schemas.microsoft.com/office/drawing/2018/hyperlinkcolor" showMasterPhAnim="0" showMasterSp="0">
+<p:notes xmlns:a="http://schemas.openxmlformats.org/drawingml/2006/main" xmlns:r="http://schemas.openxmlformats.org/officeDocument/2006/relationships" xmlns:p="http://schemas.openxmlformats.org/presentationml/2006/main" showMasterSp="0" showMasterPhAnim="0">
   <p:cSld>
     <p:spTree>
       <p:nvGrpSpPr>
-        <p:cNvPr id="38" name="Shape 38"/>
+        <p:cNvPr id="1" name="Shape 38"/>
         <p:cNvGrpSpPr/>
         <p:nvPr/>
       </p:nvGrpSpPr>
@@ -1250,9 +1289,11 @@
       <p:sp>
         <p:nvSpPr>
           <p:cNvPr id="39" name="Google Shape;39;p3:notes"/>
-          <p:cNvSpPr/>
+          <p:cNvSpPr>
+            <a:spLocks noGrp="1" noRot="1" noChangeAspect="1"/>
+          </p:cNvSpPr>
           <p:nvPr>
-            <p:ph idx="2" type="sldImg"/>
+            <p:ph type="sldImg" idx="2"/>
           </p:nvPr>
         </p:nvSpPr>
         <p:spPr>
@@ -1261,9 +1302,13 @@
             <a:ext cx="3000000" cy="3000000"/>
           </a:xfrm>
           <a:custGeom>
-            <a:rect b="b" l="l" r="r" t="t"/>
+            <a:avLst/>
+            <a:gdLst/>
+            <a:ahLst/>
+            <a:cxnLst/>
+            <a:rect l="l" t="t" r="r" b="b"/>
             <a:pathLst>
-              <a:path extrusionOk="0" h="120000" w="120000">
+              <a:path w="120000" h="120000" extrusionOk="0">
                 <a:moveTo>
                   <a:pt x="0" y="0"/>
                 </a:moveTo>
@@ -1289,9 +1334,11 @@
       <p:sp>
         <p:nvSpPr>
           <p:cNvPr id="40" name="Google Shape;40;p3:notes"/>
-          <p:cNvSpPr txBox="1"/>
+          <p:cNvSpPr txBox="1">
+            <a:spLocks noGrp="1"/>
+          </p:cNvSpPr>
           <p:nvPr>
-            <p:ph idx="1" type="body"/>
+            <p:ph type="body" idx="1"/>
           </p:nvPr>
         </p:nvSpPr>
         <p:spPr>
@@ -1308,12 +1355,12 @@
           </a:ln>
         </p:spPr>
         <p:txBody>
-          <a:bodyPr anchorCtr="0" anchor="t" bIns="45700" lIns="91425" spcFirstLastPara="1" rIns="91425" wrap="square" tIns="45700">
+          <a:bodyPr spcFirstLastPara="1" wrap="square" lIns="91425" tIns="45700" rIns="91425" bIns="45700" anchor="t" anchorCtr="0">
             <a:noAutofit/>
           </a:bodyPr>
           <a:lstStyle/>
           <a:p>
-            <a:pPr indent="0" lvl="0" marL="0" marR="0" rtl="0" algn="l">
+            <a:pPr marL="0" marR="0" lvl="0" indent="0" algn="l" rtl="0">
               <a:spcBef>
                 <a:spcPts val="0"/>
               </a:spcBef>
@@ -1322,9 +1369,6 @@
               </a:spcAft>
               <a:buNone/>
             </a:pPr>
-            <a:r>
-              <a:t/>
-            </a:r>
             <a:endParaRPr sz="1200">
               <a:solidFill>
                 <a:schemeClr val="dk1"/>
@@ -1340,9 +1384,11 @@
       <p:sp>
         <p:nvSpPr>
           <p:cNvPr id="41" name="Google Shape;41;p3:notes"/>
-          <p:cNvSpPr txBox="1"/>
+          <p:cNvSpPr txBox="1">
+            <a:spLocks noGrp="1"/>
+          </p:cNvSpPr>
           <p:nvPr>
-            <p:ph idx="12" type="sldNum"/>
+            <p:ph type="sldNum" idx="12"/>
           </p:nvPr>
         </p:nvSpPr>
         <p:spPr>
@@ -1359,12 +1405,12 @@
           </a:ln>
         </p:spPr>
         <p:txBody>
-          <a:bodyPr anchorCtr="0" anchor="t" bIns="45700" lIns="91425" spcFirstLastPara="1" rIns="91425" wrap="square" tIns="45700">
+          <a:bodyPr spcFirstLastPara="1" wrap="square" lIns="91425" tIns="45700" rIns="91425" bIns="45700" anchor="t" anchorCtr="0">
             <a:noAutofit/>
           </a:bodyPr>
           <a:lstStyle/>
           <a:p>
-            <a:pPr indent="0" lvl="0" marL="0" marR="0" rtl="0" algn="l">
+            <a:pPr marL="0" marR="0" lvl="0" indent="0" algn="l" rtl="0">
               <a:spcBef>
                 <a:spcPts val="0"/>
               </a:spcBef>
@@ -1383,7 +1429,7 @@
                 <a:cs typeface="Arial"/>
                 <a:sym typeface="Arial"/>
               </a:rPr>
-              <a:t>‹#›</a:t>
+              <a:t>3</a:t>
             </a:fld>
             <a:endParaRPr sz="1800">
               <a:solidFill>
@@ -1406,11 +1452,11 @@
 </file>
 
 <file path=ppt/notesSlides/notesSlide4.xml><?xml version="1.0" encoding="utf-8"?>
-<p:notes xmlns:a="http://schemas.openxmlformats.org/drawingml/2006/main" xmlns:r="http://schemas.openxmlformats.org/officeDocument/2006/relationships" xmlns:mc="http://schemas.openxmlformats.org/markup-compatibility/2006" xmlns:mv="urn:schemas-microsoft-com:mac:vml" xmlns:p="http://schemas.openxmlformats.org/presentationml/2006/main" xmlns:c="http://schemas.openxmlformats.org/drawingml/2006/chart" xmlns:dgm="http://schemas.openxmlformats.org/drawingml/2006/diagram" xmlns:o="urn:schemas-microsoft-com:office:office" xmlns:v="urn:schemas-microsoft-com:vml" xmlns:pvml="urn:schemas-microsoft-com:office:powerpoint" xmlns:com="http://schemas.openxmlformats.org/drawingml/2006/compatibility" xmlns:p14="http://schemas.microsoft.com/office/powerpoint/2010/main" xmlns:p15="http://schemas.microsoft.com/office/powerpoint/2012/main" xmlns:ahyp="http://schemas.microsoft.com/office/drawing/2018/hyperlinkcolor" showMasterPhAnim="0" showMasterSp="0">
+<p:notes xmlns:a="http://schemas.openxmlformats.org/drawingml/2006/main" xmlns:r="http://schemas.openxmlformats.org/officeDocument/2006/relationships" xmlns:p="http://schemas.openxmlformats.org/presentationml/2006/main" showMasterSp="0" showMasterPhAnim="0">
   <p:cSld>
     <p:spTree>
       <p:nvGrpSpPr>
-        <p:cNvPr id="61" name="Shape 61"/>
+        <p:cNvPr id="1" name="Shape 61"/>
         <p:cNvGrpSpPr/>
         <p:nvPr/>
       </p:nvGrpSpPr>
@@ -1425,20 +1471,26 @@
       <p:sp>
         <p:nvSpPr>
           <p:cNvPr id="62" name="Google Shape;62;p4:notes"/>
-          <p:cNvSpPr/>
+          <p:cNvSpPr>
+            <a:spLocks noGrp="1" noRot="1" noChangeAspect="1"/>
+          </p:cNvSpPr>
           <p:nvPr>
-            <p:ph idx="2" type="sldImg"/>
+            <p:ph type="sldImg" idx="2"/>
           </p:nvPr>
         </p:nvSpPr>
         <p:spPr>
           <a:xfrm>
-            <a:off x="0" y="0"/>
-            <a:ext cx="3000000" cy="3000000"/>
+            <a:off x="-1166813" y="0"/>
+            <a:ext cx="5334001" cy="3000375"/>
           </a:xfrm>
           <a:custGeom>
-            <a:rect b="b" l="l" r="r" t="t"/>
+            <a:avLst/>
+            <a:gdLst/>
+            <a:ahLst/>
+            <a:cxnLst/>
+            <a:rect l="l" t="t" r="r" b="b"/>
             <a:pathLst>
-              <a:path extrusionOk="0" h="120000" w="120000">
+              <a:path w="120000" h="120000" extrusionOk="0">
                 <a:moveTo>
                   <a:pt x="0" y="0"/>
                 </a:moveTo>
@@ -1464,9 +1516,11 @@
       <p:sp>
         <p:nvSpPr>
           <p:cNvPr id="63" name="Google Shape;63;p4:notes"/>
-          <p:cNvSpPr txBox="1"/>
+          <p:cNvSpPr txBox="1">
+            <a:spLocks noGrp="1"/>
+          </p:cNvSpPr>
           <p:nvPr>
-            <p:ph idx="1" type="body"/>
+            <p:ph type="body" idx="1"/>
           </p:nvPr>
         </p:nvSpPr>
         <p:spPr>
@@ -1483,12 +1537,12 @@
           </a:ln>
         </p:spPr>
         <p:txBody>
-          <a:bodyPr anchorCtr="0" anchor="t" bIns="45700" lIns="91425" spcFirstLastPara="1" rIns="91425" wrap="square" tIns="45700">
+          <a:bodyPr spcFirstLastPara="1" wrap="square" lIns="91425" tIns="45700" rIns="91425" bIns="45700" anchor="t" anchorCtr="0">
             <a:noAutofit/>
           </a:bodyPr>
           <a:lstStyle/>
           <a:p>
-            <a:pPr indent="0" lvl="0" marL="0" marR="0" rtl="0" algn="l">
+            <a:pPr marL="0" marR="0" lvl="0" indent="0" algn="l" rtl="0">
               <a:spcBef>
                 <a:spcPts val="0"/>
               </a:spcBef>
@@ -1497,9 +1551,6 @@
               </a:spcAft>
               <a:buNone/>
             </a:pPr>
-            <a:r>
-              <a:t/>
-            </a:r>
             <a:endParaRPr sz="1200">
               <a:solidFill>
                 <a:schemeClr val="dk1"/>
@@ -1515,9 +1566,11 @@
       <p:sp>
         <p:nvSpPr>
           <p:cNvPr id="64" name="Google Shape;64;p4:notes"/>
-          <p:cNvSpPr txBox="1"/>
+          <p:cNvSpPr txBox="1">
+            <a:spLocks noGrp="1"/>
+          </p:cNvSpPr>
           <p:nvPr>
-            <p:ph idx="12" type="sldNum"/>
+            <p:ph type="sldNum" idx="12"/>
           </p:nvPr>
         </p:nvSpPr>
         <p:spPr>
@@ -1534,12 +1587,12 @@
           </a:ln>
         </p:spPr>
         <p:txBody>
-          <a:bodyPr anchorCtr="0" anchor="t" bIns="45700" lIns="91425" spcFirstLastPara="1" rIns="91425" wrap="square" tIns="45700">
+          <a:bodyPr spcFirstLastPara="1" wrap="square" lIns="91425" tIns="45700" rIns="91425" bIns="45700" anchor="t" anchorCtr="0">
             <a:noAutofit/>
           </a:bodyPr>
           <a:lstStyle/>
           <a:p>
-            <a:pPr indent="0" lvl="0" marL="0" marR="0" rtl="0" algn="l">
+            <a:pPr marL="0" marR="0" lvl="0" indent="0" algn="l" rtl="0">
               <a:spcBef>
                 <a:spcPts val="0"/>
               </a:spcBef>
@@ -1558,7 +1611,7 @@
                 <a:cs typeface="Arial"/>
                 <a:sym typeface="Arial"/>
               </a:rPr>
-              <a:t>‹#›</a:t>
+              <a:t>4</a:t>
             </a:fld>
             <a:endParaRPr sz="1800">
               <a:solidFill>
@@ -1581,11 +1634,11 @@
 </file>
 
 <file path=ppt/notesSlides/notesSlide5.xml><?xml version="1.0" encoding="utf-8"?>
-<p:notes xmlns:a="http://schemas.openxmlformats.org/drawingml/2006/main" xmlns:r="http://schemas.openxmlformats.org/officeDocument/2006/relationships" xmlns:mc="http://schemas.openxmlformats.org/markup-compatibility/2006" xmlns:mv="urn:schemas-microsoft-com:mac:vml" xmlns:p="http://schemas.openxmlformats.org/presentationml/2006/main" xmlns:c="http://schemas.openxmlformats.org/drawingml/2006/chart" xmlns:dgm="http://schemas.openxmlformats.org/drawingml/2006/diagram" xmlns:o="urn:schemas-microsoft-com:office:office" xmlns:v="urn:schemas-microsoft-com:vml" xmlns:pvml="urn:schemas-microsoft-com:office:powerpoint" xmlns:com="http://schemas.openxmlformats.org/drawingml/2006/compatibility" xmlns:p14="http://schemas.microsoft.com/office/powerpoint/2010/main" xmlns:p15="http://schemas.microsoft.com/office/powerpoint/2012/main" xmlns:ahyp="http://schemas.microsoft.com/office/drawing/2018/hyperlinkcolor" showMasterPhAnim="0" showMasterSp="0">
+<p:notes xmlns:a="http://schemas.openxmlformats.org/drawingml/2006/main" xmlns:r="http://schemas.openxmlformats.org/officeDocument/2006/relationships" xmlns:p="http://schemas.openxmlformats.org/presentationml/2006/main" showMasterSp="0" showMasterPhAnim="0">
   <p:cSld>
     <p:spTree>
       <p:nvGrpSpPr>
-        <p:cNvPr id="72" name="Shape 72"/>
+        <p:cNvPr id="1" name="Shape 72"/>
         <p:cNvGrpSpPr/>
         <p:nvPr/>
       </p:nvGrpSpPr>
@@ -1600,20 +1653,26 @@
       <p:sp>
         <p:nvSpPr>
           <p:cNvPr id="73" name="Google Shape;73;g3fa6aa0c82d_0_1:notes"/>
-          <p:cNvSpPr/>
+          <p:cNvSpPr>
+            <a:spLocks noGrp="1" noRot="1" noChangeAspect="1"/>
+          </p:cNvSpPr>
           <p:nvPr>
-            <p:ph idx="2" type="sldImg"/>
+            <p:ph type="sldImg" idx="2"/>
           </p:nvPr>
         </p:nvSpPr>
         <p:spPr>
           <a:xfrm>
-            <a:off x="0" y="0"/>
-            <a:ext cx="3000000" cy="3000000"/>
+            <a:off x="-1166813" y="0"/>
+            <a:ext cx="5334001" cy="3000375"/>
           </a:xfrm>
           <a:custGeom>
-            <a:rect b="b" l="l" r="r" t="t"/>
+            <a:avLst/>
+            <a:gdLst/>
+            <a:ahLst/>
+            <a:cxnLst/>
+            <a:rect l="l" t="t" r="r" b="b"/>
             <a:pathLst>
-              <a:path extrusionOk="0" h="120000" w="120000">
+              <a:path w="120000" h="120000" extrusionOk="0">
                 <a:moveTo>
                   <a:pt x="0" y="0"/>
                 </a:moveTo>
@@ -1639,9 +1698,11 @@
       <p:sp>
         <p:nvSpPr>
           <p:cNvPr id="74" name="Google Shape;74;g3fa6aa0c82d_0_1:notes"/>
-          <p:cNvSpPr txBox="1"/>
+          <p:cNvSpPr txBox="1">
+            <a:spLocks noGrp="1"/>
+          </p:cNvSpPr>
           <p:nvPr>
-            <p:ph idx="1" type="body"/>
+            <p:ph type="body" idx="1"/>
           </p:nvPr>
         </p:nvSpPr>
         <p:spPr>
@@ -1658,12 +1719,12 @@
           </a:ln>
         </p:spPr>
         <p:txBody>
-          <a:bodyPr anchorCtr="0" anchor="t" bIns="45700" lIns="91425" spcFirstLastPara="1" rIns="91425" wrap="square" tIns="45700">
+          <a:bodyPr spcFirstLastPara="1" wrap="square" lIns="91425" tIns="45700" rIns="91425" bIns="45700" anchor="t" anchorCtr="0">
             <a:noAutofit/>
           </a:bodyPr>
           <a:lstStyle/>
           <a:p>
-            <a:pPr indent="0" lvl="0" marL="0" marR="0" rtl="0" algn="l">
+            <a:pPr marL="0" marR="0" lvl="0" indent="0" algn="l" rtl="0">
               <a:spcBef>
                 <a:spcPts val="0"/>
               </a:spcBef>
@@ -1672,9 +1733,6 @@
               </a:spcAft>
               <a:buNone/>
             </a:pPr>
-            <a:r>
-              <a:t/>
-            </a:r>
             <a:endParaRPr sz="1200">
               <a:solidFill>
                 <a:schemeClr val="dk1"/>
@@ -1690,9 +1748,11 @@
       <p:sp>
         <p:nvSpPr>
           <p:cNvPr id="75" name="Google Shape;75;g3fa6aa0c82d_0_1:notes"/>
-          <p:cNvSpPr txBox="1"/>
+          <p:cNvSpPr txBox="1">
+            <a:spLocks noGrp="1"/>
+          </p:cNvSpPr>
           <p:nvPr>
-            <p:ph idx="12" type="sldNum"/>
+            <p:ph type="sldNum" idx="12"/>
           </p:nvPr>
         </p:nvSpPr>
         <p:spPr>
@@ -1709,12 +1769,12 @@
           </a:ln>
         </p:spPr>
         <p:txBody>
-          <a:bodyPr anchorCtr="0" anchor="t" bIns="45700" lIns="91425" spcFirstLastPara="1" rIns="91425" wrap="square" tIns="45700">
+          <a:bodyPr spcFirstLastPara="1" wrap="square" lIns="91425" tIns="45700" rIns="91425" bIns="45700" anchor="t" anchorCtr="0">
             <a:noAutofit/>
           </a:bodyPr>
           <a:lstStyle/>
           <a:p>
-            <a:pPr indent="0" lvl="0" marL="0" marR="0" rtl="0" algn="l">
+            <a:pPr marL="0" marR="0" lvl="0" indent="0" algn="l" rtl="0">
               <a:spcBef>
                 <a:spcPts val="0"/>
               </a:spcBef>
@@ -1733,7 +1793,7 @@
                 <a:cs typeface="Arial"/>
                 <a:sym typeface="Arial"/>
               </a:rPr>
-              <a:t>‹#›</a:t>
+              <a:t>5</a:t>
             </a:fld>
             <a:endParaRPr sz="1800">
               <a:solidFill>
@@ -1756,11 +1816,11 @@
 </file>
 
 <file path=ppt/notesSlides/notesSlide6.xml><?xml version="1.0" encoding="utf-8"?>
-<p:notes xmlns:a="http://schemas.openxmlformats.org/drawingml/2006/main" xmlns:r="http://schemas.openxmlformats.org/officeDocument/2006/relationships" xmlns:mc="http://schemas.openxmlformats.org/markup-compatibility/2006" xmlns:mv="urn:schemas-microsoft-com:mac:vml" xmlns:p="http://schemas.openxmlformats.org/presentationml/2006/main" xmlns:c="http://schemas.openxmlformats.org/drawingml/2006/chart" xmlns:dgm="http://schemas.openxmlformats.org/drawingml/2006/diagram" xmlns:o="urn:schemas-microsoft-com:office:office" xmlns:v="urn:schemas-microsoft-com:vml" xmlns:pvml="urn:schemas-microsoft-com:office:powerpoint" xmlns:com="http://schemas.openxmlformats.org/drawingml/2006/compatibility" xmlns:p14="http://schemas.microsoft.com/office/powerpoint/2010/main" xmlns:p15="http://schemas.microsoft.com/office/powerpoint/2012/main" xmlns:ahyp="http://schemas.microsoft.com/office/drawing/2018/hyperlinkcolor" showMasterPhAnim="0" showMasterSp="0">
+<p:notes xmlns:a="http://schemas.openxmlformats.org/drawingml/2006/main" xmlns:r="http://schemas.openxmlformats.org/officeDocument/2006/relationships" xmlns:p="http://schemas.openxmlformats.org/presentationml/2006/main" showMasterSp="0" showMasterPhAnim="0">
   <p:cSld>
     <p:spTree>
       <p:nvGrpSpPr>
-        <p:cNvPr id="84" name="Shape 84"/>
+        <p:cNvPr id="1" name="Shape 84"/>
         <p:cNvGrpSpPr/>
         <p:nvPr/>
       </p:nvGrpSpPr>
@@ -1775,9 +1835,11 @@
       <p:sp>
         <p:nvSpPr>
           <p:cNvPr id="85" name="Google Shape;85;p5:notes"/>
-          <p:cNvSpPr/>
+          <p:cNvSpPr>
+            <a:spLocks noGrp="1" noRot="1" noChangeAspect="1"/>
+          </p:cNvSpPr>
           <p:nvPr>
-            <p:ph idx="2" type="sldImg"/>
+            <p:ph type="sldImg" idx="2"/>
           </p:nvPr>
         </p:nvSpPr>
         <p:spPr>
@@ -1786,9 +1848,13 @@
             <a:ext cx="3000000" cy="3000000"/>
           </a:xfrm>
           <a:custGeom>
-            <a:rect b="b" l="l" r="r" t="t"/>
+            <a:avLst/>
+            <a:gdLst/>
+            <a:ahLst/>
+            <a:cxnLst/>
+            <a:rect l="l" t="t" r="r" b="b"/>
             <a:pathLst>
-              <a:path extrusionOk="0" h="120000" w="120000">
+              <a:path w="120000" h="120000" extrusionOk="0">
                 <a:moveTo>
                   <a:pt x="0" y="0"/>
                 </a:moveTo>
@@ -1814,9 +1880,11 @@
       <p:sp>
         <p:nvSpPr>
           <p:cNvPr id="86" name="Google Shape;86;p5:notes"/>
-          <p:cNvSpPr txBox="1"/>
+          <p:cNvSpPr txBox="1">
+            <a:spLocks noGrp="1"/>
+          </p:cNvSpPr>
           <p:nvPr>
-            <p:ph idx="1" type="body"/>
+            <p:ph type="body" idx="1"/>
           </p:nvPr>
         </p:nvSpPr>
         <p:spPr>
@@ -1833,12 +1901,12 @@
           </a:ln>
         </p:spPr>
         <p:txBody>
-          <a:bodyPr anchorCtr="0" anchor="t" bIns="45700" lIns="91425" spcFirstLastPara="1" rIns="91425" wrap="square" tIns="45700">
+          <a:bodyPr spcFirstLastPara="1" wrap="square" lIns="91425" tIns="45700" rIns="91425" bIns="45700" anchor="t" anchorCtr="0">
             <a:noAutofit/>
           </a:bodyPr>
           <a:lstStyle/>
           <a:p>
-            <a:pPr indent="0" lvl="0" marL="0" marR="0" rtl="0" algn="l">
+            <a:pPr marL="0" marR="0" lvl="0" indent="0" algn="l" rtl="0">
               <a:spcBef>
                 <a:spcPts val="0"/>
               </a:spcBef>
@@ -1847,9 +1915,6 @@
               </a:spcAft>
               <a:buNone/>
             </a:pPr>
-            <a:r>
-              <a:t/>
-            </a:r>
             <a:endParaRPr sz="1200">
               <a:solidFill>
                 <a:schemeClr val="dk1"/>
@@ -1865,9 +1930,11 @@
       <p:sp>
         <p:nvSpPr>
           <p:cNvPr id="87" name="Google Shape;87;p5:notes"/>
-          <p:cNvSpPr txBox="1"/>
+          <p:cNvSpPr txBox="1">
+            <a:spLocks noGrp="1"/>
+          </p:cNvSpPr>
           <p:nvPr>
-            <p:ph idx="12" type="sldNum"/>
+            <p:ph type="sldNum" idx="12"/>
           </p:nvPr>
         </p:nvSpPr>
         <p:spPr>
@@ -1884,12 +1951,12 @@
           </a:ln>
         </p:spPr>
         <p:txBody>
-          <a:bodyPr anchorCtr="0" anchor="t" bIns="45700" lIns="91425" spcFirstLastPara="1" rIns="91425" wrap="square" tIns="45700">
+          <a:bodyPr spcFirstLastPara="1" wrap="square" lIns="91425" tIns="45700" rIns="91425" bIns="45700" anchor="t" anchorCtr="0">
             <a:noAutofit/>
           </a:bodyPr>
           <a:lstStyle/>
           <a:p>
-            <a:pPr indent="0" lvl="0" marL="0" marR="0" rtl="0" algn="l">
+            <a:pPr marL="0" marR="0" lvl="0" indent="0" algn="l" rtl="0">
               <a:spcBef>
                 <a:spcPts val="0"/>
               </a:spcBef>
@@ -1908,7 +1975,7 @@
                 <a:cs typeface="Arial"/>
                 <a:sym typeface="Arial"/>
               </a:rPr>
-              <a:t>‹#›</a:t>
+              <a:t>6</a:t>
             </a:fld>
             <a:endParaRPr sz="1800">
               <a:solidFill>
@@ -1931,11 +1998,11 @@
 </file>
 
 <file path=ppt/notesSlides/notesSlide7.xml><?xml version="1.0" encoding="utf-8"?>
-<p:notes xmlns:a="http://schemas.openxmlformats.org/drawingml/2006/main" xmlns:r="http://schemas.openxmlformats.org/officeDocument/2006/relationships" xmlns:mc="http://schemas.openxmlformats.org/markup-compatibility/2006" xmlns:mv="urn:schemas-microsoft-com:mac:vml" xmlns:p="http://schemas.openxmlformats.org/presentationml/2006/main" xmlns:c="http://schemas.openxmlformats.org/drawingml/2006/chart" xmlns:dgm="http://schemas.openxmlformats.org/drawingml/2006/diagram" xmlns:o="urn:schemas-microsoft-com:office:office" xmlns:v="urn:schemas-microsoft-com:vml" xmlns:pvml="urn:schemas-microsoft-com:office:powerpoint" xmlns:com="http://schemas.openxmlformats.org/drawingml/2006/compatibility" xmlns:p14="http://schemas.microsoft.com/office/powerpoint/2010/main" xmlns:p15="http://schemas.microsoft.com/office/powerpoint/2012/main" xmlns:ahyp="http://schemas.microsoft.com/office/drawing/2018/hyperlinkcolor" showMasterPhAnim="0" showMasterSp="0">
+<p:notes xmlns:a="http://schemas.openxmlformats.org/drawingml/2006/main" xmlns:r="http://schemas.openxmlformats.org/officeDocument/2006/relationships" xmlns:p="http://schemas.openxmlformats.org/presentationml/2006/main" showMasterSp="0" showMasterPhAnim="0">
   <p:cSld>
     <p:spTree>
       <p:nvGrpSpPr>
-        <p:cNvPr id="93" name="Shape 93"/>
+        <p:cNvPr id="1" name="Shape 93"/>
         <p:cNvGrpSpPr/>
         <p:nvPr/>
       </p:nvGrpSpPr>
@@ -1950,9 +2017,11 @@
       <p:sp>
         <p:nvSpPr>
           <p:cNvPr id="94" name="Google Shape;94;p6:notes"/>
-          <p:cNvSpPr/>
+          <p:cNvSpPr>
+            <a:spLocks noGrp="1" noRot="1" noChangeAspect="1"/>
+          </p:cNvSpPr>
           <p:nvPr>
-            <p:ph idx="2" type="sldImg"/>
+            <p:ph type="sldImg" idx="2"/>
           </p:nvPr>
         </p:nvSpPr>
         <p:spPr>
@@ -1961,9 +2030,13 @@
             <a:ext cx="3000000" cy="3000000"/>
           </a:xfrm>
           <a:custGeom>
-            <a:rect b="b" l="l" r="r" t="t"/>
+            <a:avLst/>
+            <a:gdLst/>
+            <a:ahLst/>
+            <a:cxnLst/>
+            <a:rect l="l" t="t" r="r" b="b"/>
             <a:pathLst>
-              <a:path extrusionOk="0" h="120000" w="120000">
+              <a:path w="120000" h="120000" extrusionOk="0">
                 <a:moveTo>
                   <a:pt x="0" y="0"/>
                 </a:moveTo>
@@ -1989,9 +2062,11 @@
       <p:sp>
         <p:nvSpPr>
           <p:cNvPr id="95" name="Google Shape;95;p6:notes"/>
-          <p:cNvSpPr txBox="1"/>
+          <p:cNvSpPr txBox="1">
+            <a:spLocks noGrp="1"/>
+          </p:cNvSpPr>
           <p:nvPr>
-            <p:ph idx="1" type="body"/>
+            <p:ph type="body" idx="1"/>
           </p:nvPr>
         </p:nvSpPr>
         <p:spPr>
@@ -2008,12 +2083,12 @@
           </a:ln>
         </p:spPr>
         <p:txBody>
-          <a:bodyPr anchorCtr="0" anchor="t" bIns="45700" lIns="91425" spcFirstLastPara="1" rIns="91425" wrap="square" tIns="45700">
+          <a:bodyPr spcFirstLastPara="1" wrap="square" lIns="91425" tIns="45700" rIns="91425" bIns="45700" anchor="t" anchorCtr="0">
             <a:noAutofit/>
           </a:bodyPr>
           <a:lstStyle/>
           <a:p>
-            <a:pPr indent="0" lvl="0" marL="0" marR="0" rtl="0" algn="l">
+            <a:pPr marL="0" marR="0" lvl="0" indent="0" algn="l" rtl="0">
               <a:spcBef>
                 <a:spcPts val="0"/>
               </a:spcBef>
@@ -2022,9 +2097,6 @@
               </a:spcAft>
               <a:buNone/>
             </a:pPr>
-            <a:r>
-              <a:t/>
-            </a:r>
             <a:endParaRPr sz="1200">
               <a:solidFill>
                 <a:schemeClr val="dk1"/>
@@ -2040,9 +2112,11 @@
       <p:sp>
         <p:nvSpPr>
           <p:cNvPr id="96" name="Google Shape;96;p6:notes"/>
-          <p:cNvSpPr txBox="1"/>
+          <p:cNvSpPr txBox="1">
+            <a:spLocks noGrp="1"/>
+          </p:cNvSpPr>
           <p:nvPr>
-            <p:ph idx="12" type="sldNum"/>
+            <p:ph type="sldNum" idx="12"/>
           </p:nvPr>
         </p:nvSpPr>
         <p:spPr>
@@ -2059,12 +2133,12 @@
           </a:ln>
         </p:spPr>
         <p:txBody>
-          <a:bodyPr anchorCtr="0" anchor="t" bIns="45700" lIns="91425" spcFirstLastPara="1" rIns="91425" wrap="square" tIns="45700">
+          <a:bodyPr spcFirstLastPara="1" wrap="square" lIns="91425" tIns="45700" rIns="91425" bIns="45700" anchor="t" anchorCtr="0">
             <a:noAutofit/>
           </a:bodyPr>
           <a:lstStyle/>
           <a:p>
-            <a:pPr indent="0" lvl="0" marL="0" marR="0" rtl="0" algn="l">
+            <a:pPr marL="0" marR="0" lvl="0" indent="0" algn="l" rtl="0">
               <a:spcBef>
                 <a:spcPts val="0"/>
               </a:spcBef>
@@ -2083,7 +2157,7 @@
                 <a:cs typeface="Arial"/>
                 <a:sym typeface="Arial"/>
               </a:rPr>
-              <a:t>‹#›</a:t>
+              <a:t>7</a:t>
             </a:fld>
             <a:endParaRPr sz="1800">
               <a:solidFill>
@@ -2106,11 +2180,11 @@
 </file>
 
 <file path=ppt/notesSlides/notesSlide8.xml><?xml version="1.0" encoding="utf-8"?>
-<p:notes xmlns:a="http://schemas.openxmlformats.org/drawingml/2006/main" xmlns:r="http://schemas.openxmlformats.org/officeDocument/2006/relationships" xmlns:mc="http://schemas.openxmlformats.org/markup-compatibility/2006" xmlns:mv="urn:schemas-microsoft-com:mac:vml" xmlns:p="http://schemas.openxmlformats.org/presentationml/2006/main" xmlns:c="http://schemas.openxmlformats.org/drawingml/2006/chart" xmlns:dgm="http://schemas.openxmlformats.org/drawingml/2006/diagram" xmlns:o="urn:schemas-microsoft-com:office:office" xmlns:v="urn:schemas-microsoft-com:vml" xmlns:pvml="urn:schemas-microsoft-com:office:powerpoint" xmlns:com="http://schemas.openxmlformats.org/drawingml/2006/compatibility" xmlns:p14="http://schemas.microsoft.com/office/powerpoint/2010/main" xmlns:p15="http://schemas.microsoft.com/office/powerpoint/2012/main" xmlns:ahyp="http://schemas.microsoft.com/office/drawing/2018/hyperlinkcolor" showMasterPhAnim="0" showMasterSp="0">
+<p:notes xmlns:a="http://schemas.openxmlformats.org/drawingml/2006/main" xmlns:r="http://schemas.openxmlformats.org/officeDocument/2006/relationships" xmlns:p="http://schemas.openxmlformats.org/presentationml/2006/main" showMasterSp="0" showMasterPhAnim="0">
   <p:cSld>
     <p:spTree>
       <p:nvGrpSpPr>
-        <p:cNvPr id="111" name="Shape 111"/>
+        <p:cNvPr id="1" name="Shape 111"/>
         <p:cNvGrpSpPr/>
         <p:nvPr/>
       </p:nvGrpSpPr>
@@ -2125,9 +2199,11 @@
       <p:sp>
         <p:nvSpPr>
           <p:cNvPr id="112" name="Google Shape;112;p7:notes"/>
-          <p:cNvSpPr/>
+          <p:cNvSpPr>
+            <a:spLocks noGrp="1" noRot="1" noChangeAspect="1"/>
+          </p:cNvSpPr>
           <p:nvPr>
-            <p:ph idx="2" type="sldImg"/>
+            <p:ph type="sldImg" idx="2"/>
           </p:nvPr>
         </p:nvSpPr>
         <p:spPr>
@@ -2136,9 +2212,13 @@
             <a:ext cx="3000000" cy="3000000"/>
           </a:xfrm>
           <a:custGeom>
-            <a:rect b="b" l="l" r="r" t="t"/>
+            <a:avLst/>
+            <a:gdLst/>
+            <a:ahLst/>
+            <a:cxnLst/>
+            <a:rect l="l" t="t" r="r" b="b"/>
             <a:pathLst>
-              <a:path extrusionOk="0" h="120000" w="120000">
+              <a:path w="120000" h="120000" extrusionOk="0">
                 <a:moveTo>
                   <a:pt x="0" y="0"/>
                 </a:moveTo>
@@ -2164,9 +2244,11 @@
       <p:sp>
         <p:nvSpPr>
           <p:cNvPr id="113" name="Google Shape;113;p7:notes"/>
-          <p:cNvSpPr txBox="1"/>
+          <p:cNvSpPr txBox="1">
+            <a:spLocks noGrp="1"/>
+          </p:cNvSpPr>
           <p:nvPr>
-            <p:ph idx="1" type="body"/>
+            <p:ph type="body" idx="1"/>
           </p:nvPr>
         </p:nvSpPr>
         <p:spPr>
@@ -2183,12 +2265,12 @@
           </a:ln>
         </p:spPr>
         <p:txBody>
-          <a:bodyPr anchorCtr="0" anchor="t" bIns="45700" lIns="91425" spcFirstLastPara="1" rIns="91425" wrap="square" tIns="45700">
+          <a:bodyPr spcFirstLastPara="1" wrap="square" lIns="91425" tIns="45700" rIns="91425" bIns="45700" anchor="t" anchorCtr="0">
             <a:noAutofit/>
           </a:bodyPr>
           <a:lstStyle/>
           <a:p>
-            <a:pPr indent="0" lvl="0" marL="0" marR="0" rtl="0" algn="l">
+            <a:pPr marL="0" marR="0" lvl="0" indent="0" algn="l" rtl="0">
               <a:spcBef>
                 <a:spcPts val="0"/>
               </a:spcBef>
@@ -2197,9 +2279,6 @@
               </a:spcAft>
               <a:buNone/>
             </a:pPr>
-            <a:r>
-              <a:t/>
-            </a:r>
             <a:endParaRPr sz="1200">
               <a:solidFill>
                 <a:schemeClr val="dk1"/>
@@ -2215,9 +2294,11 @@
       <p:sp>
         <p:nvSpPr>
           <p:cNvPr id="114" name="Google Shape;114;p7:notes"/>
-          <p:cNvSpPr txBox="1"/>
+          <p:cNvSpPr txBox="1">
+            <a:spLocks noGrp="1"/>
+          </p:cNvSpPr>
           <p:nvPr>
-            <p:ph idx="12" type="sldNum"/>
+            <p:ph type="sldNum" idx="12"/>
           </p:nvPr>
         </p:nvSpPr>
         <p:spPr>
@@ -2234,12 +2315,12 @@
           </a:ln>
         </p:spPr>
         <p:txBody>
-          <a:bodyPr anchorCtr="0" anchor="t" bIns="45700" lIns="91425" spcFirstLastPara="1" rIns="91425" wrap="square" tIns="45700">
+          <a:bodyPr spcFirstLastPara="1" wrap="square" lIns="91425" tIns="45700" rIns="91425" bIns="45700" anchor="t" anchorCtr="0">
             <a:noAutofit/>
           </a:bodyPr>
           <a:lstStyle/>
           <a:p>
-            <a:pPr indent="0" lvl="0" marL="0" marR="0" rtl="0" algn="l">
+            <a:pPr marL="0" marR="0" lvl="0" indent="0" algn="l" rtl="0">
               <a:spcBef>
                 <a:spcPts val="0"/>
               </a:spcBef>
@@ -2258,7 +2339,7 @@
                 <a:cs typeface="Arial"/>
                 <a:sym typeface="Arial"/>
               </a:rPr>
-              <a:t>‹#›</a:t>
+              <a:t>8</a:t>
             </a:fld>
             <a:endParaRPr sz="1800">
               <a:solidFill>
@@ -2281,11 +2362,11 @@
 </file>
 
 <file path=ppt/notesSlides/notesSlide9.xml><?xml version="1.0" encoding="utf-8"?>
-<p:notes xmlns:a="http://schemas.openxmlformats.org/drawingml/2006/main" xmlns:r="http://schemas.openxmlformats.org/officeDocument/2006/relationships" xmlns:mc="http://schemas.openxmlformats.org/markup-compatibility/2006" xmlns:mv="urn:schemas-microsoft-com:mac:vml" xmlns:p="http://schemas.openxmlformats.org/presentationml/2006/main" xmlns:c="http://schemas.openxmlformats.org/drawingml/2006/chart" xmlns:dgm="http://schemas.openxmlformats.org/drawingml/2006/diagram" xmlns:o="urn:schemas-microsoft-com:office:office" xmlns:v="urn:schemas-microsoft-com:vml" xmlns:pvml="urn:schemas-microsoft-com:office:powerpoint" xmlns:com="http://schemas.openxmlformats.org/drawingml/2006/compatibility" xmlns:p14="http://schemas.microsoft.com/office/powerpoint/2010/main" xmlns:p15="http://schemas.microsoft.com/office/powerpoint/2012/main" xmlns:ahyp="http://schemas.microsoft.com/office/drawing/2018/hyperlinkcolor" showMasterPhAnim="0" showMasterSp="0">
+<p:notes xmlns:a="http://schemas.openxmlformats.org/drawingml/2006/main" xmlns:r="http://schemas.openxmlformats.org/officeDocument/2006/relationships" xmlns:p="http://schemas.openxmlformats.org/presentationml/2006/main" showMasterSp="0" showMasterPhAnim="0">
   <p:cSld>
     <p:spTree>
       <p:nvGrpSpPr>
-        <p:cNvPr id="120" name="Shape 120"/>
+        <p:cNvPr id="1" name="Shape 120"/>
         <p:cNvGrpSpPr/>
         <p:nvPr/>
       </p:nvGrpSpPr>
@@ -2300,9 +2381,11 @@
       <p:sp>
         <p:nvSpPr>
           <p:cNvPr id="121" name="Google Shape;121;p8:notes"/>
-          <p:cNvSpPr/>
+          <p:cNvSpPr>
+            <a:spLocks noGrp="1" noRot="1" noChangeAspect="1"/>
+          </p:cNvSpPr>
           <p:nvPr>
-            <p:ph idx="2" type="sldImg"/>
+            <p:ph type="sldImg" idx="2"/>
           </p:nvPr>
         </p:nvSpPr>
         <p:spPr>
@@ -2311,9 +2394,13 @@
             <a:ext cx="3000000" cy="3000000"/>
           </a:xfrm>
           <a:custGeom>
-            <a:rect b="b" l="l" r="r" t="t"/>
+            <a:avLst/>
+            <a:gdLst/>
+            <a:ahLst/>
+            <a:cxnLst/>
+            <a:rect l="l" t="t" r="r" b="b"/>
             <a:pathLst>
-              <a:path extrusionOk="0" h="120000" w="120000">
+              <a:path w="120000" h="120000" extrusionOk="0">
                 <a:moveTo>
                   <a:pt x="0" y="0"/>
                 </a:moveTo>
@@ -2339,9 +2426,11 @@
       <p:sp>
         <p:nvSpPr>
           <p:cNvPr id="122" name="Google Shape;122;p8:notes"/>
-          <p:cNvSpPr txBox="1"/>
+          <p:cNvSpPr txBox="1">
+            <a:spLocks noGrp="1"/>
+          </p:cNvSpPr>
           <p:nvPr>
-            <p:ph idx="1" type="body"/>
+            <p:ph type="body" idx="1"/>
           </p:nvPr>
         </p:nvSpPr>
         <p:spPr>
@@ -2358,12 +2447,12 @@
           </a:ln>
         </p:spPr>
         <p:txBody>
-          <a:bodyPr anchorCtr="0" anchor="t" bIns="45700" lIns="91425" spcFirstLastPara="1" rIns="91425" wrap="square" tIns="45700">
+          <a:bodyPr spcFirstLastPara="1" wrap="square" lIns="91425" tIns="45700" rIns="91425" bIns="45700" anchor="t" anchorCtr="0">
             <a:noAutofit/>
           </a:bodyPr>
           <a:lstStyle/>
           <a:p>
-            <a:pPr indent="0" lvl="0" marL="0" marR="0" rtl="0" algn="l">
+            <a:pPr marL="0" marR="0" lvl="0" indent="0" algn="l" rtl="0">
               <a:spcBef>
                 <a:spcPts val="0"/>
               </a:spcBef>
@@ -2372,9 +2461,6 @@
               </a:spcAft>
               <a:buNone/>
             </a:pPr>
-            <a:r>
-              <a:t/>
-            </a:r>
             <a:endParaRPr sz="1200">
               <a:solidFill>
                 <a:schemeClr val="dk1"/>
@@ -2390,9 +2476,11 @@
       <p:sp>
         <p:nvSpPr>
           <p:cNvPr id="123" name="Google Shape;123;p8:notes"/>
-          <p:cNvSpPr txBox="1"/>
+          <p:cNvSpPr txBox="1">
+            <a:spLocks noGrp="1"/>
+          </p:cNvSpPr>
           <p:nvPr>
-            <p:ph idx="12" type="sldNum"/>
+            <p:ph type="sldNum" idx="12"/>
           </p:nvPr>
         </p:nvSpPr>
         <p:spPr>
@@ -2409,12 +2497,12 @@
           </a:ln>
         </p:spPr>
         <p:txBody>
-          <a:bodyPr anchorCtr="0" anchor="t" bIns="45700" lIns="91425" spcFirstLastPara="1" rIns="91425" wrap="square" tIns="45700">
+          <a:bodyPr spcFirstLastPara="1" wrap="square" lIns="91425" tIns="45700" rIns="91425" bIns="45700" anchor="t" anchorCtr="0">
             <a:noAutofit/>
           </a:bodyPr>
           <a:lstStyle/>
           <a:p>
-            <a:pPr indent="0" lvl="0" marL="0" marR="0" rtl="0" algn="l">
+            <a:pPr marL="0" marR="0" lvl="0" indent="0" algn="l" rtl="0">
               <a:spcBef>
                 <a:spcPts val="0"/>
               </a:spcBef>
@@ -2433,7 +2521,7 @@
                 <a:cs typeface="Arial"/>
                 <a:sym typeface="Arial"/>
               </a:rPr>
-              <a:t>‹#›</a:t>
+              <a:t>9</a:t>
             </a:fld>
             <a:endParaRPr sz="1800">
               <a:solidFill>
@@ -2456,11 +2544,11 @@
 </file>
 
 <file path=ppt/slideLayouts/slideLayout1.xml><?xml version="1.0" encoding="utf-8"?>
-<p:sldLayout xmlns:a="http://schemas.openxmlformats.org/drawingml/2006/main" xmlns:r="http://schemas.openxmlformats.org/officeDocument/2006/relationships" xmlns:mc="http://schemas.openxmlformats.org/markup-compatibility/2006" xmlns:mv="urn:schemas-microsoft-com:mac:vml" xmlns:p="http://schemas.openxmlformats.org/presentationml/2006/main" xmlns:c="http://schemas.openxmlformats.org/drawingml/2006/chart" xmlns:dgm="http://schemas.openxmlformats.org/drawingml/2006/diagram" xmlns:o="urn:schemas-microsoft-com:office:office" xmlns:v="urn:schemas-microsoft-com:vml" xmlns:pvml="urn:schemas-microsoft-com:office:powerpoint" xmlns:com="http://schemas.openxmlformats.org/drawingml/2006/compatibility" xmlns:p14="http://schemas.microsoft.com/office/powerpoint/2010/main" xmlns:p15="http://schemas.microsoft.com/office/powerpoint/2012/main" xmlns:ahyp="http://schemas.microsoft.com/office/drawing/2018/hyperlinkcolor" matchingName="Slide master 1">
+<p:sldLayout xmlns:a="http://schemas.openxmlformats.org/drawingml/2006/main" xmlns:r="http://schemas.openxmlformats.org/officeDocument/2006/relationships" xmlns:p="http://schemas.openxmlformats.org/presentationml/2006/main" matchingName="Slide master 1">
   <p:cSld name="Slide master 1">
     <p:spTree>
       <p:nvGrpSpPr>
-        <p:cNvPr id="6" name="Shape 6"/>
+        <p:cNvPr id="1" name="Shape 6"/>
         <p:cNvGrpSpPr/>
         <p:nvPr/>
       </p:nvGrpSpPr>
@@ -2474,7 +2562,7 @@
       </p:grpSpPr>
       <p:pic>
         <p:nvPicPr>
-          <p:cNvPr descr="preencoded.png" id="7" name="Google Shape;7;p11"/>
+          <p:cNvPr id="7" name="Google Shape;7;p11" descr="preencoded.png"/>
           <p:cNvPicPr preferRelativeResize="0"/>
           <p:nvPr/>
         </p:nvPicPr>
@@ -2482,7 +2570,7 @@
           <a:blip r:embed="rId2">
             <a:alphaModFix/>
           </a:blip>
-          <a:srcRect b="0" l="0" r="0" t="0"/>
+          <a:srcRect/>
           <a:stretch/>
         </p:blipFill>
         <p:spPr>
@@ -2523,12 +2611,12 @@
           </a:ln>
         </p:spPr>
         <p:txBody>
-          <a:bodyPr anchorCtr="0" anchor="t" bIns="45700" lIns="91425" spcFirstLastPara="1" rIns="91425" wrap="square" tIns="45700">
+          <a:bodyPr spcFirstLastPara="1" wrap="square" lIns="91425" tIns="45700" rIns="91425" bIns="45700" anchor="t" anchorCtr="0">
             <a:noAutofit/>
           </a:bodyPr>
           <a:lstStyle/>
           <a:p>
-            <a:pPr indent="0" lvl="0" marL="0" marR="0" rtl="0" algn="l">
+            <a:pPr marL="0" marR="0" lvl="0" indent="0" algn="l" rtl="0">
               <a:spcBef>
                 <a:spcPts val="0"/>
               </a:spcBef>
@@ -2537,9 +2625,6 @@
               </a:spcAft>
               <a:buNone/>
             </a:pPr>
-            <a:r>
-              <a:t/>
-            </a:r>
             <a:endParaRPr sz="1800">
               <a:solidFill>
                 <a:schemeClr val="dk1"/>
@@ -2554,7 +2639,7 @@
       </p:sp>
       <p:pic>
         <p:nvPicPr>
-          <p:cNvPr descr="preencoded.png" id="9" name="Google Shape;9;p11">
+          <p:cNvPr id="9" name="Google Shape;9;p11" descr="preencoded.png">
             <a:hlinkClick r:id="rId3"/>
           </p:cNvPr>
           <p:cNvPicPr preferRelativeResize="0"/>
@@ -2564,7 +2649,7 @@
           <a:blip r:embed="rId4">
             <a:alphaModFix/>
           </a:blip>
-          <a:srcRect b="0" l="0" r="0" t="0"/>
+          <a:srcRect/>
           <a:stretch/>
         </p:blipFill>
         <p:spPr>
@@ -2590,18 +2675,19 @@
 </file>
 
 <file path=ppt/slideLayouts/slideLayout2.xml><?xml version="1.0" encoding="utf-8"?>
-<p:sldLayout xmlns:a="http://schemas.openxmlformats.org/drawingml/2006/main" xmlns:r="http://schemas.openxmlformats.org/officeDocument/2006/relationships" xmlns:mc="http://schemas.openxmlformats.org/markup-compatibility/2006" xmlns:mv="urn:schemas-microsoft-com:mac:vml" xmlns:p="http://schemas.openxmlformats.org/presentationml/2006/main" xmlns:c="http://schemas.openxmlformats.org/drawingml/2006/chart" xmlns:dgm="http://schemas.openxmlformats.org/drawingml/2006/diagram" xmlns:o="urn:schemas-microsoft-com:office:office" xmlns:v="urn:schemas-microsoft-com:vml" xmlns:pvml="urn:schemas-microsoft-com:office:powerpoint" xmlns:com="http://schemas.openxmlformats.org/drawingml/2006/compatibility" xmlns:p14="http://schemas.microsoft.com/office/powerpoint/2010/main" xmlns:p15="http://schemas.microsoft.com/office/powerpoint/2012/main" xmlns:ahyp="http://schemas.microsoft.com/office/drawing/2018/hyperlinkcolor" matchingName="DEFAULT">
+<p:sldLayout xmlns:a="http://schemas.openxmlformats.org/drawingml/2006/main" xmlns:r="http://schemas.openxmlformats.org/officeDocument/2006/relationships" xmlns:p="http://schemas.openxmlformats.org/presentationml/2006/main" matchingName="DEFAULT">
   <p:cSld name="DEFAULT">
     <p:bg>
       <p:bgPr>
         <a:solidFill>
           <a:schemeClr val="lt1"/>
         </a:solidFill>
+        <a:effectLst/>
       </p:bgPr>
     </p:bg>
     <p:spTree>
       <p:nvGrpSpPr>
-        <p:cNvPr id="10" name="Shape 10"/>
+        <p:cNvPr id="1" name="Shape 10"/>
         <p:cNvGrpSpPr/>
         <p:nvPr/>
       </p:nvGrpSpPr>
@@ -2622,18 +2708,19 @@
 </file>
 
 <file path=ppt/slideMasters/slideMaster1.xml><?xml version="1.0" encoding="utf-8"?>
-<p:sldMaster xmlns:a="http://schemas.openxmlformats.org/drawingml/2006/main" xmlns:r="http://schemas.openxmlformats.org/officeDocument/2006/relationships" xmlns:mc="http://schemas.openxmlformats.org/markup-compatibility/2006" xmlns:mv="urn:schemas-microsoft-com:mac:vml" xmlns:p="http://schemas.openxmlformats.org/presentationml/2006/main" xmlns:c="http://schemas.openxmlformats.org/drawingml/2006/chart" xmlns:dgm="http://schemas.openxmlformats.org/drawingml/2006/diagram" xmlns:o="urn:schemas-microsoft-com:office:office" xmlns:v="urn:schemas-microsoft-com:vml" xmlns:pvml="urn:schemas-microsoft-com:office:powerpoint" xmlns:com="http://schemas.openxmlformats.org/drawingml/2006/compatibility" xmlns:p14="http://schemas.microsoft.com/office/powerpoint/2010/main" xmlns:p15="http://schemas.microsoft.com/office/powerpoint/2012/main" xmlns:ahyp="http://schemas.microsoft.com/office/drawing/2018/hyperlinkcolor">
+<p:sldMaster xmlns:a="http://schemas.openxmlformats.org/drawingml/2006/main" xmlns:r="http://schemas.openxmlformats.org/officeDocument/2006/relationships" xmlns:p="http://schemas.openxmlformats.org/presentationml/2006/main">
   <p:cSld>
     <p:bg>
       <p:bgPr>
         <a:solidFill>
           <a:schemeClr val="lt1"/>
         </a:solidFill>
+        <a:effectLst/>
       </p:bgPr>
     </p:bg>
     <p:spTree>
       <p:nvGrpSpPr>
-        <p:cNvPr id="5" name="Shape 5"/>
+        <p:cNvPr id="1" name="Shape 5"/>
         <p:cNvGrpSpPr/>
         <p:nvPr/>
       </p:nvGrpSpPr>
@@ -2647,15 +2734,15 @@
       </p:grpSpPr>
     </p:spTree>
   </p:cSld>
-  <p:clrMap accent1="accent1" accent2="accent2" accent3="accent3" accent4="accent4" accent5="accent5" accent6="accent6" bg1="lt1" bg2="dk2" tx1="dk1" tx2="lt2" folHlink="folHlink" hlink="hlink"/>
+  <p:clrMap bg1="lt1" tx1="dk1" bg2="dk2" tx2="lt2" accent1="accent1" accent2="accent2" accent3="accent3" accent4="accent4" accent5="accent5" accent6="accent6" hlink="hlink" folHlink="folHlink"/>
   <p:sldLayoutIdLst>
     <p:sldLayoutId id="2147483649" r:id="rId1"/>
     <p:sldLayoutId id="2147483650" r:id="rId2"/>
   </p:sldLayoutIdLst>
-  <p:hf dt="0" ftr="0" hdr="0" sldNum="0"/>
+  <p:hf sldNum="0" hdr="0" ftr="0" dt="0"/>
   <p:txStyles>
     <p:titleStyle>
-      <a:defPPr lvl="0" marR="0" rtl="0" algn="l">
+      <a:defPPr marR="0" lvl="0" algn="l" rtl="0">
         <a:lnSpc>
           <a:spcPct val="100000"/>
         </a:lnSpc>
@@ -2666,7 +2753,7 @@
           <a:spcPts val="0"/>
         </a:spcAft>
       </a:defPPr>
-      <a:lvl1pPr lvl="0" marR="0" rtl="0" algn="l">
+      <a:lvl1pPr marR="0" lvl="0" algn="l" rtl="0">
         <a:lnSpc>
           <a:spcPct val="100000"/>
         </a:lnSpc>
@@ -2680,7 +2767,7 @@
           <a:srgbClr val="000000"/>
         </a:buClr>
         <a:buFont typeface="Arial"/>
-        <a:defRPr b="0" i="0" spc="0" sz="1400" u="none" cap="none" strike="noStrike">
+        <a:defRPr sz="1400" b="0" i="0" u="none" strike="noStrike" cap="none" spc="0">
           <a:solidFill>
             <a:srgbClr val="000000"/>
           </a:solidFill>
@@ -2690,7 +2777,7 @@
           <a:sym typeface="Arial"/>
         </a:defRPr>
       </a:lvl1pPr>
-      <a:lvl2pPr lvl="1" marR="0" rtl="0" algn="l">
+      <a:lvl2pPr marR="0" lvl="1" algn="l" rtl="0">
         <a:lnSpc>
           <a:spcPct val="100000"/>
         </a:lnSpc>
@@ -2704,7 +2791,7 @@
           <a:srgbClr val="000000"/>
         </a:buClr>
         <a:buFont typeface="Arial"/>
-        <a:defRPr b="0" i="0" spc="0" sz="1400" u="none" cap="none" strike="noStrike">
+        <a:defRPr sz="1400" b="0" i="0" u="none" strike="noStrike" cap="none" spc="0">
           <a:solidFill>
             <a:srgbClr val="000000"/>
           </a:solidFill>
@@ -2714,7 +2801,7 @@
           <a:sym typeface="Arial"/>
         </a:defRPr>
       </a:lvl2pPr>
-      <a:lvl3pPr lvl="2" marR="0" rtl="0" algn="l">
+      <a:lvl3pPr marR="0" lvl="2" algn="l" rtl="0">
         <a:lnSpc>
           <a:spcPct val="100000"/>
         </a:lnSpc>
@@ -2728,7 +2815,7 @@
           <a:srgbClr val="000000"/>
         </a:buClr>
         <a:buFont typeface="Arial"/>
-        <a:defRPr b="0" i="0" spc="0" sz="1400" u="none" cap="none" strike="noStrike">
+        <a:defRPr sz="1400" b="0" i="0" u="none" strike="noStrike" cap="none" spc="0">
           <a:solidFill>
             <a:srgbClr val="000000"/>
           </a:solidFill>
@@ -2738,7 +2825,7 @@
           <a:sym typeface="Arial"/>
         </a:defRPr>
       </a:lvl3pPr>
-      <a:lvl4pPr lvl="3" marR="0" rtl="0" algn="l">
+      <a:lvl4pPr marR="0" lvl="3" algn="l" rtl="0">
         <a:lnSpc>
           <a:spcPct val="100000"/>
         </a:lnSpc>
@@ -2752,7 +2839,7 @@
           <a:srgbClr val="000000"/>
         </a:buClr>
         <a:buFont typeface="Arial"/>
-        <a:defRPr b="0" i="0" spc="0" sz="1400" u="none" cap="none" strike="noStrike">
+        <a:defRPr sz="1400" b="0" i="0" u="none" strike="noStrike" cap="none" spc="0">
           <a:solidFill>
             <a:srgbClr val="000000"/>
           </a:solidFill>
@@ -2762,7 +2849,7 @@
           <a:sym typeface="Arial"/>
         </a:defRPr>
       </a:lvl4pPr>
-      <a:lvl5pPr lvl="4" marR="0" rtl="0" algn="l">
+      <a:lvl5pPr marR="0" lvl="4" algn="l" rtl="0">
         <a:lnSpc>
           <a:spcPct val="100000"/>
         </a:lnSpc>
@@ -2776,7 +2863,7 @@
           <a:srgbClr val="000000"/>
         </a:buClr>
         <a:buFont typeface="Arial"/>
-        <a:defRPr b="0" i="0" spc="0" sz="1400" u="none" cap="none" strike="noStrike">
+        <a:defRPr sz="1400" b="0" i="0" u="none" strike="noStrike" cap="none" spc="0">
           <a:solidFill>
             <a:srgbClr val="000000"/>
           </a:solidFill>
@@ -2786,7 +2873,7 @@
           <a:sym typeface="Arial"/>
         </a:defRPr>
       </a:lvl5pPr>
-      <a:lvl6pPr lvl="5" marR="0" rtl="0" algn="l">
+      <a:lvl6pPr marR="0" lvl="5" algn="l" rtl="0">
         <a:lnSpc>
           <a:spcPct val="100000"/>
         </a:lnSpc>
@@ -2800,7 +2887,7 @@
           <a:srgbClr val="000000"/>
         </a:buClr>
         <a:buFont typeface="Arial"/>
-        <a:defRPr b="0" i="0" spc="0" sz="1400" u="none" cap="none" strike="noStrike">
+        <a:defRPr sz="1400" b="0" i="0" u="none" strike="noStrike" cap="none" spc="0">
           <a:solidFill>
             <a:srgbClr val="000000"/>
           </a:solidFill>
@@ -2810,7 +2897,7 @@
           <a:sym typeface="Arial"/>
         </a:defRPr>
       </a:lvl6pPr>
-      <a:lvl7pPr lvl="6" marR="0" rtl="0" algn="l">
+      <a:lvl7pPr marR="0" lvl="6" algn="l" rtl="0">
         <a:lnSpc>
           <a:spcPct val="100000"/>
         </a:lnSpc>
@@ -2824,7 +2911,7 @@
           <a:srgbClr val="000000"/>
         </a:buClr>
         <a:buFont typeface="Arial"/>
-        <a:defRPr b="0" i="0" spc="0" sz="1400" u="none" cap="none" strike="noStrike">
+        <a:defRPr sz="1400" b="0" i="0" u="none" strike="noStrike" cap="none" spc="0">
           <a:solidFill>
             <a:srgbClr val="000000"/>
           </a:solidFill>
@@ -2834,7 +2921,7 @@
           <a:sym typeface="Arial"/>
         </a:defRPr>
       </a:lvl7pPr>
-      <a:lvl8pPr lvl="7" marR="0" rtl="0" algn="l">
+      <a:lvl8pPr marR="0" lvl="7" algn="l" rtl="0">
         <a:lnSpc>
           <a:spcPct val="100000"/>
         </a:lnSpc>
@@ -2848,7 +2935,7 @@
           <a:srgbClr val="000000"/>
         </a:buClr>
         <a:buFont typeface="Arial"/>
-        <a:defRPr b="0" i="0" spc="0" sz="1400" u="none" cap="none" strike="noStrike">
+        <a:defRPr sz="1400" b="0" i="0" u="none" strike="noStrike" cap="none" spc="0">
           <a:solidFill>
             <a:srgbClr val="000000"/>
           </a:solidFill>
@@ -2858,7 +2945,7 @@
           <a:sym typeface="Arial"/>
         </a:defRPr>
       </a:lvl8pPr>
-      <a:lvl9pPr lvl="8" marR="0" rtl="0" algn="l">
+      <a:lvl9pPr marR="0" lvl="8" algn="l" rtl="0">
         <a:lnSpc>
           <a:spcPct val="100000"/>
         </a:lnSpc>
@@ -2872,7 +2959,7 @@
           <a:srgbClr val="000000"/>
         </a:buClr>
         <a:buFont typeface="Arial"/>
-        <a:defRPr b="0" i="0" spc="0" sz="1400" u="none" cap="none" strike="noStrike">
+        <a:defRPr sz="1400" b="0" i="0" u="none" strike="noStrike" cap="none" spc="0">
           <a:solidFill>
             <a:srgbClr val="000000"/>
           </a:solidFill>
@@ -2884,7 +2971,7 @@
       </a:lvl9pPr>
     </p:titleStyle>
     <p:bodyStyle>
-      <a:defPPr lvl="0" marR="0" rtl="0" algn="l">
+      <a:defPPr marR="0" lvl="0" algn="l" rtl="0">
         <a:lnSpc>
           <a:spcPct val="100000"/>
         </a:lnSpc>
@@ -2895,7 +2982,7 @@
           <a:spcPts val="0"/>
         </a:spcAft>
       </a:defPPr>
-      <a:lvl1pPr lvl="0" marR="0" rtl="0" algn="l">
+      <a:lvl1pPr marR="0" lvl="0" algn="l" rtl="0">
         <a:lnSpc>
           <a:spcPct val="100000"/>
         </a:lnSpc>
@@ -2909,7 +2996,7 @@
           <a:srgbClr val="000000"/>
         </a:buClr>
         <a:buFont typeface="Arial"/>
-        <a:defRPr b="0" i="0" spc="0" sz="1400" u="none" cap="none" strike="noStrike">
+        <a:defRPr sz="1400" b="0" i="0" u="none" strike="noStrike" cap="none" spc="0">
           <a:solidFill>
             <a:srgbClr val="000000"/>
           </a:solidFill>
@@ -2919,7 +3006,7 @@
           <a:sym typeface="Arial"/>
         </a:defRPr>
       </a:lvl1pPr>
-      <a:lvl2pPr lvl="1" marR="0" rtl="0" algn="l">
+      <a:lvl2pPr marR="0" lvl="1" algn="l" rtl="0">
         <a:lnSpc>
           <a:spcPct val="100000"/>
         </a:lnSpc>
@@ -2933,7 +3020,7 @@
           <a:srgbClr val="000000"/>
         </a:buClr>
         <a:buFont typeface="Arial"/>
-        <a:defRPr b="0" i="0" spc="0" sz="1400" u="none" cap="none" strike="noStrike">
+        <a:defRPr sz="1400" b="0" i="0" u="none" strike="noStrike" cap="none" spc="0">
           <a:solidFill>
             <a:srgbClr val="000000"/>
           </a:solidFill>
@@ -2943,7 +3030,7 @@
           <a:sym typeface="Arial"/>
         </a:defRPr>
       </a:lvl2pPr>
-      <a:lvl3pPr lvl="2" marR="0" rtl="0" algn="l">
+      <a:lvl3pPr marR="0" lvl="2" algn="l" rtl="0">
         <a:lnSpc>
           <a:spcPct val="100000"/>
         </a:lnSpc>
@@ -2957,7 +3044,7 @@
           <a:srgbClr val="000000"/>
         </a:buClr>
         <a:buFont typeface="Arial"/>
-        <a:defRPr b="0" i="0" spc="0" sz="1400" u="none" cap="none" strike="noStrike">
+        <a:defRPr sz="1400" b="0" i="0" u="none" strike="noStrike" cap="none" spc="0">
           <a:solidFill>
             <a:srgbClr val="000000"/>
           </a:solidFill>
@@ -2967,7 +3054,7 @@
           <a:sym typeface="Arial"/>
         </a:defRPr>
       </a:lvl3pPr>
-      <a:lvl4pPr lvl="3" marR="0" rtl="0" algn="l">
+      <a:lvl4pPr marR="0" lvl="3" algn="l" rtl="0">
         <a:lnSpc>
           <a:spcPct val="100000"/>
         </a:lnSpc>
@@ -2981,7 +3068,7 @@
           <a:srgbClr val="000000"/>
         </a:buClr>
         <a:buFont typeface="Arial"/>
-        <a:defRPr b="0" i="0" spc="0" sz="1400" u="none" cap="none" strike="noStrike">
+        <a:defRPr sz="1400" b="0" i="0" u="none" strike="noStrike" cap="none" spc="0">
           <a:solidFill>
             <a:srgbClr val="000000"/>
           </a:solidFill>
@@ -2991,7 +3078,7 @@
           <a:sym typeface="Arial"/>
         </a:defRPr>
       </a:lvl4pPr>
-      <a:lvl5pPr lvl="4" marR="0" rtl="0" algn="l">
+      <a:lvl5pPr marR="0" lvl="4" algn="l" rtl="0">
         <a:lnSpc>
           <a:spcPct val="100000"/>
         </a:lnSpc>
@@ -3005,7 +3092,7 @@
           <a:srgbClr val="000000"/>
         </a:buClr>
         <a:buFont typeface="Arial"/>
-        <a:defRPr b="0" i="0" spc="0" sz="1400" u="none" cap="none" strike="noStrike">
+        <a:defRPr sz="1400" b="0" i="0" u="none" strike="noStrike" cap="none" spc="0">
           <a:solidFill>
             <a:srgbClr val="000000"/>
           </a:solidFill>
@@ -3015,7 +3102,7 @@
           <a:sym typeface="Arial"/>
         </a:defRPr>
       </a:lvl5pPr>
-      <a:lvl6pPr lvl="5" marR="0" rtl="0" algn="l">
+      <a:lvl6pPr marR="0" lvl="5" algn="l" rtl="0">
         <a:lnSpc>
           <a:spcPct val="100000"/>
         </a:lnSpc>
@@ -3029,7 +3116,7 @@
           <a:srgbClr val="000000"/>
         </a:buClr>
         <a:buFont typeface="Arial"/>
-        <a:defRPr b="0" i="0" spc="0" sz="1400" u="none" cap="none" strike="noStrike">
+        <a:defRPr sz="1400" b="0" i="0" u="none" strike="noStrike" cap="none" spc="0">
           <a:solidFill>
             <a:srgbClr val="000000"/>
           </a:solidFill>
@@ -3039,7 +3126,7 @@
           <a:sym typeface="Arial"/>
         </a:defRPr>
       </a:lvl6pPr>
-      <a:lvl7pPr lvl="6" marR="0" rtl="0" algn="l">
+      <a:lvl7pPr marR="0" lvl="6" algn="l" rtl="0">
         <a:lnSpc>
           <a:spcPct val="100000"/>
         </a:lnSpc>
@@ -3053,7 +3140,7 @@
           <a:srgbClr val="000000"/>
         </a:buClr>
         <a:buFont typeface="Arial"/>
-        <a:defRPr b="0" i="0" spc="0" sz="1400" u="none" cap="none" strike="noStrike">
+        <a:defRPr sz="1400" b="0" i="0" u="none" strike="noStrike" cap="none" spc="0">
           <a:solidFill>
             <a:srgbClr val="000000"/>
           </a:solidFill>
@@ -3063,7 +3150,7 @@
           <a:sym typeface="Arial"/>
         </a:defRPr>
       </a:lvl7pPr>
-      <a:lvl8pPr lvl="7" marR="0" rtl="0" algn="l">
+      <a:lvl8pPr marR="0" lvl="7" algn="l" rtl="0">
         <a:lnSpc>
           <a:spcPct val="100000"/>
         </a:lnSpc>
@@ -3077,7 +3164,7 @@
           <a:srgbClr val="000000"/>
         </a:buClr>
         <a:buFont typeface="Arial"/>
-        <a:defRPr b="0" i="0" spc="0" sz="1400" u="none" cap="none" strike="noStrike">
+        <a:defRPr sz="1400" b="0" i="0" u="none" strike="noStrike" cap="none" spc="0">
           <a:solidFill>
             <a:srgbClr val="000000"/>
           </a:solidFill>
@@ -3087,7 +3174,7 @@
           <a:sym typeface="Arial"/>
         </a:defRPr>
       </a:lvl8pPr>
-      <a:lvl9pPr lvl="8" marR="0" rtl="0" algn="l">
+      <a:lvl9pPr marR="0" lvl="8" algn="l" rtl="0">
         <a:lnSpc>
           <a:spcPct val="100000"/>
         </a:lnSpc>
@@ -3101,7 +3188,7 @@
           <a:srgbClr val="000000"/>
         </a:buClr>
         <a:buFont typeface="Arial"/>
-        <a:defRPr b="0" i="0" spc="0" sz="1400" u="none" cap="none" strike="noStrike">
+        <a:defRPr sz="1400" b="0" i="0" u="none" strike="noStrike" cap="none" spc="0">
           <a:solidFill>
             <a:srgbClr val="000000"/>
           </a:solidFill>
@@ -3113,7 +3200,7 @@
       </a:lvl9pPr>
     </p:bodyStyle>
     <p:otherStyle>
-      <a:defPPr lvl="0" marR="0" rtl="0" algn="l">
+      <a:defPPr marR="0" lvl="0" algn="l" rtl="0">
         <a:lnSpc>
           <a:spcPct val="100000"/>
         </a:lnSpc>
@@ -3124,7 +3211,7 @@
           <a:spcPts val="0"/>
         </a:spcAft>
       </a:defPPr>
-      <a:lvl1pPr lvl="0" marR="0" rtl="0" algn="l">
+      <a:lvl1pPr marR="0" lvl="0" algn="l" rtl="0">
         <a:lnSpc>
           <a:spcPct val="100000"/>
         </a:lnSpc>
@@ -3138,7 +3225,7 @@
           <a:srgbClr val="000000"/>
         </a:buClr>
         <a:buFont typeface="Arial"/>
-        <a:defRPr b="0" i="0" spc="0" sz="1400" u="none" cap="none" strike="noStrike">
+        <a:defRPr sz="1400" b="0" i="0" u="none" strike="noStrike" cap="none" spc="0">
           <a:solidFill>
             <a:srgbClr val="000000"/>
           </a:solidFill>
@@ -3148,7 +3235,7 @@
           <a:sym typeface="Arial"/>
         </a:defRPr>
       </a:lvl1pPr>
-      <a:lvl2pPr lvl="1" marR="0" rtl="0" algn="l">
+      <a:lvl2pPr marR="0" lvl="1" algn="l" rtl="0">
         <a:lnSpc>
           <a:spcPct val="100000"/>
         </a:lnSpc>
@@ -3162,7 +3249,7 @@
           <a:srgbClr val="000000"/>
         </a:buClr>
         <a:buFont typeface="Arial"/>
-        <a:defRPr b="0" i="0" spc="0" sz="1400" u="none" cap="none" strike="noStrike">
+        <a:defRPr sz="1400" b="0" i="0" u="none" strike="noStrike" cap="none" spc="0">
           <a:solidFill>
             <a:srgbClr val="000000"/>
           </a:solidFill>
@@ -3172,7 +3259,7 @@
           <a:sym typeface="Arial"/>
         </a:defRPr>
       </a:lvl2pPr>
-      <a:lvl3pPr lvl="2" marR="0" rtl="0" algn="l">
+      <a:lvl3pPr marR="0" lvl="2" algn="l" rtl="0">
         <a:lnSpc>
           <a:spcPct val="100000"/>
         </a:lnSpc>
@@ -3186,7 +3273,7 @@
           <a:srgbClr val="000000"/>
         </a:buClr>
         <a:buFont typeface="Arial"/>
-        <a:defRPr b="0" i="0" spc="0" sz="1400" u="none" cap="none" strike="noStrike">
+        <a:defRPr sz="1400" b="0" i="0" u="none" strike="noStrike" cap="none" spc="0">
           <a:solidFill>
             <a:srgbClr val="000000"/>
           </a:solidFill>
@@ -3196,7 +3283,7 @@
           <a:sym typeface="Arial"/>
         </a:defRPr>
       </a:lvl3pPr>
-      <a:lvl4pPr lvl="3" marR="0" rtl="0" algn="l">
+      <a:lvl4pPr marR="0" lvl="3" algn="l" rtl="0">
         <a:lnSpc>
           <a:spcPct val="100000"/>
         </a:lnSpc>
@@ -3210,7 +3297,7 @@
           <a:srgbClr val="000000"/>
         </a:buClr>
         <a:buFont typeface="Arial"/>
-        <a:defRPr b="0" i="0" spc="0" sz="1400" u="none" cap="none" strike="noStrike">
+        <a:defRPr sz="1400" b="0" i="0" u="none" strike="noStrike" cap="none" spc="0">
           <a:solidFill>
             <a:srgbClr val="000000"/>
           </a:solidFill>
@@ -3220,7 +3307,7 @@
           <a:sym typeface="Arial"/>
         </a:defRPr>
       </a:lvl4pPr>
-      <a:lvl5pPr lvl="4" marR="0" rtl="0" algn="l">
+      <a:lvl5pPr marR="0" lvl="4" algn="l" rtl="0">
         <a:lnSpc>
           <a:spcPct val="100000"/>
         </a:lnSpc>
@@ -3234,7 +3321,7 @@
           <a:srgbClr val="000000"/>
         </a:buClr>
         <a:buFont typeface="Arial"/>
-        <a:defRPr b="0" i="0" spc="0" sz="1400" u="none" cap="none" strike="noStrike">
+        <a:defRPr sz="1400" b="0" i="0" u="none" strike="noStrike" cap="none" spc="0">
           <a:solidFill>
             <a:srgbClr val="000000"/>
           </a:solidFill>
@@ -3244,7 +3331,7 @@
           <a:sym typeface="Arial"/>
         </a:defRPr>
       </a:lvl5pPr>
-      <a:lvl6pPr lvl="5" marR="0" rtl="0" algn="l">
+      <a:lvl6pPr marR="0" lvl="5" algn="l" rtl="0">
         <a:lnSpc>
           <a:spcPct val="100000"/>
         </a:lnSpc>
@@ -3258,7 +3345,7 @@
           <a:srgbClr val="000000"/>
         </a:buClr>
         <a:buFont typeface="Arial"/>
-        <a:defRPr b="0" i="0" spc="0" sz="1400" u="none" cap="none" strike="noStrike">
+        <a:defRPr sz="1400" b="0" i="0" u="none" strike="noStrike" cap="none" spc="0">
           <a:solidFill>
             <a:srgbClr val="000000"/>
           </a:solidFill>
@@ -3268,7 +3355,7 @@
           <a:sym typeface="Arial"/>
         </a:defRPr>
       </a:lvl6pPr>
-      <a:lvl7pPr lvl="6" marR="0" rtl="0" algn="l">
+      <a:lvl7pPr marR="0" lvl="6" algn="l" rtl="0">
         <a:lnSpc>
           <a:spcPct val="100000"/>
         </a:lnSpc>
@@ -3282,7 +3369,7 @@
           <a:srgbClr val="000000"/>
         </a:buClr>
         <a:buFont typeface="Arial"/>
-        <a:defRPr b="0" i="0" spc="0" sz="1400" u="none" cap="none" strike="noStrike">
+        <a:defRPr sz="1400" b="0" i="0" u="none" strike="noStrike" cap="none" spc="0">
           <a:solidFill>
             <a:srgbClr val="000000"/>
           </a:solidFill>
@@ -3292,7 +3379,7 @@
           <a:sym typeface="Arial"/>
         </a:defRPr>
       </a:lvl7pPr>
-      <a:lvl8pPr lvl="7" marR="0" rtl="0" algn="l">
+      <a:lvl8pPr marR="0" lvl="7" algn="l" rtl="0">
         <a:lnSpc>
           <a:spcPct val="100000"/>
         </a:lnSpc>
@@ -3306,7 +3393,7 @@
           <a:srgbClr val="000000"/>
         </a:buClr>
         <a:buFont typeface="Arial"/>
-        <a:defRPr b="0" i="0" spc="0" sz="1400" u="none" cap="none" strike="noStrike">
+        <a:defRPr sz="1400" b="0" i="0" u="none" strike="noStrike" cap="none" spc="0">
           <a:solidFill>
             <a:srgbClr val="000000"/>
           </a:solidFill>
@@ -3316,7 +3403,7 @@
           <a:sym typeface="Arial"/>
         </a:defRPr>
       </a:lvl8pPr>
-      <a:lvl9pPr lvl="8" marR="0" rtl="0" algn="l">
+      <a:lvl9pPr marR="0" lvl="8" algn="l" rtl="0">
         <a:lnSpc>
           <a:spcPct val="100000"/>
         </a:lnSpc>
@@ -3330,7 +3417,7 @@
           <a:srgbClr val="000000"/>
         </a:buClr>
         <a:buFont typeface="Arial"/>
-        <a:defRPr b="0" i="0" spc="0" sz="1400" u="none" cap="none" strike="noStrike">
+        <a:defRPr sz="1400" b="0" i="0" u="none" strike="noStrike" cap="none" spc="0">
           <a:solidFill>
             <a:srgbClr val="000000"/>
           </a:solidFill>
@@ -3346,11 +3433,11 @@
 </file>
 
 <file path=ppt/slides/slide1.xml><?xml version="1.0" encoding="utf-8"?>
-<p:sld xmlns:a="http://schemas.openxmlformats.org/drawingml/2006/main" xmlns:r="http://schemas.openxmlformats.org/officeDocument/2006/relationships" xmlns:mc="http://schemas.openxmlformats.org/markup-compatibility/2006" xmlns:mv="urn:schemas-microsoft-com:mac:vml" xmlns:p="http://schemas.openxmlformats.org/presentationml/2006/main" xmlns:c="http://schemas.openxmlformats.org/drawingml/2006/chart" xmlns:dgm="http://schemas.openxmlformats.org/drawingml/2006/diagram" xmlns:o="urn:schemas-microsoft-com:office:office" xmlns:v="urn:schemas-microsoft-com:vml" xmlns:pvml="urn:schemas-microsoft-com:office:powerpoint" xmlns:com="http://schemas.openxmlformats.org/drawingml/2006/compatibility" xmlns:p14="http://schemas.microsoft.com/office/powerpoint/2010/main" xmlns:p15="http://schemas.microsoft.com/office/powerpoint/2012/main" xmlns:ahyp="http://schemas.microsoft.com/office/drawing/2018/hyperlinkcolor">
+<p:sld xmlns:a="http://schemas.openxmlformats.org/drawingml/2006/main" xmlns:r="http://schemas.openxmlformats.org/officeDocument/2006/relationships" xmlns:p="http://schemas.openxmlformats.org/presentationml/2006/main">
   <p:cSld>
     <p:spTree>
       <p:nvGrpSpPr>
-        <p:cNvPr id="15" name="Shape 15"/>
+        <p:cNvPr id="1" name="Shape 15"/>
         <p:cNvGrpSpPr/>
         <p:nvPr/>
       </p:nvGrpSpPr>
@@ -3382,12 +3469,12 @@
           </a:ln>
         </p:spPr>
         <p:txBody>
-          <a:bodyPr anchorCtr="0" anchor="t" bIns="0" lIns="0" spcFirstLastPara="1" rIns="0" wrap="square" tIns="0">
+          <a:bodyPr spcFirstLastPara="1" wrap="square" lIns="0" tIns="0" rIns="0" bIns="0" anchor="t" anchorCtr="0">
             <a:noAutofit/>
           </a:bodyPr>
           <a:lstStyle/>
           <a:p>
-            <a:pPr indent="0" lvl="0" marL="0" marR="0" rtl="0" algn="ctr">
+            <a:pPr marL="0" marR="0" lvl="0" indent="0" algn="ctr" rtl="0">
               <a:lnSpc>
                 <a:spcPct val="104000"/>
               </a:lnSpc>
@@ -3405,7 +3492,7 @@
               <a:buNone/>
             </a:pPr>
             <a:r>
-              <a:rPr b="1" lang="en-US" sz="3900">
+              <a:rPr lang="en-US" sz="3900" b="1">
                 <a:solidFill>
                   <a:srgbClr val="FF8AAF"/>
                 </a:solidFill>
@@ -3448,12 +3535,12 @@
           </a:ln>
         </p:spPr>
         <p:txBody>
-          <a:bodyPr anchorCtr="0" anchor="t" bIns="0" lIns="0" spcFirstLastPara="1" rIns="0" wrap="square" tIns="0">
+          <a:bodyPr spcFirstLastPara="1" wrap="square" lIns="0" tIns="0" rIns="0" bIns="0" anchor="t" anchorCtr="0">
             <a:noAutofit/>
           </a:bodyPr>
           <a:lstStyle/>
           <a:p>
-            <a:pPr indent="0" lvl="0" marL="0" marR="0" rtl="0" algn="ctr">
+            <a:pPr marL="0" marR="0" lvl="0" indent="0" algn="ctr" rtl="0">
               <a:lnSpc>
                 <a:spcPct val="104000"/>
               </a:lnSpc>
@@ -3471,7 +3558,7 @@
               <a:buNone/>
             </a:pPr>
             <a:r>
-              <a:rPr b="1" lang="en-US" sz="1950">
+              <a:rPr lang="en-US" sz="1950" b="1">
                 <a:solidFill>
                   <a:srgbClr val="FF8AAF"/>
                 </a:solidFill>
@@ -3514,12 +3601,12 @@
           </a:ln>
         </p:spPr>
         <p:txBody>
-          <a:bodyPr anchorCtr="0" anchor="t" bIns="0" lIns="0" spcFirstLastPara="1" rIns="0" wrap="square" tIns="0">
+          <a:bodyPr spcFirstLastPara="1" wrap="square" lIns="0" tIns="0" rIns="0" bIns="0" anchor="t" anchorCtr="0">
             <a:noAutofit/>
           </a:bodyPr>
           <a:lstStyle/>
           <a:p>
-            <a:pPr indent="0" lvl="0" marL="0" marR="0" rtl="0" algn="ctr">
+            <a:pPr marL="0" marR="0" lvl="0" indent="0" algn="ctr" rtl="0">
               <a:lnSpc>
                 <a:spcPct val="133000"/>
               </a:lnSpc>
@@ -3559,7 +3646,7 @@
             </a:endParaRPr>
           </a:p>
           <a:p>
-            <a:pPr indent="0" lvl="0" marL="0" marR="0" rtl="0" algn="ctr">
+            <a:pPr marL="0" marR="0" lvl="0" indent="0" algn="ctr" rtl="0">
               <a:lnSpc>
                 <a:spcPct val="133000"/>
               </a:lnSpc>
@@ -3591,7 +3678,7 @@
             <a:endParaRPr/>
           </a:p>
           <a:p>
-            <a:pPr indent="0" lvl="0" marL="0" marR="0" rtl="0" algn="ctr">
+            <a:pPr marL="0" marR="0" lvl="0" indent="0" algn="ctr" rtl="0">
               <a:lnSpc>
                 <a:spcPct val="133000"/>
               </a:lnSpc>
@@ -3623,7 +3710,7 @@
             <a:endParaRPr/>
           </a:p>
           <a:p>
-            <a:pPr indent="0" lvl="0" marL="0" marR="0" rtl="0" algn="ctr">
+            <a:pPr marL="0" marR="0" lvl="0" indent="0" algn="ctr" rtl="0">
               <a:lnSpc>
                 <a:spcPct val="133000"/>
               </a:lnSpc>
@@ -3655,7 +3742,7 @@
             <a:endParaRPr/>
           </a:p>
           <a:p>
-            <a:pPr indent="0" lvl="0" marL="0" marR="0" rtl="0" algn="ctr">
+            <a:pPr marL="0" marR="0" lvl="0" indent="0" algn="ctr" rtl="0">
               <a:lnSpc>
                 <a:spcPct val="133000"/>
               </a:lnSpc>
@@ -3725,11 +3812,11 @@
 </file>
 
 <file path=ppt/slides/slide10.xml><?xml version="1.0" encoding="utf-8"?>
-<p:sld xmlns:a="http://schemas.openxmlformats.org/drawingml/2006/main" xmlns:r="http://schemas.openxmlformats.org/officeDocument/2006/relationships" xmlns:mc="http://schemas.openxmlformats.org/markup-compatibility/2006" xmlns:mv="urn:schemas-microsoft-com:mac:vml" xmlns:p="http://schemas.openxmlformats.org/presentationml/2006/main" xmlns:c="http://schemas.openxmlformats.org/drawingml/2006/chart" xmlns:dgm="http://schemas.openxmlformats.org/drawingml/2006/diagram" xmlns:o="urn:schemas-microsoft-com:office:office" xmlns:v="urn:schemas-microsoft-com:vml" xmlns:pvml="urn:schemas-microsoft-com:office:powerpoint" xmlns:com="http://schemas.openxmlformats.org/drawingml/2006/compatibility" xmlns:p14="http://schemas.microsoft.com/office/powerpoint/2010/main" xmlns:p15="http://schemas.microsoft.com/office/powerpoint/2012/main" xmlns:ahyp="http://schemas.microsoft.com/office/drawing/2018/hyperlinkcolor">
+<p:sld xmlns:a="http://schemas.openxmlformats.org/drawingml/2006/main" xmlns:r="http://schemas.openxmlformats.org/officeDocument/2006/relationships" xmlns:p="http://schemas.openxmlformats.org/presentationml/2006/main">
   <p:cSld>
     <p:spTree>
       <p:nvGrpSpPr>
-        <p:cNvPr id="135" name="Shape 135"/>
+        <p:cNvPr id="1" name="Shape 135"/>
         <p:cNvGrpSpPr/>
         <p:nvPr/>
       </p:nvGrpSpPr>
@@ -3761,12 +3848,12 @@
           </a:ln>
         </p:spPr>
         <p:txBody>
-          <a:bodyPr anchorCtr="0" anchor="t" bIns="0" lIns="0" spcFirstLastPara="1" rIns="0" wrap="square" tIns="0">
+          <a:bodyPr spcFirstLastPara="1" wrap="square" lIns="0" tIns="0" rIns="0" bIns="0" anchor="t" anchorCtr="0">
             <a:noAutofit/>
           </a:bodyPr>
           <a:lstStyle/>
           <a:p>
-            <a:pPr indent="0" lvl="0" marL="0" marR="0" rtl="0" algn="ctr">
+            <a:pPr marL="0" marR="0" lvl="0" indent="0" algn="ctr" rtl="0">
               <a:lnSpc>
                 <a:spcPct val="104000"/>
               </a:lnSpc>
@@ -3784,7 +3871,7 @@
               <a:buNone/>
             </a:pPr>
             <a:r>
-              <a:rPr b="1" lang="en-US" sz="3900">
+              <a:rPr lang="en-US" sz="3900" b="1">
                 <a:solidFill>
                   <a:srgbClr val="FF8AAF"/>
                 </a:solidFill>
@@ -3827,12 +3914,12 @@
           </a:ln>
         </p:spPr>
         <p:txBody>
-          <a:bodyPr anchorCtr="0" anchor="t" bIns="0" lIns="0" spcFirstLastPara="1" rIns="0" wrap="square" tIns="0">
+          <a:bodyPr spcFirstLastPara="1" wrap="square" lIns="0" tIns="0" rIns="0" bIns="0" anchor="t" anchorCtr="0">
             <a:noAutofit/>
           </a:bodyPr>
           <a:lstStyle/>
           <a:p>
-            <a:pPr indent="0" lvl="0" marL="0" marR="0" rtl="0" algn="ctr">
+            <a:pPr marL="0" marR="0" lvl="0" indent="0" algn="ctr" rtl="0">
               <a:lnSpc>
                 <a:spcPct val="104000"/>
               </a:lnSpc>
@@ -3850,7 +3937,7 @@
               <a:buNone/>
             </a:pPr>
             <a:r>
-              <a:rPr b="1" lang="en-US" sz="7800">
+              <a:rPr lang="en-US" sz="7800" b="1">
                 <a:solidFill>
                   <a:srgbClr val="FF8AAF"/>
                 </a:solidFill>
@@ -3886,7 +3973,7 @@
           </a:xfrm>
           <a:prstGeom prst="roundRect">
             <a:avLst>
-              <a:gd fmla="val 49999" name="adj"/>
+              <a:gd name="adj" fmla="val 49999"/>
             </a:avLst>
           </a:prstGeom>
           <a:solidFill>
@@ -3899,12 +3986,12 @@
           </a:ln>
         </p:spPr>
         <p:txBody>
-          <a:bodyPr anchorCtr="0" anchor="t" bIns="45700" lIns="91425" spcFirstLastPara="1" rIns="91425" wrap="square" tIns="45700">
+          <a:bodyPr spcFirstLastPara="1" wrap="square" lIns="91425" tIns="45700" rIns="91425" bIns="45700" anchor="t" anchorCtr="0">
             <a:noAutofit/>
           </a:bodyPr>
           <a:lstStyle/>
           <a:p>
-            <a:pPr indent="0" lvl="0" marL="0" marR="0" rtl="0" algn="l">
+            <a:pPr marL="0" marR="0" lvl="0" indent="0" algn="l" rtl="0">
               <a:spcBef>
                 <a:spcPts val="0"/>
               </a:spcBef>
@@ -3913,9 +4000,6 @@
               </a:spcAft>
               <a:buNone/>
             </a:pPr>
-            <a:r>
-              <a:t/>
-            </a:r>
             <a:endParaRPr sz="1800">
               <a:solidFill>
                 <a:schemeClr val="dk1"/>
@@ -3965,11 +4049,11 @@
 </file>
 
 <file path=ppt/slides/slide2.xml><?xml version="1.0" encoding="utf-8"?>
-<p:sld xmlns:a="http://schemas.openxmlformats.org/drawingml/2006/main" xmlns:r="http://schemas.openxmlformats.org/officeDocument/2006/relationships" xmlns:mc="http://schemas.openxmlformats.org/markup-compatibility/2006" xmlns:mv="urn:schemas-microsoft-com:mac:vml" xmlns:p="http://schemas.openxmlformats.org/presentationml/2006/main" xmlns:c="http://schemas.openxmlformats.org/drawingml/2006/chart" xmlns:dgm="http://schemas.openxmlformats.org/drawingml/2006/diagram" xmlns:o="urn:schemas-microsoft-com:office:office" xmlns:v="urn:schemas-microsoft-com:vml" xmlns:pvml="urn:schemas-microsoft-com:office:powerpoint" xmlns:com="http://schemas.openxmlformats.org/drawingml/2006/compatibility" xmlns:p14="http://schemas.microsoft.com/office/powerpoint/2010/main" xmlns:p15="http://schemas.microsoft.com/office/powerpoint/2012/main" xmlns:ahyp="http://schemas.microsoft.com/office/drawing/2018/hyperlinkcolor">
+<p:sld xmlns:a="http://schemas.openxmlformats.org/drawingml/2006/main" xmlns:r="http://schemas.openxmlformats.org/officeDocument/2006/relationships" xmlns:p="http://schemas.openxmlformats.org/presentationml/2006/main">
   <p:cSld>
     <p:spTree>
       <p:nvGrpSpPr>
-        <p:cNvPr id="24" name="Shape 24"/>
+        <p:cNvPr id="1" name="Shape 24"/>
         <p:cNvGrpSpPr/>
         <p:nvPr/>
       </p:nvGrpSpPr>
@@ -4001,12 +4085,12 @@
           </a:ln>
         </p:spPr>
         <p:txBody>
-          <a:bodyPr anchorCtr="0" anchor="t" bIns="0" lIns="0" spcFirstLastPara="1" rIns="0" wrap="square" tIns="0">
+          <a:bodyPr spcFirstLastPara="1" wrap="square" lIns="0" tIns="0" rIns="0" bIns="0" anchor="t" anchorCtr="0">
             <a:noAutofit/>
           </a:bodyPr>
           <a:lstStyle/>
           <a:p>
-            <a:pPr indent="0" lvl="0" marL="0" marR="0" rtl="0" algn="l">
+            <a:pPr marL="0" marR="0" lvl="0" indent="0" algn="l" rtl="0">
               <a:lnSpc>
                 <a:spcPct val="104000"/>
               </a:lnSpc>
@@ -4024,7 +4108,7 @@
               <a:buNone/>
             </a:pPr>
             <a:r>
-              <a:rPr b="1" lang="en-US" sz="3900">
+              <a:rPr lang="en-US" sz="3900" b="1">
                 <a:solidFill>
                   <a:srgbClr val="FF8AAF"/>
                 </a:solidFill>
@@ -4067,12 +4151,12 @@
           </a:ln>
         </p:spPr>
         <p:txBody>
-          <a:bodyPr anchorCtr="0" anchor="t" bIns="0" lIns="0" spcFirstLastPara="1" rIns="0" wrap="square" tIns="0">
+          <a:bodyPr spcFirstLastPara="1" wrap="square" lIns="0" tIns="0" rIns="0" bIns="0" anchor="t" anchorCtr="0">
             <a:noAutofit/>
           </a:bodyPr>
           <a:lstStyle/>
           <a:p>
-            <a:pPr indent="0" lvl="0" marL="0" marR="0" rtl="0" algn="l">
+            <a:pPr marL="0" marR="0" lvl="0" indent="0" algn="l" rtl="0">
               <a:lnSpc>
                 <a:spcPct val="104000"/>
               </a:lnSpc>
@@ -4090,7 +4174,7 @@
               <a:buNone/>
             </a:pPr>
             <a:r>
-              <a:rPr b="1" lang="en-US" sz="1950">
+              <a:rPr lang="en-US" sz="1950" b="1">
                 <a:solidFill>
                   <a:srgbClr val="FF8AAF"/>
                 </a:solidFill>
@@ -4133,12 +4217,12 @@
           </a:ln>
         </p:spPr>
         <p:txBody>
-          <a:bodyPr anchorCtr="0" anchor="t" bIns="0" lIns="0" spcFirstLastPara="1" rIns="0" wrap="square" tIns="0">
+          <a:bodyPr spcFirstLastPara="1" wrap="square" lIns="0" tIns="0" rIns="0" bIns="0" anchor="t" anchorCtr="0">
             <a:normAutofit/>
           </a:bodyPr>
           <a:lstStyle/>
           <a:p>
-            <a:pPr indent="0" lvl="0" marL="0" marR="0" rtl="0" algn="l">
+            <a:pPr marL="0" marR="0" lvl="0" indent="0" algn="l" rtl="0">
               <a:lnSpc>
                 <a:spcPct val="133000"/>
               </a:lnSpc>
@@ -4168,7 +4252,7 @@
               <a:t>Sonido Vivo lleva 11 años en Viña del Mar, pero gestiona todo de forma manual: los pedidos llegan por WhatsApp e Instagram, y </a:t>
             </a:r>
             <a:r>
-              <a:rPr b="1" lang="en-US" sz="1450">
+              <a:rPr lang="en-US" sz="1450" b="1">
                 <a:solidFill>
                   <a:srgbClr val="E0D6DE"/>
                 </a:solidFill>
@@ -4190,7 +4274,7 @@
             </a:endParaRPr>
           </a:p>
           <a:p>
-            <a:pPr indent="0" lvl="0" marL="0" marR="0" rtl="0" algn="l">
+            <a:pPr marL="0" marR="0" lvl="0" indent="0" algn="l" rtl="0">
               <a:lnSpc>
                 <a:spcPct val="133000"/>
               </a:lnSpc>
@@ -4220,7 +4304,7 @@
               <a:t>Su catálogo de más de </a:t>
             </a:r>
             <a:r>
-              <a:rPr b="1" lang="en-US" sz="1450">
+              <a:rPr lang="en-US" sz="1450" b="1">
                 <a:solidFill>
                   <a:srgbClr val="E0D6DE"/>
                 </a:solidFill>
@@ -4275,12 +4359,12 @@
           </a:ln>
         </p:spPr>
         <p:txBody>
-          <a:bodyPr anchorCtr="0" anchor="t" bIns="0" lIns="0" spcFirstLastPara="1" rIns="0" wrap="square" tIns="0">
+          <a:bodyPr spcFirstLastPara="1" wrap="square" lIns="0" tIns="0" rIns="0" bIns="0" anchor="t" anchorCtr="0">
             <a:noAutofit/>
           </a:bodyPr>
           <a:lstStyle/>
           <a:p>
-            <a:pPr indent="0" lvl="0" marL="0" marR="0" rtl="0" algn="ctr">
+            <a:pPr marL="0" marR="0" lvl="0" indent="0" algn="ctr" rtl="0">
               <a:lnSpc>
                 <a:spcPct val="83000"/>
               </a:lnSpc>
@@ -4298,7 +4382,7 @@
               <a:buNone/>
             </a:pPr>
             <a:r>
-              <a:rPr b="1" lang="en-US" sz="4900">
+              <a:rPr lang="en-US" sz="4900" b="1">
                 <a:solidFill>
                   <a:srgbClr val="E0D6DE"/>
                 </a:solidFill>
@@ -4341,12 +4425,12 @@
           </a:ln>
         </p:spPr>
         <p:txBody>
-          <a:bodyPr anchorCtr="0" anchor="t" bIns="0" lIns="0" spcFirstLastPara="1" rIns="0" wrap="square" tIns="0">
+          <a:bodyPr spcFirstLastPara="1" wrap="square" lIns="0" tIns="0" rIns="0" bIns="0" anchor="t" anchorCtr="0">
             <a:noAutofit/>
           </a:bodyPr>
           <a:lstStyle/>
           <a:p>
-            <a:pPr indent="0" lvl="0" marL="0" marR="0" rtl="0" algn="ctr">
+            <a:pPr marL="0" marR="0" lvl="0" indent="0" algn="ctr" rtl="0">
               <a:lnSpc>
                 <a:spcPct val="104000"/>
               </a:lnSpc>
@@ -4364,7 +4448,7 @@
               <a:buNone/>
             </a:pPr>
             <a:r>
-              <a:rPr b="1" lang="en-US" sz="1950">
+              <a:rPr lang="en-US" sz="1950" b="1">
                 <a:solidFill>
                   <a:srgbClr val="E0D6DE"/>
                 </a:solidFill>
@@ -4407,12 +4491,12 @@
           </a:ln>
         </p:spPr>
         <p:txBody>
-          <a:bodyPr anchorCtr="0" anchor="t" bIns="0" lIns="0" spcFirstLastPara="1" rIns="0" wrap="square" tIns="0">
+          <a:bodyPr spcFirstLastPara="1" wrap="square" lIns="0" tIns="0" rIns="0" bIns="0" anchor="t" anchorCtr="0">
             <a:noAutofit/>
           </a:bodyPr>
           <a:lstStyle/>
           <a:p>
-            <a:pPr indent="0" lvl="0" marL="0" marR="0" rtl="0" algn="ctr">
+            <a:pPr marL="0" marR="0" lvl="0" indent="0" algn="ctr" rtl="0">
               <a:lnSpc>
                 <a:spcPct val="133000"/>
               </a:lnSpc>
@@ -4473,12 +4557,12 @@
           </a:ln>
         </p:spPr>
         <p:txBody>
-          <a:bodyPr anchorCtr="0" anchor="t" bIns="0" lIns="0" spcFirstLastPara="1" rIns="0" wrap="square" tIns="0">
+          <a:bodyPr spcFirstLastPara="1" wrap="square" lIns="0" tIns="0" rIns="0" bIns="0" anchor="t" anchorCtr="0">
             <a:noAutofit/>
           </a:bodyPr>
           <a:lstStyle/>
           <a:p>
-            <a:pPr indent="0" lvl="0" marL="0" marR="0" rtl="0" algn="ctr">
+            <a:pPr marL="0" marR="0" lvl="0" indent="0" algn="ctr" rtl="0">
               <a:lnSpc>
                 <a:spcPct val="83000"/>
               </a:lnSpc>
@@ -4496,7 +4580,7 @@
               <a:buNone/>
             </a:pPr>
             <a:r>
-              <a:rPr b="1" lang="en-US" sz="4900">
+              <a:rPr lang="en-US" sz="4900" b="1">
                 <a:solidFill>
                   <a:srgbClr val="E0D6DE"/>
                 </a:solidFill>
@@ -4539,12 +4623,12 @@
           </a:ln>
         </p:spPr>
         <p:txBody>
-          <a:bodyPr anchorCtr="0" anchor="t" bIns="0" lIns="0" spcFirstLastPara="1" rIns="0" wrap="square" tIns="0">
+          <a:bodyPr spcFirstLastPara="1" wrap="square" lIns="0" tIns="0" rIns="0" bIns="0" anchor="t" anchorCtr="0">
             <a:noAutofit/>
           </a:bodyPr>
           <a:lstStyle/>
           <a:p>
-            <a:pPr indent="0" lvl="0" marL="0" marR="0" rtl="0" algn="ctr">
+            <a:pPr marL="0" marR="0" lvl="0" indent="0" algn="ctr" rtl="0">
               <a:lnSpc>
                 <a:spcPct val="104000"/>
               </a:lnSpc>
@@ -4562,7 +4646,7 @@
               <a:buNone/>
             </a:pPr>
             <a:r>
-              <a:rPr b="1" lang="en-US" sz="1950">
+              <a:rPr lang="en-US" sz="1950" b="1">
                 <a:solidFill>
                   <a:srgbClr val="E0D6DE"/>
                 </a:solidFill>
@@ -4605,12 +4689,12 @@
           </a:ln>
         </p:spPr>
         <p:txBody>
-          <a:bodyPr anchorCtr="0" anchor="t" bIns="0" lIns="0" spcFirstLastPara="1" rIns="0" wrap="square" tIns="0">
+          <a:bodyPr spcFirstLastPara="1" wrap="square" lIns="0" tIns="0" rIns="0" bIns="0" anchor="t" anchorCtr="0">
             <a:noAutofit/>
           </a:bodyPr>
           <a:lstStyle/>
           <a:p>
-            <a:pPr indent="0" lvl="0" marL="0" marR="0" rtl="0" algn="ctr">
+            <a:pPr marL="0" marR="0" lvl="0" indent="0" algn="ctr" rtl="0">
               <a:lnSpc>
                 <a:spcPct val="133000"/>
               </a:lnSpc>
@@ -4671,12 +4755,12 @@
           </a:ln>
         </p:spPr>
         <p:txBody>
-          <a:bodyPr anchorCtr="0" anchor="t" bIns="0" lIns="0" spcFirstLastPara="1" rIns="0" wrap="square" tIns="0">
+          <a:bodyPr spcFirstLastPara="1" wrap="square" lIns="0" tIns="0" rIns="0" bIns="0" anchor="t" anchorCtr="0">
             <a:noAutofit/>
           </a:bodyPr>
           <a:lstStyle/>
           <a:p>
-            <a:pPr indent="0" lvl="0" marL="0" marR="0" rtl="0" algn="ctr">
+            <a:pPr marL="0" marR="0" lvl="0" indent="0" algn="ctr" rtl="0">
               <a:lnSpc>
                 <a:spcPct val="83000"/>
               </a:lnSpc>
@@ -4694,7 +4778,7 @@
               <a:buNone/>
             </a:pPr>
             <a:r>
-              <a:rPr b="1" lang="en-US" sz="4900">
+              <a:rPr lang="en-US" sz="4900" b="1">
                 <a:solidFill>
                   <a:srgbClr val="E0D6DE"/>
                 </a:solidFill>
@@ -4737,12 +4821,12 @@
           </a:ln>
         </p:spPr>
         <p:txBody>
-          <a:bodyPr anchorCtr="0" anchor="t" bIns="0" lIns="0" spcFirstLastPara="1" rIns="0" wrap="square" tIns="0">
+          <a:bodyPr spcFirstLastPara="1" wrap="square" lIns="0" tIns="0" rIns="0" bIns="0" anchor="t" anchorCtr="0">
             <a:noAutofit/>
           </a:bodyPr>
           <a:lstStyle/>
           <a:p>
-            <a:pPr indent="0" lvl="0" marL="0" marR="0" rtl="0" algn="ctr">
+            <a:pPr marL="0" marR="0" lvl="0" indent="0" algn="ctr" rtl="0">
               <a:lnSpc>
                 <a:spcPct val="104000"/>
               </a:lnSpc>
@@ -4760,7 +4844,7 @@
               <a:buNone/>
             </a:pPr>
             <a:r>
-              <a:rPr b="1" lang="en-US" sz="1950">
+              <a:rPr lang="en-US" sz="1950" b="1">
                 <a:solidFill>
                   <a:srgbClr val="E0D6DE"/>
                 </a:solidFill>
@@ -4803,12 +4887,12 @@
           </a:ln>
         </p:spPr>
         <p:txBody>
-          <a:bodyPr anchorCtr="0" anchor="t" bIns="0" lIns="0" spcFirstLastPara="1" rIns="0" wrap="square" tIns="0">
+          <a:bodyPr spcFirstLastPara="1" wrap="square" lIns="0" tIns="0" rIns="0" bIns="0" anchor="t" anchorCtr="0">
             <a:noAutofit/>
           </a:bodyPr>
           <a:lstStyle/>
           <a:p>
-            <a:pPr indent="0" lvl="0" marL="0" marR="0" rtl="0" algn="ctr">
+            <a:pPr marL="0" marR="0" lvl="0" indent="0" algn="ctr" rtl="0">
               <a:lnSpc>
                 <a:spcPct val="133000"/>
               </a:lnSpc>
@@ -4886,11 +4970,11 @@
 </file>
 
 <file path=ppt/slides/slide3.xml><?xml version="1.0" encoding="utf-8"?>
-<p:sld xmlns:a="http://schemas.openxmlformats.org/drawingml/2006/main" xmlns:r="http://schemas.openxmlformats.org/officeDocument/2006/relationships" xmlns:mc="http://schemas.openxmlformats.org/markup-compatibility/2006" xmlns:mv="urn:schemas-microsoft-com:mac:vml" xmlns:p="http://schemas.openxmlformats.org/presentationml/2006/main" xmlns:c="http://schemas.openxmlformats.org/drawingml/2006/chart" xmlns:dgm="http://schemas.openxmlformats.org/drawingml/2006/diagram" xmlns:o="urn:schemas-microsoft-com:office:office" xmlns:v="urn:schemas-microsoft-com:vml" xmlns:pvml="urn:schemas-microsoft-com:office:powerpoint" xmlns:com="http://schemas.openxmlformats.org/drawingml/2006/compatibility" xmlns:p14="http://schemas.microsoft.com/office/powerpoint/2010/main" xmlns:p15="http://schemas.microsoft.com/office/powerpoint/2012/main" xmlns:ahyp="http://schemas.microsoft.com/office/drawing/2018/hyperlinkcolor">
+<p:sld xmlns:a="http://schemas.openxmlformats.org/drawingml/2006/main" xmlns:r="http://schemas.openxmlformats.org/officeDocument/2006/relationships" xmlns:p="http://schemas.openxmlformats.org/presentationml/2006/main">
   <p:cSld>
     <p:spTree>
       <p:nvGrpSpPr>
-        <p:cNvPr id="42" name="Shape 42"/>
+        <p:cNvPr id="1" name="Shape 42"/>
         <p:cNvGrpSpPr/>
         <p:nvPr/>
       </p:nvGrpSpPr>
@@ -4922,12 +5006,12 @@
           </a:ln>
         </p:spPr>
         <p:txBody>
-          <a:bodyPr anchorCtr="0" anchor="t" bIns="0" lIns="0" spcFirstLastPara="1" rIns="0" wrap="square" tIns="0">
+          <a:bodyPr spcFirstLastPara="1" wrap="square" lIns="0" tIns="0" rIns="0" bIns="0" anchor="t" anchorCtr="0">
             <a:noAutofit/>
           </a:bodyPr>
           <a:lstStyle/>
           <a:p>
-            <a:pPr indent="0" lvl="0" marL="0" marR="0" rtl="0" algn="l">
+            <a:pPr marL="0" marR="0" lvl="0" indent="0" algn="l" rtl="0">
               <a:lnSpc>
                 <a:spcPct val="104000"/>
               </a:lnSpc>
@@ -4945,7 +5029,7 @@
               <a:buNone/>
             </a:pPr>
             <a:r>
-              <a:rPr b="1" lang="en-US" sz="3900">
+              <a:rPr lang="en-US" sz="3900" b="1">
                 <a:solidFill>
                   <a:srgbClr val="FF8AAF"/>
                 </a:solidFill>
@@ -4988,12 +5072,12 @@
           </a:ln>
         </p:spPr>
         <p:txBody>
-          <a:bodyPr anchorCtr="0" anchor="t" bIns="0" lIns="0" spcFirstLastPara="1" rIns="0" wrap="square" tIns="0">
+          <a:bodyPr spcFirstLastPara="1" wrap="square" lIns="0" tIns="0" rIns="0" bIns="0" anchor="t" anchorCtr="0">
             <a:normAutofit/>
           </a:bodyPr>
           <a:lstStyle/>
           <a:p>
-            <a:pPr indent="0" lvl="0" marL="0" marR="0" rtl="0" algn="l">
+            <a:pPr marL="0" marR="0" lvl="0" indent="0" algn="l" rtl="0">
               <a:lnSpc>
                 <a:spcPct val="133000"/>
               </a:lnSpc>
@@ -5047,29 +5131,29 @@
           </a:xfrm>
           <a:prstGeom prst="roundRect">
             <a:avLst>
-              <a:gd fmla="val 3650" name="adj"/>
+              <a:gd name="adj" fmla="val 3650"/>
             </a:avLst>
           </a:prstGeom>
           <a:solidFill>
             <a:srgbClr val="2F1D63"/>
           </a:solidFill>
-          <a:ln cap="flat" cmpd="sng" w="9525">
+          <a:ln w="9525" cap="flat" cmpd="sng">
             <a:solidFill>
               <a:srgbClr val="48367C"/>
             </a:solidFill>
             <a:prstDash val="solid"/>
             <a:round/>
-            <a:headEnd len="sm" w="sm" type="none"/>
-            <a:tailEnd len="sm" w="sm" type="none"/>
+            <a:headEnd type="none" w="sm" len="sm"/>
+            <a:tailEnd type="none" w="sm" len="sm"/>
           </a:ln>
         </p:spPr>
         <p:txBody>
-          <a:bodyPr anchorCtr="0" anchor="t" bIns="45700" lIns="91425" spcFirstLastPara="1" rIns="91425" wrap="square" tIns="45700">
+          <a:bodyPr spcFirstLastPara="1" wrap="square" lIns="91425" tIns="45700" rIns="91425" bIns="45700" anchor="t" anchorCtr="0">
             <a:noAutofit/>
           </a:bodyPr>
           <a:lstStyle/>
           <a:p>
-            <a:pPr indent="0" lvl="0" marL="0" marR="0" rtl="0" algn="l">
+            <a:pPr marL="0" marR="0" lvl="0" indent="0" algn="l" rtl="0">
               <a:spcBef>
                 <a:spcPts val="0"/>
               </a:spcBef>
@@ -5078,9 +5162,6 @@
               </a:spcAft>
               <a:buNone/>
             </a:pPr>
-            <a:r>
-              <a:t/>
-            </a:r>
             <a:endParaRPr sz="1800">
               <a:solidFill>
                 <a:schemeClr val="dk1"/>
@@ -5115,12 +5196,12 @@
           </a:ln>
         </p:spPr>
         <p:txBody>
-          <a:bodyPr anchorCtr="0" anchor="t" bIns="45700" lIns="91425" spcFirstLastPara="1" rIns="91425" wrap="square" tIns="45700">
+          <a:bodyPr spcFirstLastPara="1" wrap="square" lIns="91425" tIns="45700" rIns="91425" bIns="45700" anchor="t" anchorCtr="0">
             <a:noAutofit/>
           </a:bodyPr>
           <a:lstStyle/>
           <a:p>
-            <a:pPr indent="0" lvl="0" marL="0" marR="0" rtl="0" algn="l">
+            <a:pPr marL="0" marR="0" lvl="0" indent="0" algn="l" rtl="0">
               <a:spcBef>
                 <a:spcPts val="0"/>
               </a:spcBef>
@@ -5129,9 +5210,6 @@
               </a:spcAft>
               <a:buNone/>
             </a:pPr>
-            <a:r>
-              <a:t/>
-            </a:r>
             <a:endParaRPr sz="1800">
               <a:solidFill>
                 <a:schemeClr val="dk1"/>
@@ -5146,7 +5224,7 @@
       </p:sp>
       <p:sp>
         <p:nvSpPr>
-          <p:cNvPr descr="preencoded.png" id="47" name="Google Shape;47;p3"/>
+          <p:cNvPr id="47" name="Google Shape;47;p3" descr="preencoded.png"/>
           <p:cNvSpPr/>
           <p:nvPr/>
         </p:nvSpPr>
@@ -5163,6 +5241,13 @@
             <a:noFill/>
           </a:ln>
         </p:spPr>
+        <p:txBody>
+          <a:bodyPr/>
+          <a:lstStyle/>
+          <a:p>
+            <a:endParaRPr lang="es-CL"/>
+          </a:p>
+        </p:txBody>
       </p:sp>
       <p:sp>
         <p:nvSpPr>
@@ -5184,12 +5269,12 @@
           </a:ln>
         </p:spPr>
         <p:txBody>
-          <a:bodyPr anchorCtr="0" anchor="t" bIns="0" lIns="0" spcFirstLastPara="1" rIns="0" wrap="square" tIns="0">
+          <a:bodyPr spcFirstLastPara="1" wrap="square" lIns="0" tIns="0" rIns="0" bIns="0" anchor="t" anchorCtr="0">
             <a:noAutofit/>
           </a:bodyPr>
           <a:lstStyle/>
           <a:p>
-            <a:pPr indent="0" lvl="0" marL="0" marR="0" rtl="0" algn="l">
+            <a:pPr marL="0" marR="0" lvl="0" indent="0" algn="l" rtl="0">
               <a:lnSpc>
                 <a:spcPct val="104000"/>
               </a:lnSpc>
@@ -5207,7 +5292,7 @@
               <a:buNone/>
             </a:pPr>
             <a:r>
-              <a:rPr b="1" lang="en-US" sz="1950">
+              <a:rPr lang="en-US" sz="1950" b="1">
                 <a:solidFill>
                   <a:srgbClr val="E0D6DE"/>
                 </a:solidFill>
@@ -5250,12 +5335,12 @@
           </a:ln>
         </p:spPr>
         <p:txBody>
-          <a:bodyPr anchorCtr="0" anchor="t" bIns="0" lIns="0" spcFirstLastPara="1" rIns="0" wrap="square" tIns="0">
+          <a:bodyPr spcFirstLastPara="1" wrap="square" lIns="0" tIns="0" rIns="0" bIns="0" anchor="t" anchorCtr="0">
             <a:normAutofit/>
           </a:bodyPr>
           <a:lstStyle/>
           <a:p>
-            <a:pPr indent="0" lvl="0" marL="0" marR="0" rtl="0" algn="l">
+            <a:pPr marL="0" marR="0" lvl="0" indent="0" algn="l" rtl="0">
               <a:lnSpc>
                 <a:spcPct val="133000"/>
               </a:lnSpc>
@@ -5309,29 +5394,29 @@
           </a:xfrm>
           <a:prstGeom prst="roundRect">
             <a:avLst>
-              <a:gd fmla="val 3650" name="adj"/>
+              <a:gd name="adj" fmla="val 3650"/>
             </a:avLst>
           </a:prstGeom>
           <a:solidFill>
             <a:srgbClr val="2F1D63"/>
           </a:solidFill>
-          <a:ln cap="flat" cmpd="sng" w="9525">
+          <a:ln w="9525" cap="flat" cmpd="sng">
             <a:solidFill>
               <a:srgbClr val="48367C"/>
             </a:solidFill>
             <a:prstDash val="solid"/>
             <a:round/>
-            <a:headEnd len="sm" w="sm" type="none"/>
-            <a:tailEnd len="sm" w="sm" type="none"/>
+            <a:headEnd type="none" w="sm" len="sm"/>
+            <a:tailEnd type="none" w="sm" len="sm"/>
           </a:ln>
         </p:spPr>
         <p:txBody>
-          <a:bodyPr anchorCtr="0" anchor="t" bIns="45700" lIns="91425" spcFirstLastPara="1" rIns="91425" wrap="square" tIns="45700">
+          <a:bodyPr spcFirstLastPara="1" wrap="square" lIns="91425" tIns="45700" rIns="91425" bIns="45700" anchor="t" anchorCtr="0">
             <a:noAutofit/>
           </a:bodyPr>
           <a:lstStyle/>
           <a:p>
-            <a:pPr indent="0" lvl="0" marL="0" marR="0" rtl="0" algn="l">
+            <a:pPr marL="0" marR="0" lvl="0" indent="0" algn="l" rtl="0">
               <a:spcBef>
                 <a:spcPts val="0"/>
               </a:spcBef>
@@ -5340,9 +5425,6 @@
               </a:spcAft>
               <a:buNone/>
             </a:pPr>
-            <a:r>
-              <a:t/>
-            </a:r>
             <a:endParaRPr sz="1800">
               <a:solidFill>
                 <a:schemeClr val="dk1"/>
@@ -5377,12 +5459,12 @@
           </a:ln>
         </p:spPr>
         <p:txBody>
-          <a:bodyPr anchorCtr="0" anchor="t" bIns="45700" lIns="91425" spcFirstLastPara="1" rIns="91425" wrap="square" tIns="45700">
+          <a:bodyPr spcFirstLastPara="1" wrap="square" lIns="91425" tIns="45700" rIns="91425" bIns="45700" anchor="t" anchorCtr="0">
             <a:noAutofit/>
           </a:bodyPr>
           <a:lstStyle/>
           <a:p>
-            <a:pPr indent="0" lvl="0" marL="0" marR="0" rtl="0" algn="l">
+            <a:pPr marL="0" marR="0" lvl="0" indent="0" algn="l" rtl="0">
               <a:spcBef>
                 <a:spcPts val="0"/>
               </a:spcBef>
@@ -5391,9 +5473,6 @@
               </a:spcAft>
               <a:buNone/>
             </a:pPr>
-            <a:r>
-              <a:t/>
-            </a:r>
             <a:endParaRPr sz="1800">
               <a:solidFill>
                 <a:schemeClr val="dk1"/>
@@ -5408,7 +5487,7 @@
       </p:sp>
       <p:sp>
         <p:nvSpPr>
-          <p:cNvPr descr="preencoded.png" id="52" name="Google Shape;52;p3"/>
+          <p:cNvPr id="52" name="Google Shape;52;p3" descr="preencoded.png"/>
           <p:cNvSpPr/>
           <p:nvPr/>
         </p:nvSpPr>
@@ -5425,6 +5504,13 @@
             <a:noFill/>
           </a:ln>
         </p:spPr>
+        <p:txBody>
+          <a:bodyPr/>
+          <a:lstStyle/>
+          <a:p>
+            <a:endParaRPr lang="es-CL"/>
+          </a:p>
+        </p:txBody>
       </p:sp>
       <p:sp>
         <p:nvSpPr>
@@ -5446,12 +5532,12 @@
           </a:ln>
         </p:spPr>
         <p:txBody>
-          <a:bodyPr anchorCtr="0" anchor="t" bIns="0" lIns="0" spcFirstLastPara="1" rIns="0" wrap="square" tIns="0">
+          <a:bodyPr spcFirstLastPara="1" wrap="square" lIns="0" tIns="0" rIns="0" bIns="0" anchor="t" anchorCtr="0">
             <a:noAutofit/>
           </a:bodyPr>
           <a:lstStyle/>
           <a:p>
-            <a:pPr indent="0" lvl="0" marL="0" marR="0" rtl="0" algn="l">
+            <a:pPr marL="0" marR="0" lvl="0" indent="0" algn="l" rtl="0">
               <a:lnSpc>
                 <a:spcPct val="104000"/>
               </a:lnSpc>
@@ -5469,7 +5555,7 @@
               <a:buNone/>
             </a:pPr>
             <a:r>
-              <a:rPr b="1" lang="en-US" sz="1950">
+              <a:rPr lang="en-US" sz="1950" b="1">
                 <a:solidFill>
                   <a:srgbClr val="E0D6DE"/>
                 </a:solidFill>
@@ -5512,12 +5598,12 @@
           </a:ln>
         </p:spPr>
         <p:txBody>
-          <a:bodyPr anchorCtr="0" anchor="t" bIns="0" lIns="0" spcFirstLastPara="1" rIns="0" wrap="square" tIns="0">
+          <a:bodyPr spcFirstLastPara="1" wrap="square" lIns="0" tIns="0" rIns="0" bIns="0" anchor="t" anchorCtr="0">
             <a:normAutofit/>
           </a:bodyPr>
           <a:lstStyle/>
           <a:p>
-            <a:pPr indent="0" lvl="0" marL="0" marR="0" rtl="0" algn="l">
+            <a:pPr marL="0" marR="0" lvl="0" indent="0" algn="l" rtl="0">
               <a:lnSpc>
                 <a:spcPct val="133000"/>
               </a:lnSpc>
@@ -5571,29 +5657,29 @@
           </a:xfrm>
           <a:prstGeom prst="roundRect">
             <a:avLst>
-              <a:gd fmla="val 3650" name="adj"/>
+              <a:gd name="adj" fmla="val 3650"/>
             </a:avLst>
           </a:prstGeom>
           <a:solidFill>
             <a:srgbClr val="2F1D63"/>
           </a:solidFill>
-          <a:ln cap="flat" cmpd="sng" w="9525">
+          <a:ln w="9525" cap="flat" cmpd="sng">
             <a:solidFill>
               <a:srgbClr val="48367C"/>
             </a:solidFill>
             <a:prstDash val="solid"/>
             <a:round/>
-            <a:headEnd len="sm" w="sm" type="none"/>
-            <a:tailEnd len="sm" w="sm" type="none"/>
+            <a:headEnd type="none" w="sm" len="sm"/>
+            <a:tailEnd type="none" w="sm" len="sm"/>
           </a:ln>
         </p:spPr>
         <p:txBody>
-          <a:bodyPr anchorCtr="0" anchor="t" bIns="45700" lIns="91425" spcFirstLastPara="1" rIns="91425" wrap="square" tIns="45700">
+          <a:bodyPr spcFirstLastPara="1" wrap="square" lIns="91425" tIns="45700" rIns="91425" bIns="45700" anchor="t" anchorCtr="0">
             <a:noAutofit/>
           </a:bodyPr>
           <a:lstStyle/>
           <a:p>
-            <a:pPr indent="0" lvl="0" marL="0" marR="0" rtl="0" algn="l">
+            <a:pPr marL="0" marR="0" lvl="0" indent="0" algn="l" rtl="0">
               <a:spcBef>
                 <a:spcPts val="0"/>
               </a:spcBef>
@@ -5602,9 +5688,6 @@
               </a:spcAft>
               <a:buNone/>
             </a:pPr>
-            <a:r>
-              <a:t/>
-            </a:r>
             <a:endParaRPr sz="1800">
               <a:solidFill>
                 <a:schemeClr val="dk1"/>
@@ -5639,12 +5722,12 @@
           </a:ln>
         </p:spPr>
         <p:txBody>
-          <a:bodyPr anchorCtr="0" anchor="t" bIns="45700" lIns="91425" spcFirstLastPara="1" rIns="91425" wrap="square" tIns="45700">
+          <a:bodyPr spcFirstLastPara="1" wrap="square" lIns="91425" tIns="45700" rIns="91425" bIns="45700" anchor="t" anchorCtr="0">
             <a:noAutofit/>
           </a:bodyPr>
           <a:lstStyle/>
           <a:p>
-            <a:pPr indent="0" lvl="0" marL="0" marR="0" rtl="0" algn="l">
+            <a:pPr marL="0" marR="0" lvl="0" indent="0" algn="l" rtl="0">
               <a:spcBef>
                 <a:spcPts val="0"/>
               </a:spcBef>
@@ -5653,9 +5736,6 @@
               </a:spcAft>
               <a:buNone/>
             </a:pPr>
-            <a:r>
-              <a:t/>
-            </a:r>
             <a:endParaRPr sz="1800">
               <a:solidFill>
                 <a:schemeClr val="dk1"/>
@@ -5670,7 +5750,7 @@
       </p:sp>
       <p:sp>
         <p:nvSpPr>
-          <p:cNvPr descr="preencoded.png" id="57" name="Google Shape;57;p3"/>
+          <p:cNvPr id="57" name="Google Shape;57;p3" descr="preencoded.png"/>
           <p:cNvSpPr/>
           <p:nvPr/>
         </p:nvSpPr>
@@ -5687,6 +5767,13 @@
             <a:noFill/>
           </a:ln>
         </p:spPr>
+        <p:txBody>
+          <a:bodyPr/>
+          <a:lstStyle/>
+          <a:p>
+            <a:endParaRPr lang="es-CL"/>
+          </a:p>
+        </p:txBody>
       </p:sp>
       <p:sp>
         <p:nvSpPr>
@@ -5708,12 +5795,12 @@
           </a:ln>
         </p:spPr>
         <p:txBody>
-          <a:bodyPr anchorCtr="0" anchor="t" bIns="0" lIns="0" spcFirstLastPara="1" rIns="0" wrap="square" tIns="0">
+          <a:bodyPr spcFirstLastPara="1" wrap="square" lIns="0" tIns="0" rIns="0" bIns="0" anchor="t" anchorCtr="0">
             <a:noAutofit/>
           </a:bodyPr>
           <a:lstStyle/>
           <a:p>
-            <a:pPr indent="0" lvl="0" marL="0" marR="0" rtl="0" algn="l">
+            <a:pPr marL="0" marR="0" lvl="0" indent="0" algn="l" rtl="0">
               <a:lnSpc>
                 <a:spcPct val="104000"/>
               </a:lnSpc>
@@ -5731,7 +5818,7 @@
               <a:buNone/>
             </a:pPr>
             <a:r>
-              <a:rPr b="1" lang="en-US" sz="1950">
+              <a:rPr lang="en-US" sz="1950" b="1">
                 <a:solidFill>
                   <a:srgbClr val="E0D6DE"/>
                 </a:solidFill>
@@ -5774,12 +5861,12 @@
           </a:ln>
         </p:spPr>
         <p:txBody>
-          <a:bodyPr anchorCtr="0" anchor="t" bIns="0" lIns="0" spcFirstLastPara="1" rIns="0" wrap="square" tIns="0">
+          <a:bodyPr spcFirstLastPara="1" wrap="square" lIns="0" tIns="0" rIns="0" bIns="0" anchor="t" anchorCtr="0">
             <a:normAutofit/>
           </a:bodyPr>
           <a:lstStyle/>
           <a:p>
-            <a:pPr indent="0" lvl="0" marL="0" marR="0" rtl="0" algn="l">
+            <a:pPr marL="0" marR="0" lvl="0" indent="0" algn="l" rtl="0">
               <a:lnSpc>
                 <a:spcPct val="133000"/>
               </a:lnSpc>
@@ -5857,11 +5944,11 @@
 </file>
 
 <file path=ppt/slides/slide4.xml><?xml version="1.0" encoding="utf-8"?>
-<p:sld xmlns:a="http://schemas.openxmlformats.org/drawingml/2006/main" xmlns:r="http://schemas.openxmlformats.org/officeDocument/2006/relationships" xmlns:mc="http://schemas.openxmlformats.org/markup-compatibility/2006" xmlns:mv="urn:schemas-microsoft-com:mac:vml" xmlns:p="http://schemas.openxmlformats.org/presentationml/2006/main" xmlns:c="http://schemas.openxmlformats.org/drawingml/2006/chart" xmlns:dgm="http://schemas.openxmlformats.org/drawingml/2006/diagram" xmlns:o="urn:schemas-microsoft-com:office:office" xmlns:v="urn:schemas-microsoft-com:vml" xmlns:pvml="urn:schemas-microsoft-com:office:powerpoint" xmlns:com="http://schemas.openxmlformats.org/drawingml/2006/compatibility" xmlns:p14="http://schemas.microsoft.com/office/powerpoint/2010/main" xmlns:p15="http://schemas.microsoft.com/office/powerpoint/2012/main" xmlns:ahyp="http://schemas.microsoft.com/office/drawing/2018/hyperlinkcolor">
+<p:sld xmlns:a="http://schemas.openxmlformats.org/drawingml/2006/main" xmlns:r="http://schemas.openxmlformats.org/officeDocument/2006/relationships" xmlns:p="http://schemas.openxmlformats.org/presentationml/2006/main">
   <p:cSld>
     <p:spTree>
       <p:nvGrpSpPr>
-        <p:cNvPr id="65" name="Shape 65"/>
+        <p:cNvPr id="1" name="Shape 65"/>
         <p:cNvGrpSpPr/>
         <p:nvPr/>
       </p:nvGrpSpPr>
@@ -5893,12 +5980,12 @@
           </a:ln>
         </p:spPr>
         <p:txBody>
-          <a:bodyPr anchorCtr="0" anchor="t" bIns="0" lIns="0" spcFirstLastPara="1" rIns="0" wrap="square" tIns="0">
+          <a:bodyPr spcFirstLastPara="1" wrap="square" lIns="0" tIns="0" rIns="0" bIns="0" anchor="t" anchorCtr="0">
             <a:noAutofit/>
           </a:bodyPr>
           <a:lstStyle/>
           <a:p>
-            <a:pPr indent="0" lvl="0" marL="0" marR="0" rtl="0" algn="ctr">
+            <a:pPr marL="0" marR="0" lvl="0" indent="0" algn="ctr" rtl="0">
               <a:lnSpc>
                 <a:spcPct val="104000"/>
               </a:lnSpc>
@@ -5916,7 +6003,7 @@
               <a:buNone/>
             </a:pPr>
             <a:r>
-              <a:rPr b="1" lang="en-US" sz="2550">
+              <a:rPr lang="en-US" sz="4000" b="1" dirty="0" err="1">
                 <a:solidFill>
                   <a:srgbClr val="FF8AAF"/>
                 </a:solidFill>
@@ -5925,9 +6012,81 @@
                 <a:cs typeface="Petrona"/>
                 <a:sym typeface="Petrona"/>
               </a:rPr>
-              <a:t>Flujo de compra en la práctica</a:t>
-            </a:r>
-            <a:endParaRPr sz="2550">
+              <a:t>Flujo</a:t>
+            </a:r>
+            <a:r>
+              <a:rPr lang="en-US" sz="4000" b="1" dirty="0">
+                <a:solidFill>
+                  <a:srgbClr val="FF8AAF"/>
+                </a:solidFill>
+                <a:latin typeface="Petrona"/>
+                <a:ea typeface="Petrona"/>
+                <a:cs typeface="Petrona"/>
+                <a:sym typeface="Petrona"/>
+              </a:rPr>
+              <a:t> de </a:t>
+            </a:r>
+            <a:r>
+              <a:rPr lang="en-US" sz="4000" b="1" dirty="0" err="1">
+                <a:solidFill>
+                  <a:srgbClr val="FF8AAF"/>
+                </a:solidFill>
+                <a:latin typeface="Petrona"/>
+                <a:ea typeface="Petrona"/>
+                <a:cs typeface="Petrona"/>
+                <a:sym typeface="Petrona"/>
+              </a:rPr>
+              <a:t>compra</a:t>
+            </a:r>
+            <a:r>
+              <a:rPr lang="en-US" sz="4000" b="1" dirty="0">
+                <a:solidFill>
+                  <a:srgbClr val="FF8AAF"/>
+                </a:solidFill>
+                <a:latin typeface="Petrona"/>
+                <a:ea typeface="Petrona"/>
+                <a:cs typeface="Petrona"/>
+                <a:sym typeface="Petrona"/>
+              </a:rPr>
+              <a:t> </a:t>
+            </a:r>
+            <a:r>
+              <a:rPr lang="en-US" sz="4000" b="1" dirty="0" err="1">
+                <a:solidFill>
+                  <a:srgbClr val="FF8AAF"/>
+                </a:solidFill>
+                <a:latin typeface="Petrona"/>
+                <a:ea typeface="Petrona"/>
+                <a:cs typeface="Petrona"/>
+                <a:sym typeface="Petrona"/>
+              </a:rPr>
+              <a:t>en</a:t>
+            </a:r>
+            <a:r>
+              <a:rPr lang="en-US" sz="4000" b="1" dirty="0">
+                <a:solidFill>
+                  <a:srgbClr val="FF8AAF"/>
+                </a:solidFill>
+                <a:latin typeface="Petrona"/>
+                <a:ea typeface="Petrona"/>
+                <a:cs typeface="Petrona"/>
+                <a:sym typeface="Petrona"/>
+              </a:rPr>
+              <a:t> la </a:t>
+            </a:r>
+            <a:r>
+              <a:rPr lang="en-US" sz="4000" b="1" dirty="0" err="1">
+                <a:solidFill>
+                  <a:srgbClr val="FF8AAF"/>
+                </a:solidFill>
+                <a:latin typeface="Petrona"/>
+                <a:ea typeface="Petrona"/>
+                <a:cs typeface="Petrona"/>
+                <a:sym typeface="Petrona"/>
+              </a:rPr>
+              <a:t>práctica</a:t>
+            </a:r>
+            <a:endParaRPr sz="4000" dirty="0">
               <a:solidFill>
                 <a:schemeClr val="dk1"/>
               </a:solidFill>
@@ -5947,7 +6106,7 @@
         </p:nvSpPr>
         <p:spPr>
           <a:xfrm>
-            <a:off x="8029308" y="4664098"/>
+            <a:off x="7428174" y="5553092"/>
             <a:ext cx="2567700" cy="321000"/>
           </a:xfrm>
           <a:prstGeom prst="rect">
@@ -5959,12 +6118,12 @@
           </a:ln>
         </p:spPr>
         <p:txBody>
-          <a:bodyPr anchorCtr="0" anchor="t" bIns="0" lIns="0" spcFirstLastPara="1" rIns="0" wrap="square" tIns="0">
+          <a:bodyPr spcFirstLastPara="1" wrap="square" lIns="0" tIns="0" rIns="0" bIns="0" anchor="t" anchorCtr="0">
             <a:noAutofit/>
           </a:bodyPr>
           <a:lstStyle/>
           <a:p>
-            <a:pPr indent="0" lvl="0" marL="0" marR="0" rtl="0" algn="ctr">
+            <a:pPr marL="0" marR="0" lvl="0" indent="0" algn="ctr" rtl="0">
               <a:lnSpc>
                 <a:spcPct val="104000"/>
               </a:lnSpc>
@@ -5982,7 +6141,7 @@
               <a:buNone/>
             </a:pPr>
             <a:r>
-              <a:rPr b="1" lang="en-US" sz="2000">
+              <a:rPr lang="en-US" sz="3200" b="1" dirty="0" err="1">
                 <a:solidFill>
                   <a:srgbClr val="FFFFFF"/>
                 </a:solidFill>
@@ -5993,7 +6152,7 @@
               </a:rPr>
               <a:t>Catálogo</a:t>
             </a:r>
-            <a:endParaRPr sz="2000">
+            <a:endParaRPr sz="3200" dirty="0">
               <a:solidFill>
                 <a:schemeClr val="dk1"/>
               </a:solidFill>
@@ -6013,7 +6172,7 @@
         </p:nvSpPr>
         <p:spPr>
           <a:xfrm>
-            <a:off x="2057558" y="4664092"/>
+            <a:off x="1729950" y="5553092"/>
             <a:ext cx="2567700" cy="321000"/>
           </a:xfrm>
           <a:prstGeom prst="rect">
@@ -6025,12 +6184,12 @@
           </a:ln>
         </p:spPr>
         <p:txBody>
-          <a:bodyPr anchorCtr="0" anchor="t" bIns="0" lIns="0" spcFirstLastPara="1" rIns="0" wrap="square" tIns="0">
+          <a:bodyPr spcFirstLastPara="1" wrap="square" lIns="0" tIns="0" rIns="0" bIns="0" anchor="t" anchorCtr="0">
             <a:noAutofit/>
           </a:bodyPr>
           <a:lstStyle/>
           <a:p>
-            <a:pPr indent="0" lvl="0" marL="0" marR="0" rtl="0" algn="ctr">
+            <a:pPr marL="0" marR="0" lvl="0" indent="0" algn="ctr" rtl="0">
               <a:lnSpc>
                 <a:spcPct val="104000"/>
               </a:lnSpc>
@@ -6048,7 +6207,7 @@
               <a:buNone/>
             </a:pPr>
             <a:r>
-              <a:rPr b="1" lang="en-US" sz="2000">
+              <a:rPr lang="en-US" sz="3200" b="1" dirty="0">
                 <a:solidFill>
                   <a:srgbClr val="FFFFFF"/>
                 </a:solidFill>
@@ -6059,7 +6218,7 @@
               </a:rPr>
               <a:t>Home</a:t>
             </a:r>
-            <a:endParaRPr sz="2000">
+            <a:endParaRPr sz="3200" dirty="0">
               <a:solidFill>
                 <a:schemeClr val="dk1"/>
               </a:solidFill>
@@ -6073,7 +6232,7 @@
       </p:sp>
       <p:pic>
         <p:nvPicPr>
-          <p:cNvPr id="69" name="Google Shape;69;p4"/>
+          <p:cNvPr id="71" name="Google Shape;71;p4"/>
           <p:cNvPicPr preferRelativeResize="0"/>
           <p:nvPr/>
         </p:nvPicPr>
@@ -6087,8 +6246,8 @@
         </p:blipFill>
         <p:spPr>
           <a:xfrm>
-            <a:off x="631609" y="1695801"/>
-            <a:ext cx="5419577" cy="2858576"/>
+            <a:off x="11019875" y="6138123"/>
+            <a:ext cx="1172114" cy="719881"/>
           </a:xfrm>
           <a:prstGeom prst="rect">
             <a:avLst/>
@@ -6101,58 +6260,62 @@
       </p:pic>
       <p:pic>
         <p:nvPicPr>
-          <p:cNvPr id="70" name="Google Shape;70;p4"/>
-          <p:cNvPicPr preferRelativeResize="0"/>
+          <p:cNvPr id="3" name="Imagen 2">
+            <a:extLst>
+              <a:ext uri="{FF2B5EF4-FFF2-40B4-BE49-F238E27FC236}">
+                <a16:creationId xmlns:a16="http://schemas.microsoft.com/office/drawing/2014/main" id="{C2829CFD-2C14-103C-CDC7-7AEF793524EB}"/>
+              </a:ext>
+            </a:extLst>
+          </p:cNvPr>
+          <p:cNvPicPr>
+            <a:picLocks noChangeAspect="1"/>
+          </p:cNvPicPr>
           <p:nvPr/>
         </p:nvPicPr>
         <p:blipFill>
-          <a:blip r:embed="rId4">
-            <a:alphaModFix/>
-          </a:blip>
+          <a:blip r:embed="rId4"/>
           <a:stretch>
             <a:fillRect/>
           </a:stretch>
         </p:blipFill>
         <p:spPr>
           <a:xfrm>
-            <a:off x="6273136" y="1990628"/>
-            <a:ext cx="5836013" cy="2268911"/>
-          </a:xfrm>
-          <a:prstGeom prst="rect">
-            <a:avLst/>
-          </a:prstGeom>
-          <a:noFill/>
-          <a:ln>
-            <a:noFill/>
-          </a:ln>
+            <a:off x="373295" y="1900987"/>
+            <a:ext cx="5281010" cy="3414364"/>
+          </a:xfrm>
+          <a:prstGeom prst="rect">
+            <a:avLst/>
+          </a:prstGeom>
         </p:spPr>
       </p:pic>
       <p:pic>
         <p:nvPicPr>
-          <p:cNvPr id="71" name="Google Shape;71;p4"/>
-          <p:cNvPicPr preferRelativeResize="0"/>
+          <p:cNvPr id="5" name="Imagen 4">
+            <a:extLst>
+              <a:ext uri="{FF2B5EF4-FFF2-40B4-BE49-F238E27FC236}">
+                <a16:creationId xmlns:a16="http://schemas.microsoft.com/office/drawing/2014/main" id="{834018F4-C011-A0F9-44DC-F063F8362FB4}"/>
+              </a:ext>
+            </a:extLst>
+          </p:cNvPr>
+          <p:cNvPicPr>
+            <a:picLocks noChangeAspect="1"/>
+          </p:cNvPicPr>
           <p:nvPr/>
         </p:nvPicPr>
         <p:blipFill>
-          <a:blip r:embed="rId5">
-            <a:alphaModFix/>
-          </a:blip>
+          <a:blip r:embed="rId5"/>
           <a:stretch>
             <a:fillRect/>
           </a:stretch>
         </p:blipFill>
         <p:spPr>
           <a:xfrm>
-            <a:off x="11019875" y="6138123"/>
-            <a:ext cx="1172114" cy="719881"/>
-          </a:xfrm>
-          <a:prstGeom prst="rect">
-            <a:avLst/>
-          </a:prstGeom>
-          <a:noFill/>
-          <a:ln>
-            <a:noFill/>
-          </a:ln>
+            <a:off x="6040868" y="1900987"/>
+            <a:ext cx="5342311" cy="3414364"/>
+          </a:xfrm>
+          <a:prstGeom prst="rect">
+            <a:avLst/>
+          </a:prstGeom>
         </p:spPr>
       </p:pic>
     </p:spTree>
@@ -6164,11 +6327,11 @@
 </file>
 
 <file path=ppt/slides/slide5.xml><?xml version="1.0" encoding="utf-8"?>
-<p:sld xmlns:a="http://schemas.openxmlformats.org/drawingml/2006/main" xmlns:r="http://schemas.openxmlformats.org/officeDocument/2006/relationships" xmlns:mc="http://schemas.openxmlformats.org/markup-compatibility/2006" xmlns:mv="urn:schemas-microsoft-com:mac:vml" xmlns:p="http://schemas.openxmlformats.org/presentationml/2006/main" xmlns:c="http://schemas.openxmlformats.org/drawingml/2006/chart" xmlns:dgm="http://schemas.openxmlformats.org/drawingml/2006/diagram" xmlns:o="urn:schemas-microsoft-com:office:office" xmlns:v="urn:schemas-microsoft-com:vml" xmlns:pvml="urn:schemas-microsoft-com:office:powerpoint" xmlns:com="http://schemas.openxmlformats.org/drawingml/2006/compatibility" xmlns:p14="http://schemas.microsoft.com/office/powerpoint/2010/main" xmlns:p15="http://schemas.microsoft.com/office/powerpoint/2012/main" xmlns:ahyp="http://schemas.microsoft.com/office/drawing/2018/hyperlinkcolor">
+<p:sld xmlns:a="http://schemas.openxmlformats.org/drawingml/2006/main" xmlns:r="http://schemas.openxmlformats.org/officeDocument/2006/relationships" xmlns:p="http://schemas.openxmlformats.org/presentationml/2006/main">
   <p:cSld>
     <p:spTree>
       <p:nvGrpSpPr>
-        <p:cNvPr id="76" name="Shape 76"/>
+        <p:cNvPr id="1" name="Shape 76"/>
         <p:cNvGrpSpPr/>
         <p:nvPr/>
       </p:nvGrpSpPr>
@@ -6200,12 +6363,12 @@
           </a:ln>
         </p:spPr>
         <p:txBody>
-          <a:bodyPr anchorCtr="0" anchor="t" bIns="0" lIns="0" spcFirstLastPara="1" rIns="0" wrap="square" tIns="0">
+          <a:bodyPr spcFirstLastPara="1" wrap="square" lIns="0" tIns="0" rIns="0" bIns="0" anchor="t" anchorCtr="0">
             <a:noAutofit/>
           </a:bodyPr>
           <a:lstStyle/>
           <a:p>
-            <a:pPr indent="0" lvl="0" marL="0" marR="0" rtl="0" algn="ctr">
+            <a:pPr marL="0" marR="0" lvl="0" indent="0" algn="ctr" rtl="0">
               <a:lnSpc>
                 <a:spcPct val="104000"/>
               </a:lnSpc>
@@ -6223,7 +6386,7 @@
               <a:buNone/>
             </a:pPr>
             <a:r>
-              <a:rPr b="1" lang="en-US" sz="2550">
+              <a:rPr lang="en-US" sz="2550" b="1">
                 <a:solidFill>
                   <a:srgbClr val="FF8AAF"/>
                 </a:solidFill>
@@ -6254,7 +6417,7 @@
         </p:nvSpPr>
         <p:spPr>
           <a:xfrm>
-            <a:off x="7760958" y="4399241"/>
+            <a:off x="7800235" y="5190264"/>
             <a:ext cx="2567700" cy="321000"/>
           </a:xfrm>
           <a:prstGeom prst="rect">
@@ -6266,12 +6429,12 @@
           </a:ln>
         </p:spPr>
         <p:txBody>
-          <a:bodyPr anchorCtr="0" anchor="t" bIns="0" lIns="0" spcFirstLastPara="1" rIns="0" wrap="square" tIns="0">
+          <a:bodyPr spcFirstLastPara="1" wrap="square" lIns="0" tIns="0" rIns="0" bIns="0" anchor="t" anchorCtr="0">
             <a:noAutofit/>
           </a:bodyPr>
           <a:lstStyle/>
           <a:p>
-            <a:pPr indent="0" lvl="0" marL="0" marR="0" rtl="0" algn="ctr">
+            <a:pPr marL="0" marR="0" lvl="0" indent="0" algn="ctr" rtl="0">
               <a:lnSpc>
                 <a:spcPct val="104000"/>
               </a:lnSpc>
@@ -6289,7 +6452,7 @@
               <a:buNone/>
             </a:pPr>
             <a:r>
-              <a:rPr b="1" lang="en-US" sz="2000">
+              <a:rPr lang="en-US" sz="3200" b="1" dirty="0" err="1">
                 <a:solidFill>
                   <a:srgbClr val="FFFFFF"/>
                 </a:solidFill>
@@ -6300,7 +6463,7 @@
               </a:rPr>
               <a:t>Carrito</a:t>
             </a:r>
-            <a:endParaRPr sz="2000">
+            <a:endParaRPr sz="2000" dirty="0">
               <a:solidFill>
                 <a:schemeClr val="dk1"/>
               </a:solidFill>
@@ -6320,7 +6483,7 @@
         </p:nvSpPr>
         <p:spPr>
           <a:xfrm>
-            <a:off x="1807133" y="4399260"/>
+            <a:off x="1824067" y="5190264"/>
             <a:ext cx="2567700" cy="321000"/>
           </a:xfrm>
           <a:prstGeom prst="rect">
@@ -6332,12 +6495,12 @@
           </a:ln>
         </p:spPr>
         <p:txBody>
-          <a:bodyPr anchorCtr="0" anchor="t" bIns="0" lIns="0" spcFirstLastPara="1" rIns="0" wrap="square" tIns="0">
+          <a:bodyPr spcFirstLastPara="1" wrap="square" lIns="0" tIns="0" rIns="0" bIns="0" anchor="t" anchorCtr="0">
             <a:noAutofit/>
           </a:bodyPr>
           <a:lstStyle/>
           <a:p>
-            <a:pPr indent="0" lvl="0" marL="0" marR="0" rtl="0" algn="ctr">
+            <a:pPr marL="0" marR="0" lvl="0" indent="0" algn="ctr" rtl="0">
               <a:lnSpc>
                 <a:spcPct val="104000"/>
               </a:lnSpc>
@@ -6355,7 +6518,7 @@
               <a:buNone/>
             </a:pPr>
             <a:r>
-              <a:rPr b="1" lang="en-US" sz="2000">
+              <a:rPr lang="en-US" sz="3200" b="1" dirty="0" err="1">
                 <a:solidFill>
                   <a:srgbClr val="FFFFFF"/>
                 </a:solidFill>
@@ -6366,7 +6529,7 @@
               </a:rPr>
               <a:t>Ficha</a:t>
             </a:r>
-            <a:endParaRPr sz="2000">
+            <a:endParaRPr sz="3200" dirty="0">
               <a:solidFill>
                 <a:schemeClr val="dk1"/>
               </a:solidFill>
@@ -6398,12 +6561,12 @@
           </a:ln>
         </p:spPr>
         <p:txBody>
-          <a:bodyPr anchorCtr="0" anchor="t" bIns="0" lIns="0" spcFirstLastPara="1" rIns="0" wrap="square" tIns="0">
+          <a:bodyPr spcFirstLastPara="1" wrap="square" lIns="0" tIns="0" rIns="0" bIns="0" anchor="t" anchorCtr="0">
             <a:noAutofit/>
           </a:bodyPr>
           <a:lstStyle/>
           <a:p>
-            <a:pPr indent="0" lvl="0" marL="0" marR="0" rtl="0" algn="l">
+            <a:pPr marL="0" marR="0" lvl="0" indent="0" algn="l" rtl="0">
               <a:lnSpc>
                 <a:spcPct val="110000"/>
               </a:lnSpc>
@@ -6421,7 +6584,7 @@
               <a:buNone/>
             </a:pPr>
             <a:r>
-              <a:rPr lang="en-US" sz="950">
+              <a:rPr lang="en-US" sz="950" dirty="0" err="1">
                 <a:solidFill>
                   <a:srgbClr val="E0D6DE"/>
                 </a:solidFill>
@@ -6430,9 +6593,429 @@
                 <a:cs typeface="Inter"/>
                 <a:sym typeface="Inter"/>
               </a:rPr>
-              <a:t>Desde el home se entra al catálogo, se filtra por categoría, se abre la ficha técnica de un producto con su marca, precio y stock, y desde ahí se agrega al carrito, donde se calcula automáticamente el subtotal, el IVA y el total.</a:t>
-            </a:r>
-            <a:endParaRPr sz="950">
+              <a:t>Desde</a:t>
+            </a:r>
+            <a:r>
+              <a:rPr lang="en-US" sz="950" dirty="0">
+                <a:solidFill>
+                  <a:srgbClr val="E0D6DE"/>
+                </a:solidFill>
+                <a:latin typeface="Inter"/>
+                <a:ea typeface="Inter"/>
+                <a:cs typeface="Inter"/>
+                <a:sym typeface="Inter"/>
+              </a:rPr>
+              <a:t> el home se </a:t>
+            </a:r>
+            <a:r>
+              <a:rPr lang="en-US" sz="950" dirty="0" err="1">
+                <a:solidFill>
+                  <a:srgbClr val="E0D6DE"/>
+                </a:solidFill>
+                <a:latin typeface="Inter"/>
+                <a:ea typeface="Inter"/>
+                <a:cs typeface="Inter"/>
+                <a:sym typeface="Inter"/>
+              </a:rPr>
+              <a:t>entra</a:t>
+            </a:r>
+            <a:r>
+              <a:rPr lang="en-US" sz="950" dirty="0">
+                <a:solidFill>
+                  <a:srgbClr val="E0D6DE"/>
+                </a:solidFill>
+                <a:latin typeface="Inter"/>
+                <a:ea typeface="Inter"/>
+                <a:cs typeface="Inter"/>
+                <a:sym typeface="Inter"/>
+              </a:rPr>
+              <a:t> al </a:t>
+            </a:r>
+            <a:r>
+              <a:rPr lang="en-US" sz="950" dirty="0" err="1">
+                <a:solidFill>
+                  <a:srgbClr val="E0D6DE"/>
+                </a:solidFill>
+                <a:latin typeface="Inter"/>
+                <a:ea typeface="Inter"/>
+                <a:cs typeface="Inter"/>
+                <a:sym typeface="Inter"/>
+              </a:rPr>
+              <a:t>catálogo</a:t>
+            </a:r>
+            <a:r>
+              <a:rPr lang="en-US" sz="950" dirty="0">
+                <a:solidFill>
+                  <a:srgbClr val="E0D6DE"/>
+                </a:solidFill>
+                <a:latin typeface="Inter"/>
+                <a:ea typeface="Inter"/>
+                <a:cs typeface="Inter"/>
+                <a:sym typeface="Inter"/>
+              </a:rPr>
+              <a:t>, se filtra </a:t>
+            </a:r>
+            <a:r>
+              <a:rPr lang="en-US" sz="950" dirty="0" err="1">
+                <a:solidFill>
+                  <a:srgbClr val="E0D6DE"/>
+                </a:solidFill>
+                <a:latin typeface="Inter"/>
+                <a:ea typeface="Inter"/>
+                <a:cs typeface="Inter"/>
+                <a:sym typeface="Inter"/>
+              </a:rPr>
+              <a:t>por</a:t>
+            </a:r>
+            <a:r>
+              <a:rPr lang="en-US" sz="950" dirty="0">
+                <a:solidFill>
+                  <a:srgbClr val="E0D6DE"/>
+                </a:solidFill>
+                <a:latin typeface="Inter"/>
+                <a:ea typeface="Inter"/>
+                <a:cs typeface="Inter"/>
+                <a:sym typeface="Inter"/>
+              </a:rPr>
+              <a:t> </a:t>
+            </a:r>
+            <a:r>
+              <a:rPr lang="en-US" sz="950" dirty="0" err="1">
+                <a:solidFill>
+                  <a:srgbClr val="E0D6DE"/>
+                </a:solidFill>
+                <a:latin typeface="Inter"/>
+                <a:ea typeface="Inter"/>
+                <a:cs typeface="Inter"/>
+                <a:sym typeface="Inter"/>
+              </a:rPr>
+              <a:t>categoría</a:t>
+            </a:r>
+            <a:r>
+              <a:rPr lang="en-US" sz="950" dirty="0">
+                <a:solidFill>
+                  <a:srgbClr val="E0D6DE"/>
+                </a:solidFill>
+                <a:latin typeface="Inter"/>
+                <a:ea typeface="Inter"/>
+                <a:cs typeface="Inter"/>
+                <a:sym typeface="Inter"/>
+              </a:rPr>
+              <a:t>, se </a:t>
+            </a:r>
+            <a:r>
+              <a:rPr lang="en-US" sz="950" dirty="0" err="1">
+                <a:solidFill>
+                  <a:srgbClr val="E0D6DE"/>
+                </a:solidFill>
+                <a:latin typeface="Inter"/>
+                <a:ea typeface="Inter"/>
+                <a:cs typeface="Inter"/>
+                <a:sym typeface="Inter"/>
+              </a:rPr>
+              <a:t>abre</a:t>
+            </a:r>
+            <a:r>
+              <a:rPr lang="en-US" sz="950" dirty="0">
+                <a:solidFill>
+                  <a:srgbClr val="E0D6DE"/>
+                </a:solidFill>
+                <a:latin typeface="Inter"/>
+                <a:ea typeface="Inter"/>
+                <a:cs typeface="Inter"/>
+                <a:sym typeface="Inter"/>
+              </a:rPr>
+              <a:t> la </a:t>
+            </a:r>
+            <a:r>
+              <a:rPr lang="en-US" sz="950" dirty="0" err="1">
+                <a:solidFill>
+                  <a:srgbClr val="E0D6DE"/>
+                </a:solidFill>
+                <a:latin typeface="Inter"/>
+                <a:ea typeface="Inter"/>
+                <a:cs typeface="Inter"/>
+                <a:sym typeface="Inter"/>
+              </a:rPr>
+              <a:t>ficha</a:t>
+            </a:r>
+            <a:r>
+              <a:rPr lang="en-US" sz="950" dirty="0">
+                <a:solidFill>
+                  <a:srgbClr val="E0D6DE"/>
+                </a:solidFill>
+                <a:latin typeface="Inter"/>
+                <a:ea typeface="Inter"/>
+                <a:cs typeface="Inter"/>
+                <a:sym typeface="Inter"/>
+              </a:rPr>
+              <a:t> </a:t>
+            </a:r>
+            <a:r>
+              <a:rPr lang="en-US" sz="950" dirty="0" err="1">
+                <a:solidFill>
+                  <a:srgbClr val="E0D6DE"/>
+                </a:solidFill>
+                <a:latin typeface="Inter"/>
+                <a:ea typeface="Inter"/>
+                <a:cs typeface="Inter"/>
+                <a:sym typeface="Inter"/>
+              </a:rPr>
+              <a:t>técnica</a:t>
+            </a:r>
+            <a:r>
+              <a:rPr lang="en-US" sz="950" dirty="0">
+                <a:solidFill>
+                  <a:srgbClr val="E0D6DE"/>
+                </a:solidFill>
+                <a:latin typeface="Inter"/>
+                <a:ea typeface="Inter"/>
+                <a:cs typeface="Inter"/>
+                <a:sym typeface="Inter"/>
+              </a:rPr>
+              <a:t> de un </a:t>
+            </a:r>
+            <a:r>
+              <a:rPr lang="en-US" sz="950" dirty="0" err="1">
+                <a:solidFill>
+                  <a:srgbClr val="E0D6DE"/>
+                </a:solidFill>
+                <a:latin typeface="Inter"/>
+                <a:ea typeface="Inter"/>
+                <a:cs typeface="Inter"/>
+                <a:sym typeface="Inter"/>
+              </a:rPr>
+              <a:t>producto</a:t>
+            </a:r>
+            <a:r>
+              <a:rPr lang="en-US" sz="950" dirty="0">
+                <a:solidFill>
+                  <a:srgbClr val="E0D6DE"/>
+                </a:solidFill>
+                <a:latin typeface="Inter"/>
+                <a:ea typeface="Inter"/>
+                <a:cs typeface="Inter"/>
+                <a:sym typeface="Inter"/>
+              </a:rPr>
+              <a:t> con </a:t>
+            </a:r>
+            <a:r>
+              <a:rPr lang="en-US" sz="950" dirty="0" err="1">
+                <a:solidFill>
+                  <a:srgbClr val="E0D6DE"/>
+                </a:solidFill>
+                <a:latin typeface="Inter"/>
+                <a:ea typeface="Inter"/>
+                <a:cs typeface="Inter"/>
+                <a:sym typeface="Inter"/>
+              </a:rPr>
+              <a:t>su</a:t>
+            </a:r>
+            <a:r>
+              <a:rPr lang="en-US" sz="950" dirty="0">
+                <a:solidFill>
+                  <a:srgbClr val="E0D6DE"/>
+                </a:solidFill>
+                <a:latin typeface="Inter"/>
+                <a:ea typeface="Inter"/>
+                <a:cs typeface="Inter"/>
+                <a:sym typeface="Inter"/>
+              </a:rPr>
+              <a:t> </a:t>
+            </a:r>
+            <a:r>
+              <a:rPr lang="en-US" sz="950" dirty="0" err="1">
+                <a:solidFill>
+                  <a:srgbClr val="E0D6DE"/>
+                </a:solidFill>
+                <a:latin typeface="Inter"/>
+                <a:ea typeface="Inter"/>
+                <a:cs typeface="Inter"/>
+                <a:sym typeface="Inter"/>
+              </a:rPr>
+              <a:t>marca</a:t>
+            </a:r>
+            <a:r>
+              <a:rPr lang="en-US" sz="950" dirty="0">
+                <a:solidFill>
+                  <a:srgbClr val="E0D6DE"/>
+                </a:solidFill>
+                <a:latin typeface="Inter"/>
+                <a:ea typeface="Inter"/>
+                <a:cs typeface="Inter"/>
+                <a:sym typeface="Inter"/>
+              </a:rPr>
+              <a:t>, </a:t>
+            </a:r>
+            <a:r>
+              <a:rPr lang="en-US" sz="950" dirty="0" err="1">
+                <a:solidFill>
+                  <a:srgbClr val="E0D6DE"/>
+                </a:solidFill>
+                <a:latin typeface="Inter"/>
+                <a:ea typeface="Inter"/>
+                <a:cs typeface="Inter"/>
+                <a:sym typeface="Inter"/>
+              </a:rPr>
+              <a:t>precio</a:t>
+            </a:r>
+            <a:r>
+              <a:rPr lang="en-US" sz="950" dirty="0">
+                <a:solidFill>
+                  <a:srgbClr val="E0D6DE"/>
+                </a:solidFill>
+                <a:latin typeface="Inter"/>
+                <a:ea typeface="Inter"/>
+                <a:cs typeface="Inter"/>
+                <a:sym typeface="Inter"/>
+              </a:rPr>
+              <a:t> y stock, y </a:t>
+            </a:r>
+            <a:r>
+              <a:rPr lang="en-US" sz="950" dirty="0" err="1">
+                <a:solidFill>
+                  <a:srgbClr val="E0D6DE"/>
+                </a:solidFill>
+                <a:latin typeface="Inter"/>
+                <a:ea typeface="Inter"/>
+                <a:cs typeface="Inter"/>
+                <a:sym typeface="Inter"/>
+              </a:rPr>
+              <a:t>desde</a:t>
+            </a:r>
+            <a:r>
+              <a:rPr lang="en-US" sz="950" dirty="0">
+                <a:solidFill>
+                  <a:srgbClr val="E0D6DE"/>
+                </a:solidFill>
+                <a:latin typeface="Inter"/>
+                <a:ea typeface="Inter"/>
+                <a:cs typeface="Inter"/>
+                <a:sym typeface="Inter"/>
+              </a:rPr>
+              <a:t> ahí se </a:t>
+            </a:r>
+            <a:r>
+              <a:rPr lang="en-US" sz="950" dirty="0" err="1">
+                <a:solidFill>
+                  <a:srgbClr val="E0D6DE"/>
+                </a:solidFill>
+                <a:latin typeface="Inter"/>
+                <a:ea typeface="Inter"/>
+                <a:cs typeface="Inter"/>
+                <a:sym typeface="Inter"/>
+              </a:rPr>
+              <a:t>agrega</a:t>
+            </a:r>
+            <a:r>
+              <a:rPr lang="en-US" sz="950" dirty="0">
+                <a:solidFill>
+                  <a:srgbClr val="E0D6DE"/>
+                </a:solidFill>
+                <a:latin typeface="Inter"/>
+                <a:ea typeface="Inter"/>
+                <a:cs typeface="Inter"/>
+                <a:sym typeface="Inter"/>
+              </a:rPr>
+              <a:t> al </a:t>
+            </a:r>
+            <a:r>
+              <a:rPr lang="en-US" sz="950" dirty="0" err="1">
+                <a:solidFill>
+                  <a:srgbClr val="E0D6DE"/>
+                </a:solidFill>
+                <a:latin typeface="Inter"/>
+                <a:ea typeface="Inter"/>
+                <a:cs typeface="Inter"/>
+                <a:sym typeface="Inter"/>
+              </a:rPr>
+              <a:t>carrito</a:t>
+            </a:r>
+            <a:r>
+              <a:rPr lang="en-US" sz="950" dirty="0">
+                <a:solidFill>
+                  <a:srgbClr val="E0D6DE"/>
+                </a:solidFill>
+                <a:latin typeface="Inter"/>
+                <a:ea typeface="Inter"/>
+                <a:cs typeface="Inter"/>
+                <a:sym typeface="Inter"/>
+              </a:rPr>
+              <a:t>, </a:t>
+            </a:r>
+            <a:r>
+              <a:rPr lang="en-US" sz="950" dirty="0" err="1">
+                <a:solidFill>
+                  <a:srgbClr val="E0D6DE"/>
+                </a:solidFill>
+                <a:latin typeface="Inter"/>
+                <a:ea typeface="Inter"/>
+                <a:cs typeface="Inter"/>
+                <a:sym typeface="Inter"/>
+              </a:rPr>
+              <a:t>donde</a:t>
+            </a:r>
+            <a:r>
+              <a:rPr lang="en-US" sz="950" dirty="0">
+                <a:solidFill>
+                  <a:srgbClr val="E0D6DE"/>
+                </a:solidFill>
+                <a:latin typeface="Inter"/>
+                <a:ea typeface="Inter"/>
+                <a:cs typeface="Inter"/>
+                <a:sym typeface="Inter"/>
+              </a:rPr>
+              <a:t> se </a:t>
+            </a:r>
+            <a:r>
+              <a:rPr lang="en-US" sz="950" dirty="0" err="1">
+                <a:solidFill>
+                  <a:srgbClr val="E0D6DE"/>
+                </a:solidFill>
+                <a:latin typeface="Inter"/>
+                <a:ea typeface="Inter"/>
+                <a:cs typeface="Inter"/>
+                <a:sym typeface="Inter"/>
+              </a:rPr>
+              <a:t>calcula</a:t>
+            </a:r>
+            <a:r>
+              <a:rPr lang="en-US" sz="950" dirty="0">
+                <a:solidFill>
+                  <a:srgbClr val="E0D6DE"/>
+                </a:solidFill>
+                <a:latin typeface="Inter"/>
+                <a:ea typeface="Inter"/>
+                <a:cs typeface="Inter"/>
+                <a:sym typeface="Inter"/>
+              </a:rPr>
+              <a:t> </a:t>
+            </a:r>
+            <a:r>
+              <a:rPr lang="en-US" sz="950" dirty="0" err="1">
+                <a:solidFill>
+                  <a:srgbClr val="E0D6DE"/>
+                </a:solidFill>
+                <a:latin typeface="Inter"/>
+                <a:ea typeface="Inter"/>
+                <a:cs typeface="Inter"/>
+                <a:sym typeface="Inter"/>
+              </a:rPr>
+              <a:t>automáticamente</a:t>
+            </a:r>
+            <a:r>
+              <a:rPr lang="en-US" sz="950" dirty="0">
+                <a:solidFill>
+                  <a:srgbClr val="E0D6DE"/>
+                </a:solidFill>
+                <a:latin typeface="Inter"/>
+                <a:ea typeface="Inter"/>
+                <a:cs typeface="Inter"/>
+                <a:sym typeface="Inter"/>
+              </a:rPr>
+              <a:t> el subtotal, el IVA y el total.</a:t>
+            </a:r>
+            <a:endParaRPr sz="950" dirty="0">
               <a:solidFill>
                 <a:schemeClr val="dk1"/>
               </a:solidFill>
@@ -6446,7 +7029,7 @@
       </p:sp>
       <p:pic>
         <p:nvPicPr>
-          <p:cNvPr id="81" name="Google Shape;81;g3fa6aa0c82d_0_1" title="Gemini_Generated_Image_jys8ygjys8ygjys8.jpg"/>
+          <p:cNvPr id="83" name="Google Shape;83;g3fa6aa0c82d_0_1"/>
           <p:cNvPicPr preferRelativeResize="0"/>
           <p:nvPr/>
         </p:nvPicPr>
@@ -6460,8 +7043,8 @@
         </p:blipFill>
         <p:spPr>
           <a:xfrm>
-            <a:off x="735875" y="1460866"/>
-            <a:ext cx="4839793" cy="2625493"/>
+            <a:off x="10982325" y="6115060"/>
+            <a:ext cx="1209675" cy="742950"/>
           </a:xfrm>
           <a:prstGeom prst="rect">
             <a:avLst/>
@@ -6474,58 +7057,62 @@
       </p:pic>
       <p:pic>
         <p:nvPicPr>
-          <p:cNvPr id="82" name="Google Shape;82;g3fa6aa0c82d_0_1"/>
-          <p:cNvPicPr preferRelativeResize="0"/>
+          <p:cNvPr id="3" name="Imagen 2">
+            <a:extLst>
+              <a:ext uri="{FF2B5EF4-FFF2-40B4-BE49-F238E27FC236}">
+                <a16:creationId xmlns:a16="http://schemas.microsoft.com/office/drawing/2014/main" id="{2B956242-4F04-1B28-F757-C9DE5C459973}"/>
+              </a:ext>
+            </a:extLst>
+          </p:cNvPr>
+          <p:cNvPicPr>
+            <a:picLocks noChangeAspect="1"/>
+          </p:cNvPicPr>
           <p:nvPr/>
         </p:nvPicPr>
         <p:blipFill>
-          <a:blip r:embed="rId4">
-            <a:alphaModFix/>
-          </a:blip>
+          <a:blip r:embed="rId4"/>
           <a:stretch>
             <a:fillRect/>
           </a:stretch>
         </p:blipFill>
         <p:spPr>
           <a:xfrm>
-            <a:off x="6505838" y="1460875"/>
-            <a:ext cx="5077926" cy="2625476"/>
-          </a:xfrm>
-          <a:prstGeom prst="rect">
-            <a:avLst/>
-          </a:prstGeom>
-          <a:noFill/>
-          <a:ln>
-            <a:noFill/>
-          </a:ln>
+            <a:off x="278035" y="1646481"/>
+            <a:ext cx="5615253" cy="3294979"/>
+          </a:xfrm>
+          <a:prstGeom prst="rect">
+            <a:avLst/>
+          </a:prstGeom>
         </p:spPr>
       </p:pic>
       <p:pic>
         <p:nvPicPr>
-          <p:cNvPr id="83" name="Google Shape;83;g3fa6aa0c82d_0_1"/>
-          <p:cNvPicPr preferRelativeResize="0"/>
+          <p:cNvPr id="5" name="Imagen 4">
+            <a:extLst>
+              <a:ext uri="{FF2B5EF4-FFF2-40B4-BE49-F238E27FC236}">
+                <a16:creationId xmlns:a16="http://schemas.microsoft.com/office/drawing/2014/main" id="{E41B05BC-EF69-A516-58C7-61C8286A0A09}"/>
+              </a:ext>
+            </a:extLst>
+          </p:cNvPr>
+          <p:cNvPicPr>
+            <a:picLocks noChangeAspect="1"/>
+          </p:cNvPicPr>
           <p:nvPr/>
         </p:nvPicPr>
         <p:blipFill>
-          <a:blip r:embed="rId5">
-            <a:alphaModFix/>
-          </a:blip>
+          <a:blip r:embed="rId5"/>
           <a:stretch>
             <a:fillRect/>
           </a:stretch>
         </p:blipFill>
         <p:spPr>
           <a:xfrm>
-            <a:off x="10982325" y="6115060"/>
-            <a:ext cx="1209675" cy="742950"/>
-          </a:xfrm>
-          <a:prstGeom prst="rect">
-            <a:avLst/>
-          </a:prstGeom>
-          <a:noFill/>
-          <a:ln>
-            <a:noFill/>
-          </a:ln>
+            <a:off x="6095825" y="1646480"/>
+            <a:ext cx="5818140" cy="3294979"/>
+          </a:xfrm>
+          <a:prstGeom prst="rect">
+            <a:avLst/>
+          </a:prstGeom>
         </p:spPr>
       </p:pic>
     </p:spTree>
@@ -6537,11 +7124,11 @@
 </file>
 
 <file path=ppt/slides/slide6.xml><?xml version="1.0" encoding="utf-8"?>
-<p:sld xmlns:a="http://schemas.openxmlformats.org/drawingml/2006/main" xmlns:r="http://schemas.openxmlformats.org/officeDocument/2006/relationships" xmlns:mc="http://schemas.openxmlformats.org/markup-compatibility/2006" xmlns:mv="urn:schemas-microsoft-com:mac:vml" xmlns:p="http://schemas.openxmlformats.org/presentationml/2006/main" xmlns:c="http://schemas.openxmlformats.org/drawingml/2006/chart" xmlns:dgm="http://schemas.openxmlformats.org/drawingml/2006/diagram" xmlns:o="urn:schemas-microsoft-com:office:office" xmlns:v="urn:schemas-microsoft-com:vml" xmlns:pvml="urn:schemas-microsoft-com:office:powerpoint" xmlns:com="http://schemas.openxmlformats.org/drawingml/2006/compatibility" xmlns:p14="http://schemas.microsoft.com/office/powerpoint/2010/main" xmlns:p15="http://schemas.microsoft.com/office/powerpoint/2012/main" xmlns:ahyp="http://schemas.microsoft.com/office/drawing/2018/hyperlinkcolor">
+<p:sld xmlns:a="http://schemas.openxmlformats.org/drawingml/2006/main" xmlns:r="http://schemas.openxmlformats.org/officeDocument/2006/relationships" xmlns:p="http://schemas.openxmlformats.org/presentationml/2006/main">
   <p:cSld>
     <p:spTree>
       <p:nvGrpSpPr>
-        <p:cNvPr id="88" name="Shape 88"/>
+        <p:cNvPr id="1" name="Shape 88"/>
         <p:cNvGrpSpPr/>
         <p:nvPr/>
       </p:nvGrpSpPr>
@@ -6573,12 +7160,12 @@
           </a:ln>
         </p:spPr>
         <p:txBody>
-          <a:bodyPr anchorCtr="0" anchor="t" bIns="0" lIns="0" spcFirstLastPara="1" rIns="0" wrap="square" tIns="0">
+          <a:bodyPr spcFirstLastPara="1" wrap="square" lIns="0" tIns="0" rIns="0" bIns="0" anchor="t" anchorCtr="0">
             <a:noAutofit/>
           </a:bodyPr>
           <a:lstStyle/>
           <a:p>
-            <a:pPr indent="0" lvl="0" marL="0" marR="0" rtl="0" algn="l">
+            <a:pPr marL="0" marR="0" lvl="0" indent="0" algn="l" rtl="0">
               <a:lnSpc>
                 <a:spcPct val="104000"/>
               </a:lnSpc>
@@ -6596,7 +7183,7 @@
               <a:buNone/>
             </a:pPr>
             <a:r>
-              <a:rPr b="1" lang="en-US" sz="3700">
+              <a:rPr lang="en-US" sz="3700" b="1">
                 <a:solidFill>
                   <a:srgbClr val="FF8AAF"/>
                 </a:solidFill>
@@ -6639,12 +7226,12 @@
           </a:ln>
         </p:spPr>
         <p:txBody>
-          <a:bodyPr anchorCtr="0" anchor="t" bIns="0" lIns="0" spcFirstLastPara="1" rIns="0" wrap="square" tIns="0">
+          <a:bodyPr spcFirstLastPara="1" wrap="square" lIns="0" tIns="0" rIns="0" bIns="0" anchor="t" anchorCtr="0">
             <a:normAutofit/>
           </a:bodyPr>
           <a:lstStyle/>
           <a:p>
-            <a:pPr indent="0" lvl="0" marL="0" marR="0" rtl="0" algn="l">
+            <a:pPr marL="0" marR="0" lvl="0" indent="0" algn="l" rtl="0">
               <a:lnSpc>
                 <a:spcPct val="130000"/>
               </a:lnSpc>
@@ -6684,7 +7271,7 @@
             </a:endParaRPr>
           </a:p>
           <a:p>
-            <a:pPr indent="0" lvl="0" marL="0" marR="0" rtl="0" algn="l">
+            <a:pPr marL="0" marR="0" lvl="0" indent="0" algn="l" rtl="0">
               <a:lnSpc>
                 <a:spcPct val="130000"/>
               </a:lnSpc>
@@ -6701,9 +7288,6 @@
               <a:buFont typeface="Inter"/>
               <a:buNone/>
             </a:pPr>
-            <a:r>
-              <a:t/>
-            </a:r>
             <a:endParaRPr>
               <a:solidFill>
                 <a:srgbClr val="E0D6DE"/>
@@ -6715,7 +7299,7 @@
             </a:endParaRPr>
           </a:p>
           <a:p>
-            <a:pPr indent="0" lvl="0" marL="0" marR="0" rtl="0" algn="l">
+            <a:pPr marL="0" marR="0" lvl="0" indent="0" algn="l" rtl="0">
               <a:lnSpc>
                 <a:spcPct val="130000"/>
               </a:lnSpc>
@@ -6755,7 +7339,7 @@
             </a:endParaRPr>
           </a:p>
           <a:p>
-            <a:pPr indent="0" lvl="0" marL="0" marR="0" rtl="0" algn="l">
+            <a:pPr marL="0" marR="0" lvl="0" indent="0" algn="l" rtl="0">
               <a:lnSpc>
                 <a:spcPct val="130000"/>
               </a:lnSpc>
@@ -6772,9 +7356,6 @@
               <a:buFont typeface="Inter"/>
               <a:buNone/>
             </a:pPr>
-            <a:r>
-              <a:t/>
-            </a:r>
             <a:endParaRPr>
               <a:solidFill>
                 <a:srgbClr val="E0D6DE"/>
@@ -6786,7 +7367,7 @@
             </a:endParaRPr>
           </a:p>
           <a:p>
-            <a:pPr indent="0" lvl="0" marL="0" marR="0" rtl="0" algn="l">
+            <a:pPr marL="0" marR="0" lvl="0" indent="0" algn="l" rtl="0">
               <a:lnSpc>
                 <a:spcPct val="130000"/>
               </a:lnSpc>
@@ -6892,11 +7473,11 @@
 </file>
 
 <file path=ppt/slides/slide7.xml><?xml version="1.0" encoding="utf-8"?>
-<p:sld xmlns:a="http://schemas.openxmlformats.org/drawingml/2006/main" xmlns:r="http://schemas.openxmlformats.org/officeDocument/2006/relationships" xmlns:mc="http://schemas.openxmlformats.org/markup-compatibility/2006" xmlns:mv="urn:schemas-microsoft-com:mac:vml" xmlns:p="http://schemas.openxmlformats.org/presentationml/2006/main" xmlns:c="http://schemas.openxmlformats.org/drawingml/2006/chart" xmlns:dgm="http://schemas.openxmlformats.org/drawingml/2006/diagram" xmlns:o="urn:schemas-microsoft-com:office:office" xmlns:v="urn:schemas-microsoft-com:vml" xmlns:pvml="urn:schemas-microsoft-com:office:powerpoint" xmlns:com="http://schemas.openxmlformats.org/drawingml/2006/compatibility" xmlns:p14="http://schemas.microsoft.com/office/powerpoint/2010/main" xmlns:p15="http://schemas.microsoft.com/office/powerpoint/2012/main" xmlns:ahyp="http://schemas.microsoft.com/office/drawing/2018/hyperlinkcolor">
+<p:sld xmlns:a="http://schemas.openxmlformats.org/drawingml/2006/main" xmlns:r="http://schemas.openxmlformats.org/officeDocument/2006/relationships" xmlns:p="http://schemas.openxmlformats.org/presentationml/2006/main">
   <p:cSld>
     <p:spTree>
       <p:nvGrpSpPr>
-        <p:cNvPr id="97" name="Shape 97"/>
+        <p:cNvPr id="1" name="Shape 97"/>
         <p:cNvGrpSpPr/>
         <p:nvPr/>
       </p:nvGrpSpPr>
@@ -6928,12 +7509,12 @@
           </a:ln>
         </p:spPr>
         <p:txBody>
-          <a:bodyPr anchorCtr="0" anchor="t" bIns="0" lIns="0" spcFirstLastPara="1" rIns="0" wrap="square" tIns="0">
+          <a:bodyPr spcFirstLastPara="1" wrap="square" lIns="0" tIns="0" rIns="0" bIns="0" anchor="t" anchorCtr="0">
             <a:noAutofit/>
           </a:bodyPr>
           <a:lstStyle/>
           <a:p>
-            <a:pPr indent="0" lvl="0" marL="0" marR="0" rtl="0" algn="l">
+            <a:pPr marL="0" marR="0" lvl="0" indent="0" algn="l" rtl="0">
               <a:lnSpc>
                 <a:spcPct val="104000"/>
               </a:lnSpc>
@@ -6951,7 +7532,7 @@
               <a:buNone/>
             </a:pPr>
             <a:r>
-              <a:rPr b="1" lang="en-US" sz="3900">
+              <a:rPr lang="en-US" sz="3900" b="1">
                 <a:solidFill>
                   <a:srgbClr val="FF8AAF"/>
                 </a:solidFill>
@@ -6976,7 +7557,7 @@
       </p:sp>
       <p:pic>
         <p:nvPicPr>
-          <p:cNvPr descr="preencoded.png" id="99" name="Google Shape;99;p6"/>
+          <p:cNvPr id="99" name="Google Shape;99;p6" descr="preencoded.png"/>
           <p:cNvPicPr preferRelativeResize="0"/>
           <p:nvPr/>
         </p:nvPicPr>
@@ -6984,7 +7565,7 @@
           <a:blip r:embed="rId3">
             <a:alphaModFix/>
           </a:blip>
-          <a:srcRect b="0" l="0" r="0" t="0"/>
+          <a:srcRect/>
           <a:stretch/>
         </p:blipFill>
         <p:spPr>
@@ -7021,12 +7602,12 @@
           </a:ln>
         </p:spPr>
         <p:txBody>
-          <a:bodyPr anchorCtr="0" anchor="t" bIns="0" lIns="0" spcFirstLastPara="1" rIns="0" wrap="square" tIns="0">
+          <a:bodyPr spcFirstLastPara="1" wrap="square" lIns="0" tIns="0" rIns="0" bIns="0" anchor="t" anchorCtr="0">
             <a:noAutofit/>
           </a:bodyPr>
           <a:lstStyle/>
           <a:p>
-            <a:pPr indent="0" lvl="0" marL="0" marR="0" rtl="0" algn="l">
+            <a:pPr marL="0" marR="0" lvl="0" indent="0" algn="l" rtl="0">
               <a:lnSpc>
                 <a:spcPct val="104000"/>
               </a:lnSpc>
@@ -7044,7 +7625,7 @@
               <a:buNone/>
             </a:pPr>
             <a:r>
-              <a:rPr b="1" lang="en-US" sz="1950">
+              <a:rPr lang="en-US" sz="1950" b="1">
                 <a:solidFill>
                   <a:srgbClr val="E0D6DE"/>
                 </a:solidFill>
@@ -7087,12 +7668,12 @@
           </a:ln>
         </p:spPr>
         <p:txBody>
-          <a:bodyPr anchorCtr="0" anchor="t" bIns="0" lIns="0" spcFirstLastPara="1" rIns="0" wrap="square" tIns="0">
+          <a:bodyPr spcFirstLastPara="1" wrap="square" lIns="0" tIns="0" rIns="0" bIns="0" anchor="t" anchorCtr="0">
             <a:normAutofit/>
           </a:bodyPr>
           <a:lstStyle/>
           <a:p>
-            <a:pPr indent="0" lvl="0" marL="0" marR="0" rtl="0" algn="l">
+            <a:pPr marL="0" marR="0" lvl="0" indent="0" algn="l" rtl="0">
               <a:lnSpc>
                 <a:spcPct val="133000"/>
               </a:lnSpc>
@@ -7150,7 +7731,7 @@
       </p:sp>
       <p:pic>
         <p:nvPicPr>
-          <p:cNvPr descr="preencoded.png" id="102" name="Google Shape;102;p6"/>
+          <p:cNvPr id="102" name="Google Shape;102;p6" descr="preencoded.png"/>
           <p:cNvPicPr preferRelativeResize="0"/>
           <p:nvPr/>
         </p:nvPicPr>
@@ -7158,7 +7739,7 @@
           <a:blip r:embed="rId4">
             <a:alphaModFix/>
           </a:blip>
-          <a:srcRect b="0" l="0" r="0" t="0"/>
+          <a:srcRect/>
           <a:stretch/>
         </p:blipFill>
         <p:spPr>
@@ -7195,12 +7776,12 @@
           </a:ln>
         </p:spPr>
         <p:txBody>
-          <a:bodyPr anchorCtr="0" anchor="t" bIns="0" lIns="0" spcFirstLastPara="1" rIns="0" wrap="square" tIns="0">
+          <a:bodyPr spcFirstLastPara="1" wrap="square" lIns="0" tIns="0" rIns="0" bIns="0" anchor="t" anchorCtr="0">
             <a:noAutofit/>
           </a:bodyPr>
           <a:lstStyle/>
           <a:p>
-            <a:pPr indent="0" lvl="0" marL="0" marR="0" rtl="0" algn="l">
+            <a:pPr marL="0" marR="0" lvl="0" indent="0" algn="l" rtl="0">
               <a:lnSpc>
                 <a:spcPct val="104000"/>
               </a:lnSpc>
@@ -7218,7 +7799,7 @@
               <a:buNone/>
             </a:pPr>
             <a:r>
-              <a:rPr b="1" lang="en-US" sz="1950">
+              <a:rPr lang="en-US" sz="1950" b="1">
                 <a:solidFill>
                   <a:srgbClr val="E0D6DE"/>
                 </a:solidFill>
@@ -7261,12 +7842,12 @@
           </a:ln>
         </p:spPr>
         <p:txBody>
-          <a:bodyPr anchorCtr="0" anchor="t" bIns="0" lIns="0" spcFirstLastPara="1" rIns="0" wrap="square" tIns="0">
+          <a:bodyPr spcFirstLastPara="1" wrap="square" lIns="0" tIns="0" rIns="0" bIns="0" anchor="t" anchorCtr="0">
             <a:normAutofit/>
           </a:bodyPr>
           <a:lstStyle/>
           <a:p>
-            <a:pPr indent="0" lvl="0" marL="0" marR="0" rtl="0" algn="l">
+            <a:pPr marL="0" marR="0" lvl="0" indent="0" algn="l" rtl="0">
               <a:lnSpc>
                 <a:spcPct val="133000"/>
               </a:lnSpc>
@@ -7309,7 +7890,7 @@
       </p:sp>
       <p:pic>
         <p:nvPicPr>
-          <p:cNvPr descr="preencoded.png" id="105" name="Google Shape;105;p6"/>
+          <p:cNvPr id="105" name="Google Shape;105;p6" descr="preencoded.png"/>
           <p:cNvPicPr preferRelativeResize="0"/>
           <p:nvPr/>
         </p:nvPicPr>
@@ -7317,7 +7898,7 @@
           <a:blip r:embed="rId5">
             <a:alphaModFix/>
           </a:blip>
-          <a:srcRect b="0" l="0" r="0" t="0"/>
+          <a:srcRect/>
           <a:stretch/>
         </p:blipFill>
         <p:spPr>
@@ -7354,12 +7935,12 @@
           </a:ln>
         </p:spPr>
         <p:txBody>
-          <a:bodyPr anchorCtr="0" anchor="t" bIns="0" lIns="0" spcFirstLastPara="1" rIns="0" wrap="square" tIns="0">
+          <a:bodyPr spcFirstLastPara="1" wrap="square" lIns="0" tIns="0" rIns="0" bIns="0" anchor="t" anchorCtr="0">
             <a:noAutofit/>
           </a:bodyPr>
           <a:lstStyle/>
           <a:p>
-            <a:pPr indent="0" lvl="0" marL="0" marR="0" rtl="0" algn="l">
+            <a:pPr marL="0" marR="0" lvl="0" indent="0" algn="l" rtl="0">
               <a:lnSpc>
                 <a:spcPct val="104000"/>
               </a:lnSpc>
@@ -7377,7 +7958,7 @@
               <a:buNone/>
             </a:pPr>
             <a:r>
-              <a:rPr b="1" lang="en-US" sz="1950">
+              <a:rPr lang="en-US" sz="1950" b="1">
                 <a:solidFill>
                   <a:srgbClr val="E0D6DE"/>
                 </a:solidFill>
@@ -7420,12 +8001,12 @@
           </a:ln>
         </p:spPr>
         <p:txBody>
-          <a:bodyPr anchorCtr="0" anchor="t" bIns="0" lIns="0" spcFirstLastPara="1" rIns="0" wrap="square" tIns="0">
+          <a:bodyPr spcFirstLastPara="1" wrap="square" lIns="0" tIns="0" rIns="0" bIns="0" anchor="t" anchorCtr="0">
             <a:normAutofit/>
           </a:bodyPr>
           <a:lstStyle/>
           <a:p>
-            <a:pPr indent="0" lvl="0" marL="0" marR="0" rtl="0" algn="l">
+            <a:pPr marL="0" marR="0" lvl="0" indent="0" algn="l" rtl="0">
               <a:lnSpc>
                 <a:spcPct val="133000"/>
               </a:lnSpc>
@@ -7559,11 +8140,11 @@
 </file>
 
 <file path=ppt/slides/slide8.xml><?xml version="1.0" encoding="utf-8"?>
-<p:sld xmlns:a="http://schemas.openxmlformats.org/drawingml/2006/main" xmlns:r="http://schemas.openxmlformats.org/officeDocument/2006/relationships" xmlns:mc="http://schemas.openxmlformats.org/markup-compatibility/2006" xmlns:mv="urn:schemas-microsoft-com:mac:vml" xmlns:p="http://schemas.openxmlformats.org/presentationml/2006/main" xmlns:c="http://schemas.openxmlformats.org/drawingml/2006/chart" xmlns:dgm="http://schemas.openxmlformats.org/drawingml/2006/diagram" xmlns:o="urn:schemas-microsoft-com:office:office" xmlns:v="urn:schemas-microsoft-com:vml" xmlns:pvml="urn:schemas-microsoft-com:office:powerpoint" xmlns:com="http://schemas.openxmlformats.org/drawingml/2006/compatibility" xmlns:p14="http://schemas.microsoft.com/office/powerpoint/2010/main" xmlns:p15="http://schemas.microsoft.com/office/powerpoint/2012/main" xmlns:ahyp="http://schemas.microsoft.com/office/drawing/2018/hyperlinkcolor">
+<p:sld xmlns:a="http://schemas.openxmlformats.org/drawingml/2006/main" xmlns:r="http://schemas.openxmlformats.org/officeDocument/2006/relationships" xmlns:p="http://schemas.openxmlformats.org/presentationml/2006/main">
   <p:cSld>
     <p:spTree>
       <p:nvGrpSpPr>
-        <p:cNvPr id="115" name="Shape 115"/>
+        <p:cNvPr id="1" name="Shape 115"/>
         <p:cNvGrpSpPr/>
         <p:nvPr/>
       </p:nvGrpSpPr>
@@ -7595,12 +8176,12 @@
           </a:ln>
         </p:spPr>
         <p:txBody>
-          <a:bodyPr anchorCtr="0" anchor="t" bIns="0" lIns="0" spcFirstLastPara="1" rIns="0" wrap="square" tIns="0">
+          <a:bodyPr spcFirstLastPara="1" wrap="square" lIns="0" tIns="0" rIns="0" bIns="0" anchor="t" anchorCtr="0">
             <a:noAutofit/>
           </a:bodyPr>
           <a:lstStyle/>
           <a:p>
-            <a:pPr indent="0" lvl="0" marL="0" marR="0" rtl="0" algn="l">
+            <a:pPr marL="0" marR="0" lvl="0" indent="0" algn="l" rtl="0">
               <a:lnSpc>
                 <a:spcPct val="104000"/>
               </a:lnSpc>
@@ -7618,7 +8199,7 @@
               <a:buNone/>
             </a:pPr>
             <a:r>
-              <a:rPr b="1" lang="en-US" sz="3050">
+              <a:rPr lang="en-US" sz="3050" b="1">
                 <a:solidFill>
                   <a:srgbClr val="FF8AAF"/>
                 </a:solidFill>
@@ -7734,11 +8315,11 @@
 </file>
 
 <file path=ppt/slides/slide9.xml><?xml version="1.0" encoding="utf-8"?>
-<p:sld xmlns:a="http://schemas.openxmlformats.org/drawingml/2006/main" xmlns:r="http://schemas.openxmlformats.org/officeDocument/2006/relationships" xmlns:mc="http://schemas.openxmlformats.org/markup-compatibility/2006" xmlns:mv="urn:schemas-microsoft-com:mac:vml" xmlns:p="http://schemas.openxmlformats.org/presentationml/2006/main" xmlns:c="http://schemas.openxmlformats.org/drawingml/2006/chart" xmlns:dgm="http://schemas.openxmlformats.org/drawingml/2006/diagram" xmlns:o="urn:schemas-microsoft-com:office:office" xmlns:v="urn:schemas-microsoft-com:vml" xmlns:pvml="urn:schemas-microsoft-com:office:powerpoint" xmlns:com="http://schemas.openxmlformats.org/drawingml/2006/compatibility" xmlns:p14="http://schemas.microsoft.com/office/powerpoint/2010/main" xmlns:p15="http://schemas.microsoft.com/office/powerpoint/2012/main" xmlns:ahyp="http://schemas.microsoft.com/office/drawing/2018/hyperlinkcolor">
+<p:sld xmlns:a="http://schemas.openxmlformats.org/drawingml/2006/main" xmlns:r="http://schemas.openxmlformats.org/officeDocument/2006/relationships" xmlns:p="http://schemas.openxmlformats.org/presentationml/2006/main">
   <p:cSld>
     <p:spTree>
       <p:nvGrpSpPr>
-        <p:cNvPr id="124" name="Shape 124"/>
+        <p:cNvPr id="1" name="Shape 124"/>
         <p:cNvGrpSpPr/>
         <p:nvPr/>
       </p:nvGrpSpPr>
@@ -7763,7 +8344,7 @@
           </a:xfrm>
           <a:prstGeom prst="roundRect">
             <a:avLst>
-              <a:gd fmla="val 22117" name="adj"/>
+              <a:gd name="adj" fmla="val 22117"/>
             </a:avLst>
           </a:prstGeom>
           <a:solidFill>
@@ -7774,12 +8355,12 @@
           </a:ln>
         </p:spPr>
         <p:txBody>
-          <a:bodyPr anchorCtr="0" anchor="t" bIns="45700" lIns="91425" spcFirstLastPara="1" rIns="91425" wrap="square" tIns="45700">
+          <a:bodyPr spcFirstLastPara="1" wrap="square" lIns="91425" tIns="45700" rIns="91425" bIns="45700" anchor="t" anchorCtr="0">
             <a:noAutofit/>
           </a:bodyPr>
           <a:lstStyle/>
           <a:p>
-            <a:pPr indent="0" lvl="0" marL="0" marR="0" rtl="0" algn="l">
+            <a:pPr marL="0" marR="0" lvl="0" indent="0" algn="l" rtl="0">
               <a:spcBef>
                 <a:spcPts val="0"/>
               </a:spcBef>
@@ -7788,9 +8369,6 @@
               </a:spcAft>
               <a:buNone/>
             </a:pPr>
-            <a:r>
-              <a:t/>
-            </a:r>
             <a:endParaRPr sz="1800">
               <a:solidFill>
                 <a:schemeClr val="dk1"/>
@@ -7823,12 +8401,12 @@
           </a:ln>
         </p:spPr>
         <p:txBody>
-          <a:bodyPr anchorCtr="0" anchor="t" bIns="0" lIns="0" spcFirstLastPara="1" rIns="0" wrap="square" tIns="0">
+          <a:bodyPr spcFirstLastPara="1" wrap="square" lIns="0" tIns="0" rIns="0" bIns="0" anchor="t" anchorCtr="0">
             <a:noAutofit/>
           </a:bodyPr>
           <a:lstStyle/>
           <a:p>
-            <a:pPr indent="0" lvl="0" marL="0" marR="0" rtl="0" algn="l">
+            <a:pPr marL="0" marR="0" lvl="0" indent="0" algn="l" rtl="0">
               <a:lnSpc>
                 <a:spcPct val="96000"/>
               </a:lnSpc>
@@ -7889,12 +8467,12 @@
           </a:ln>
         </p:spPr>
         <p:txBody>
-          <a:bodyPr anchorCtr="0" anchor="t" bIns="0" lIns="0" spcFirstLastPara="1" rIns="0" wrap="square" tIns="0">
+          <a:bodyPr spcFirstLastPara="1" wrap="square" lIns="0" tIns="0" rIns="0" bIns="0" anchor="t" anchorCtr="0">
             <a:noAutofit/>
           </a:bodyPr>
           <a:lstStyle/>
           <a:p>
-            <a:pPr indent="0" lvl="0" marL="0" marR="0" rtl="0" algn="l">
+            <a:pPr marL="0" marR="0" lvl="0" indent="0" algn="l" rtl="0">
               <a:lnSpc>
                 <a:spcPct val="104000"/>
               </a:lnSpc>
@@ -7912,7 +8490,7 @@
               <a:buNone/>
             </a:pPr>
             <a:r>
-              <a:rPr b="1" lang="en-US" sz="3800">
+              <a:rPr lang="en-US" sz="3800" b="1">
                 <a:solidFill>
                   <a:srgbClr val="FF8AAF"/>
                 </a:solidFill>
@@ -7955,12 +8533,12 @@
           </a:ln>
         </p:spPr>
         <p:txBody>
-          <a:bodyPr anchorCtr="0" anchor="t" bIns="0" lIns="0" spcFirstLastPara="1" rIns="0" wrap="square" tIns="0">
+          <a:bodyPr spcFirstLastPara="1" wrap="square" lIns="0" tIns="0" rIns="0" bIns="0" anchor="t" anchorCtr="0">
             <a:normAutofit/>
           </a:bodyPr>
           <a:lstStyle/>
           <a:p>
-            <a:pPr indent="0" lvl="0" marL="0" marR="0" rtl="0" algn="l">
+            <a:pPr marL="0" marR="0" lvl="0" indent="0" algn="l" rtl="0">
               <a:lnSpc>
                 <a:spcPct val="132000"/>
               </a:lnSpc>
@@ -8000,7 +8578,7 @@
             </a:endParaRPr>
           </a:p>
           <a:p>
-            <a:pPr indent="0" lvl="0" marL="0" marR="0" rtl="0" algn="l">
+            <a:pPr marL="0" marR="0" lvl="0" indent="0" algn="l" rtl="0">
               <a:lnSpc>
                 <a:spcPct val="132000"/>
               </a:lnSpc>
@@ -8017,9 +8595,6 @@
               <a:buFont typeface="Inter"/>
               <a:buNone/>
             </a:pPr>
-            <a:r>
-              <a:t/>
-            </a:r>
             <a:endParaRPr sz="1450">
               <a:solidFill>
                 <a:srgbClr val="E0D6DE"/>
@@ -8031,7 +8606,7 @@
             </a:endParaRPr>
           </a:p>
           <a:p>
-            <a:pPr indent="0" lvl="0" marL="0" marR="0" rtl="0" algn="l">
+            <a:pPr marL="0" marR="0" lvl="0" indent="0" algn="l" rtl="0">
               <a:lnSpc>
                 <a:spcPct val="132000"/>
               </a:lnSpc>
@@ -8071,7 +8646,7 @@
             </a:endParaRPr>
           </a:p>
           <a:p>
-            <a:pPr indent="0" lvl="0" marL="0" marR="0" rtl="0" algn="l">
+            <a:pPr marL="0" marR="0" lvl="0" indent="0" algn="l" rtl="0">
               <a:lnSpc>
                 <a:spcPct val="132000"/>
               </a:lnSpc>
@@ -8088,9 +8663,6 @@
               <a:buFont typeface="Inter"/>
               <a:buNone/>
             </a:pPr>
-            <a:r>
-              <a:t/>
-            </a:r>
             <a:endParaRPr sz="1450">
               <a:solidFill>
                 <a:srgbClr val="E0D6DE"/>
@@ -8102,7 +8674,7 @@
             </a:endParaRPr>
           </a:p>
           <a:p>
-            <a:pPr indent="0" lvl="0" marL="0" marR="0" rtl="0" algn="l">
+            <a:pPr marL="0" marR="0" lvl="0" indent="0" algn="l" rtl="0">
               <a:lnSpc>
                 <a:spcPct val="132000"/>
               </a:lnSpc>
@@ -8208,7 +8780,7 @@
 </file>
 
 <file path=ppt/theme/theme1.xml><?xml version="1.0" encoding="utf-8"?>
-<a:theme xmlns:a="http://schemas.openxmlformats.org/drawingml/2006/main" xmlns:r="http://schemas.openxmlformats.org/officeDocument/2006/relationships" name="Office Theme">
+<a:theme xmlns:a="http://schemas.openxmlformats.org/drawingml/2006/main" name="Office Theme">
   <a:themeElements>
     <a:clrScheme name="Office">
       <a:dk1>
@@ -8483,11 +9055,13 @@
       </a:bgFillStyleLst>
     </a:fmtScheme>
   </a:themeElements>
+  <a:objectDefaults/>
+  <a:extraClrSchemeLst/>
 </a:theme>
 </file>
 
 <file path=ppt/theme/theme2.xml><?xml version="1.0" encoding="utf-8"?>
-<a:theme xmlns:a="http://schemas.openxmlformats.org/drawingml/2006/main" xmlns:r="http://schemas.openxmlformats.org/officeDocument/2006/relationships" name="Tema de Office">
+<a:theme xmlns:a="http://schemas.openxmlformats.org/drawingml/2006/main" name="Tema de Office">
   <a:themeElements>
     <a:clrScheme name="Office">
       <a:dk1>
@@ -8762,5 +9336,7 @@
       </a:bgFillStyleLst>
     </a:fmtScheme>
   </a:themeElements>
+  <a:objectDefaults/>
+  <a:extraClrSchemeLst/>
 </a:theme>
 </file>
</xml_diff>

<commit_message>
docs: agrega presentacion final del proyecto
</commit_message>
<xml_diff>
--- a/docs/Sonido-Vivo (1).pptx
+++ b/docs/Sonido-Vivo (1).pptx
@@ -1,42 +1,49 @@
 
 <file path=ppt/presentation.xml><?xml version="1.0" encoding="utf-8"?>
-<p:presentation xmlns:a="http://schemas.openxmlformats.org/drawingml/2006/main" xmlns:r="http://schemas.openxmlformats.org/officeDocument/2006/relationships" xmlns:mc="http://schemas.openxmlformats.org/markup-compatibility/2006" xmlns:mv="urn:schemas-microsoft-com:mac:vml" xmlns:p="http://schemas.openxmlformats.org/presentationml/2006/main" xmlns:c="http://schemas.openxmlformats.org/drawingml/2006/chart" xmlns:dgm="http://schemas.openxmlformats.org/drawingml/2006/diagram" xmlns:o="urn:schemas-microsoft-com:office:office" xmlns:v="urn:schemas-microsoft-com:vml" xmlns:pvml="urn:schemas-microsoft-com:office:powerpoint" xmlns:com="http://schemas.openxmlformats.org/drawingml/2006/compatibility" xmlns:p14="http://schemas.microsoft.com/office/powerpoint/2010/main" xmlns:p15="http://schemas.microsoft.com/office/powerpoint/2012/main" xmlns:ahyp="http://schemas.microsoft.com/office/drawing/2018/hyperlinkcolor" autoCompressPictures="0" embedTrueTypeFonts="1" strictFirstAndLastChars="0" saveSubsetFonts="1">
+<p:presentation xmlns:a="http://schemas.openxmlformats.org/drawingml/2006/main" xmlns:r="http://schemas.openxmlformats.org/officeDocument/2006/relationships" xmlns:p="http://schemas.openxmlformats.org/presentationml/2006/main" strictFirstAndLastChars="0" embedTrueTypeFonts="1" saveSubsetFonts="1" autoCompressPictures="0">
   <p:sldMasterIdLst>
-    <p:sldMasterId id="2147483648" r:id="rId3"/>
+    <p:sldMasterId id="2147483648" r:id="rId1"/>
   </p:sldMasterIdLst>
   <p:notesMasterIdLst>
-    <p:notesMasterId r:id="rId4"/>
+    <p:notesMasterId r:id="rId12"/>
   </p:notesMasterIdLst>
   <p:sldIdLst>
-    <p:sldId id="256" r:id="rId5"/>
-    <p:sldId id="257" r:id="rId6"/>
-    <p:sldId id="258" r:id="rId7"/>
-    <p:sldId id="259" r:id="rId8"/>
-    <p:sldId id="260" r:id="rId9"/>
-    <p:sldId id="261" r:id="rId10"/>
-    <p:sldId id="262" r:id="rId11"/>
-    <p:sldId id="263" r:id="rId12"/>
-    <p:sldId id="264" r:id="rId13"/>
-    <p:sldId id="265" r:id="rId14"/>
+    <p:sldId id="256" r:id="rId2"/>
+    <p:sldId id="257" r:id="rId3"/>
+    <p:sldId id="258" r:id="rId4"/>
+    <p:sldId id="259" r:id="rId5"/>
+    <p:sldId id="260" r:id="rId6"/>
+    <p:sldId id="261" r:id="rId7"/>
+    <p:sldId id="262" r:id="rId8"/>
+    <p:sldId id="263" r:id="rId9"/>
+    <p:sldId id="264" r:id="rId10"/>
+    <p:sldId id="265" r:id="rId11"/>
   </p:sldIdLst>
-  <p:sldSz cy="6858000" cx="12192000"/>
+  <p:sldSz cx="12192000" cy="6858000"/>
   <p:notesSz cx="6858000" cy="12192000"/>
   <p:embeddedFontLst>
     <p:embeddedFont>
-      <p:font typeface="Inter"/>
-      <p:regular r:id="rId15"/>
-      <p:bold r:id="rId16"/>
-      <p:italic r:id="rId17"/>
-      <p:boldItalic r:id="rId18"/>
+      <p:font typeface="Consolas" panose="020B0609020204030204" pitchFamily="49" charset="0"/>
+      <p:regular r:id="rId13"/>
+      <p:bold r:id="rId14"/>
+      <p:italic r:id="rId15"/>
+      <p:boldItalic r:id="rId16"/>
     </p:embeddedFont>
     <p:embeddedFont>
-      <p:font typeface="Petrona"/>
-      <p:bold r:id="rId19"/>
+      <p:font typeface="Inter" panose="020B0604020202020204" charset="0"/>
+      <p:regular r:id="rId17"/>
+      <p:bold r:id="rId18"/>
+      <p:italic r:id="rId19"/>
       <p:boldItalic r:id="rId20"/>
+    </p:embeddedFont>
+    <p:embeddedFont>
+      <p:font typeface="Petrona" panose="020B0604020202020204" charset="0"/>
+      <p:bold r:id="rId21"/>
+      <p:boldItalic r:id="rId22"/>
     </p:embeddedFont>
   </p:embeddedFontLst>
   <p:defaultTextStyle>
-    <a:defPPr lvl="0" marR="0" rtl="0" algn="l">
+    <a:defPPr marR="0" lvl="0" algn="l" rtl="0">
       <a:lnSpc>
         <a:spcPct val="100000"/>
       </a:lnSpc>
@@ -47,7 +54,7 @@
         <a:spcPts val="0"/>
       </a:spcAft>
     </a:defPPr>
-    <a:lvl1pPr lvl="0" marR="0" rtl="0" algn="l">
+    <a:lvl1pPr marR="0" lvl="0" algn="l" rtl="0">
       <a:lnSpc>
         <a:spcPct val="100000"/>
       </a:lnSpc>
@@ -61,7 +68,7 @@
         <a:srgbClr val="000000"/>
       </a:buClr>
       <a:buFont typeface="Arial"/>
-      <a:defRPr b="0" i="0" spc="0" sz="1400" u="none" cap="none" strike="noStrike">
+      <a:defRPr sz="1400" b="0" i="0" u="none" strike="noStrike" cap="none" spc="0">
         <a:solidFill>
           <a:srgbClr val="000000"/>
         </a:solidFill>
@@ -71,7 +78,7 @@
         <a:sym typeface="Arial"/>
       </a:defRPr>
     </a:lvl1pPr>
-    <a:lvl2pPr lvl="1" marR="0" rtl="0" algn="l">
+    <a:lvl2pPr marR="0" lvl="1" algn="l" rtl="0">
       <a:lnSpc>
         <a:spcPct val="100000"/>
       </a:lnSpc>
@@ -85,7 +92,7 @@
         <a:srgbClr val="000000"/>
       </a:buClr>
       <a:buFont typeface="Arial"/>
-      <a:defRPr b="0" i="0" spc="0" sz="1400" u="none" cap="none" strike="noStrike">
+      <a:defRPr sz="1400" b="0" i="0" u="none" strike="noStrike" cap="none" spc="0">
         <a:solidFill>
           <a:srgbClr val="000000"/>
         </a:solidFill>
@@ -95,7 +102,7 @@
         <a:sym typeface="Arial"/>
       </a:defRPr>
     </a:lvl2pPr>
-    <a:lvl3pPr lvl="2" marR="0" rtl="0" algn="l">
+    <a:lvl3pPr marR="0" lvl="2" algn="l" rtl="0">
       <a:lnSpc>
         <a:spcPct val="100000"/>
       </a:lnSpc>
@@ -109,7 +116,7 @@
         <a:srgbClr val="000000"/>
       </a:buClr>
       <a:buFont typeface="Arial"/>
-      <a:defRPr b="0" i="0" spc="0" sz="1400" u="none" cap="none" strike="noStrike">
+      <a:defRPr sz="1400" b="0" i="0" u="none" strike="noStrike" cap="none" spc="0">
         <a:solidFill>
           <a:srgbClr val="000000"/>
         </a:solidFill>
@@ -119,7 +126,7 @@
         <a:sym typeface="Arial"/>
       </a:defRPr>
     </a:lvl3pPr>
-    <a:lvl4pPr lvl="3" marR="0" rtl="0" algn="l">
+    <a:lvl4pPr marR="0" lvl="3" algn="l" rtl="0">
       <a:lnSpc>
         <a:spcPct val="100000"/>
       </a:lnSpc>
@@ -133,7 +140,7 @@
         <a:srgbClr val="000000"/>
       </a:buClr>
       <a:buFont typeface="Arial"/>
-      <a:defRPr b="0" i="0" spc="0" sz="1400" u="none" cap="none" strike="noStrike">
+      <a:defRPr sz="1400" b="0" i="0" u="none" strike="noStrike" cap="none" spc="0">
         <a:solidFill>
           <a:srgbClr val="000000"/>
         </a:solidFill>
@@ -143,7 +150,7 @@
         <a:sym typeface="Arial"/>
       </a:defRPr>
     </a:lvl4pPr>
-    <a:lvl5pPr lvl="4" marR="0" rtl="0" algn="l">
+    <a:lvl5pPr marR="0" lvl="4" algn="l" rtl="0">
       <a:lnSpc>
         <a:spcPct val="100000"/>
       </a:lnSpc>
@@ -157,7 +164,7 @@
         <a:srgbClr val="000000"/>
       </a:buClr>
       <a:buFont typeface="Arial"/>
-      <a:defRPr b="0" i="0" spc="0" sz="1400" u="none" cap="none" strike="noStrike">
+      <a:defRPr sz="1400" b="0" i="0" u="none" strike="noStrike" cap="none" spc="0">
         <a:solidFill>
           <a:srgbClr val="000000"/>
         </a:solidFill>
@@ -167,7 +174,7 @@
         <a:sym typeface="Arial"/>
       </a:defRPr>
     </a:lvl5pPr>
-    <a:lvl6pPr lvl="5" marR="0" rtl="0" algn="l">
+    <a:lvl6pPr marR="0" lvl="5" algn="l" rtl="0">
       <a:lnSpc>
         <a:spcPct val="100000"/>
       </a:lnSpc>
@@ -181,7 +188,7 @@
         <a:srgbClr val="000000"/>
       </a:buClr>
       <a:buFont typeface="Arial"/>
-      <a:defRPr b="0" i="0" spc="0" sz="1400" u="none" cap="none" strike="noStrike">
+      <a:defRPr sz="1400" b="0" i="0" u="none" strike="noStrike" cap="none" spc="0">
         <a:solidFill>
           <a:srgbClr val="000000"/>
         </a:solidFill>
@@ -191,7 +198,7 @@
         <a:sym typeface="Arial"/>
       </a:defRPr>
     </a:lvl6pPr>
-    <a:lvl7pPr lvl="6" marR="0" rtl="0" algn="l">
+    <a:lvl7pPr marR="0" lvl="6" algn="l" rtl="0">
       <a:lnSpc>
         <a:spcPct val="100000"/>
       </a:lnSpc>
@@ -205,7 +212,7 @@
         <a:srgbClr val="000000"/>
       </a:buClr>
       <a:buFont typeface="Arial"/>
-      <a:defRPr b="0" i="0" spc="0" sz="1400" u="none" cap="none" strike="noStrike">
+      <a:defRPr sz="1400" b="0" i="0" u="none" strike="noStrike" cap="none" spc="0">
         <a:solidFill>
           <a:srgbClr val="000000"/>
         </a:solidFill>
@@ -215,7 +222,7 @@
         <a:sym typeface="Arial"/>
       </a:defRPr>
     </a:lvl7pPr>
-    <a:lvl8pPr lvl="7" marR="0" rtl="0" algn="l">
+    <a:lvl8pPr marR="0" lvl="7" algn="l" rtl="0">
       <a:lnSpc>
         <a:spcPct val="100000"/>
       </a:lnSpc>
@@ -229,7 +236,7 @@
         <a:srgbClr val="000000"/>
       </a:buClr>
       <a:buFont typeface="Arial"/>
-      <a:defRPr b="0" i="0" spc="0" sz="1400" u="none" cap="none" strike="noStrike">
+      <a:defRPr sz="1400" b="0" i="0" u="none" strike="noStrike" cap="none" spc="0">
         <a:solidFill>
           <a:srgbClr val="000000"/>
         </a:solidFill>
@@ -239,7 +246,7 @@
         <a:sym typeface="Arial"/>
       </a:defRPr>
     </a:lvl8pPr>
-    <a:lvl9pPr lvl="8" marR="0" rtl="0" algn="l">
+    <a:lvl9pPr marR="0" lvl="8" algn="l" rtl="0">
       <a:lnSpc>
         <a:spcPct val="100000"/>
       </a:lnSpc>
@@ -253,7 +260,7 @@
         <a:srgbClr val="000000"/>
       </a:buClr>
       <a:buFont typeface="Arial"/>
-      <a:defRPr b="0" i="0" spc="0" sz="1400" u="none" cap="none" strike="noStrike">
+      <a:defRPr sz="1400" b="0" i="0" u="none" strike="noStrike" cap="none" spc="0">
         <a:solidFill>
           <a:srgbClr val="000000"/>
         </a:solidFill>
@@ -266,25 +273,26 @@
   </p:defaultTextStyle>
   <p:extLst>
     <p:ext uri="GoogleSlidesCustomDataVersion2">
-      <go:slidesCustomData xmlns:go="http://customooxmlschemas.google.com/" r:id="rId21" roundtripDataSignature="AMtx7mh48V+udFt60gXffsQxkFb0dpTBtg=="/>
+      <go:slidesCustomData xmlns:go="http://customooxmlschemas.google.com/" xmlns:ahyp="http://schemas.microsoft.com/office/drawing/2018/hyperlinkcolor" xmlns:p15="http://schemas.microsoft.com/office/powerpoint/2012/main" xmlns:p14="http://schemas.microsoft.com/office/powerpoint/2010/main" xmlns:com="http://schemas.openxmlformats.org/drawingml/2006/compatibility" xmlns:pvml="urn:schemas-microsoft-com:office:powerpoint" xmlns:v="urn:schemas-microsoft-com:vml" xmlns:o="urn:schemas-microsoft-com:office:office" xmlns:dgm="http://schemas.openxmlformats.org/drawingml/2006/diagram" xmlns:c="http://schemas.openxmlformats.org/drawingml/2006/chart" xmlns:mv="urn:schemas-microsoft-com:mac:vml" xmlns:mc="http://schemas.openxmlformats.org/markup-compatibility/2006" xmlns="" r:id="rId23" roundtripDataSignature="AMtx7mh48V+udFt60gXffsQxkFb0dpTBtg=="/>
     </p:ext>
   </p:extLst>
 </p:presentation>
 </file>
 
 <file path=ppt/notesMasters/notesMaster1.xml><?xml version="1.0" encoding="utf-8"?>
-<p:notesMaster xmlns:a="http://schemas.openxmlformats.org/drawingml/2006/main" xmlns:r="http://schemas.openxmlformats.org/officeDocument/2006/relationships" xmlns:mc="http://schemas.openxmlformats.org/markup-compatibility/2006" xmlns:mv="urn:schemas-microsoft-com:mac:vml" xmlns:p="http://schemas.openxmlformats.org/presentationml/2006/main" xmlns:c="http://schemas.openxmlformats.org/drawingml/2006/chart" xmlns:dgm="http://schemas.openxmlformats.org/drawingml/2006/diagram" xmlns:o="urn:schemas-microsoft-com:office:office" xmlns:v="urn:schemas-microsoft-com:vml" xmlns:pvml="urn:schemas-microsoft-com:office:powerpoint" xmlns:com="http://schemas.openxmlformats.org/drawingml/2006/compatibility" xmlns:p14="http://schemas.microsoft.com/office/powerpoint/2010/main" xmlns:p15="http://schemas.microsoft.com/office/powerpoint/2012/main" xmlns:ahyp="http://schemas.microsoft.com/office/drawing/2018/hyperlinkcolor">
+<p:notesMaster xmlns:a="http://schemas.openxmlformats.org/drawingml/2006/main" xmlns:r="http://schemas.openxmlformats.org/officeDocument/2006/relationships" xmlns:p="http://schemas.openxmlformats.org/presentationml/2006/main">
   <p:cSld>
     <p:bg>
       <p:bgPr>
         <a:solidFill>
           <a:schemeClr val="lt1"/>
         </a:solidFill>
+        <a:effectLst/>
       </p:bgPr>
     </p:bg>
     <p:spTree>
       <p:nvGrpSpPr>
-        <p:cNvPr id="2" name="Shape 2"/>
+        <p:cNvPr id="1" name="Shape 2"/>
         <p:cNvGrpSpPr/>
         <p:nvPr/>
       </p:nvGrpSpPr>
@@ -299,9 +307,11 @@
       <p:sp>
         <p:nvSpPr>
           <p:cNvPr id="3" name="Google Shape;3;n"/>
-          <p:cNvSpPr/>
+          <p:cNvSpPr>
+            <a:spLocks noGrp="1" noRot="1" noChangeAspect="1"/>
+          </p:cNvSpPr>
           <p:nvPr>
-            <p:ph idx="2" type="sldImg"/>
+            <p:ph type="sldImg" idx="2"/>
           </p:nvPr>
         </p:nvSpPr>
         <p:spPr>
@@ -310,9 +320,13 @@
             <a:ext cx="4572225" cy="4572000"/>
           </a:xfrm>
           <a:custGeom>
-            <a:rect b="b" l="l" r="r" t="t"/>
+            <a:avLst/>
+            <a:gdLst/>
+            <a:ahLst/>
+            <a:cxnLst/>
+            <a:rect l="l" t="t" r="r" b="b"/>
             <a:pathLst>
-              <a:path extrusionOk="0" h="120000" w="120000">
+              <a:path w="120000" h="120000" extrusionOk="0">
                 <a:moveTo>
                   <a:pt x="0" y="0"/>
                 </a:moveTo>
@@ -330,23 +344,25 @@
             </a:pathLst>
           </a:custGeom>
           <a:noFill/>
-          <a:ln cap="flat" cmpd="sng" w="9525">
+          <a:ln w="9525" cap="flat" cmpd="sng">
             <a:solidFill>
               <a:srgbClr val="000000"/>
             </a:solidFill>
             <a:prstDash val="solid"/>
             <a:round/>
-            <a:headEnd len="sm" w="sm" type="none"/>
-            <a:tailEnd len="sm" w="sm" type="none"/>
+            <a:headEnd type="none" w="sm" len="sm"/>
+            <a:tailEnd type="none" w="sm" len="sm"/>
           </a:ln>
         </p:spPr>
       </p:sp>
       <p:sp>
         <p:nvSpPr>
           <p:cNvPr id="4" name="Google Shape;4;n"/>
-          <p:cNvSpPr txBox="1"/>
+          <p:cNvSpPr txBox="1">
+            <a:spLocks noGrp="1"/>
+          </p:cNvSpPr>
           <p:nvPr>
-            <p:ph idx="1" type="body"/>
+            <p:ph type="body" idx="1"/>
           </p:nvPr>
         </p:nvSpPr>
         <p:spPr>
@@ -363,11 +379,11 @@
           </a:ln>
         </p:spPr>
         <p:txBody>
-          <a:bodyPr anchorCtr="0" anchor="t" bIns="91425" lIns="91425" spcFirstLastPara="1" rIns="91425" wrap="square" tIns="91425">
+          <a:bodyPr spcFirstLastPara="1" wrap="square" lIns="91425" tIns="91425" rIns="91425" bIns="91425" anchor="t" anchorCtr="0">
             <a:noAutofit/>
           </a:bodyPr>
           <a:lstStyle>
-            <a:lvl1pPr indent="-298450" lvl="0" marL="457200">
+            <a:lvl1pPr marL="457200" lvl="0" indent="-298450">
               <a:spcBef>
                 <a:spcPts val="0"/>
               </a:spcBef>
@@ -378,7 +394,7 @@
               <a:buChar char="●"/>
               <a:defRPr sz="1100"/>
             </a:lvl1pPr>
-            <a:lvl2pPr indent="-298450" lvl="1" marL="914400">
+            <a:lvl2pPr marL="914400" lvl="1" indent="-298450">
               <a:spcBef>
                 <a:spcPts val="0"/>
               </a:spcBef>
@@ -389,7 +405,7 @@
               <a:buChar char="○"/>
               <a:defRPr sz="1100"/>
             </a:lvl2pPr>
-            <a:lvl3pPr indent="-298450" lvl="2" marL="1371600">
+            <a:lvl3pPr marL="1371600" lvl="2" indent="-298450">
               <a:spcBef>
                 <a:spcPts val="0"/>
               </a:spcBef>
@@ -400,7 +416,7 @@
               <a:buChar char="■"/>
               <a:defRPr sz="1100"/>
             </a:lvl3pPr>
-            <a:lvl4pPr indent="-298450" lvl="3" marL="1828800">
+            <a:lvl4pPr marL="1828800" lvl="3" indent="-298450">
               <a:spcBef>
                 <a:spcPts val="0"/>
               </a:spcBef>
@@ -411,7 +427,7 @@
               <a:buChar char="●"/>
               <a:defRPr sz="1100"/>
             </a:lvl4pPr>
-            <a:lvl5pPr indent="-298450" lvl="4" marL="2286000">
+            <a:lvl5pPr marL="2286000" lvl="4" indent="-298450">
               <a:spcBef>
                 <a:spcPts val="0"/>
               </a:spcBef>
@@ -422,7 +438,7 @@
               <a:buChar char="○"/>
               <a:defRPr sz="1100"/>
             </a:lvl5pPr>
-            <a:lvl6pPr indent="-298450" lvl="5" marL="2743200">
+            <a:lvl6pPr marL="2743200" lvl="5" indent="-298450">
               <a:spcBef>
                 <a:spcPts val="0"/>
               </a:spcBef>
@@ -433,7 +449,7 @@
               <a:buChar char="■"/>
               <a:defRPr sz="1100"/>
             </a:lvl6pPr>
-            <a:lvl7pPr indent="-298450" lvl="6" marL="3200400">
+            <a:lvl7pPr marL="3200400" lvl="6" indent="-298450">
               <a:spcBef>
                 <a:spcPts val="0"/>
               </a:spcBef>
@@ -444,7 +460,7 @@
               <a:buChar char="●"/>
               <a:defRPr sz="1100"/>
             </a:lvl7pPr>
-            <a:lvl8pPr indent="-298450" lvl="7" marL="3657600">
+            <a:lvl8pPr marL="3657600" lvl="7" indent="-298450">
               <a:spcBef>
                 <a:spcPts val="0"/>
               </a:spcBef>
@@ -455,7 +471,7 @@
               <a:buChar char="○"/>
               <a:defRPr sz="1100"/>
             </a:lvl8pPr>
-            <a:lvl9pPr indent="-298450" lvl="8" marL="4114800">
+            <a:lvl9pPr marL="4114800" lvl="8" indent="-298450">
               <a:spcBef>
                 <a:spcPts val="0"/>
               </a:spcBef>
@@ -467,14 +483,16 @@
               <a:defRPr sz="1100"/>
             </a:lvl9pPr>
           </a:lstStyle>
-          <a:p/>
+          <a:p>
+            <a:endParaRPr/>
+          </a:p>
         </p:txBody>
       </p:sp>
     </p:spTree>
   </p:cSld>
-  <p:clrMap accent1="accent1" accent2="accent2" accent3="accent3" accent4="accent4" accent5="accent5" accent6="accent6" bg1="lt1" bg2="dk2" tx1="dk1" tx2="lt2" folHlink="folHlink" hlink="hlink"/>
+  <p:clrMap bg1="lt1" tx1="dk1" bg2="dk2" tx2="lt2" accent1="accent1" accent2="accent2" accent3="accent3" accent4="accent4" accent5="accent5" accent6="accent6" hlink="hlink" folHlink="folHlink"/>
   <p:notesStyle>
-    <a:defPPr lvl="0" marR="0" rtl="0" algn="l">
+    <a:defPPr marR="0" lvl="0" algn="l" rtl="0">
       <a:lnSpc>
         <a:spcPct val="100000"/>
       </a:lnSpc>
@@ -485,7 +503,7 @@
         <a:spcPts val="0"/>
       </a:spcAft>
     </a:defPPr>
-    <a:lvl1pPr lvl="0" marR="0" rtl="0" algn="l">
+    <a:lvl1pPr marR="0" lvl="0" algn="l" rtl="0">
       <a:lnSpc>
         <a:spcPct val="100000"/>
       </a:lnSpc>
@@ -499,7 +517,7 @@
         <a:srgbClr val="000000"/>
       </a:buClr>
       <a:buFont typeface="Arial"/>
-      <a:defRPr b="0" i="0" spc="0" sz="1400" u="none" cap="none" strike="noStrike">
+      <a:defRPr sz="1400" b="0" i="0" u="none" strike="noStrike" cap="none" spc="0">
         <a:solidFill>
           <a:srgbClr val="000000"/>
         </a:solidFill>
@@ -509,7 +527,7 @@
         <a:sym typeface="Arial"/>
       </a:defRPr>
     </a:lvl1pPr>
-    <a:lvl2pPr lvl="1" marR="0" rtl="0" algn="l">
+    <a:lvl2pPr marR="0" lvl="1" algn="l" rtl="0">
       <a:lnSpc>
         <a:spcPct val="100000"/>
       </a:lnSpc>
@@ -523,7 +541,7 @@
         <a:srgbClr val="000000"/>
       </a:buClr>
       <a:buFont typeface="Arial"/>
-      <a:defRPr b="0" i="0" spc="0" sz="1400" u="none" cap="none" strike="noStrike">
+      <a:defRPr sz="1400" b="0" i="0" u="none" strike="noStrike" cap="none" spc="0">
         <a:solidFill>
           <a:srgbClr val="000000"/>
         </a:solidFill>
@@ -533,7 +551,7 @@
         <a:sym typeface="Arial"/>
       </a:defRPr>
     </a:lvl2pPr>
-    <a:lvl3pPr lvl="2" marR="0" rtl="0" algn="l">
+    <a:lvl3pPr marR="0" lvl="2" algn="l" rtl="0">
       <a:lnSpc>
         <a:spcPct val="100000"/>
       </a:lnSpc>
@@ -547,7 +565,7 @@
         <a:srgbClr val="000000"/>
       </a:buClr>
       <a:buFont typeface="Arial"/>
-      <a:defRPr b="0" i="0" spc="0" sz="1400" u="none" cap="none" strike="noStrike">
+      <a:defRPr sz="1400" b="0" i="0" u="none" strike="noStrike" cap="none" spc="0">
         <a:solidFill>
           <a:srgbClr val="000000"/>
         </a:solidFill>
@@ -557,7 +575,7 @@
         <a:sym typeface="Arial"/>
       </a:defRPr>
     </a:lvl3pPr>
-    <a:lvl4pPr lvl="3" marR="0" rtl="0" algn="l">
+    <a:lvl4pPr marR="0" lvl="3" algn="l" rtl="0">
       <a:lnSpc>
         <a:spcPct val="100000"/>
       </a:lnSpc>
@@ -571,7 +589,7 @@
         <a:srgbClr val="000000"/>
       </a:buClr>
       <a:buFont typeface="Arial"/>
-      <a:defRPr b="0" i="0" spc="0" sz="1400" u="none" cap="none" strike="noStrike">
+      <a:defRPr sz="1400" b="0" i="0" u="none" strike="noStrike" cap="none" spc="0">
         <a:solidFill>
           <a:srgbClr val="000000"/>
         </a:solidFill>
@@ -581,7 +599,7 @@
         <a:sym typeface="Arial"/>
       </a:defRPr>
     </a:lvl4pPr>
-    <a:lvl5pPr lvl="4" marR="0" rtl="0" algn="l">
+    <a:lvl5pPr marR="0" lvl="4" algn="l" rtl="0">
       <a:lnSpc>
         <a:spcPct val="100000"/>
       </a:lnSpc>
@@ -595,7 +613,7 @@
         <a:srgbClr val="000000"/>
       </a:buClr>
       <a:buFont typeface="Arial"/>
-      <a:defRPr b="0" i="0" spc="0" sz="1400" u="none" cap="none" strike="noStrike">
+      <a:defRPr sz="1400" b="0" i="0" u="none" strike="noStrike" cap="none" spc="0">
         <a:solidFill>
           <a:srgbClr val="000000"/>
         </a:solidFill>
@@ -605,7 +623,7 @@
         <a:sym typeface="Arial"/>
       </a:defRPr>
     </a:lvl5pPr>
-    <a:lvl6pPr lvl="5" marR="0" rtl="0" algn="l">
+    <a:lvl6pPr marR="0" lvl="5" algn="l" rtl="0">
       <a:lnSpc>
         <a:spcPct val="100000"/>
       </a:lnSpc>
@@ -619,7 +637,7 @@
         <a:srgbClr val="000000"/>
       </a:buClr>
       <a:buFont typeface="Arial"/>
-      <a:defRPr b="0" i="0" spc="0" sz="1400" u="none" cap="none" strike="noStrike">
+      <a:defRPr sz="1400" b="0" i="0" u="none" strike="noStrike" cap="none" spc="0">
         <a:solidFill>
           <a:srgbClr val="000000"/>
         </a:solidFill>
@@ -629,7 +647,7 @@
         <a:sym typeface="Arial"/>
       </a:defRPr>
     </a:lvl6pPr>
-    <a:lvl7pPr lvl="6" marR="0" rtl="0" algn="l">
+    <a:lvl7pPr marR="0" lvl="6" algn="l" rtl="0">
       <a:lnSpc>
         <a:spcPct val="100000"/>
       </a:lnSpc>
@@ -643,7 +661,7 @@
         <a:srgbClr val="000000"/>
       </a:buClr>
       <a:buFont typeface="Arial"/>
-      <a:defRPr b="0" i="0" spc="0" sz="1400" u="none" cap="none" strike="noStrike">
+      <a:defRPr sz="1400" b="0" i="0" u="none" strike="noStrike" cap="none" spc="0">
         <a:solidFill>
           <a:srgbClr val="000000"/>
         </a:solidFill>
@@ -653,7 +671,7 @@
         <a:sym typeface="Arial"/>
       </a:defRPr>
     </a:lvl7pPr>
-    <a:lvl8pPr lvl="7" marR="0" rtl="0" algn="l">
+    <a:lvl8pPr marR="0" lvl="7" algn="l" rtl="0">
       <a:lnSpc>
         <a:spcPct val="100000"/>
       </a:lnSpc>
@@ -667,7 +685,7 @@
         <a:srgbClr val="000000"/>
       </a:buClr>
       <a:buFont typeface="Arial"/>
-      <a:defRPr b="0" i="0" spc="0" sz="1400" u="none" cap="none" strike="noStrike">
+      <a:defRPr sz="1400" b="0" i="0" u="none" strike="noStrike" cap="none" spc="0">
         <a:solidFill>
           <a:srgbClr val="000000"/>
         </a:solidFill>
@@ -677,7 +695,7 @@
         <a:sym typeface="Arial"/>
       </a:defRPr>
     </a:lvl8pPr>
-    <a:lvl9pPr lvl="8" marR="0" rtl="0" algn="l">
+    <a:lvl9pPr marR="0" lvl="8" algn="l" rtl="0">
       <a:lnSpc>
         <a:spcPct val="100000"/>
       </a:lnSpc>
@@ -691,7 +709,7 @@
         <a:srgbClr val="000000"/>
       </a:buClr>
       <a:buFont typeface="Arial"/>
-      <a:defRPr b="0" i="0" spc="0" sz="1400" u="none" cap="none" strike="noStrike">
+      <a:defRPr sz="1400" b="0" i="0" u="none" strike="noStrike" cap="none" spc="0">
         <a:solidFill>
           <a:srgbClr val="000000"/>
         </a:solidFill>
@@ -706,11 +724,11 @@
 </file>
 
 <file path=ppt/notesSlides/notesSlide1.xml><?xml version="1.0" encoding="utf-8"?>
-<p:notes xmlns:a="http://schemas.openxmlformats.org/drawingml/2006/main" xmlns:r="http://schemas.openxmlformats.org/officeDocument/2006/relationships" xmlns:mc="http://schemas.openxmlformats.org/markup-compatibility/2006" xmlns:mv="urn:schemas-microsoft-com:mac:vml" xmlns:p="http://schemas.openxmlformats.org/presentationml/2006/main" xmlns:c="http://schemas.openxmlformats.org/drawingml/2006/chart" xmlns:dgm="http://schemas.openxmlformats.org/drawingml/2006/diagram" xmlns:o="urn:schemas-microsoft-com:office:office" xmlns:v="urn:schemas-microsoft-com:vml" xmlns:pvml="urn:schemas-microsoft-com:office:powerpoint" xmlns:com="http://schemas.openxmlformats.org/drawingml/2006/compatibility" xmlns:p14="http://schemas.microsoft.com/office/powerpoint/2010/main" xmlns:p15="http://schemas.microsoft.com/office/powerpoint/2012/main" xmlns:ahyp="http://schemas.microsoft.com/office/drawing/2018/hyperlinkcolor" showMasterPhAnim="0" showMasterSp="0">
+<p:notes xmlns:a="http://schemas.openxmlformats.org/drawingml/2006/main" xmlns:r="http://schemas.openxmlformats.org/officeDocument/2006/relationships" xmlns:p="http://schemas.openxmlformats.org/presentationml/2006/main" showMasterSp="0" showMasterPhAnim="0">
   <p:cSld>
     <p:spTree>
       <p:nvGrpSpPr>
-        <p:cNvPr id="11" name="Shape 11"/>
+        <p:cNvPr id="1" name="Shape 11"/>
         <p:cNvGrpSpPr/>
         <p:nvPr/>
       </p:nvGrpSpPr>
@@ -725,9 +743,11 @@
       <p:sp>
         <p:nvSpPr>
           <p:cNvPr id="12" name="Google Shape;12;p1:notes"/>
-          <p:cNvSpPr/>
+          <p:cNvSpPr>
+            <a:spLocks noGrp="1" noRot="1" noChangeAspect="1"/>
+          </p:cNvSpPr>
           <p:nvPr>
-            <p:ph idx="2" type="sldImg"/>
+            <p:ph type="sldImg" idx="2"/>
           </p:nvPr>
         </p:nvSpPr>
         <p:spPr>
@@ -736,9 +756,13 @@
             <a:ext cx="3000000" cy="3000000"/>
           </a:xfrm>
           <a:custGeom>
-            <a:rect b="b" l="l" r="r" t="t"/>
+            <a:avLst/>
+            <a:gdLst/>
+            <a:ahLst/>
+            <a:cxnLst/>
+            <a:rect l="l" t="t" r="r" b="b"/>
             <a:pathLst>
-              <a:path extrusionOk="0" h="120000" w="120000">
+              <a:path w="120000" h="120000" extrusionOk="0">
                 <a:moveTo>
                   <a:pt x="0" y="0"/>
                 </a:moveTo>
@@ -764,9 +788,11 @@
       <p:sp>
         <p:nvSpPr>
           <p:cNvPr id="13" name="Google Shape;13;p1:notes"/>
-          <p:cNvSpPr txBox="1"/>
+          <p:cNvSpPr txBox="1">
+            <a:spLocks noGrp="1"/>
+          </p:cNvSpPr>
           <p:nvPr>
-            <p:ph idx="1" type="body"/>
+            <p:ph type="body" idx="1"/>
           </p:nvPr>
         </p:nvSpPr>
         <p:spPr>
@@ -783,12 +809,12 @@
           </a:ln>
         </p:spPr>
         <p:txBody>
-          <a:bodyPr anchorCtr="0" anchor="t" bIns="45700" lIns="91425" spcFirstLastPara="1" rIns="91425" wrap="square" tIns="45700">
+          <a:bodyPr spcFirstLastPara="1" wrap="square" lIns="91425" tIns="45700" rIns="91425" bIns="45700" anchor="t" anchorCtr="0">
             <a:noAutofit/>
           </a:bodyPr>
           <a:lstStyle/>
           <a:p>
-            <a:pPr indent="0" lvl="0" marL="0" marR="0" rtl="0" algn="l">
+            <a:pPr marL="0" marR="0" lvl="0" indent="0" algn="l" rtl="0">
               <a:spcBef>
                 <a:spcPts val="0"/>
               </a:spcBef>
@@ -797,9 +823,6 @@
               </a:spcAft>
               <a:buNone/>
             </a:pPr>
-            <a:r>
-              <a:t/>
-            </a:r>
             <a:endParaRPr sz="1200">
               <a:solidFill>
                 <a:schemeClr val="dk1"/>
@@ -815,9 +838,11 @@
       <p:sp>
         <p:nvSpPr>
           <p:cNvPr id="14" name="Google Shape;14;p1:notes"/>
-          <p:cNvSpPr txBox="1"/>
+          <p:cNvSpPr txBox="1">
+            <a:spLocks noGrp="1"/>
+          </p:cNvSpPr>
           <p:nvPr>
-            <p:ph idx="12" type="sldNum"/>
+            <p:ph type="sldNum" idx="12"/>
           </p:nvPr>
         </p:nvSpPr>
         <p:spPr>
@@ -834,12 +859,12 @@
           </a:ln>
         </p:spPr>
         <p:txBody>
-          <a:bodyPr anchorCtr="0" anchor="t" bIns="45700" lIns="91425" spcFirstLastPara="1" rIns="91425" wrap="square" tIns="45700">
+          <a:bodyPr spcFirstLastPara="1" wrap="square" lIns="91425" tIns="45700" rIns="91425" bIns="45700" anchor="t" anchorCtr="0">
             <a:noAutofit/>
           </a:bodyPr>
           <a:lstStyle/>
           <a:p>
-            <a:pPr indent="0" lvl="0" marL="0" marR="0" rtl="0" algn="l">
+            <a:pPr marL="0" marR="0" lvl="0" indent="0" algn="l" rtl="0">
               <a:spcBef>
                 <a:spcPts val="0"/>
               </a:spcBef>
@@ -858,7 +883,7 @@
                 <a:cs typeface="Arial"/>
                 <a:sym typeface="Arial"/>
               </a:rPr>
-              <a:t>‹#›</a:t>
+              <a:t>1</a:t>
             </a:fld>
             <a:endParaRPr sz="1800">
               <a:solidFill>
@@ -881,11 +906,11 @@
 </file>
 
 <file path=ppt/notesSlides/notesSlide10.xml><?xml version="1.0" encoding="utf-8"?>
-<p:notes xmlns:a="http://schemas.openxmlformats.org/drawingml/2006/main" xmlns:r="http://schemas.openxmlformats.org/officeDocument/2006/relationships" xmlns:mc="http://schemas.openxmlformats.org/markup-compatibility/2006" xmlns:mv="urn:schemas-microsoft-com:mac:vml" xmlns:p="http://schemas.openxmlformats.org/presentationml/2006/main" xmlns:c="http://schemas.openxmlformats.org/drawingml/2006/chart" xmlns:dgm="http://schemas.openxmlformats.org/drawingml/2006/diagram" xmlns:o="urn:schemas-microsoft-com:office:office" xmlns:v="urn:schemas-microsoft-com:vml" xmlns:pvml="urn:schemas-microsoft-com:office:powerpoint" xmlns:com="http://schemas.openxmlformats.org/drawingml/2006/compatibility" xmlns:p14="http://schemas.microsoft.com/office/powerpoint/2010/main" xmlns:p15="http://schemas.microsoft.com/office/powerpoint/2012/main" xmlns:ahyp="http://schemas.microsoft.com/office/drawing/2018/hyperlinkcolor" showMasterPhAnim="0" showMasterSp="0">
+<p:notes xmlns:a="http://schemas.openxmlformats.org/drawingml/2006/main" xmlns:r="http://schemas.openxmlformats.org/officeDocument/2006/relationships" xmlns:p="http://schemas.openxmlformats.org/presentationml/2006/main" showMasterSp="0" showMasterPhAnim="0">
   <p:cSld>
     <p:spTree>
       <p:nvGrpSpPr>
-        <p:cNvPr id="131" name="Shape 131"/>
+        <p:cNvPr id="1" name="Shape 131"/>
         <p:cNvGrpSpPr/>
         <p:nvPr/>
       </p:nvGrpSpPr>
@@ -900,9 +925,11 @@
       <p:sp>
         <p:nvSpPr>
           <p:cNvPr id="132" name="Google Shape;132;p9:notes"/>
-          <p:cNvSpPr/>
+          <p:cNvSpPr>
+            <a:spLocks noGrp="1" noRot="1" noChangeAspect="1"/>
+          </p:cNvSpPr>
           <p:nvPr>
-            <p:ph idx="2" type="sldImg"/>
+            <p:ph type="sldImg" idx="2"/>
           </p:nvPr>
         </p:nvSpPr>
         <p:spPr>
@@ -911,9 +938,13 @@
             <a:ext cx="3000000" cy="3000000"/>
           </a:xfrm>
           <a:custGeom>
-            <a:rect b="b" l="l" r="r" t="t"/>
+            <a:avLst/>
+            <a:gdLst/>
+            <a:ahLst/>
+            <a:cxnLst/>
+            <a:rect l="l" t="t" r="r" b="b"/>
             <a:pathLst>
-              <a:path extrusionOk="0" h="120000" w="120000">
+              <a:path w="120000" h="120000" extrusionOk="0">
                 <a:moveTo>
                   <a:pt x="0" y="0"/>
                 </a:moveTo>
@@ -939,9 +970,11 @@
       <p:sp>
         <p:nvSpPr>
           <p:cNvPr id="133" name="Google Shape;133;p9:notes"/>
-          <p:cNvSpPr txBox="1"/>
+          <p:cNvSpPr txBox="1">
+            <a:spLocks noGrp="1"/>
+          </p:cNvSpPr>
           <p:nvPr>
-            <p:ph idx="1" type="body"/>
+            <p:ph type="body" idx="1"/>
           </p:nvPr>
         </p:nvSpPr>
         <p:spPr>
@@ -958,12 +991,12 @@
           </a:ln>
         </p:spPr>
         <p:txBody>
-          <a:bodyPr anchorCtr="0" anchor="t" bIns="45700" lIns="91425" spcFirstLastPara="1" rIns="91425" wrap="square" tIns="45700">
+          <a:bodyPr spcFirstLastPara="1" wrap="square" lIns="91425" tIns="45700" rIns="91425" bIns="45700" anchor="t" anchorCtr="0">
             <a:noAutofit/>
           </a:bodyPr>
           <a:lstStyle/>
           <a:p>
-            <a:pPr indent="0" lvl="0" marL="0" marR="0" rtl="0" algn="l">
+            <a:pPr marL="0" marR="0" lvl="0" indent="0" algn="l" rtl="0">
               <a:spcBef>
                 <a:spcPts val="0"/>
               </a:spcBef>
@@ -972,9 +1005,6 @@
               </a:spcAft>
               <a:buNone/>
             </a:pPr>
-            <a:r>
-              <a:t/>
-            </a:r>
             <a:endParaRPr sz="1200">
               <a:solidFill>
                 <a:schemeClr val="dk1"/>
@@ -990,9 +1020,11 @@
       <p:sp>
         <p:nvSpPr>
           <p:cNvPr id="134" name="Google Shape;134;p9:notes"/>
-          <p:cNvSpPr txBox="1"/>
+          <p:cNvSpPr txBox="1">
+            <a:spLocks noGrp="1"/>
+          </p:cNvSpPr>
           <p:nvPr>
-            <p:ph idx="12" type="sldNum"/>
+            <p:ph type="sldNum" idx="12"/>
           </p:nvPr>
         </p:nvSpPr>
         <p:spPr>
@@ -1009,12 +1041,12 @@
           </a:ln>
         </p:spPr>
         <p:txBody>
-          <a:bodyPr anchorCtr="0" anchor="t" bIns="45700" lIns="91425" spcFirstLastPara="1" rIns="91425" wrap="square" tIns="45700">
+          <a:bodyPr spcFirstLastPara="1" wrap="square" lIns="91425" tIns="45700" rIns="91425" bIns="45700" anchor="t" anchorCtr="0">
             <a:noAutofit/>
           </a:bodyPr>
           <a:lstStyle/>
           <a:p>
-            <a:pPr indent="0" lvl="0" marL="0" marR="0" rtl="0" algn="l">
+            <a:pPr marL="0" marR="0" lvl="0" indent="0" algn="l" rtl="0">
               <a:spcBef>
                 <a:spcPts val="0"/>
               </a:spcBef>
@@ -1033,7 +1065,7 @@
                 <a:cs typeface="Arial"/>
                 <a:sym typeface="Arial"/>
               </a:rPr>
-              <a:t>‹#›</a:t>
+              <a:t>10</a:t>
             </a:fld>
             <a:endParaRPr sz="1800">
               <a:solidFill>
@@ -1056,11 +1088,11 @@
 </file>
 
 <file path=ppt/notesSlides/notesSlide2.xml><?xml version="1.0" encoding="utf-8"?>
-<p:notes xmlns:a="http://schemas.openxmlformats.org/drawingml/2006/main" xmlns:r="http://schemas.openxmlformats.org/officeDocument/2006/relationships" xmlns:mc="http://schemas.openxmlformats.org/markup-compatibility/2006" xmlns:mv="urn:schemas-microsoft-com:mac:vml" xmlns:p="http://schemas.openxmlformats.org/presentationml/2006/main" xmlns:c="http://schemas.openxmlformats.org/drawingml/2006/chart" xmlns:dgm="http://schemas.openxmlformats.org/drawingml/2006/diagram" xmlns:o="urn:schemas-microsoft-com:office:office" xmlns:v="urn:schemas-microsoft-com:vml" xmlns:pvml="urn:schemas-microsoft-com:office:powerpoint" xmlns:com="http://schemas.openxmlformats.org/drawingml/2006/compatibility" xmlns:p14="http://schemas.microsoft.com/office/powerpoint/2010/main" xmlns:p15="http://schemas.microsoft.com/office/powerpoint/2012/main" xmlns:ahyp="http://schemas.microsoft.com/office/drawing/2018/hyperlinkcolor" showMasterPhAnim="0" showMasterSp="0">
+<p:notes xmlns:a="http://schemas.openxmlformats.org/drawingml/2006/main" xmlns:r="http://schemas.openxmlformats.org/officeDocument/2006/relationships" xmlns:p="http://schemas.openxmlformats.org/presentationml/2006/main" showMasterSp="0" showMasterPhAnim="0">
   <p:cSld>
     <p:spTree>
       <p:nvGrpSpPr>
-        <p:cNvPr id="20" name="Shape 20"/>
+        <p:cNvPr id="1" name="Shape 20"/>
         <p:cNvGrpSpPr/>
         <p:nvPr/>
       </p:nvGrpSpPr>
@@ -1075,9 +1107,11 @@
       <p:sp>
         <p:nvSpPr>
           <p:cNvPr id="21" name="Google Shape;21;p2:notes"/>
-          <p:cNvSpPr/>
+          <p:cNvSpPr>
+            <a:spLocks noGrp="1" noRot="1" noChangeAspect="1"/>
+          </p:cNvSpPr>
           <p:nvPr>
-            <p:ph idx="2" type="sldImg"/>
+            <p:ph type="sldImg" idx="2"/>
           </p:nvPr>
         </p:nvSpPr>
         <p:spPr>
@@ -1086,9 +1120,13 @@
             <a:ext cx="3000000" cy="3000000"/>
           </a:xfrm>
           <a:custGeom>
-            <a:rect b="b" l="l" r="r" t="t"/>
+            <a:avLst/>
+            <a:gdLst/>
+            <a:ahLst/>
+            <a:cxnLst/>
+            <a:rect l="l" t="t" r="r" b="b"/>
             <a:pathLst>
-              <a:path extrusionOk="0" h="120000" w="120000">
+              <a:path w="120000" h="120000" extrusionOk="0">
                 <a:moveTo>
                   <a:pt x="0" y="0"/>
                 </a:moveTo>
@@ -1114,9 +1152,11 @@
       <p:sp>
         <p:nvSpPr>
           <p:cNvPr id="22" name="Google Shape;22;p2:notes"/>
-          <p:cNvSpPr txBox="1"/>
+          <p:cNvSpPr txBox="1">
+            <a:spLocks noGrp="1"/>
+          </p:cNvSpPr>
           <p:nvPr>
-            <p:ph idx="1" type="body"/>
+            <p:ph type="body" idx="1"/>
           </p:nvPr>
         </p:nvSpPr>
         <p:spPr>
@@ -1133,12 +1173,12 @@
           </a:ln>
         </p:spPr>
         <p:txBody>
-          <a:bodyPr anchorCtr="0" anchor="t" bIns="45700" lIns="91425" spcFirstLastPara="1" rIns="91425" wrap="square" tIns="45700">
+          <a:bodyPr spcFirstLastPara="1" wrap="square" lIns="91425" tIns="45700" rIns="91425" bIns="45700" anchor="t" anchorCtr="0">
             <a:noAutofit/>
           </a:bodyPr>
           <a:lstStyle/>
           <a:p>
-            <a:pPr indent="0" lvl="0" marL="0" marR="0" rtl="0" algn="l">
+            <a:pPr marL="0" marR="0" lvl="0" indent="0" algn="l" rtl="0">
               <a:spcBef>
                 <a:spcPts val="0"/>
               </a:spcBef>
@@ -1147,9 +1187,6 @@
               </a:spcAft>
               <a:buNone/>
             </a:pPr>
-            <a:r>
-              <a:t/>
-            </a:r>
             <a:endParaRPr sz="1200">
               <a:solidFill>
                 <a:schemeClr val="dk1"/>
@@ -1165,9 +1202,11 @@
       <p:sp>
         <p:nvSpPr>
           <p:cNvPr id="23" name="Google Shape;23;p2:notes"/>
-          <p:cNvSpPr txBox="1"/>
+          <p:cNvSpPr txBox="1">
+            <a:spLocks noGrp="1"/>
+          </p:cNvSpPr>
           <p:nvPr>
-            <p:ph idx="12" type="sldNum"/>
+            <p:ph type="sldNum" idx="12"/>
           </p:nvPr>
         </p:nvSpPr>
         <p:spPr>
@@ -1184,12 +1223,12 @@
           </a:ln>
         </p:spPr>
         <p:txBody>
-          <a:bodyPr anchorCtr="0" anchor="t" bIns="45700" lIns="91425" spcFirstLastPara="1" rIns="91425" wrap="square" tIns="45700">
+          <a:bodyPr spcFirstLastPara="1" wrap="square" lIns="91425" tIns="45700" rIns="91425" bIns="45700" anchor="t" anchorCtr="0">
             <a:noAutofit/>
           </a:bodyPr>
           <a:lstStyle/>
           <a:p>
-            <a:pPr indent="0" lvl="0" marL="0" marR="0" rtl="0" algn="l">
+            <a:pPr marL="0" marR="0" lvl="0" indent="0" algn="l" rtl="0">
               <a:spcBef>
                 <a:spcPts val="0"/>
               </a:spcBef>
@@ -1208,7 +1247,7 @@
                 <a:cs typeface="Arial"/>
                 <a:sym typeface="Arial"/>
               </a:rPr>
-              <a:t>‹#›</a:t>
+              <a:t>2</a:t>
             </a:fld>
             <a:endParaRPr sz="1800">
               <a:solidFill>
@@ -1231,11 +1270,11 @@
 </file>
 
 <file path=ppt/notesSlides/notesSlide3.xml><?xml version="1.0" encoding="utf-8"?>
-<p:notes xmlns:a="http://schemas.openxmlformats.org/drawingml/2006/main" xmlns:r="http://schemas.openxmlformats.org/officeDocument/2006/relationships" xmlns:mc="http://schemas.openxmlformats.org/markup-compatibility/2006" xmlns:mv="urn:schemas-microsoft-com:mac:vml" xmlns:p="http://schemas.openxmlformats.org/presentationml/2006/main" xmlns:c="http://schemas.openxmlformats.org/drawingml/2006/chart" xmlns:dgm="http://schemas.openxmlformats.org/drawingml/2006/diagram" xmlns:o="urn:schemas-microsoft-com:office:office" xmlns:v="urn:schemas-microsoft-com:vml" xmlns:pvml="urn:schemas-microsoft-com:office:powerpoint" xmlns:com="http://schemas.openxmlformats.org/drawingml/2006/compatibility" xmlns:p14="http://schemas.microsoft.com/office/powerpoint/2010/main" xmlns:p15="http://schemas.microsoft.com/office/powerpoint/2012/main" xmlns:ahyp="http://schemas.microsoft.com/office/drawing/2018/hyperlinkcolor" showMasterPhAnim="0" showMasterSp="0">
+<p:notes xmlns:a="http://schemas.openxmlformats.org/drawingml/2006/main" xmlns:r="http://schemas.openxmlformats.org/officeDocument/2006/relationships" xmlns:p="http://schemas.openxmlformats.org/presentationml/2006/main" showMasterSp="0" showMasterPhAnim="0">
   <p:cSld>
     <p:spTree>
       <p:nvGrpSpPr>
-        <p:cNvPr id="38" name="Shape 38"/>
+        <p:cNvPr id="1" name="Shape 38"/>
         <p:cNvGrpSpPr/>
         <p:nvPr/>
       </p:nvGrpSpPr>
@@ -1250,9 +1289,11 @@
       <p:sp>
         <p:nvSpPr>
           <p:cNvPr id="39" name="Google Shape;39;p3:notes"/>
-          <p:cNvSpPr/>
+          <p:cNvSpPr>
+            <a:spLocks noGrp="1" noRot="1" noChangeAspect="1"/>
+          </p:cNvSpPr>
           <p:nvPr>
-            <p:ph idx="2" type="sldImg"/>
+            <p:ph type="sldImg" idx="2"/>
           </p:nvPr>
         </p:nvSpPr>
         <p:spPr>
@@ -1261,9 +1302,13 @@
             <a:ext cx="3000000" cy="3000000"/>
           </a:xfrm>
           <a:custGeom>
-            <a:rect b="b" l="l" r="r" t="t"/>
+            <a:avLst/>
+            <a:gdLst/>
+            <a:ahLst/>
+            <a:cxnLst/>
+            <a:rect l="l" t="t" r="r" b="b"/>
             <a:pathLst>
-              <a:path extrusionOk="0" h="120000" w="120000">
+              <a:path w="120000" h="120000" extrusionOk="0">
                 <a:moveTo>
                   <a:pt x="0" y="0"/>
                 </a:moveTo>
@@ -1289,9 +1334,11 @@
       <p:sp>
         <p:nvSpPr>
           <p:cNvPr id="40" name="Google Shape;40;p3:notes"/>
-          <p:cNvSpPr txBox="1"/>
+          <p:cNvSpPr txBox="1">
+            <a:spLocks noGrp="1"/>
+          </p:cNvSpPr>
           <p:nvPr>
-            <p:ph idx="1" type="body"/>
+            <p:ph type="body" idx="1"/>
           </p:nvPr>
         </p:nvSpPr>
         <p:spPr>
@@ -1308,12 +1355,12 @@
           </a:ln>
         </p:spPr>
         <p:txBody>
-          <a:bodyPr anchorCtr="0" anchor="t" bIns="45700" lIns="91425" spcFirstLastPara="1" rIns="91425" wrap="square" tIns="45700">
+          <a:bodyPr spcFirstLastPara="1" wrap="square" lIns="91425" tIns="45700" rIns="91425" bIns="45700" anchor="t" anchorCtr="0">
             <a:noAutofit/>
           </a:bodyPr>
           <a:lstStyle/>
           <a:p>
-            <a:pPr indent="0" lvl="0" marL="0" marR="0" rtl="0" algn="l">
+            <a:pPr marL="0" marR="0" lvl="0" indent="0" algn="l" rtl="0">
               <a:spcBef>
                 <a:spcPts val="0"/>
               </a:spcBef>
@@ -1322,9 +1369,6 @@
               </a:spcAft>
               <a:buNone/>
             </a:pPr>
-            <a:r>
-              <a:t/>
-            </a:r>
             <a:endParaRPr sz="1200">
               <a:solidFill>
                 <a:schemeClr val="dk1"/>
@@ -1340,9 +1384,11 @@
       <p:sp>
         <p:nvSpPr>
           <p:cNvPr id="41" name="Google Shape;41;p3:notes"/>
-          <p:cNvSpPr txBox="1"/>
+          <p:cNvSpPr txBox="1">
+            <a:spLocks noGrp="1"/>
+          </p:cNvSpPr>
           <p:nvPr>
-            <p:ph idx="12" type="sldNum"/>
+            <p:ph type="sldNum" idx="12"/>
           </p:nvPr>
         </p:nvSpPr>
         <p:spPr>
@@ -1359,12 +1405,12 @@
           </a:ln>
         </p:spPr>
         <p:txBody>
-          <a:bodyPr anchorCtr="0" anchor="t" bIns="45700" lIns="91425" spcFirstLastPara="1" rIns="91425" wrap="square" tIns="45700">
+          <a:bodyPr spcFirstLastPara="1" wrap="square" lIns="91425" tIns="45700" rIns="91425" bIns="45700" anchor="t" anchorCtr="0">
             <a:noAutofit/>
           </a:bodyPr>
           <a:lstStyle/>
           <a:p>
-            <a:pPr indent="0" lvl="0" marL="0" marR="0" rtl="0" algn="l">
+            <a:pPr marL="0" marR="0" lvl="0" indent="0" algn="l" rtl="0">
               <a:spcBef>
                 <a:spcPts val="0"/>
               </a:spcBef>
@@ -1383,7 +1429,7 @@
                 <a:cs typeface="Arial"/>
                 <a:sym typeface="Arial"/>
               </a:rPr>
-              <a:t>‹#›</a:t>
+              <a:t>3</a:t>
             </a:fld>
             <a:endParaRPr sz="1800">
               <a:solidFill>
@@ -1406,11 +1452,11 @@
 </file>
 
 <file path=ppt/notesSlides/notesSlide4.xml><?xml version="1.0" encoding="utf-8"?>
-<p:notes xmlns:a="http://schemas.openxmlformats.org/drawingml/2006/main" xmlns:r="http://schemas.openxmlformats.org/officeDocument/2006/relationships" xmlns:mc="http://schemas.openxmlformats.org/markup-compatibility/2006" xmlns:mv="urn:schemas-microsoft-com:mac:vml" xmlns:p="http://schemas.openxmlformats.org/presentationml/2006/main" xmlns:c="http://schemas.openxmlformats.org/drawingml/2006/chart" xmlns:dgm="http://schemas.openxmlformats.org/drawingml/2006/diagram" xmlns:o="urn:schemas-microsoft-com:office:office" xmlns:v="urn:schemas-microsoft-com:vml" xmlns:pvml="urn:schemas-microsoft-com:office:powerpoint" xmlns:com="http://schemas.openxmlformats.org/drawingml/2006/compatibility" xmlns:p14="http://schemas.microsoft.com/office/powerpoint/2010/main" xmlns:p15="http://schemas.microsoft.com/office/powerpoint/2012/main" xmlns:ahyp="http://schemas.microsoft.com/office/drawing/2018/hyperlinkcolor" showMasterPhAnim="0" showMasterSp="0">
+<p:notes xmlns:a="http://schemas.openxmlformats.org/drawingml/2006/main" xmlns:r="http://schemas.openxmlformats.org/officeDocument/2006/relationships" xmlns:p="http://schemas.openxmlformats.org/presentationml/2006/main" showMasterSp="0" showMasterPhAnim="0">
   <p:cSld>
     <p:spTree>
       <p:nvGrpSpPr>
-        <p:cNvPr id="61" name="Shape 61"/>
+        <p:cNvPr id="1" name="Shape 61"/>
         <p:cNvGrpSpPr/>
         <p:nvPr/>
       </p:nvGrpSpPr>
@@ -1425,20 +1471,26 @@
       <p:sp>
         <p:nvSpPr>
           <p:cNvPr id="62" name="Google Shape;62;p4:notes"/>
-          <p:cNvSpPr/>
+          <p:cNvSpPr>
+            <a:spLocks noGrp="1" noRot="1" noChangeAspect="1"/>
+          </p:cNvSpPr>
           <p:nvPr>
-            <p:ph idx="2" type="sldImg"/>
+            <p:ph type="sldImg" idx="2"/>
           </p:nvPr>
         </p:nvSpPr>
         <p:spPr>
           <a:xfrm>
-            <a:off x="0" y="0"/>
-            <a:ext cx="3000000" cy="3000000"/>
+            <a:off x="-1166813" y="0"/>
+            <a:ext cx="5334001" cy="3000375"/>
           </a:xfrm>
           <a:custGeom>
-            <a:rect b="b" l="l" r="r" t="t"/>
+            <a:avLst/>
+            <a:gdLst/>
+            <a:ahLst/>
+            <a:cxnLst/>
+            <a:rect l="l" t="t" r="r" b="b"/>
             <a:pathLst>
-              <a:path extrusionOk="0" h="120000" w="120000">
+              <a:path w="120000" h="120000" extrusionOk="0">
                 <a:moveTo>
                   <a:pt x="0" y="0"/>
                 </a:moveTo>
@@ -1464,9 +1516,11 @@
       <p:sp>
         <p:nvSpPr>
           <p:cNvPr id="63" name="Google Shape;63;p4:notes"/>
-          <p:cNvSpPr txBox="1"/>
+          <p:cNvSpPr txBox="1">
+            <a:spLocks noGrp="1"/>
+          </p:cNvSpPr>
           <p:nvPr>
-            <p:ph idx="1" type="body"/>
+            <p:ph type="body" idx="1"/>
           </p:nvPr>
         </p:nvSpPr>
         <p:spPr>
@@ -1483,12 +1537,12 @@
           </a:ln>
         </p:spPr>
         <p:txBody>
-          <a:bodyPr anchorCtr="0" anchor="t" bIns="45700" lIns="91425" spcFirstLastPara="1" rIns="91425" wrap="square" tIns="45700">
+          <a:bodyPr spcFirstLastPara="1" wrap="square" lIns="91425" tIns="45700" rIns="91425" bIns="45700" anchor="t" anchorCtr="0">
             <a:noAutofit/>
           </a:bodyPr>
           <a:lstStyle/>
           <a:p>
-            <a:pPr indent="0" lvl="0" marL="0" marR="0" rtl="0" algn="l">
+            <a:pPr marL="0" marR="0" lvl="0" indent="0" algn="l" rtl="0">
               <a:spcBef>
                 <a:spcPts val="0"/>
               </a:spcBef>
@@ -1497,9 +1551,6 @@
               </a:spcAft>
               <a:buNone/>
             </a:pPr>
-            <a:r>
-              <a:t/>
-            </a:r>
             <a:endParaRPr sz="1200">
               <a:solidFill>
                 <a:schemeClr val="dk1"/>
@@ -1515,9 +1566,11 @@
       <p:sp>
         <p:nvSpPr>
           <p:cNvPr id="64" name="Google Shape;64;p4:notes"/>
-          <p:cNvSpPr txBox="1"/>
+          <p:cNvSpPr txBox="1">
+            <a:spLocks noGrp="1"/>
+          </p:cNvSpPr>
           <p:nvPr>
-            <p:ph idx="12" type="sldNum"/>
+            <p:ph type="sldNum" idx="12"/>
           </p:nvPr>
         </p:nvSpPr>
         <p:spPr>
@@ -1534,12 +1587,12 @@
           </a:ln>
         </p:spPr>
         <p:txBody>
-          <a:bodyPr anchorCtr="0" anchor="t" bIns="45700" lIns="91425" spcFirstLastPara="1" rIns="91425" wrap="square" tIns="45700">
+          <a:bodyPr spcFirstLastPara="1" wrap="square" lIns="91425" tIns="45700" rIns="91425" bIns="45700" anchor="t" anchorCtr="0">
             <a:noAutofit/>
           </a:bodyPr>
           <a:lstStyle/>
           <a:p>
-            <a:pPr indent="0" lvl="0" marL="0" marR="0" rtl="0" algn="l">
+            <a:pPr marL="0" marR="0" lvl="0" indent="0" algn="l" rtl="0">
               <a:spcBef>
                 <a:spcPts val="0"/>
               </a:spcBef>
@@ -1558,7 +1611,7 @@
                 <a:cs typeface="Arial"/>
                 <a:sym typeface="Arial"/>
               </a:rPr>
-              <a:t>‹#›</a:t>
+              <a:t>4</a:t>
             </a:fld>
             <a:endParaRPr sz="1800">
               <a:solidFill>
@@ -1581,11 +1634,11 @@
 </file>
 
 <file path=ppt/notesSlides/notesSlide5.xml><?xml version="1.0" encoding="utf-8"?>
-<p:notes xmlns:a="http://schemas.openxmlformats.org/drawingml/2006/main" xmlns:r="http://schemas.openxmlformats.org/officeDocument/2006/relationships" xmlns:mc="http://schemas.openxmlformats.org/markup-compatibility/2006" xmlns:mv="urn:schemas-microsoft-com:mac:vml" xmlns:p="http://schemas.openxmlformats.org/presentationml/2006/main" xmlns:c="http://schemas.openxmlformats.org/drawingml/2006/chart" xmlns:dgm="http://schemas.openxmlformats.org/drawingml/2006/diagram" xmlns:o="urn:schemas-microsoft-com:office:office" xmlns:v="urn:schemas-microsoft-com:vml" xmlns:pvml="urn:schemas-microsoft-com:office:powerpoint" xmlns:com="http://schemas.openxmlformats.org/drawingml/2006/compatibility" xmlns:p14="http://schemas.microsoft.com/office/powerpoint/2010/main" xmlns:p15="http://schemas.microsoft.com/office/powerpoint/2012/main" xmlns:ahyp="http://schemas.microsoft.com/office/drawing/2018/hyperlinkcolor" showMasterPhAnim="0" showMasterSp="0">
+<p:notes xmlns:a="http://schemas.openxmlformats.org/drawingml/2006/main" xmlns:r="http://schemas.openxmlformats.org/officeDocument/2006/relationships" xmlns:p="http://schemas.openxmlformats.org/presentationml/2006/main" showMasterSp="0" showMasterPhAnim="0">
   <p:cSld>
     <p:spTree>
       <p:nvGrpSpPr>
-        <p:cNvPr id="72" name="Shape 72"/>
+        <p:cNvPr id="1" name="Shape 72"/>
         <p:cNvGrpSpPr/>
         <p:nvPr/>
       </p:nvGrpSpPr>
@@ -1600,20 +1653,26 @@
       <p:sp>
         <p:nvSpPr>
           <p:cNvPr id="73" name="Google Shape;73;g3fa6aa0c82d_0_1:notes"/>
-          <p:cNvSpPr/>
+          <p:cNvSpPr>
+            <a:spLocks noGrp="1" noRot="1" noChangeAspect="1"/>
+          </p:cNvSpPr>
           <p:nvPr>
-            <p:ph idx="2" type="sldImg"/>
+            <p:ph type="sldImg" idx="2"/>
           </p:nvPr>
         </p:nvSpPr>
         <p:spPr>
           <a:xfrm>
-            <a:off x="0" y="0"/>
-            <a:ext cx="3000000" cy="3000000"/>
+            <a:off x="-1166813" y="0"/>
+            <a:ext cx="5334001" cy="3000375"/>
           </a:xfrm>
           <a:custGeom>
-            <a:rect b="b" l="l" r="r" t="t"/>
+            <a:avLst/>
+            <a:gdLst/>
+            <a:ahLst/>
+            <a:cxnLst/>
+            <a:rect l="l" t="t" r="r" b="b"/>
             <a:pathLst>
-              <a:path extrusionOk="0" h="120000" w="120000">
+              <a:path w="120000" h="120000" extrusionOk="0">
                 <a:moveTo>
                   <a:pt x="0" y="0"/>
                 </a:moveTo>
@@ -1639,9 +1698,11 @@
       <p:sp>
         <p:nvSpPr>
           <p:cNvPr id="74" name="Google Shape;74;g3fa6aa0c82d_0_1:notes"/>
-          <p:cNvSpPr txBox="1"/>
+          <p:cNvSpPr txBox="1">
+            <a:spLocks noGrp="1"/>
+          </p:cNvSpPr>
           <p:nvPr>
-            <p:ph idx="1" type="body"/>
+            <p:ph type="body" idx="1"/>
           </p:nvPr>
         </p:nvSpPr>
         <p:spPr>
@@ -1658,12 +1719,12 @@
           </a:ln>
         </p:spPr>
         <p:txBody>
-          <a:bodyPr anchorCtr="0" anchor="t" bIns="45700" lIns="91425" spcFirstLastPara="1" rIns="91425" wrap="square" tIns="45700">
+          <a:bodyPr spcFirstLastPara="1" wrap="square" lIns="91425" tIns="45700" rIns="91425" bIns="45700" anchor="t" anchorCtr="0">
             <a:noAutofit/>
           </a:bodyPr>
           <a:lstStyle/>
           <a:p>
-            <a:pPr indent="0" lvl="0" marL="0" marR="0" rtl="0" algn="l">
+            <a:pPr marL="0" marR="0" lvl="0" indent="0" algn="l" rtl="0">
               <a:spcBef>
                 <a:spcPts val="0"/>
               </a:spcBef>
@@ -1672,9 +1733,6 @@
               </a:spcAft>
               <a:buNone/>
             </a:pPr>
-            <a:r>
-              <a:t/>
-            </a:r>
             <a:endParaRPr sz="1200">
               <a:solidFill>
                 <a:schemeClr val="dk1"/>
@@ -1690,9 +1748,11 @@
       <p:sp>
         <p:nvSpPr>
           <p:cNvPr id="75" name="Google Shape;75;g3fa6aa0c82d_0_1:notes"/>
-          <p:cNvSpPr txBox="1"/>
+          <p:cNvSpPr txBox="1">
+            <a:spLocks noGrp="1"/>
+          </p:cNvSpPr>
           <p:nvPr>
-            <p:ph idx="12" type="sldNum"/>
+            <p:ph type="sldNum" idx="12"/>
           </p:nvPr>
         </p:nvSpPr>
         <p:spPr>
@@ -1709,12 +1769,12 @@
           </a:ln>
         </p:spPr>
         <p:txBody>
-          <a:bodyPr anchorCtr="0" anchor="t" bIns="45700" lIns="91425" spcFirstLastPara="1" rIns="91425" wrap="square" tIns="45700">
+          <a:bodyPr spcFirstLastPara="1" wrap="square" lIns="91425" tIns="45700" rIns="91425" bIns="45700" anchor="t" anchorCtr="0">
             <a:noAutofit/>
           </a:bodyPr>
           <a:lstStyle/>
           <a:p>
-            <a:pPr indent="0" lvl="0" marL="0" marR="0" rtl="0" algn="l">
+            <a:pPr marL="0" marR="0" lvl="0" indent="0" algn="l" rtl="0">
               <a:spcBef>
                 <a:spcPts val="0"/>
               </a:spcBef>
@@ -1733,7 +1793,7 @@
                 <a:cs typeface="Arial"/>
                 <a:sym typeface="Arial"/>
               </a:rPr>
-              <a:t>‹#›</a:t>
+              <a:t>5</a:t>
             </a:fld>
             <a:endParaRPr sz="1800">
               <a:solidFill>
@@ -1756,11 +1816,11 @@
 </file>
 
 <file path=ppt/notesSlides/notesSlide6.xml><?xml version="1.0" encoding="utf-8"?>
-<p:notes xmlns:a="http://schemas.openxmlformats.org/drawingml/2006/main" xmlns:r="http://schemas.openxmlformats.org/officeDocument/2006/relationships" xmlns:mc="http://schemas.openxmlformats.org/markup-compatibility/2006" xmlns:mv="urn:schemas-microsoft-com:mac:vml" xmlns:p="http://schemas.openxmlformats.org/presentationml/2006/main" xmlns:c="http://schemas.openxmlformats.org/drawingml/2006/chart" xmlns:dgm="http://schemas.openxmlformats.org/drawingml/2006/diagram" xmlns:o="urn:schemas-microsoft-com:office:office" xmlns:v="urn:schemas-microsoft-com:vml" xmlns:pvml="urn:schemas-microsoft-com:office:powerpoint" xmlns:com="http://schemas.openxmlformats.org/drawingml/2006/compatibility" xmlns:p14="http://schemas.microsoft.com/office/powerpoint/2010/main" xmlns:p15="http://schemas.microsoft.com/office/powerpoint/2012/main" xmlns:ahyp="http://schemas.microsoft.com/office/drawing/2018/hyperlinkcolor" showMasterPhAnim="0" showMasterSp="0">
+<p:notes xmlns:a="http://schemas.openxmlformats.org/drawingml/2006/main" xmlns:r="http://schemas.openxmlformats.org/officeDocument/2006/relationships" xmlns:p="http://schemas.openxmlformats.org/presentationml/2006/main" showMasterSp="0" showMasterPhAnim="0">
   <p:cSld>
     <p:spTree>
       <p:nvGrpSpPr>
-        <p:cNvPr id="84" name="Shape 84"/>
+        <p:cNvPr id="1" name="Shape 84"/>
         <p:cNvGrpSpPr/>
         <p:nvPr/>
       </p:nvGrpSpPr>
@@ -1775,9 +1835,11 @@
       <p:sp>
         <p:nvSpPr>
           <p:cNvPr id="85" name="Google Shape;85;p5:notes"/>
-          <p:cNvSpPr/>
+          <p:cNvSpPr>
+            <a:spLocks noGrp="1" noRot="1" noChangeAspect="1"/>
+          </p:cNvSpPr>
           <p:nvPr>
-            <p:ph idx="2" type="sldImg"/>
+            <p:ph type="sldImg" idx="2"/>
           </p:nvPr>
         </p:nvSpPr>
         <p:spPr>
@@ -1786,9 +1848,13 @@
             <a:ext cx="3000000" cy="3000000"/>
           </a:xfrm>
           <a:custGeom>
-            <a:rect b="b" l="l" r="r" t="t"/>
+            <a:avLst/>
+            <a:gdLst/>
+            <a:ahLst/>
+            <a:cxnLst/>
+            <a:rect l="l" t="t" r="r" b="b"/>
             <a:pathLst>
-              <a:path extrusionOk="0" h="120000" w="120000">
+              <a:path w="120000" h="120000" extrusionOk="0">
                 <a:moveTo>
                   <a:pt x="0" y="0"/>
                 </a:moveTo>
@@ -1814,9 +1880,11 @@
       <p:sp>
         <p:nvSpPr>
           <p:cNvPr id="86" name="Google Shape;86;p5:notes"/>
-          <p:cNvSpPr txBox="1"/>
+          <p:cNvSpPr txBox="1">
+            <a:spLocks noGrp="1"/>
+          </p:cNvSpPr>
           <p:nvPr>
-            <p:ph idx="1" type="body"/>
+            <p:ph type="body" idx="1"/>
           </p:nvPr>
         </p:nvSpPr>
         <p:spPr>
@@ -1833,12 +1901,12 @@
           </a:ln>
         </p:spPr>
         <p:txBody>
-          <a:bodyPr anchorCtr="0" anchor="t" bIns="45700" lIns="91425" spcFirstLastPara="1" rIns="91425" wrap="square" tIns="45700">
+          <a:bodyPr spcFirstLastPara="1" wrap="square" lIns="91425" tIns="45700" rIns="91425" bIns="45700" anchor="t" anchorCtr="0">
             <a:noAutofit/>
           </a:bodyPr>
           <a:lstStyle/>
           <a:p>
-            <a:pPr indent="0" lvl="0" marL="0" marR="0" rtl="0" algn="l">
+            <a:pPr marL="0" marR="0" lvl="0" indent="0" algn="l" rtl="0">
               <a:spcBef>
                 <a:spcPts val="0"/>
               </a:spcBef>
@@ -1847,9 +1915,6 @@
               </a:spcAft>
               <a:buNone/>
             </a:pPr>
-            <a:r>
-              <a:t/>
-            </a:r>
             <a:endParaRPr sz="1200">
               <a:solidFill>
                 <a:schemeClr val="dk1"/>
@@ -1865,9 +1930,11 @@
       <p:sp>
         <p:nvSpPr>
           <p:cNvPr id="87" name="Google Shape;87;p5:notes"/>
-          <p:cNvSpPr txBox="1"/>
+          <p:cNvSpPr txBox="1">
+            <a:spLocks noGrp="1"/>
+          </p:cNvSpPr>
           <p:nvPr>
-            <p:ph idx="12" type="sldNum"/>
+            <p:ph type="sldNum" idx="12"/>
           </p:nvPr>
         </p:nvSpPr>
         <p:spPr>
@@ -1884,12 +1951,12 @@
           </a:ln>
         </p:spPr>
         <p:txBody>
-          <a:bodyPr anchorCtr="0" anchor="t" bIns="45700" lIns="91425" spcFirstLastPara="1" rIns="91425" wrap="square" tIns="45700">
+          <a:bodyPr spcFirstLastPara="1" wrap="square" lIns="91425" tIns="45700" rIns="91425" bIns="45700" anchor="t" anchorCtr="0">
             <a:noAutofit/>
           </a:bodyPr>
           <a:lstStyle/>
           <a:p>
-            <a:pPr indent="0" lvl="0" marL="0" marR="0" rtl="0" algn="l">
+            <a:pPr marL="0" marR="0" lvl="0" indent="0" algn="l" rtl="0">
               <a:spcBef>
                 <a:spcPts val="0"/>
               </a:spcBef>
@@ -1908,7 +1975,7 @@
                 <a:cs typeface="Arial"/>
                 <a:sym typeface="Arial"/>
               </a:rPr>
-              <a:t>‹#›</a:t>
+              <a:t>6</a:t>
             </a:fld>
             <a:endParaRPr sz="1800">
               <a:solidFill>
@@ -1931,11 +1998,11 @@
 </file>
 
 <file path=ppt/notesSlides/notesSlide7.xml><?xml version="1.0" encoding="utf-8"?>
-<p:notes xmlns:a="http://schemas.openxmlformats.org/drawingml/2006/main" xmlns:r="http://schemas.openxmlformats.org/officeDocument/2006/relationships" xmlns:mc="http://schemas.openxmlformats.org/markup-compatibility/2006" xmlns:mv="urn:schemas-microsoft-com:mac:vml" xmlns:p="http://schemas.openxmlformats.org/presentationml/2006/main" xmlns:c="http://schemas.openxmlformats.org/drawingml/2006/chart" xmlns:dgm="http://schemas.openxmlformats.org/drawingml/2006/diagram" xmlns:o="urn:schemas-microsoft-com:office:office" xmlns:v="urn:schemas-microsoft-com:vml" xmlns:pvml="urn:schemas-microsoft-com:office:powerpoint" xmlns:com="http://schemas.openxmlformats.org/drawingml/2006/compatibility" xmlns:p14="http://schemas.microsoft.com/office/powerpoint/2010/main" xmlns:p15="http://schemas.microsoft.com/office/powerpoint/2012/main" xmlns:ahyp="http://schemas.microsoft.com/office/drawing/2018/hyperlinkcolor" showMasterPhAnim="0" showMasterSp="0">
+<p:notes xmlns:a="http://schemas.openxmlformats.org/drawingml/2006/main" xmlns:r="http://schemas.openxmlformats.org/officeDocument/2006/relationships" xmlns:p="http://schemas.openxmlformats.org/presentationml/2006/main" showMasterSp="0" showMasterPhAnim="0">
   <p:cSld>
     <p:spTree>
       <p:nvGrpSpPr>
-        <p:cNvPr id="93" name="Shape 93"/>
+        <p:cNvPr id="1" name="Shape 93"/>
         <p:cNvGrpSpPr/>
         <p:nvPr/>
       </p:nvGrpSpPr>
@@ -1950,9 +2017,11 @@
       <p:sp>
         <p:nvSpPr>
           <p:cNvPr id="94" name="Google Shape;94;p6:notes"/>
-          <p:cNvSpPr/>
+          <p:cNvSpPr>
+            <a:spLocks noGrp="1" noRot="1" noChangeAspect="1"/>
+          </p:cNvSpPr>
           <p:nvPr>
-            <p:ph idx="2" type="sldImg"/>
+            <p:ph type="sldImg" idx="2"/>
           </p:nvPr>
         </p:nvSpPr>
         <p:spPr>
@@ -1961,9 +2030,13 @@
             <a:ext cx="3000000" cy="3000000"/>
           </a:xfrm>
           <a:custGeom>
-            <a:rect b="b" l="l" r="r" t="t"/>
+            <a:avLst/>
+            <a:gdLst/>
+            <a:ahLst/>
+            <a:cxnLst/>
+            <a:rect l="l" t="t" r="r" b="b"/>
             <a:pathLst>
-              <a:path extrusionOk="0" h="120000" w="120000">
+              <a:path w="120000" h="120000" extrusionOk="0">
                 <a:moveTo>
                   <a:pt x="0" y="0"/>
                 </a:moveTo>
@@ -1989,9 +2062,11 @@
       <p:sp>
         <p:nvSpPr>
           <p:cNvPr id="95" name="Google Shape;95;p6:notes"/>
-          <p:cNvSpPr txBox="1"/>
+          <p:cNvSpPr txBox="1">
+            <a:spLocks noGrp="1"/>
+          </p:cNvSpPr>
           <p:nvPr>
-            <p:ph idx="1" type="body"/>
+            <p:ph type="body" idx="1"/>
           </p:nvPr>
         </p:nvSpPr>
         <p:spPr>
@@ -2008,12 +2083,12 @@
           </a:ln>
         </p:spPr>
         <p:txBody>
-          <a:bodyPr anchorCtr="0" anchor="t" bIns="45700" lIns="91425" spcFirstLastPara="1" rIns="91425" wrap="square" tIns="45700">
+          <a:bodyPr spcFirstLastPara="1" wrap="square" lIns="91425" tIns="45700" rIns="91425" bIns="45700" anchor="t" anchorCtr="0">
             <a:noAutofit/>
           </a:bodyPr>
           <a:lstStyle/>
           <a:p>
-            <a:pPr indent="0" lvl="0" marL="0" marR="0" rtl="0" algn="l">
+            <a:pPr marL="0" marR="0" lvl="0" indent="0" algn="l" rtl="0">
               <a:spcBef>
                 <a:spcPts val="0"/>
               </a:spcBef>
@@ -2022,9 +2097,6 @@
               </a:spcAft>
               <a:buNone/>
             </a:pPr>
-            <a:r>
-              <a:t/>
-            </a:r>
             <a:endParaRPr sz="1200">
               <a:solidFill>
                 <a:schemeClr val="dk1"/>
@@ -2040,9 +2112,11 @@
       <p:sp>
         <p:nvSpPr>
           <p:cNvPr id="96" name="Google Shape;96;p6:notes"/>
-          <p:cNvSpPr txBox="1"/>
+          <p:cNvSpPr txBox="1">
+            <a:spLocks noGrp="1"/>
+          </p:cNvSpPr>
           <p:nvPr>
-            <p:ph idx="12" type="sldNum"/>
+            <p:ph type="sldNum" idx="12"/>
           </p:nvPr>
         </p:nvSpPr>
         <p:spPr>
@@ -2059,12 +2133,12 @@
           </a:ln>
         </p:spPr>
         <p:txBody>
-          <a:bodyPr anchorCtr="0" anchor="t" bIns="45700" lIns="91425" spcFirstLastPara="1" rIns="91425" wrap="square" tIns="45700">
+          <a:bodyPr spcFirstLastPara="1" wrap="square" lIns="91425" tIns="45700" rIns="91425" bIns="45700" anchor="t" anchorCtr="0">
             <a:noAutofit/>
           </a:bodyPr>
           <a:lstStyle/>
           <a:p>
-            <a:pPr indent="0" lvl="0" marL="0" marR="0" rtl="0" algn="l">
+            <a:pPr marL="0" marR="0" lvl="0" indent="0" algn="l" rtl="0">
               <a:spcBef>
                 <a:spcPts val="0"/>
               </a:spcBef>
@@ -2083,7 +2157,7 @@
                 <a:cs typeface="Arial"/>
                 <a:sym typeface="Arial"/>
               </a:rPr>
-              <a:t>‹#›</a:t>
+              <a:t>7</a:t>
             </a:fld>
             <a:endParaRPr sz="1800">
               <a:solidFill>
@@ -2106,11 +2180,11 @@
 </file>
 
 <file path=ppt/notesSlides/notesSlide8.xml><?xml version="1.0" encoding="utf-8"?>
-<p:notes xmlns:a="http://schemas.openxmlformats.org/drawingml/2006/main" xmlns:r="http://schemas.openxmlformats.org/officeDocument/2006/relationships" xmlns:mc="http://schemas.openxmlformats.org/markup-compatibility/2006" xmlns:mv="urn:schemas-microsoft-com:mac:vml" xmlns:p="http://schemas.openxmlformats.org/presentationml/2006/main" xmlns:c="http://schemas.openxmlformats.org/drawingml/2006/chart" xmlns:dgm="http://schemas.openxmlformats.org/drawingml/2006/diagram" xmlns:o="urn:schemas-microsoft-com:office:office" xmlns:v="urn:schemas-microsoft-com:vml" xmlns:pvml="urn:schemas-microsoft-com:office:powerpoint" xmlns:com="http://schemas.openxmlformats.org/drawingml/2006/compatibility" xmlns:p14="http://schemas.microsoft.com/office/powerpoint/2010/main" xmlns:p15="http://schemas.microsoft.com/office/powerpoint/2012/main" xmlns:ahyp="http://schemas.microsoft.com/office/drawing/2018/hyperlinkcolor" showMasterPhAnim="0" showMasterSp="0">
+<p:notes xmlns:a="http://schemas.openxmlformats.org/drawingml/2006/main" xmlns:r="http://schemas.openxmlformats.org/officeDocument/2006/relationships" xmlns:p="http://schemas.openxmlformats.org/presentationml/2006/main" showMasterSp="0" showMasterPhAnim="0">
   <p:cSld>
     <p:spTree>
       <p:nvGrpSpPr>
-        <p:cNvPr id="111" name="Shape 111"/>
+        <p:cNvPr id="1" name="Shape 111"/>
         <p:cNvGrpSpPr/>
         <p:nvPr/>
       </p:nvGrpSpPr>
@@ -2125,9 +2199,11 @@
       <p:sp>
         <p:nvSpPr>
           <p:cNvPr id="112" name="Google Shape;112;p7:notes"/>
-          <p:cNvSpPr/>
+          <p:cNvSpPr>
+            <a:spLocks noGrp="1" noRot="1" noChangeAspect="1"/>
+          </p:cNvSpPr>
           <p:nvPr>
-            <p:ph idx="2" type="sldImg"/>
+            <p:ph type="sldImg" idx="2"/>
           </p:nvPr>
         </p:nvSpPr>
         <p:spPr>
@@ -2136,9 +2212,13 @@
             <a:ext cx="3000000" cy="3000000"/>
           </a:xfrm>
           <a:custGeom>
-            <a:rect b="b" l="l" r="r" t="t"/>
+            <a:avLst/>
+            <a:gdLst/>
+            <a:ahLst/>
+            <a:cxnLst/>
+            <a:rect l="l" t="t" r="r" b="b"/>
             <a:pathLst>
-              <a:path extrusionOk="0" h="120000" w="120000">
+              <a:path w="120000" h="120000" extrusionOk="0">
                 <a:moveTo>
                   <a:pt x="0" y="0"/>
                 </a:moveTo>
@@ -2164,9 +2244,11 @@
       <p:sp>
         <p:nvSpPr>
           <p:cNvPr id="113" name="Google Shape;113;p7:notes"/>
-          <p:cNvSpPr txBox="1"/>
+          <p:cNvSpPr txBox="1">
+            <a:spLocks noGrp="1"/>
+          </p:cNvSpPr>
           <p:nvPr>
-            <p:ph idx="1" type="body"/>
+            <p:ph type="body" idx="1"/>
           </p:nvPr>
         </p:nvSpPr>
         <p:spPr>
@@ -2183,12 +2265,12 @@
           </a:ln>
         </p:spPr>
         <p:txBody>
-          <a:bodyPr anchorCtr="0" anchor="t" bIns="45700" lIns="91425" spcFirstLastPara="1" rIns="91425" wrap="square" tIns="45700">
+          <a:bodyPr spcFirstLastPara="1" wrap="square" lIns="91425" tIns="45700" rIns="91425" bIns="45700" anchor="t" anchorCtr="0">
             <a:noAutofit/>
           </a:bodyPr>
           <a:lstStyle/>
           <a:p>
-            <a:pPr indent="0" lvl="0" marL="0" marR="0" rtl="0" algn="l">
+            <a:pPr marL="0" marR="0" lvl="0" indent="0" algn="l" rtl="0">
               <a:spcBef>
                 <a:spcPts val="0"/>
               </a:spcBef>
@@ -2197,9 +2279,6 @@
               </a:spcAft>
               <a:buNone/>
             </a:pPr>
-            <a:r>
-              <a:t/>
-            </a:r>
             <a:endParaRPr sz="1200">
               <a:solidFill>
                 <a:schemeClr val="dk1"/>
@@ -2215,9 +2294,11 @@
       <p:sp>
         <p:nvSpPr>
           <p:cNvPr id="114" name="Google Shape;114;p7:notes"/>
-          <p:cNvSpPr txBox="1"/>
+          <p:cNvSpPr txBox="1">
+            <a:spLocks noGrp="1"/>
+          </p:cNvSpPr>
           <p:nvPr>
-            <p:ph idx="12" type="sldNum"/>
+            <p:ph type="sldNum" idx="12"/>
           </p:nvPr>
         </p:nvSpPr>
         <p:spPr>
@@ -2234,12 +2315,12 @@
           </a:ln>
         </p:spPr>
         <p:txBody>
-          <a:bodyPr anchorCtr="0" anchor="t" bIns="45700" lIns="91425" spcFirstLastPara="1" rIns="91425" wrap="square" tIns="45700">
+          <a:bodyPr spcFirstLastPara="1" wrap="square" lIns="91425" tIns="45700" rIns="91425" bIns="45700" anchor="t" anchorCtr="0">
             <a:noAutofit/>
           </a:bodyPr>
           <a:lstStyle/>
           <a:p>
-            <a:pPr indent="0" lvl="0" marL="0" marR="0" rtl="0" algn="l">
+            <a:pPr marL="0" marR="0" lvl="0" indent="0" algn="l" rtl="0">
               <a:spcBef>
                 <a:spcPts val="0"/>
               </a:spcBef>
@@ -2258,7 +2339,7 @@
                 <a:cs typeface="Arial"/>
                 <a:sym typeface="Arial"/>
               </a:rPr>
-              <a:t>‹#›</a:t>
+              <a:t>8</a:t>
             </a:fld>
             <a:endParaRPr sz="1800">
               <a:solidFill>
@@ -2281,11 +2362,11 @@
 </file>
 
 <file path=ppt/notesSlides/notesSlide9.xml><?xml version="1.0" encoding="utf-8"?>
-<p:notes xmlns:a="http://schemas.openxmlformats.org/drawingml/2006/main" xmlns:r="http://schemas.openxmlformats.org/officeDocument/2006/relationships" xmlns:mc="http://schemas.openxmlformats.org/markup-compatibility/2006" xmlns:mv="urn:schemas-microsoft-com:mac:vml" xmlns:p="http://schemas.openxmlformats.org/presentationml/2006/main" xmlns:c="http://schemas.openxmlformats.org/drawingml/2006/chart" xmlns:dgm="http://schemas.openxmlformats.org/drawingml/2006/diagram" xmlns:o="urn:schemas-microsoft-com:office:office" xmlns:v="urn:schemas-microsoft-com:vml" xmlns:pvml="urn:schemas-microsoft-com:office:powerpoint" xmlns:com="http://schemas.openxmlformats.org/drawingml/2006/compatibility" xmlns:p14="http://schemas.microsoft.com/office/powerpoint/2010/main" xmlns:p15="http://schemas.microsoft.com/office/powerpoint/2012/main" xmlns:ahyp="http://schemas.microsoft.com/office/drawing/2018/hyperlinkcolor" showMasterPhAnim="0" showMasterSp="0">
+<p:notes xmlns:a="http://schemas.openxmlformats.org/drawingml/2006/main" xmlns:r="http://schemas.openxmlformats.org/officeDocument/2006/relationships" xmlns:p="http://schemas.openxmlformats.org/presentationml/2006/main" showMasterSp="0" showMasterPhAnim="0">
   <p:cSld>
     <p:spTree>
       <p:nvGrpSpPr>
-        <p:cNvPr id="120" name="Shape 120"/>
+        <p:cNvPr id="1" name="Shape 120"/>
         <p:cNvGrpSpPr/>
         <p:nvPr/>
       </p:nvGrpSpPr>
@@ -2300,9 +2381,11 @@
       <p:sp>
         <p:nvSpPr>
           <p:cNvPr id="121" name="Google Shape;121;p8:notes"/>
-          <p:cNvSpPr/>
+          <p:cNvSpPr>
+            <a:spLocks noGrp="1" noRot="1" noChangeAspect="1"/>
+          </p:cNvSpPr>
           <p:nvPr>
-            <p:ph idx="2" type="sldImg"/>
+            <p:ph type="sldImg" idx="2"/>
           </p:nvPr>
         </p:nvSpPr>
         <p:spPr>
@@ -2311,9 +2394,13 @@
             <a:ext cx="3000000" cy="3000000"/>
           </a:xfrm>
           <a:custGeom>
-            <a:rect b="b" l="l" r="r" t="t"/>
+            <a:avLst/>
+            <a:gdLst/>
+            <a:ahLst/>
+            <a:cxnLst/>
+            <a:rect l="l" t="t" r="r" b="b"/>
             <a:pathLst>
-              <a:path extrusionOk="0" h="120000" w="120000">
+              <a:path w="120000" h="120000" extrusionOk="0">
                 <a:moveTo>
                   <a:pt x="0" y="0"/>
                 </a:moveTo>
@@ -2339,9 +2426,11 @@
       <p:sp>
         <p:nvSpPr>
           <p:cNvPr id="122" name="Google Shape;122;p8:notes"/>
-          <p:cNvSpPr txBox="1"/>
+          <p:cNvSpPr txBox="1">
+            <a:spLocks noGrp="1"/>
+          </p:cNvSpPr>
           <p:nvPr>
-            <p:ph idx="1" type="body"/>
+            <p:ph type="body" idx="1"/>
           </p:nvPr>
         </p:nvSpPr>
         <p:spPr>
@@ -2358,12 +2447,12 @@
           </a:ln>
         </p:spPr>
         <p:txBody>
-          <a:bodyPr anchorCtr="0" anchor="t" bIns="45700" lIns="91425" spcFirstLastPara="1" rIns="91425" wrap="square" tIns="45700">
+          <a:bodyPr spcFirstLastPara="1" wrap="square" lIns="91425" tIns="45700" rIns="91425" bIns="45700" anchor="t" anchorCtr="0">
             <a:noAutofit/>
           </a:bodyPr>
           <a:lstStyle/>
           <a:p>
-            <a:pPr indent="0" lvl="0" marL="0" marR="0" rtl="0" algn="l">
+            <a:pPr marL="0" marR="0" lvl="0" indent="0" algn="l" rtl="0">
               <a:spcBef>
                 <a:spcPts val="0"/>
               </a:spcBef>
@@ -2372,9 +2461,6 @@
               </a:spcAft>
               <a:buNone/>
             </a:pPr>
-            <a:r>
-              <a:t/>
-            </a:r>
             <a:endParaRPr sz="1200">
               <a:solidFill>
                 <a:schemeClr val="dk1"/>
@@ -2390,9 +2476,11 @@
       <p:sp>
         <p:nvSpPr>
           <p:cNvPr id="123" name="Google Shape;123;p8:notes"/>
-          <p:cNvSpPr txBox="1"/>
+          <p:cNvSpPr txBox="1">
+            <a:spLocks noGrp="1"/>
+          </p:cNvSpPr>
           <p:nvPr>
-            <p:ph idx="12" type="sldNum"/>
+            <p:ph type="sldNum" idx="12"/>
           </p:nvPr>
         </p:nvSpPr>
         <p:spPr>
@@ -2409,12 +2497,12 @@
           </a:ln>
         </p:spPr>
         <p:txBody>
-          <a:bodyPr anchorCtr="0" anchor="t" bIns="45700" lIns="91425" spcFirstLastPara="1" rIns="91425" wrap="square" tIns="45700">
+          <a:bodyPr spcFirstLastPara="1" wrap="square" lIns="91425" tIns="45700" rIns="91425" bIns="45700" anchor="t" anchorCtr="0">
             <a:noAutofit/>
           </a:bodyPr>
           <a:lstStyle/>
           <a:p>
-            <a:pPr indent="0" lvl="0" marL="0" marR="0" rtl="0" algn="l">
+            <a:pPr marL="0" marR="0" lvl="0" indent="0" algn="l" rtl="0">
               <a:spcBef>
                 <a:spcPts val="0"/>
               </a:spcBef>
@@ -2433,7 +2521,7 @@
                 <a:cs typeface="Arial"/>
                 <a:sym typeface="Arial"/>
               </a:rPr>
-              <a:t>‹#›</a:t>
+              <a:t>9</a:t>
             </a:fld>
             <a:endParaRPr sz="1800">
               <a:solidFill>
@@ -2456,11 +2544,11 @@
 </file>
 
 <file path=ppt/slideLayouts/slideLayout1.xml><?xml version="1.0" encoding="utf-8"?>
-<p:sldLayout xmlns:a="http://schemas.openxmlformats.org/drawingml/2006/main" xmlns:r="http://schemas.openxmlformats.org/officeDocument/2006/relationships" xmlns:mc="http://schemas.openxmlformats.org/markup-compatibility/2006" xmlns:mv="urn:schemas-microsoft-com:mac:vml" xmlns:p="http://schemas.openxmlformats.org/presentationml/2006/main" xmlns:c="http://schemas.openxmlformats.org/drawingml/2006/chart" xmlns:dgm="http://schemas.openxmlformats.org/drawingml/2006/diagram" xmlns:o="urn:schemas-microsoft-com:office:office" xmlns:v="urn:schemas-microsoft-com:vml" xmlns:pvml="urn:schemas-microsoft-com:office:powerpoint" xmlns:com="http://schemas.openxmlformats.org/drawingml/2006/compatibility" xmlns:p14="http://schemas.microsoft.com/office/powerpoint/2010/main" xmlns:p15="http://schemas.microsoft.com/office/powerpoint/2012/main" xmlns:ahyp="http://schemas.microsoft.com/office/drawing/2018/hyperlinkcolor" matchingName="Slide master 1">
+<p:sldLayout xmlns:a="http://schemas.openxmlformats.org/drawingml/2006/main" xmlns:r="http://schemas.openxmlformats.org/officeDocument/2006/relationships" xmlns:p="http://schemas.openxmlformats.org/presentationml/2006/main" matchingName="Slide master 1">
   <p:cSld name="Slide master 1">
     <p:spTree>
       <p:nvGrpSpPr>
-        <p:cNvPr id="6" name="Shape 6"/>
+        <p:cNvPr id="1" name="Shape 6"/>
         <p:cNvGrpSpPr/>
         <p:nvPr/>
       </p:nvGrpSpPr>
@@ -2474,7 +2562,7 @@
       </p:grpSpPr>
       <p:pic>
         <p:nvPicPr>
-          <p:cNvPr descr="preencoded.png" id="7" name="Google Shape;7;p11"/>
+          <p:cNvPr id="7" name="Google Shape;7;p11" descr="preencoded.png"/>
           <p:cNvPicPr preferRelativeResize="0"/>
           <p:nvPr/>
         </p:nvPicPr>
@@ -2482,7 +2570,7 @@
           <a:blip r:embed="rId2">
             <a:alphaModFix/>
           </a:blip>
-          <a:srcRect b="0" l="0" r="0" t="0"/>
+          <a:srcRect/>
           <a:stretch/>
         </p:blipFill>
         <p:spPr>
@@ -2523,12 +2611,12 @@
           </a:ln>
         </p:spPr>
         <p:txBody>
-          <a:bodyPr anchorCtr="0" anchor="t" bIns="45700" lIns="91425" spcFirstLastPara="1" rIns="91425" wrap="square" tIns="45700">
+          <a:bodyPr spcFirstLastPara="1" wrap="square" lIns="91425" tIns="45700" rIns="91425" bIns="45700" anchor="t" anchorCtr="0">
             <a:noAutofit/>
           </a:bodyPr>
           <a:lstStyle/>
           <a:p>
-            <a:pPr indent="0" lvl="0" marL="0" marR="0" rtl="0" algn="l">
+            <a:pPr marL="0" marR="0" lvl="0" indent="0" algn="l" rtl="0">
               <a:spcBef>
                 <a:spcPts val="0"/>
               </a:spcBef>
@@ -2537,9 +2625,6 @@
               </a:spcAft>
               <a:buNone/>
             </a:pPr>
-            <a:r>
-              <a:t/>
-            </a:r>
             <a:endParaRPr sz="1800">
               <a:solidFill>
                 <a:schemeClr val="dk1"/>
@@ -2554,7 +2639,7 @@
       </p:sp>
       <p:pic>
         <p:nvPicPr>
-          <p:cNvPr descr="preencoded.png" id="9" name="Google Shape;9;p11">
+          <p:cNvPr id="9" name="Google Shape;9;p11" descr="preencoded.png">
             <a:hlinkClick r:id="rId3"/>
           </p:cNvPr>
           <p:cNvPicPr preferRelativeResize="0"/>
@@ -2564,7 +2649,7 @@
           <a:blip r:embed="rId4">
             <a:alphaModFix/>
           </a:blip>
-          <a:srcRect b="0" l="0" r="0" t="0"/>
+          <a:srcRect/>
           <a:stretch/>
         </p:blipFill>
         <p:spPr>
@@ -2590,18 +2675,19 @@
 </file>
 
 <file path=ppt/slideLayouts/slideLayout2.xml><?xml version="1.0" encoding="utf-8"?>
-<p:sldLayout xmlns:a="http://schemas.openxmlformats.org/drawingml/2006/main" xmlns:r="http://schemas.openxmlformats.org/officeDocument/2006/relationships" xmlns:mc="http://schemas.openxmlformats.org/markup-compatibility/2006" xmlns:mv="urn:schemas-microsoft-com:mac:vml" xmlns:p="http://schemas.openxmlformats.org/presentationml/2006/main" xmlns:c="http://schemas.openxmlformats.org/drawingml/2006/chart" xmlns:dgm="http://schemas.openxmlformats.org/drawingml/2006/diagram" xmlns:o="urn:schemas-microsoft-com:office:office" xmlns:v="urn:schemas-microsoft-com:vml" xmlns:pvml="urn:schemas-microsoft-com:office:powerpoint" xmlns:com="http://schemas.openxmlformats.org/drawingml/2006/compatibility" xmlns:p14="http://schemas.microsoft.com/office/powerpoint/2010/main" xmlns:p15="http://schemas.microsoft.com/office/powerpoint/2012/main" xmlns:ahyp="http://schemas.microsoft.com/office/drawing/2018/hyperlinkcolor" matchingName="DEFAULT">
+<p:sldLayout xmlns:a="http://schemas.openxmlformats.org/drawingml/2006/main" xmlns:r="http://schemas.openxmlformats.org/officeDocument/2006/relationships" xmlns:p="http://schemas.openxmlformats.org/presentationml/2006/main" matchingName="DEFAULT">
   <p:cSld name="DEFAULT">
     <p:bg>
       <p:bgPr>
         <a:solidFill>
           <a:schemeClr val="lt1"/>
         </a:solidFill>
+        <a:effectLst/>
       </p:bgPr>
     </p:bg>
     <p:spTree>
       <p:nvGrpSpPr>
-        <p:cNvPr id="10" name="Shape 10"/>
+        <p:cNvPr id="1" name="Shape 10"/>
         <p:cNvGrpSpPr/>
         <p:nvPr/>
       </p:nvGrpSpPr>
@@ -2622,18 +2708,19 @@
 </file>
 
 <file path=ppt/slideMasters/slideMaster1.xml><?xml version="1.0" encoding="utf-8"?>
-<p:sldMaster xmlns:a="http://schemas.openxmlformats.org/drawingml/2006/main" xmlns:r="http://schemas.openxmlformats.org/officeDocument/2006/relationships" xmlns:mc="http://schemas.openxmlformats.org/markup-compatibility/2006" xmlns:mv="urn:schemas-microsoft-com:mac:vml" xmlns:p="http://schemas.openxmlformats.org/presentationml/2006/main" xmlns:c="http://schemas.openxmlformats.org/drawingml/2006/chart" xmlns:dgm="http://schemas.openxmlformats.org/drawingml/2006/diagram" xmlns:o="urn:schemas-microsoft-com:office:office" xmlns:v="urn:schemas-microsoft-com:vml" xmlns:pvml="urn:schemas-microsoft-com:office:powerpoint" xmlns:com="http://schemas.openxmlformats.org/drawingml/2006/compatibility" xmlns:p14="http://schemas.microsoft.com/office/powerpoint/2010/main" xmlns:p15="http://schemas.microsoft.com/office/powerpoint/2012/main" xmlns:ahyp="http://schemas.microsoft.com/office/drawing/2018/hyperlinkcolor">
+<p:sldMaster xmlns:a="http://schemas.openxmlformats.org/drawingml/2006/main" xmlns:r="http://schemas.openxmlformats.org/officeDocument/2006/relationships" xmlns:p="http://schemas.openxmlformats.org/presentationml/2006/main">
   <p:cSld>
     <p:bg>
       <p:bgPr>
         <a:solidFill>
           <a:schemeClr val="lt1"/>
         </a:solidFill>
+        <a:effectLst/>
       </p:bgPr>
     </p:bg>
     <p:spTree>
       <p:nvGrpSpPr>
-        <p:cNvPr id="5" name="Shape 5"/>
+        <p:cNvPr id="1" name="Shape 5"/>
         <p:cNvGrpSpPr/>
         <p:nvPr/>
       </p:nvGrpSpPr>
@@ -2647,15 +2734,15 @@
       </p:grpSpPr>
     </p:spTree>
   </p:cSld>
-  <p:clrMap accent1="accent1" accent2="accent2" accent3="accent3" accent4="accent4" accent5="accent5" accent6="accent6" bg1="lt1" bg2="dk2" tx1="dk1" tx2="lt2" folHlink="folHlink" hlink="hlink"/>
+  <p:clrMap bg1="lt1" tx1="dk1" bg2="dk2" tx2="lt2" accent1="accent1" accent2="accent2" accent3="accent3" accent4="accent4" accent5="accent5" accent6="accent6" hlink="hlink" folHlink="folHlink"/>
   <p:sldLayoutIdLst>
     <p:sldLayoutId id="2147483649" r:id="rId1"/>
     <p:sldLayoutId id="2147483650" r:id="rId2"/>
   </p:sldLayoutIdLst>
-  <p:hf dt="0" ftr="0" hdr="0" sldNum="0"/>
+  <p:hf sldNum="0" hdr="0" ftr="0" dt="0"/>
   <p:txStyles>
     <p:titleStyle>
-      <a:defPPr lvl="0" marR="0" rtl="0" algn="l">
+      <a:defPPr marR="0" lvl="0" algn="l" rtl="0">
         <a:lnSpc>
           <a:spcPct val="100000"/>
         </a:lnSpc>
@@ -2666,7 +2753,7 @@
           <a:spcPts val="0"/>
         </a:spcAft>
       </a:defPPr>
-      <a:lvl1pPr lvl="0" marR="0" rtl="0" algn="l">
+      <a:lvl1pPr marR="0" lvl="0" algn="l" rtl="0">
         <a:lnSpc>
           <a:spcPct val="100000"/>
         </a:lnSpc>
@@ -2680,7 +2767,7 @@
           <a:srgbClr val="000000"/>
         </a:buClr>
         <a:buFont typeface="Arial"/>
-        <a:defRPr b="0" i="0" spc="0" sz="1400" u="none" cap="none" strike="noStrike">
+        <a:defRPr sz="1400" b="0" i="0" u="none" strike="noStrike" cap="none" spc="0">
           <a:solidFill>
             <a:srgbClr val="000000"/>
           </a:solidFill>
@@ -2690,7 +2777,7 @@
           <a:sym typeface="Arial"/>
         </a:defRPr>
       </a:lvl1pPr>
-      <a:lvl2pPr lvl="1" marR="0" rtl="0" algn="l">
+      <a:lvl2pPr marR="0" lvl="1" algn="l" rtl="0">
         <a:lnSpc>
           <a:spcPct val="100000"/>
         </a:lnSpc>
@@ -2704,7 +2791,7 @@
           <a:srgbClr val="000000"/>
         </a:buClr>
         <a:buFont typeface="Arial"/>
-        <a:defRPr b="0" i="0" spc="0" sz="1400" u="none" cap="none" strike="noStrike">
+        <a:defRPr sz="1400" b="0" i="0" u="none" strike="noStrike" cap="none" spc="0">
           <a:solidFill>
             <a:srgbClr val="000000"/>
           </a:solidFill>
@@ -2714,7 +2801,7 @@
           <a:sym typeface="Arial"/>
         </a:defRPr>
       </a:lvl2pPr>
-      <a:lvl3pPr lvl="2" marR="0" rtl="0" algn="l">
+      <a:lvl3pPr marR="0" lvl="2" algn="l" rtl="0">
         <a:lnSpc>
           <a:spcPct val="100000"/>
         </a:lnSpc>
@@ -2728,7 +2815,7 @@
           <a:srgbClr val="000000"/>
         </a:buClr>
         <a:buFont typeface="Arial"/>
-        <a:defRPr b="0" i="0" spc="0" sz="1400" u="none" cap="none" strike="noStrike">
+        <a:defRPr sz="1400" b="0" i="0" u="none" strike="noStrike" cap="none" spc="0">
           <a:solidFill>
             <a:srgbClr val="000000"/>
           </a:solidFill>
@@ -2738,7 +2825,7 @@
           <a:sym typeface="Arial"/>
         </a:defRPr>
       </a:lvl3pPr>
-      <a:lvl4pPr lvl="3" marR="0" rtl="0" algn="l">
+      <a:lvl4pPr marR="0" lvl="3" algn="l" rtl="0">
         <a:lnSpc>
           <a:spcPct val="100000"/>
         </a:lnSpc>
@@ -2752,7 +2839,7 @@
           <a:srgbClr val="000000"/>
         </a:buClr>
         <a:buFont typeface="Arial"/>
-        <a:defRPr b="0" i="0" spc="0" sz="1400" u="none" cap="none" strike="noStrike">
+        <a:defRPr sz="1400" b="0" i="0" u="none" strike="noStrike" cap="none" spc="0">
           <a:solidFill>
             <a:srgbClr val="000000"/>
           </a:solidFill>
@@ -2762,7 +2849,7 @@
           <a:sym typeface="Arial"/>
         </a:defRPr>
       </a:lvl4pPr>
-      <a:lvl5pPr lvl="4" marR="0" rtl="0" algn="l">
+      <a:lvl5pPr marR="0" lvl="4" algn="l" rtl="0">
         <a:lnSpc>
           <a:spcPct val="100000"/>
         </a:lnSpc>
@@ -2776,7 +2863,7 @@
           <a:srgbClr val="000000"/>
         </a:buClr>
         <a:buFont typeface="Arial"/>
-        <a:defRPr b="0" i="0" spc="0" sz="1400" u="none" cap="none" strike="noStrike">
+        <a:defRPr sz="1400" b="0" i="0" u="none" strike="noStrike" cap="none" spc="0">
           <a:solidFill>
             <a:srgbClr val="000000"/>
           </a:solidFill>
@@ -2786,7 +2873,7 @@
           <a:sym typeface="Arial"/>
         </a:defRPr>
       </a:lvl5pPr>
-      <a:lvl6pPr lvl="5" marR="0" rtl="0" algn="l">
+      <a:lvl6pPr marR="0" lvl="5" algn="l" rtl="0">
         <a:lnSpc>
           <a:spcPct val="100000"/>
         </a:lnSpc>
@@ -2800,7 +2887,7 @@
           <a:srgbClr val="000000"/>
         </a:buClr>
         <a:buFont typeface="Arial"/>
-        <a:defRPr b="0" i="0" spc="0" sz="1400" u="none" cap="none" strike="noStrike">
+        <a:defRPr sz="1400" b="0" i="0" u="none" strike="noStrike" cap="none" spc="0">
           <a:solidFill>
             <a:srgbClr val="000000"/>
           </a:solidFill>
@@ -2810,7 +2897,7 @@
           <a:sym typeface="Arial"/>
         </a:defRPr>
       </a:lvl6pPr>
-      <a:lvl7pPr lvl="6" marR="0" rtl="0" algn="l">
+      <a:lvl7pPr marR="0" lvl="6" algn="l" rtl="0">
         <a:lnSpc>
           <a:spcPct val="100000"/>
         </a:lnSpc>
@@ -2824,7 +2911,7 @@
           <a:srgbClr val="000000"/>
         </a:buClr>
         <a:buFont typeface="Arial"/>
-        <a:defRPr b="0" i="0" spc="0" sz="1400" u="none" cap="none" strike="noStrike">
+        <a:defRPr sz="1400" b="0" i="0" u="none" strike="noStrike" cap="none" spc="0">
           <a:solidFill>
             <a:srgbClr val="000000"/>
           </a:solidFill>
@@ -2834,7 +2921,7 @@
           <a:sym typeface="Arial"/>
         </a:defRPr>
       </a:lvl7pPr>
-      <a:lvl8pPr lvl="7" marR="0" rtl="0" algn="l">
+      <a:lvl8pPr marR="0" lvl="7" algn="l" rtl="0">
         <a:lnSpc>
           <a:spcPct val="100000"/>
         </a:lnSpc>
@@ -2848,7 +2935,7 @@
           <a:srgbClr val="000000"/>
         </a:buClr>
         <a:buFont typeface="Arial"/>
-        <a:defRPr b="0" i="0" spc="0" sz="1400" u="none" cap="none" strike="noStrike">
+        <a:defRPr sz="1400" b="0" i="0" u="none" strike="noStrike" cap="none" spc="0">
           <a:solidFill>
             <a:srgbClr val="000000"/>
           </a:solidFill>
@@ -2858,7 +2945,7 @@
           <a:sym typeface="Arial"/>
         </a:defRPr>
       </a:lvl8pPr>
-      <a:lvl9pPr lvl="8" marR="0" rtl="0" algn="l">
+      <a:lvl9pPr marR="0" lvl="8" algn="l" rtl="0">
         <a:lnSpc>
           <a:spcPct val="100000"/>
         </a:lnSpc>
@@ -2872,7 +2959,7 @@
           <a:srgbClr val="000000"/>
         </a:buClr>
         <a:buFont typeface="Arial"/>
-        <a:defRPr b="0" i="0" spc="0" sz="1400" u="none" cap="none" strike="noStrike">
+        <a:defRPr sz="1400" b="0" i="0" u="none" strike="noStrike" cap="none" spc="0">
           <a:solidFill>
             <a:srgbClr val="000000"/>
           </a:solidFill>
@@ -2884,7 +2971,7 @@
       </a:lvl9pPr>
     </p:titleStyle>
     <p:bodyStyle>
-      <a:defPPr lvl="0" marR="0" rtl="0" algn="l">
+      <a:defPPr marR="0" lvl="0" algn="l" rtl="0">
         <a:lnSpc>
           <a:spcPct val="100000"/>
         </a:lnSpc>
@@ -2895,7 +2982,7 @@
           <a:spcPts val="0"/>
         </a:spcAft>
       </a:defPPr>
-      <a:lvl1pPr lvl="0" marR="0" rtl="0" algn="l">
+      <a:lvl1pPr marR="0" lvl="0" algn="l" rtl="0">
         <a:lnSpc>
           <a:spcPct val="100000"/>
         </a:lnSpc>
@@ -2909,7 +2996,7 @@
           <a:srgbClr val="000000"/>
         </a:buClr>
         <a:buFont typeface="Arial"/>
-        <a:defRPr b="0" i="0" spc="0" sz="1400" u="none" cap="none" strike="noStrike">
+        <a:defRPr sz="1400" b="0" i="0" u="none" strike="noStrike" cap="none" spc="0">
           <a:solidFill>
             <a:srgbClr val="000000"/>
           </a:solidFill>
@@ -2919,7 +3006,7 @@
           <a:sym typeface="Arial"/>
         </a:defRPr>
       </a:lvl1pPr>
-      <a:lvl2pPr lvl="1" marR="0" rtl="0" algn="l">
+      <a:lvl2pPr marR="0" lvl="1" algn="l" rtl="0">
         <a:lnSpc>
           <a:spcPct val="100000"/>
         </a:lnSpc>
@@ -2933,7 +3020,7 @@
           <a:srgbClr val="000000"/>
         </a:buClr>
         <a:buFont typeface="Arial"/>
-        <a:defRPr b="0" i="0" spc="0" sz="1400" u="none" cap="none" strike="noStrike">
+        <a:defRPr sz="1400" b="0" i="0" u="none" strike="noStrike" cap="none" spc="0">
           <a:solidFill>
             <a:srgbClr val="000000"/>
           </a:solidFill>
@@ -2943,7 +3030,7 @@
           <a:sym typeface="Arial"/>
         </a:defRPr>
       </a:lvl2pPr>
-      <a:lvl3pPr lvl="2" marR="0" rtl="0" algn="l">
+      <a:lvl3pPr marR="0" lvl="2" algn="l" rtl="0">
         <a:lnSpc>
           <a:spcPct val="100000"/>
         </a:lnSpc>
@@ -2957,7 +3044,7 @@
           <a:srgbClr val="000000"/>
         </a:buClr>
         <a:buFont typeface="Arial"/>
-        <a:defRPr b="0" i="0" spc="0" sz="1400" u="none" cap="none" strike="noStrike">
+        <a:defRPr sz="1400" b="0" i="0" u="none" strike="noStrike" cap="none" spc="0">
           <a:solidFill>
             <a:srgbClr val="000000"/>
           </a:solidFill>
@@ -2967,7 +3054,7 @@
           <a:sym typeface="Arial"/>
         </a:defRPr>
       </a:lvl3pPr>
-      <a:lvl4pPr lvl="3" marR="0" rtl="0" algn="l">
+      <a:lvl4pPr marR="0" lvl="3" algn="l" rtl="0">
         <a:lnSpc>
           <a:spcPct val="100000"/>
         </a:lnSpc>
@@ -2981,7 +3068,7 @@
           <a:srgbClr val="000000"/>
         </a:buClr>
         <a:buFont typeface="Arial"/>
-        <a:defRPr b="0" i="0" spc="0" sz="1400" u="none" cap="none" strike="noStrike">
+        <a:defRPr sz="1400" b="0" i="0" u="none" strike="noStrike" cap="none" spc="0">
           <a:solidFill>
             <a:srgbClr val="000000"/>
           </a:solidFill>
@@ -2991,7 +3078,7 @@
           <a:sym typeface="Arial"/>
         </a:defRPr>
       </a:lvl4pPr>
-      <a:lvl5pPr lvl="4" marR="0" rtl="0" algn="l">
+      <a:lvl5pPr marR="0" lvl="4" algn="l" rtl="0">
         <a:lnSpc>
           <a:spcPct val="100000"/>
         </a:lnSpc>
@@ -3005,7 +3092,7 @@
           <a:srgbClr val="000000"/>
         </a:buClr>
         <a:buFont typeface="Arial"/>
-        <a:defRPr b="0" i="0" spc="0" sz="1400" u="none" cap="none" strike="noStrike">
+        <a:defRPr sz="1400" b="0" i="0" u="none" strike="noStrike" cap="none" spc="0">
           <a:solidFill>
             <a:srgbClr val="000000"/>
           </a:solidFill>
@@ -3015,7 +3102,7 @@
           <a:sym typeface="Arial"/>
         </a:defRPr>
       </a:lvl5pPr>
-      <a:lvl6pPr lvl="5" marR="0" rtl="0" algn="l">
+      <a:lvl6pPr marR="0" lvl="5" algn="l" rtl="0">
         <a:lnSpc>
           <a:spcPct val="100000"/>
         </a:lnSpc>
@@ -3029,7 +3116,7 @@
           <a:srgbClr val="000000"/>
         </a:buClr>
         <a:buFont typeface="Arial"/>
-        <a:defRPr b="0" i="0" spc="0" sz="1400" u="none" cap="none" strike="noStrike">
+        <a:defRPr sz="1400" b="0" i="0" u="none" strike="noStrike" cap="none" spc="0">
           <a:solidFill>
             <a:srgbClr val="000000"/>
           </a:solidFill>
@@ -3039,7 +3126,7 @@
           <a:sym typeface="Arial"/>
         </a:defRPr>
       </a:lvl6pPr>
-      <a:lvl7pPr lvl="6" marR="0" rtl="0" algn="l">
+      <a:lvl7pPr marR="0" lvl="6" algn="l" rtl="0">
         <a:lnSpc>
           <a:spcPct val="100000"/>
         </a:lnSpc>
@@ -3053,7 +3140,7 @@
           <a:srgbClr val="000000"/>
         </a:buClr>
         <a:buFont typeface="Arial"/>
-        <a:defRPr b="0" i="0" spc="0" sz="1400" u="none" cap="none" strike="noStrike">
+        <a:defRPr sz="1400" b="0" i="0" u="none" strike="noStrike" cap="none" spc="0">
           <a:solidFill>
             <a:srgbClr val="000000"/>
           </a:solidFill>
@@ -3063,7 +3150,7 @@
           <a:sym typeface="Arial"/>
         </a:defRPr>
       </a:lvl7pPr>
-      <a:lvl8pPr lvl="7" marR="0" rtl="0" algn="l">
+      <a:lvl8pPr marR="0" lvl="7" algn="l" rtl="0">
         <a:lnSpc>
           <a:spcPct val="100000"/>
         </a:lnSpc>
@@ -3077,7 +3164,7 @@
           <a:srgbClr val="000000"/>
         </a:buClr>
         <a:buFont typeface="Arial"/>
-        <a:defRPr b="0" i="0" spc="0" sz="1400" u="none" cap="none" strike="noStrike">
+        <a:defRPr sz="1400" b="0" i="0" u="none" strike="noStrike" cap="none" spc="0">
           <a:solidFill>
             <a:srgbClr val="000000"/>
           </a:solidFill>
@@ -3087,7 +3174,7 @@
           <a:sym typeface="Arial"/>
         </a:defRPr>
       </a:lvl8pPr>
-      <a:lvl9pPr lvl="8" marR="0" rtl="0" algn="l">
+      <a:lvl9pPr marR="0" lvl="8" algn="l" rtl="0">
         <a:lnSpc>
           <a:spcPct val="100000"/>
         </a:lnSpc>
@@ -3101,7 +3188,7 @@
           <a:srgbClr val="000000"/>
         </a:buClr>
         <a:buFont typeface="Arial"/>
-        <a:defRPr b="0" i="0" spc="0" sz="1400" u="none" cap="none" strike="noStrike">
+        <a:defRPr sz="1400" b="0" i="0" u="none" strike="noStrike" cap="none" spc="0">
           <a:solidFill>
             <a:srgbClr val="000000"/>
           </a:solidFill>
@@ -3113,7 +3200,7 @@
       </a:lvl9pPr>
     </p:bodyStyle>
     <p:otherStyle>
-      <a:defPPr lvl="0" marR="0" rtl="0" algn="l">
+      <a:defPPr marR="0" lvl="0" algn="l" rtl="0">
         <a:lnSpc>
           <a:spcPct val="100000"/>
         </a:lnSpc>
@@ -3124,7 +3211,7 @@
           <a:spcPts val="0"/>
         </a:spcAft>
       </a:defPPr>
-      <a:lvl1pPr lvl="0" marR="0" rtl="0" algn="l">
+      <a:lvl1pPr marR="0" lvl="0" algn="l" rtl="0">
         <a:lnSpc>
           <a:spcPct val="100000"/>
         </a:lnSpc>
@@ -3138,7 +3225,7 @@
           <a:srgbClr val="000000"/>
         </a:buClr>
         <a:buFont typeface="Arial"/>
-        <a:defRPr b="0" i="0" spc="0" sz="1400" u="none" cap="none" strike="noStrike">
+        <a:defRPr sz="1400" b="0" i="0" u="none" strike="noStrike" cap="none" spc="0">
           <a:solidFill>
             <a:srgbClr val="000000"/>
           </a:solidFill>
@@ -3148,7 +3235,7 @@
           <a:sym typeface="Arial"/>
         </a:defRPr>
       </a:lvl1pPr>
-      <a:lvl2pPr lvl="1" marR="0" rtl="0" algn="l">
+      <a:lvl2pPr marR="0" lvl="1" algn="l" rtl="0">
         <a:lnSpc>
           <a:spcPct val="100000"/>
         </a:lnSpc>
@@ -3162,7 +3249,7 @@
           <a:srgbClr val="000000"/>
         </a:buClr>
         <a:buFont typeface="Arial"/>
-        <a:defRPr b="0" i="0" spc="0" sz="1400" u="none" cap="none" strike="noStrike">
+        <a:defRPr sz="1400" b="0" i="0" u="none" strike="noStrike" cap="none" spc="0">
           <a:solidFill>
             <a:srgbClr val="000000"/>
           </a:solidFill>
@@ -3172,7 +3259,7 @@
           <a:sym typeface="Arial"/>
         </a:defRPr>
       </a:lvl2pPr>
-      <a:lvl3pPr lvl="2" marR="0" rtl="0" algn="l">
+      <a:lvl3pPr marR="0" lvl="2" algn="l" rtl="0">
         <a:lnSpc>
           <a:spcPct val="100000"/>
         </a:lnSpc>
@@ -3186,7 +3273,7 @@
           <a:srgbClr val="000000"/>
         </a:buClr>
         <a:buFont typeface="Arial"/>
-        <a:defRPr b="0" i="0" spc="0" sz="1400" u="none" cap="none" strike="noStrike">
+        <a:defRPr sz="1400" b="0" i="0" u="none" strike="noStrike" cap="none" spc="0">
           <a:solidFill>
             <a:srgbClr val="000000"/>
           </a:solidFill>
@@ -3196,7 +3283,7 @@
           <a:sym typeface="Arial"/>
         </a:defRPr>
       </a:lvl3pPr>
-      <a:lvl4pPr lvl="3" marR="0" rtl="0" algn="l">
+      <a:lvl4pPr marR="0" lvl="3" algn="l" rtl="0">
         <a:lnSpc>
           <a:spcPct val="100000"/>
         </a:lnSpc>
@@ -3210,7 +3297,7 @@
           <a:srgbClr val="000000"/>
         </a:buClr>
         <a:buFont typeface="Arial"/>
-        <a:defRPr b="0" i="0" spc="0" sz="1400" u="none" cap="none" strike="noStrike">
+        <a:defRPr sz="1400" b="0" i="0" u="none" strike="noStrike" cap="none" spc="0">
           <a:solidFill>
             <a:srgbClr val="000000"/>
           </a:solidFill>
@@ -3220,7 +3307,7 @@
           <a:sym typeface="Arial"/>
         </a:defRPr>
       </a:lvl4pPr>
-      <a:lvl5pPr lvl="4" marR="0" rtl="0" algn="l">
+      <a:lvl5pPr marR="0" lvl="4" algn="l" rtl="0">
         <a:lnSpc>
           <a:spcPct val="100000"/>
         </a:lnSpc>
@@ -3234,7 +3321,7 @@
           <a:srgbClr val="000000"/>
         </a:buClr>
         <a:buFont typeface="Arial"/>
-        <a:defRPr b="0" i="0" spc="0" sz="1400" u="none" cap="none" strike="noStrike">
+        <a:defRPr sz="1400" b="0" i="0" u="none" strike="noStrike" cap="none" spc="0">
           <a:solidFill>
             <a:srgbClr val="000000"/>
           </a:solidFill>
@@ -3244,7 +3331,7 @@
           <a:sym typeface="Arial"/>
         </a:defRPr>
       </a:lvl5pPr>
-      <a:lvl6pPr lvl="5" marR="0" rtl="0" algn="l">
+      <a:lvl6pPr marR="0" lvl="5" algn="l" rtl="0">
         <a:lnSpc>
           <a:spcPct val="100000"/>
         </a:lnSpc>
@@ -3258,7 +3345,7 @@
           <a:srgbClr val="000000"/>
         </a:buClr>
         <a:buFont typeface="Arial"/>
-        <a:defRPr b="0" i="0" spc="0" sz="1400" u="none" cap="none" strike="noStrike">
+        <a:defRPr sz="1400" b="0" i="0" u="none" strike="noStrike" cap="none" spc="0">
           <a:solidFill>
             <a:srgbClr val="000000"/>
           </a:solidFill>
@@ -3268,7 +3355,7 @@
           <a:sym typeface="Arial"/>
         </a:defRPr>
       </a:lvl6pPr>
-      <a:lvl7pPr lvl="6" marR="0" rtl="0" algn="l">
+      <a:lvl7pPr marR="0" lvl="6" algn="l" rtl="0">
         <a:lnSpc>
           <a:spcPct val="100000"/>
         </a:lnSpc>
@@ -3282,7 +3369,7 @@
           <a:srgbClr val="000000"/>
         </a:buClr>
         <a:buFont typeface="Arial"/>
-        <a:defRPr b="0" i="0" spc="0" sz="1400" u="none" cap="none" strike="noStrike">
+        <a:defRPr sz="1400" b="0" i="0" u="none" strike="noStrike" cap="none" spc="0">
           <a:solidFill>
             <a:srgbClr val="000000"/>
           </a:solidFill>
@@ -3292,7 +3379,7 @@
           <a:sym typeface="Arial"/>
         </a:defRPr>
       </a:lvl7pPr>
-      <a:lvl8pPr lvl="7" marR="0" rtl="0" algn="l">
+      <a:lvl8pPr marR="0" lvl="7" algn="l" rtl="0">
         <a:lnSpc>
           <a:spcPct val="100000"/>
         </a:lnSpc>
@@ -3306,7 +3393,7 @@
           <a:srgbClr val="000000"/>
         </a:buClr>
         <a:buFont typeface="Arial"/>
-        <a:defRPr b="0" i="0" spc="0" sz="1400" u="none" cap="none" strike="noStrike">
+        <a:defRPr sz="1400" b="0" i="0" u="none" strike="noStrike" cap="none" spc="0">
           <a:solidFill>
             <a:srgbClr val="000000"/>
           </a:solidFill>
@@ -3316,7 +3403,7 @@
           <a:sym typeface="Arial"/>
         </a:defRPr>
       </a:lvl8pPr>
-      <a:lvl9pPr lvl="8" marR="0" rtl="0" algn="l">
+      <a:lvl9pPr marR="0" lvl="8" algn="l" rtl="0">
         <a:lnSpc>
           <a:spcPct val="100000"/>
         </a:lnSpc>
@@ -3330,7 +3417,7 @@
           <a:srgbClr val="000000"/>
         </a:buClr>
         <a:buFont typeface="Arial"/>
-        <a:defRPr b="0" i="0" spc="0" sz="1400" u="none" cap="none" strike="noStrike">
+        <a:defRPr sz="1400" b="0" i="0" u="none" strike="noStrike" cap="none" spc="0">
           <a:solidFill>
             <a:srgbClr val="000000"/>
           </a:solidFill>
@@ -3346,11 +3433,11 @@
 </file>
 
 <file path=ppt/slides/slide1.xml><?xml version="1.0" encoding="utf-8"?>
-<p:sld xmlns:a="http://schemas.openxmlformats.org/drawingml/2006/main" xmlns:r="http://schemas.openxmlformats.org/officeDocument/2006/relationships" xmlns:mc="http://schemas.openxmlformats.org/markup-compatibility/2006" xmlns:mv="urn:schemas-microsoft-com:mac:vml" xmlns:p="http://schemas.openxmlformats.org/presentationml/2006/main" xmlns:c="http://schemas.openxmlformats.org/drawingml/2006/chart" xmlns:dgm="http://schemas.openxmlformats.org/drawingml/2006/diagram" xmlns:o="urn:schemas-microsoft-com:office:office" xmlns:v="urn:schemas-microsoft-com:vml" xmlns:pvml="urn:schemas-microsoft-com:office:powerpoint" xmlns:com="http://schemas.openxmlformats.org/drawingml/2006/compatibility" xmlns:p14="http://schemas.microsoft.com/office/powerpoint/2010/main" xmlns:p15="http://schemas.microsoft.com/office/powerpoint/2012/main" xmlns:ahyp="http://schemas.microsoft.com/office/drawing/2018/hyperlinkcolor">
+<p:sld xmlns:a="http://schemas.openxmlformats.org/drawingml/2006/main" xmlns:r="http://schemas.openxmlformats.org/officeDocument/2006/relationships" xmlns:p="http://schemas.openxmlformats.org/presentationml/2006/main">
   <p:cSld>
     <p:spTree>
       <p:nvGrpSpPr>
-        <p:cNvPr id="15" name="Shape 15"/>
+        <p:cNvPr id="1" name="Shape 15"/>
         <p:cNvGrpSpPr/>
         <p:nvPr/>
       </p:nvGrpSpPr>
@@ -3382,12 +3469,12 @@
           </a:ln>
         </p:spPr>
         <p:txBody>
-          <a:bodyPr anchorCtr="0" anchor="t" bIns="0" lIns="0" spcFirstLastPara="1" rIns="0" wrap="square" tIns="0">
+          <a:bodyPr spcFirstLastPara="1" wrap="square" lIns="0" tIns="0" rIns="0" bIns="0" anchor="t" anchorCtr="0">
             <a:noAutofit/>
           </a:bodyPr>
           <a:lstStyle/>
           <a:p>
-            <a:pPr indent="0" lvl="0" marL="0" marR="0" rtl="0" algn="ctr">
+            <a:pPr marL="0" marR="0" lvl="0" indent="0" algn="ctr" rtl="0">
               <a:lnSpc>
                 <a:spcPct val="104000"/>
               </a:lnSpc>
@@ -3405,7 +3492,7 @@
               <a:buNone/>
             </a:pPr>
             <a:r>
-              <a:rPr b="1" lang="en-US" sz="3900">
+              <a:rPr lang="en-US" sz="3900" b="1">
                 <a:solidFill>
                   <a:srgbClr val="FF8AAF"/>
                 </a:solidFill>
@@ -3448,12 +3535,12 @@
           </a:ln>
         </p:spPr>
         <p:txBody>
-          <a:bodyPr anchorCtr="0" anchor="t" bIns="0" lIns="0" spcFirstLastPara="1" rIns="0" wrap="square" tIns="0">
+          <a:bodyPr spcFirstLastPara="1" wrap="square" lIns="0" tIns="0" rIns="0" bIns="0" anchor="t" anchorCtr="0">
             <a:noAutofit/>
           </a:bodyPr>
           <a:lstStyle/>
           <a:p>
-            <a:pPr indent="0" lvl="0" marL="0" marR="0" rtl="0" algn="ctr">
+            <a:pPr marL="0" marR="0" lvl="0" indent="0" algn="ctr" rtl="0">
               <a:lnSpc>
                 <a:spcPct val="104000"/>
               </a:lnSpc>
@@ -3471,7 +3558,7 @@
               <a:buNone/>
             </a:pPr>
             <a:r>
-              <a:rPr b="1" lang="en-US" sz="1950">
+              <a:rPr lang="en-US" sz="1950" b="1">
                 <a:solidFill>
                   <a:srgbClr val="FF8AAF"/>
                 </a:solidFill>
@@ -3514,12 +3601,12 @@
           </a:ln>
         </p:spPr>
         <p:txBody>
-          <a:bodyPr anchorCtr="0" anchor="t" bIns="0" lIns="0" spcFirstLastPara="1" rIns="0" wrap="square" tIns="0">
+          <a:bodyPr spcFirstLastPara="1" wrap="square" lIns="0" tIns="0" rIns="0" bIns="0" anchor="t" anchorCtr="0">
             <a:noAutofit/>
           </a:bodyPr>
           <a:lstStyle/>
           <a:p>
-            <a:pPr indent="0" lvl="0" marL="0" marR="0" rtl="0" algn="ctr">
+            <a:pPr marL="0" marR="0" lvl="0" indent="0" algn="ctr" rtl="0">
               <a:lnSpc>
                 <a:spcPct val="133000"/>
               </a:lnSpc>
@@ -3559,7 +3646,7 @@
             </a:endParaRPr>
           </a:p>
           <a:p>
-            <a:pPr indent="0" lvl="0" marL="0" marR="0" rtl="0" algn="ctr">
+            <a:pPr marL="0" marR="0" lvl="0" indent="0" algn="ctr" rtl="0">
               <a:lnSpc>
                 <a:spcPct val="133000"/>
               </a:lnSpc>
@@ -3591,7 +3678,7 @@
             <a:endParaRPr/>
           </a:p>
           <a:p>
-            <a:pPr indent="0" lvl="0" marL="0" marR="0" rtl="0" algn="ctr">
+            <a:pPr marL="0" marR="0" lvl="0" indent="0" algn="ctr" rtl="0">
               <a:lnSpc>
                 <a:spcPct val="133000"/>
               </a:lnSpc>
@@ -3623,7 +3710,7 @@
             <a:endParaRPr/>
           </a:p>
           <a:p>
-            <a:pPr indent="0" lvl="0" marL="0" marR="0" rtl="0" algn="ctr">
+            <a:pPr marL="0" marR="0" lvl="0" indent="0" algn="ctr" rtl="0">
               <a:lnSpc>
                 <a:spcPct val="133000"/>
               </a:lnSpc>
@@ -3655,7 +3742,7 @@
             <a:endParaRPr/>
           </a:p>
           <a:p>
-            <a:pPr indent="0" lvl="0" marL="0" marR="0" rtl="0" algn="ctr">
+            <a:pPr marL="0" marR="0" lvl="0" indent="0" algn="ctr" rtl="0">
               <a:lnSpc>
                 <a:spcPct val="133000"/>
               </a:lnSpc>
@@ -3725,11 +3812,11 @@
 </file>
 
 <file path=ppt/slides/slide10.xml><?xml version="1.0" encoding="utf-8"?>
-<p:sld xmlns:a="http://schemas.openxmlformats.org/drawingml/2006/main" xmlns:r="http://schemas.openxmlformats.org/officeDocument/2006/relationships" xmlns:mc="http://schemas.openxmlformats.org/markup-compatibility/2006" xmlns:mv="urn:schemas-microsoft-com:mac:vml" xmlns:p="http://schemas.openxmlformats.org/presentationml/2006/main" xmlns:c="http://schemas.openxmlformats.org/drawingml/2006/chart" xmlns:dgm="http://schemas.openxmlformats.org/drawingml/2006/diagram" xmlns:o="urn:schemas-microsoft-com:office:office" xmlns:v="urn:schemas-microsoft-com:vml" xmlns:pvml="urn:schemas-microsoft-com:office:powerpoint" xmlns:com="http://schemas.openxmlformats.org/drawingml/2006/compatibility" xmlns:p14="http://schemas.microsoft.com/office/powerpoint/2010/main" xmlns:p15="http://schemas.microsoft.com/office/powerpoint/2012/main" xmlns:ahyp="http://schemas.microsoft.com/office/drawing/2018/hyperlinkcolor">
+<p:sld xmlns:a="http://schemas.openxmlformats.org/drawingml/2006/main" xmlns:r="http://schemas.openxmlformats.org/officeDocument/2006/relationships" xmlns:p="http://schemas.openxmlformats.org/presentationml/2006/main">
   <p:cSld>
     <p:spTree>
       <p:nvGrpSpPr>
-        <p:cNvPr id="135" name="Shape 135"/>
+        <p:cNvPr id="1" name="Shape 135"/>
         <p:cNvGrpSpPr/>
         <p:nvPr/>
       </p:nvGrpSpPr>
@@ -3761,12 +3848,12 @@
           </a:ln>
         </p:spPr>
         <p:txBody>
-          <a:bodyPr anchorCtr="0" anchor="t" bIns="0" lIns="0" spcFirstLastPara="1" rIns="0" wrap="square" tIns="0">
+          <a:bodyPr spcFirstLastPara="1" wrap="square" lIns="0" tIns="0" rIns="0" bIns="0" anchor="t" anchorCtr="0">
             <a:noAutofit/>
           </a:bodyPr>
           <a:lstStyle/>
           <a:p>
-            <a:pPr indent="0" lvl="0" marL="0" marR="0" rtl="0" algn="ctr">
+            <a:pPr marL="0" marR="0" lvl="0" indent="0" algn="ctr" rtl="0">
               <a:lnSpc>
                 <a:spcPct val="104000"/>
               </a:lnSpc>
@@ -3784,7 +3871,7 @@
               <a:buNone/>
             </a:pPr>
             <a:r>
-              <a:rPr b="1" lang="en-US" sz="3900">
+              <a:rPr lang="en-US" sz="3900" b="1">
                 <a:solidFill>
                   <a:srgbClr val="FF8AAF"/>
                 </a:solidFill>
@@ -3827,12 +3914,12 @@
           </a:ln>
         </p:spPr>
         <p:txBody>
-          <a:bodyPr anchorCtr="0" anchor="t" bIns="0" lIns="0" spcFirstLastPara="1" rIns="0" wrap="square" tIns="0">
+          <a:bodyPr spcFirstLastPara="1" wrap="square" lIns="0" tIns="0" rIns="0" bIns="0" anchor="t" anchorCtr="0">
             <a:noAutofit/>
           </a:bodyPr>
           <a:lstStyle/>
           <a:p>
-            <a:pPr indent="0" lvl="0" marL="0" marR="0" rtl="0" algn="ctr">
+            <a:pPr marL="0" marR="0" lvl="0" indent="0" algn="ctr" rtl="0">
               <a:lnSpc>
                 <a:spcPct val="104000"/>
               </a:lnSpc>
@@ -3850,7 +3937,7 @@
               <a:buNone/>
             </a:pPr>
             <a:r>
-              <a:rPr b="1" lang="en-US" sz="7800">
+              <a:rPr lang="en-US" sz="7800" b="1">
                 <a:solidFill>
                   <a:srgbClr val="FF8AAF"/>
                 </a:solidFill>
@@ -3886,7 +3973,7 @@
           </a:xfrm>
           <a:prstGeom prst="roundRect">
             <a:avLst>
-              <a:gd fmla="val 49999" name="adj"/>
+              <a:gd name="adj" fmla="val 49999"/>
             </a:avLst>
           </a:prstGeom>
           <a:solidFill>
@@ -3899,12 +3986,12 @@
           </a:ln>
         </p:spPr>
         <p:txBody>
-          <a:bodyPr anchorCtr="0" anchor="t" bIns="45700" lIns="91425" spcFirstLastPara="1" rIns="91425" wrap="square" tIns="45700">
+          <a:bodyPr spcFirstLastPara="1" wrap="square" lIns="91425" tIns="45700" rIns="91425" bIns="45700" anchor="t" anchorCtr="0">
             <a:noAutofit/>
           </a:bodyPr>
           <a:lstStyle/>
           <a:p>
-            <a:pPr indent="0" lvl="0" marL="0" marR="0" rtl="0" algn="l">
+            <a:pPr marL="0" marR="0" lvl="0" indent="0" algn="l" rtl="0">
               <a:spcBef>
                 <a:spcPts val="0"/>
               </a:spcBef>
@@ -3913,9 +4000,6 @@
               </a:spcAft>
               <a:buNone/>
             </a:pPr>
-            <a:r>
-              <a:t/>
-            </a:r>
             <a:endParaRPr sz="1800">
               <a:solidFill>
                 <a:schemeClr val="dk1"/>
@@ -3965,11 +4049,11 @@
 </file>
 
 <file path=ppt/slides/slide2.xml><?xml version="1.0" encoding="utf-8"?>
-<p:sld xmlns:a="http://schemas.openxmlformats.org/drawingml/2006/main" xmlns:r="http://schemas.openxmlformats.org/officeDocument/2006/relationships" xmlns:mc="http://schemas.openxmlformats.org/markup-compatibility/2006" xmlns:mv="urn:schemas-microsoft-com:mac:vml" xmlns:p="http://schemas.openxmlformats.org/presentationml/2006/main" xmlns:c="http://schemas.openxmlformats.org/drawingml/2006/chart" xmlns:dgm="http://schemas.openxmlformats.org/drawingml/2006/diagram" xmlns:o="urn:schemas-microsoft-com:office:office" xmlns:v="urn:schemas-microsoft-com:vml" xmlns:pvml="urn:schemas-microsoft-com:office:powerpoint" xmlns:com="http://schemas.openxmlformats.org/drawingml/2006/compatibility" xmlns:p14="http://schemas.microsoft.com/office/powerpoint/2010/main" xmlns:p15="http://schemas.microsoft.com/office/powerpoint/2012/main" xmlns:ahyp="http://schemas.microsoft.com/office/drawing/2018/hyperlinkcolor">
+<p:sld xmlns:a="http://schemas.openxmlformats.org/drawingml/2006/main" xmlns:r="http://schemas.openxmlformats.org/officeDocument/2006/relationships" xmlns:p="http://schemas.openxmlformats.org/presentationml/2006/main">
   <p:cSld>
     <p:spTree>
       <p:nvGrpSpPr>
-        <p:cNvPr id="24" name="Shape 24"/>
+        <p:cNvPr id="1" name="Shape 24"/>
         <p:cNvGrpSpPr/>
         <p:nvPr/>
       </p:nvGrpSpPr>
@@ -4001,12 +4085,12 @@
           </a:ln>
         </p:spPr>
         <p:txBody>
-          <a:bodyPr anchorCtr="0" anchor="t" bIns="0" lIns="0" spcFirstLastPara="1" rIns="0" wrap="square" tIns="0">
+          <a:bodyPr spcFirstLastPara="1" wrap="square" lIns="0" tIns="0" rIns="0" bIns="0" anchor="t" anchorCtr="0">
             <a:noAutofit/>
           </a:bodyPr>
           <a:lstStyle/>
           <a:p>
-            <a:pPr indent="0" lvl="0" marL="0" marR="0" rtl="0" algn="l">
+            <a:pPr marL="0" marR="0" lvl="0" indent="0" algn="l" rtl="0">
               <a:lnSpc>
                 <a:spcPct val="104000"/>
               </a:lnSpc>
@@ -4024,7 +4108,7 @@
               <a:buNone/>
             </a:pPr>
             <a:r>
-              <a:rPr b="1" lang="en-US" sz="3900">
+              <a:rPr lang="en-US" sz="3900" b="1">
                 <a:solidFill>
                   <a:srgbClr val="FF8AAF"/>
                 </a:solidFill>
@@ -4067,12 +4151,12 @@
           </a:ln>
         </p:spPr>
         <p:txBody>
-          <a:bodyPr anchorCtr="0" anchor="t" bIns="0" lIns="0" spcFirstLastPara="1" rIns="0" wrap="square" tIns="0">
+          <a:bodyPr spcFirstLastPara="1" wrap="square" lIns="0" tIns="0" rIns="0" bIns="0" anchor="t" anchorCtr="0">
             <a:noAutofit/>
           </a:bodyPr>
           <a:lstStyle/>
           <a:p>
-            <a:pPr indent="0" lvl="0" marL="0" marR="0" rtl="0" algn="l">
+            <a:pPr marL="0" marR="0" lvl="0" indent="0" algn="l" rtl="0">
               <a:lnSpc>
                 <a:spcPct val="104000"/>
               </a:lnSpc>
@@ -4090,7 +4174,7 @@
               <a:buNone/>
             </a:pPr>
             <a:r>
-              <a:rPr b="1" lang="en-US" sz="1950">
+              <a:rPr lang="en-US" sz="1950" b="1">
                 <a:solidFill>
                   <a:srgbClr val="FF8AAF"/>
                 </a:solidFill>
@@ -4133,12 +4217,12 @@
           </a:ln>
         </p:spPr>
         <p:txBody>
-          <a:bodyPr anchorCtr="0" anchor="t" bIns="0" lIns="0" spcFirstLastPara="1" rIns="0" wrap="square" tIns="0">
+          <a:bodyPr spcFirstLastPara="1" wrap="square" lIns="0" tIns="0" rIns="0" bIns="0" anchor="t" anchorCtr="0">
             <a:normAutofit/>
           </a:bodyPr>
           <a:lstStyle/>
           <a:p>
-            <a:pPr indent="0" lvl="0" marL="0" marR="0" rtl="0" algn="l">
+            <a:pPr marL="0" marR="0" lvl="0" indent="0" algn="l" rtl="0">
               <a:lnSpc>
                 <a:spcPct val="133000"/>
               </a:lnSpc>
@@ -4168,7 +4252,7 @@
               <a:t>Sonido Vivo lleva 11 años en Viña del Mar, pero gestiona todo de forma manual: los pedidos llegan por WhatsApp e Instagram, y </a:t>
             </a:r>
             <a:r>
-              <a:rPr b="1" lang="en-US" sz="1450">
+              <a:rPr lang="en-US" sz="1450" b="1">
                 <a:solidFill>
                   <a:srgbClr val="E0D6DE"/>
                 </a:solidFill>
@@ -4190,7 +4274,7 @@
             </a:endParaRPr>
           </a:p>
           <a:p>
-            <a:pPr indent="0" lvl="0" marL="0" marR="0" rtl="0" algn="l">
+            <a:pPr marL="0" marR="0" lvl="0" indent="0" algn="l" rtl="0">
               <a:lnSpc>
                 <a:spcPct val="133000"/>
               </a:lnSpc>
@@ -4220,7 +4304,7 @@
               <a:t>Su catálogo de más de </a:t>
             </a:r>
             <a:r>
-              <a:rPr b="1" lang="en-US" sz="1450">
+              <a:rPr lang="en-US" sz="1450" b="1">
                 <a:solidFill>
                   <a:srgbClr val="E0D6DE"/>
                 </a:solidFill>
@@ -4275,12 +4359,12 @@
           </a:ln>
         </p:spPr>
         <p:txBody>
-          <a:bodyPr anchorCtr="0" anchor="t" bIns="0" lIns="0" spcFirstLastPara="1" rIns="0" wrap="square" tIns="0">
+          <a:bodyPr spcFirstLastPara="1" wrap="square" lIns="0" tIns="0" rIns="0" bIns="0" anchor="t" anchorCtr="0">
             <a:noAutofit/>
           </a:bodyPr>
           <a:lstStyle/>
           <a:p>
-            <a:pPr indent="0" lvl="0" marL="0" marR="0" rtl="0" algn="ctr">
+            <a:pPr marL="0" marR="0" lvl="0" indent="0" algn="ctr" rtl="0">
               <a:lnSpc>
                 <a:spcPct val="83000"/>
               </a:lnSpc>
@@ -4298,7 +4382,7 @@
               <a:buNone/>
             </a:pPr>
             <a:r>
-              <a:rPr b="1" lang="en-US" sz="4900">
+              <a:rPr lang="en-US" sz="4900" b="1">
                 <a:solidFill>
                   <a:srgbClr val="E0D6DE"/>
                 </a:solidFill>
@@ -4341,12 +4425,12 @@
           </a:ln>
         </p:spPr>
         <p:txBody>
-          <a:bodyPr anchorCtr="0" anchor="t" bIns="0" lIns="0" spcFirstLastPara="1" rIns="0" wrap="square" tIns="0">
+          <a:bodyPr spcFirstLastPara="1" wrap="square" lIns="0" tIns="0" rIns="0" bIns="0" anchor="t" anchorCtr="0">
             <a:noAutofit/>
           </a:bodyPr>
           <a:lstStyle/>
           <a:p>
-            <a:pPr indent="0" lvl="0" marL="0" marR="0" rtl="0" algn="ctr">
+            <a:pPr marL="0" marR="0" lvl="0" indent="0" algn="ctr" rtl="0">
               <a:lnSpc>
                 <a:spcPct val="104000"/>
               </a:lnSpc>
@@ -4364,7 +4448,7 @@
               <a:buNone/>
             </a:pPr>
             <a:r>
-              <a:rPr b="1" lang="en-US" sz="1950">
+              <a:rPr lang="en-US" sz="1950" b="1">
                 <a:solidFill>
                   <a:srgbClr val="E0D6DE"/>
                 </a:solidFill>
@@ -4407,12 +4491,12 @@
           </a:ln>
         </p:spPr>
         <p:txBody>
-          <a:bodyPr anchorCtr="0" anchor="t" bIns="0" lIns="0" spcFirstLastPara="1" rIns="0" wrap="square" tIns="0">
+          <a:bodyPr spcFirstLastPara="1" wrap="square" lIns="0" tIns="0" rIns="0" bIns="0" anchor="t" anchorCtr="0">
             <a:noAutofit/>
           </a:bodyPr>
           <a:lstStyle/>
           <a:p>
-            <a:pPr indent="0" lvl="0" marL="0" marR="0" rtl="0" algn="ctr">
+            <a:pPr marL="0" marR="0" lvl="0" indent="0" algn="ctr" rtl="0">
               <a:lnSpc>
                 <a:spcPct val="133000"/>
               </a:lnSpc>
@@ -4473,12 +4557,12 @@
           </a:ln>
         </p:spPr>
         <p:txBody>
-          <a:bodyPr anchorCtr="0" anchor="t" bIns="0" lIns="0" spcFirstLastPara="1" rIns="0" wrap="square" tIns="0">
+          <a:bodyPr spcFirstLastPara="1" wrap="square" lIns="0" tIns="0" rIns="0" bIns="0" anchor="t" anchorCtr="0">
             <a:noAutofit/>
           </a:bodyPr>
           <a:lstStyle/>
           <a:p>
-            <a:pPr indent="0" lvl="0" marL="0" marR="0" rtl="0" algn="ctr">
+            <a:pPr marL="0" marR="0" lvl="0" indent="0" algn="ctr" rtl="0">
               <a:lnSpc>
                 <a:spcPct val="83000"/>
               </a:lnSpc>
@@ -4496,7 +4580,7 @@
               <a:buNone/>
             </a:pPr>
             <a:r>
-              <a:rPr b="1" lang="en-US" sz="4900">
+              <a:rPr lang="en-US" sz="4900" b="1">
                 <a:solidFill>
                   <a:srgbClr val="E0D6DE"/>
                 </a:solidFill>
@@ -4539,12 +4623,12 @@
           </a:ln>
         </p:spPr>
         <p:txBody>
-          <a:bodyPr anchorCtr="0" anchor="t" bIns="0" lIns="0" spcFirstLastPara="1" rIns="0" wrap="square" tIns="0">
+          <a:bodyPr spcFirstLastPara="1" wrap="square" lIns="0" tIns="0" rIns="0" bIns="0" anchor="t" anchorCtr="0">
             <a:noAutofit/>
           </a:bodyPr>
           <a:lstStyle/>
           <a:p>
-            <a:pPr indent="0" lvl="0" marL="0" marR="0" rtl="0" algn="ctr">
+            <a:pPr marL="0" marR="0" lvl="0" indent="0" algn="ctr" rtl="0">
               <a:lnSpc>
                 <a:spcPct val="104000"/>
               </a:lnSpc>
@@ -4562,7 +4646,7 @@
               <a:buNone/>
             </a:pPr>
             <a:r>
-              <a:rPr b="1" lang="en-US" sz="1950">
+              <a:rPr lang="en-US" sz="1950" b="1">
                 <a:solidFill>
                   <a:srgbClr val="E0D6DE"/>
                 </a:solidFill>
@@ -4605,12 +4689,12 @@
           </a:ln>
         </p:spPr>
         <p:txBody>
-          <a:bodyPr anchorCtr="0" anchor="t" bIns="0" lIns="0" spcFirstLastPara="1" rIns="0" wrap="square" tIns="0">
+          <a:bodyPr spcFirstLastPara="1" wrap="square" lIns="0" tIns="0" rIns="0" bIns="0" anchor="t" anchorCtr="0">
             <a:noAutofit/>
           </a:bodyPr>
           <a:lstStyle/>
           <a:p>
-            <a:pPr indent="0" lvl="0" marL="0" marR="0" rtl="0" algn="ctr">
+            <a:pPr marL="0" marR="0" lvl="0" indent="0" algn="ctr" rtl="0">
               <a:lnSpc>
                 <a:spcPct val="133000"/>
               </a:lnSpc>
@@ -4671,12 +4755,12 @@
           </a:ln>
         </p:spPr>
         <p:txBody>
-          <a:bodyPr anchorCtr="0" anchor="t" bIns="0" lIns="0" spcFirstLastPara="1" rIns="0" wrap="square" tIns="0">
+          <a:bodyPr spcFirstLastPara="1" wrap="square" lIns="0" tIns="0" rIns="0" bIns="0" anchor="t" anchorCtr="0">
             <a:noAutofit/>
           </a:bodyPr>
           <a:lstStyle/>
           <a:p>
-            <a:pPr indent="0" lvl="0" marL="0" marR="0" rtl="0" algn="ctr">
+            <a:pPr marL="0" marR="0" lvl="0" indent="0" algn="ctr" rtl="0">
               <a:lnSpc>
                 <a:spcPct val="83000"/>
               </a:lnSpc>
@@ -4694,7 +4778,7 @@
               <a:buNone/>
             </a:pPr>
             <a:r>
-              <a:rPr b="1" lang="en-US" sz="4900">
+              <a:rPr lang="en-US" sz="4900" b="1">
                 <a:solidFill>
                   <a:srgbClr val="E0D6DE"/>
                 </a:solidFill>
@@ -4737,12 +4821,12 @@
           </a:ln>
         </p:spPr>
         <p:txBody>
-          <a:bodyPr anchorCtr="0" anchor="t" bIns="0" lIns="0" spcFirstLastPara="1" rIns="0" wrap="square" tIns="0">
+          <a:bodyPr spcFirstLastPara="1" wrap="square" lIns="0" tIns="0" rIns="0" bIns="0" anchor="t" anchorCtr="0">
             <a:noAutofit/>
           </a:bodyPr>
           <a:lstStyle/>
           <a:p>
-            <a:pPr indent="0" lvl="0" marL="0" marR="0" rtl="0" algn="ctr">
+            <a:pPr marL="0" marR="0" lvl="0" indent="0" algn="ctr" rtl="0">
               <a:lnSpc>
                 <a:spcPct val="104000"/>
               </a:lnSpc>
@@ -4760,7 +4844,7 @@
               <a:buNone/>
             </a:pPr>
             <a:r>
-              <a:rPr b="1" lang="en-US" sz="1950">
+              <a:rPr lang="en-US" sz="1950" b="1">
                 <a:solidFill>
                   <a:srgbClr val="E0D6DE"/>
                 </a:solidFill>
@@ -4803,12 +4887,12 @@
           </a:ln>
         </p:spPr>
         <p:txBody>
-          <a:bodyPr anchorCtr="0" anchor="t" bIns="0" lIns="0" spcFirstLastPara="1" rIns="0" wrap="square" tIns="0">
+          <a:bodyPr spcFirstLastPara="1" wrap="square" lIns="0" tIns="0" rIns="0" bIns="0" anchor="t" anchorCtr="0">
             <a:noAutofit/>
           </a:bodyPr>
           <a:lstStyle/>
           <a:p>
-            <a:pPr indent="0" lvl="0" marL="0" marR="0" rtl="0" algn="ctr">
+            <a:pPr marL="0" marR="0" lvl="0" indent="0" algn="ctr" rtl="0">
               <a:lnSpc>
                 <a:spcPct val="133000"/>
               </a:lnSpc>
@@ -4886,11 +4970,11 @@
 </file>
 
 <file path=ppt/slides/slide3.xml><?xml version="1.0" encoding="utf-8"?>
-<p:sld xmlns:a="http://schemas.openxmlformats.org/drawingml/2006/main" xmlns:r="http://schemas.openxmlformats.org/officeDocument/2006/relationships" xmlns:mc="http://schemas.openxmlformats.org/markup-compatibility/2006" xmlns:mv="urn:schemas-microsoft-com:mac:vml" xmlns:p="http://schemas.openxmlformats.org/presentationml/2006/main" xmlns:c="http://schemas.openxmlformats.org/drawingml/2006/chart" xmlns:dgm="http://schemas.openxmlformats.org/drawingml/2006/diagram" xmlns:o="urn:schemas-microsoft-com:office:office" xmlns:v="urn:schemas-microsoft-com:vml" xmlns:pvml="urn:schemas-microsoft-com:office:powerpoint" xmlns:com="http://schemas.openxmlformats.org/drawingml/2006/compatibility" xmlns:p14="http://schemas.microsoft.com/office/powerpoint/2010/main" xmlns:p15="http://schemas.microsoft.com/office/powerpoint/2012/main" xmlns:ahyp="http://schemas.microsoft.com/office/drawing/2018/hyperlinkcolor">
+<p:sld xmlns:a="http://schemas.openxmlformats.org/drawingml/2006/main" xmlns:r="http://schemas.openxmlformats.org/officeDocument/2006/relationships" xmlns:p="http://schemas.openxmlformats.org/presentationml/2006/main">
   <p:cSld>
     <p:spTree>
       <p:nvGrpSpPr>
-        <p:cNvPr id="42" name="Shape 42"/>
+        <p:cNvPr id="1" name="Shape 42"/>
         <p:cNvGrpSpPr/>
         <p:nvPr/>
       </p:nvGrpSpPr>
@@ -4922,12 +5006,12 @@
           </a:ln>
         </p:spPr>
         <p:txBody>
-          <a:bodyPr anchorCtr="0" anchor="t" bIns="0" lIns="0" spcFirstLastPara="1" rIns="0" wrap="square" tIns="0">
+          <a:bodyPr spcFirstLastPara="1" wrap="square" lIns="0" tIns="0" rIns="0" bIns="0" anchor="t" anchorCtr="0">
             <a:noAutofit/>
           </a:bodyPr>
           <a:lstStyle/>
           <a:p>
-            <a:pPr indent="0" lvl="0" marL="0" marR="0" rtl="0" algn="l">
+            <a:pPr marL="0" marR="0" lvl="0" indent="0" algn="l" rtl="0">
               <a:lnSpc>
                 <a:spcPct val="104000"/>
               </a:lnSpc>
@@ -4945,7 +5029,7 @@
               <a:buNone/>
             </a:pPr>
             <a:r>
-              <a:rPr b="1" lang="en-US" sz="3900">
+              <a:rPr lang="en-US" sz="3900" b="1">
                 <a:solidFill>
                   <a:srgbClr val="FF8AAF"/>
                 </a:solidFill>
@@ -4988,12 +5072,12 @@
           </a:ln>
         </p:spPr>
         <p:txBody>
-          <a:bodyPr anchorCtr="0" anchor="t" bIns="0" lIns="0" spcFirstLastPara="1" rIns="0" wrap="square" tIns="0">
+          <a:bodyPr spcFirstLastPara="1" wrap="square" lIns="0" tIns="0" rIns="0" bIns="0" anchor="t" anchorCtr="0">
             <a:normAutofit/>
           </a:bodyPr>
           <a:lstStyle/>
           <a:p>
-            <a:pPr indent="0" lvl="0" marL="0" marR="0" rtl="0" algn="l">
+            <a:pPr marL="0" marR="0" lvl="0" indent="0" algn="l" rtl="0">
               <a:lnSpc>
                 <a:spcPct val="133000"/>
               </a:lnSpc>
@@ -5047,29 +5131,29 @@
           </a:xfrm>
           <a:prstGeom prst="roundRect">
             <a:avLst>
-              <a:gd fmla="val 3650" name="adj"/>
+              <a:gd name="adj" fmla="val 3650"/>
             </a:avLst>
           </a:prstGeom>
           <a:solidFill>
             <a:srgbClr val="2F1D63"/>
           </a:solidFill>
-          <a:ln cap="flat" cmpd="sng" w="9525">
+          <a:ln w="9525" cap="flat" cmpd="sng">
             <a:solidFill>
               <a:srgbClr val="48367C"/>
             </a:solidFill>
             <a:prstDash val="solid"/>
             <a:round/>
-            <a:headEnd len="sm" w="sm" type="none"/>
-            <a:tailEnd len="sm" w="sm" type="none"/>
+            <a:headEnd type="none" w="sm" len="sm"/>
+            <a:tailEnd type="none" w="sm" len="sm"/>
           </a:ln>
         </p:spPr>
         <p:txBody>
-          <a:bodyPr anchorCtr="0" anchor="t" bIns="45700" lIns="91425" spcFirstLastPara="1" rIns="91425" wrap="square" tIns="45700">
+          <a:bodyPr spcFirstLastPara="1" wrap="square" lIns="91425" tIns="45700" rIns="91425" bIns="45700" anchor="t" anchorCtr="0">
             <a:noAutofit/>
           </a:bodyPr>
           <a:lstStyle/>
           <a:p>
-            <a:pPr indent="0" lvl="0" marL="0" marR="0" rtl="0" algn="l">
+            <a:pPr marL="0" marR="0" lvl="0" indent="0" algn="l" rtl="0">
               <a:spcBef>
                 <a:spcPts val="0"/>
               </a:spcBef>
@@ -5078,9 +5162,6 @@
               </a:spcAft>
               <a:buNone/>
             </a:pPr>
-            <a:r>
-              <a:t/>
-            </a:r>
             <a:endParaRPr sz="1800">
               <a:solidFill>
                 <a:schemeClr val="dk1"/>
@@ -5115,12 +5196,12 @@
           </a:ln>
         </p:spPr>
         <p:txBody>
-          <a:bodyPr anchorCtr="0" anchor="t" bIns="45700" lIns="91425" spcFirstLastPara="1" rIns="91425" wrap="square" tIns="45700">
+          <a:bodyPr spcFirstLastPara="1" wrap="square" lIns="91425" tIns="45700" rIns="91425" bIns="45700" anchor="t" anchorCtr="0">
             <a:noAutofit/>
           </a:bodyPr>
           <a:lstStyle/>
           <a:p>
-            <a:pPr indent="0" lvl="0" marL="0" marR="0" rtl="0" algn="l">
+            <a:pPr marL="0" marR="0" lvl="0" indent="0" algn="l" rtl="0">
               <a:spcBef>
                 <a:spcPts val="0"/>
               </a:spcBef>
@@ -5129,9 +5210,6 @@
               </a:spcAft>
               <a:buNone/>
             </a:pPr>
-            <a:r>
-              <a:t/>
-            </a:r>
             <a:endParaRPr sz="1800">
               <a:solidFill>
                 <a:schemeClr val="dk1"/>
@@ -5146,7 +5224,7 @@
       </p:sp>
       <p:sp>
         <p:nvSpPr>
-          <p:cNvPr descr="preencoded.png" id="47" name="Google Shape;47;p3"/>
+          <p:cNvPr id="47" name="Google Shape;47;p3" descr="preencoded.png"/>
           <p:cNvSpPr/>
           <p:nvPr/>
         </p:nvSpPr>
@@ -5163,6 +5241,13 @@
             <a:noFill/>
           </a:ln>
         </p:spPr>
+        <p:txBody>
+          <a:bodyPr/>
+          <a:lstStyle/>
+          <a:p>
+            <a:endParaRPr lang="es-CL"/>
+          </a:p>
+        </p:txBody>
       </p:sp>
       <p:sp>
         <p:nvSpPr>
@@ -5184,12 +5269,12 @@
           </a:ln>
         </p:spPr>
         <p:txBody>
-          <a:bodyPr anchorCtr="0" anchor="t" bIns="0" lIns="0" spcFirstLastPara="1" rIns="0" wrap="square" tIns="0">
+          <a:bodyPr spcFirstLastPara="1" wrap="square" lIns="0" tIns="0" rIns="0" bIns="0" anchor="t" anchorCtr="0">
             <a:noAutofit/>
           </a:bodyPr>
           <a:lstStyle/>
           <a:p>
-            <a:pPr indent="0" lvl="0" marL="0" marR="0" rtl="0" algn="l">
+            <a:pPr marL="0" marR="0" lvl="0" indent="0" algn="l" rtl="0">
               <a:lnSpc>
                 <a:spcPct val="104000"/>
               </a:lnSpc>
@@ -5207,7 +5292,7 @@
               <a:buNone/>
             </a:pPr>
             <a:r>
-              <a:rPr b="1" lang="en-US" sz="1950">
+              <a:rPr lang="en-US" sz="1950" b="1">
                 <a:solidFill>
                   <a:srgbClr val="E0D6DE"/>
                 </a:solidFill>
@@ -5250,12 +5335,12 @@
           </a:ln>
         </p:spPr>
         <p:txBody>
-          <a:bodyPr anchorCtr="0" anchor="t" bIns="0" lIns="0" spcFirstLastPara="1" rIns="0" wrap="square" tIns="0">
+          <a:bodyPr spcFirstLastPara="1" wrap="square" lIns="0" tIns="0" rIns="0" bIns="0" anchor="t" anchorCtr="0">
             <a:normAutofit/>
           </a:bodyPr>
           <a:lstStyle/>
           <a:p>
-            <a:pPr indent="0" lvl="0" marL="0" marR="0" rtl="0" algn="l">
+            <a:pPr marL="0" marR="0" lvl="0" indent="0" algn="l" rtl="0">
               <a:lnSpc>
                 <a:spcPct val="133000"/>
               </a:lnSpc>
@@ -5309,29 +5394,29 @@
           </a:xfrm>
           <a:prstGeom prst="roundRect">
             <a:avLst>
-              <a:gd fmla="val 3650" name="adj"/>
+              <a:gd name="adj" fmla="val 3650"/>
             </a:avLst>
           </a:prstGeom>
           <a:solidFill>
             <a:srgbClr val="2F1D63"/>
           </a:solidFill>
-          <a:ln cap="flat" cmpd="sng" w="9525">
+          <a:ln w="9525" cap="flat" cmpd="sng">
             <a:solidFill>
               <a:srgbClr val="48367C"/>
             </a:solidFill>
             <a:prstDash val="solid"/>
             <a:round/>
-            <a:headEnd len="sm" w="sm" type="none"/>
-            <a:tailEnd len="sm" w="sm" type="none"/>
+            <a:headEnd type="none" w="sm" len="sm"/>
+            <a:tailEnd type="none" w="sm" len="sm"/>
           </a:ln>
         </p:spPr>
         <p:txBody>
-          <a:bodyPr anchorCtr="0" anchor="t" bIns="45700" lIns="91425" spcFirstLastPara="1" rIns="91425" wrap="square" tIns="45700">
+          <a:bodyPr spcFirstLastPara="1" wrap="square" lIns="91425" tIns="45700" rIns="91425" bIns="45700" anchor="t" anchorCtr="0">
             <a:noAutofit/>
           </a:bodyPr>
           <a:lstStyle/>
           <a:p>
-            <a:pPr indent="0" lvl="0" marL="0" marR="0" rtl="0" algn="l">
+            <a:pPr marL="0" marR="0" lvl="0" indent="0" algn="l" rtl="0">
               <a:spcBef>
                 <a:spcPts val="0"/>
               </a:spcBef>
@@ -5340,9 +5425,6 @@
               </a:spcAft>
               <a:buNone/>
             </a:pPr>
-            <a:r>
-              <a:t/>
-            </a:r>
             <a:endParaRPr sz="1800">
               <a:solidFill>
                 <a:schemeClr val="dk1"/>
@@ -5377,12 +5459,12 @@
           </a:ln>
         </p:spPr>
         <p:txBody>
-          <a:bodyPr anchorCtr="0" anchor="t" bIns="45700" lIns="91425" spcFirstLastPara="1" rIns="91425" wrap="square" tIns="45700">
+          <a:bodyPr spcFirstLastPara="1" wrap="square" lIns="91425" tIns="45700" rIns="91425" bIns="45700" anchor="t" anchorCtr="0">
             <a:noAutofit/>
           </a:bodyPr>
           <a:lstStyle/>
           <a:p>
-            <a:pPr indent="0" lvl="0" marL="0" marR="0" rtl="0" algn="l">
+            <a:pPr marL="0" marR="0" lvl="0" indent="0" algn="l" rtl="0">
               <a:spcBef>
                 <a:spcPts val="0"/>
               </a:spcBef>
@@ -5391,9 +5473,6 @@
               </a:spcAft>
               <a:buNone/>
             </a:pPr>
-            <a:r>
-              <a:t/>
-            </a:r>
             <a:endParaRPr sz="1800">
               <a:solidFill>
                 <a:schemeClr val="dk1"/>
@@ -5408,7 +5487,7 @@
       </p:sp>
       <p:sp>
         <p:nvSpPr>
-          <p:cNvPr descr="preencoded.png" id="52" name="Google Shape;52;p3"/>
+          <p:cNvPr id="52" name="Google Shape;52;p3" descr="preencoded.png"/>
           <p:cNvSpPr/>
           <p:nvPr/>
         </p:nvSpPr>
@@ -5425,6 +5504,13 @@
             <a:noFill/>
           </a:ln>
         </p:spPr>
+        <p:txBody>
+          <a:bodyPr/>
+          <a:lstStyle/>
+          <a:p>
+            <a:endParaRPr lang="es-CL"/>
+          </a:p>
+        </p:txBody>
       </p:sp>
       <p:sp>
         <p:nvSpPr>
@@ -5446,12 +5532,12 @@
           </a:ln>
         </p:spPr>
         <p:txBody>
-          <a:bodyPr anchorCtr="0" anchor="t" bIns="0" lIns="0" spcFirstLastPara="1" rIns="0" wrap="square" tIns="0">
+          <a:bodyPr spcFirstLastPara="1" wrap="square" lIns="0" tIns="0" rIns="0" bIns="0" anchor="t" anchorCtr="0">
             <a:noAutofit/>
           </a:bodyPr>
           <a:lstStyle/>
           <a:p>
-            <a:pPr indent="0" lvl="0" marL="0" marR="0" rtl="0" algn="l">
+            <a:pPr marL="0" marR="0" lvl="0" indent="0" algn="l" rtl="0">
               <a:lnSpc>
                 <a:spcPct val="104000"/>
               </a:lnSpc>
@@ -5469,7 +5555,7 @@
               <a:buNone/>
             </a:pPr>
             <a:r>
-              <a:rPr b="1" lang="en-US" sz="1950">
+              <a:rPr lang="en-US" sz="1950" b="1">
                 <a:solidFill>
                   <a:srgbClr val="E0D6DE"/>
                 </a:solidFill>
@@ -5512,12 +5598,12 @@
           </a:ln>
         </p:spPr>
         <p:txBody>
-          <a:bodyPr anchorCtr="0" anchor="t" bIns="0" lIns="0" spcFirstLastPara="1" rIns="0" wrap="square" tIns="0">
+          <a:bodyPr spcFirstLastPara="1" wrap="square" lIns="0" tIns="0" rIns="0" bIns="0" anchor="t" anchorCtr="0">
             <a:normAutofit/>
           </a:bodyPr>
           <a:lstStyle/>
           <a:p>
-            <a:pPr indent="0" lvl="0" marL="0" marR="0" rtl="0" algn="l">
+            <a:pPr marL="0" marR="0" lvl="0" indent="0" algn="l" rtl="0">
               <a:lnSpc>
                 <a:spcPct val="133000"/>
               </a:lnSpc>
@@ -5571,29 +5657,29 @@
           </a:xfrm>
           <a:prstGeom prst="roundRect">
             <a:avLst>
-              <a:gd fmla="val 3650" name="adj"/>
+              <a:gd name="adj" fmla="val 3650"/>
             </a:avLst>
           </a:prstGeom>
           <a:solidFill>
             <a:srgbClr val="2F1D63"/>
           </a:solidFill>
-          <a:ln cap="flat" cmpd="sng" w="9525">
+          <a:ln w="9525" cap="flat" cmpd="sng">
             <a:solidFill>
               <a:srgbClr val="48367C"/>
             </a:solidFill>
             <a:prstDash val="solid"/>
             <a:round/>
-            <a:headEnd len="sm" w="sm" type="none"/>
-            <a:tailEnd len="sm" w="sm" type="none"/>
+            <a:headEnd type="none" w="sm" len="sm"/>
+            <a:tailEnd type="none" w="sm" len="sm"/>
           </a:ln>
         </p:spPr>
         <p:txBody>
-          <a:bodyPr anchorCtr="0" anchor="t" bIns="45700" lIns="91425" spcFirstLastPara="1" rIns="91425" wrap="square" tIns="45700">
+          <a:bodyPr spcFirstLastPara="1" wrap="square" lIns="91425" tIns="45700" rIns="91425" bIns="45700" anchor="t" anchorCtr="0">
             <a:noAutofit/>
           </a:bodyPr>
           <a:lstStyle/>
           <a:p>
-            <a:pPr indent="0" lvl="0" marL="0" marR="0" rtl="0" algn="l">
+            <a:pPr marL="0" marR="0" lvl="0" indent="0" algn="l" rtl="0">
               <a:spcBef>
                 <a:spcPts val="0"/>
               </a:spcBef>
@@ -5602,9 +5688,6 @@
               </a:spcAft>
               <a:buNone/>
             </a:pPr>
-            <a:r>
-              <a:t/>
-            </a:r>
             <a:endParaRPr sz="1800">
               <a:solidFill>
                 <a:schemeClr val="dk1"/>
@@ -5639,12 +5722,12 @@
           </a:ln>
         </p:spPr>
         <p:txBody>
-          <a:bodyPr anchorCtr="0" anchor="t" bIns="45700" lIns="91425" spcFirstLastPara="1" rIns="91425" wrap="square" tIns="45700">
+          <a:bodyPr spcFirstLastPara="1" wrap="square" lIns="91425" tIns="45700" rIns="91425" bIns="45700" anchor="t" anchorCtr="0">
             <a:noAutofit/>
           </a:bodyPr>
           <a:lstStyle/>
           <a:p>
-            <a:pPr indent="0" lvl="0" marL="0" marR="0" rtl="0" algn="l">
+            <a:pPr marL="0" marR="0" lvl="0" indent="0" algn="l" rtl="0">
               <a:spcBef>
                 <a:spcPts val="0"/>
               </a:spcBef>
@@ -5653,9 +5736,6 @@
               </a:spcAft>
               <a:buNone/>
             </a:pPr>
-            <a:r>
-              <a:t/>
-            </a:r>
             <a:endParaRPr sz="1800">
               <a:solidFill>
                 <a:schemeClr val="dk1"/>
@@ -5670,7 +5750,7 @@
       </p:sp>
       <p:sp>
         <p:nvSpPr>
-          <p:cNvPr descr="preencoded.png" id="57" name="Google Shape;57;p3"/>
+          <p:cNvPr id="57" name="Google Shape;57;p3" descr="preencoded.png"/>
           <p:cNvSpPr/>
           <p:nvPr/>
         </p:nvSpPr>
@@ -5687,6 +5767,13 @@
             <a:noFill/>
           </a:ln>
         </p:spPr>
+        <p:txBody>
+          <a:bodyPr/>
+          <a:lstStyle/>
+          <a:p>
+            <a:endParaRPr lang="es-CL"/>
+          </a:p>
+        </p:txBody>
       </p:sp>
       <p:sp>
         <p:nvSpPr>
@@ -5708,12 +5795,12 @@
           </a:ln>
         </p:spPr>
         <p:txBody>
-          <a:bodyPr anchorCtr="0" anchor="t" bIns="0" lIns="0" spcFirstLastPara="1" rIns="0" wrap="square" tIns="0">
+          <a:bodyPr spcFirstLastPara="1" wrap="square" lIns="0" tIns="0" rIns="0" bIns="0" anchor="t" anchorCtr="0">
             <a:noAutofit/>
           </a:bodyPr>
           <a:lstStyle/>
           <a:p>
-            <a:pPr indent="0" lvl="0" marL="0" marR="0" rtl="0" algn="l">
+            <a:pPr marL="0" marR="0" lvl="0" indent="0" algn="l" rtl="0">
               <a:lnSpc>
                 <a:spcPct val="104000"/>
               </a:lnSpc>
@@ -5731,7 +5818,7 @@
               <a:buNone/>
             </a:pPr>
             <a:r>
-              <a:rPr b="1" lang="en-US" sz="1950">
+              <a:rPr lang="en-US" sz="1950" b="1">
                 <a:solidFill>
                   <a:srgbClr val="E0D6DE"/>
                 </a:solidFill>
@@ -5774,12 +5861,12 @@
           </a:ln>
         </p:spPr>
         <p:txBody>
-          <a:bodyPr anchorCtr="0" anchor="t" bIns="0" lIns="0" spcFirstLastPara="1" rIns="0" wrap="square" tIns="0">
+          <a:bodyPr spcFirstLastPara="1" wrap="square" lIns="0" tIns="0" rIns="0" bIns="0" anchor="t" anchorCtr="0">
             <a:normAutofit/>
           </a:bodyPr>
           <a:lstStyle/>
           <a:p>
-            <a:pPr indent="0" lvl="0" marL="0" marR="0" rtl="0" algn="l">
+            <a:pPr marL="0" marR="0" lvl="0" indent="0" algn="l" rtl="0">
               <a:lnSpc>
                 <a:spcPct val="133000"/>
               </a:lnSpc>
@@ -5857,11 +5944,11 @@
 </file>
 
 <file path=ppt/slides/slide4.xml><?xml version="1.0" encoding="utf-8"?>
-<p:sld xmlns:a="http://schemas.openxmlformats.org/drawingml/2006/main" xmlns:r="http://schemas.openxmlformats.org/officeDocument/2006/relationships" xmlns:mc="http://schemas.openxmlformats.org/markup-compatibility/2006" xmlns:mv="urn:schemas-microsoft-com:mac:vml" xmlns:p="http://schemas.openxmlformats.org/presentationml/2006/main" xmlns:c="http://schemas.openxmlformats.org/drawingml/2006/chart" xmlns:dgm="http://schemas.openxmlformats.org/drawingml/2006/diagram" xmlns:o="urn:schemas-microsoft-com:office:office" xmlns:v="urn:schemas-microsoft-com:vml" xmlns:pvml="urn:schemas-microsoft-com:office:powerpoint" xmlns:com="http://schemas.openxmlformats.org/drawingml/2006/compatibility" xmlns:p14="http://schemas.microsoft.com/office/powerpoint/2010/main" xmlns:p15="http://schemas.microsoft.com/office/powerpoint/2012/main" xmlns:ahyp="http://schemas.microsoft.com/office/drawing/2018/hyperlinkcolor">
+<p:sld xmlns:a="http://schemas.openxmlformats.org/drawingml/2006/main" xmlns:r="http://schemas.openxmlformats.org/officeDocument/2006/relationships" xmlns:p="http://schemas.openxmlformats.org/presentationml/2006/main">
   <p:cSld>
     <p:spTree>
       <p:nvGrpSpPr>
-        <p:cNvPr id="65" name="Shape 65"/>
+        <p:cNvPr id="1" name="Shape 65"/>
         <p:cNvGrpSpPr/>
         <p:nvPr/>
       </p:nvGrpSpPr>
@@ -5893,12 +5980,12 @@
           </a:ln>
         </p:spPr>
         <p:txBody>
-          <a:bodyPr anchorCtr="0" anchor="t" bIns="0" lIns="0" spcFirstLastPara="1" rIns="0" wrap="square" tIns="0">
+          <a:bodyPr spcFirstLastPara="1" wrap="square" lIns="0" tIns="0" rIns="0" bIns="0" anchor="t" anchorCtr="0">
             <a:noAutofit/>
           </a:bodyPr>
           <a:lstStyle/>
           <a:p>
-            <a:pPr indent="0" lvl="0" marL="0" marR="0" rtl="0" algn="ctr">
+            <a:pPr marL="0" marR="0" lvl="0" indent="0" algn="ctr" rtl="0">
               <a:lnSpc>
                 <a:spcPct val="104000"/>
               </a:lnSpc>
@@ -5916,7 +6003,7 @@
               <a:buNone/>
             </a:pPr>
             <a:r>
-              <a:rPr b="1" lang="en-US" sz="2550">
+              <a:rPr lang="en-US" sz="4000" b="1" dirty="0" err="1">
                 <a:solidFill>
                   <a:srgbClr val="FF8AAF"/>
                 </a:solidFill>
@@ -5925,9 +6012,81 @@
                 <a:cs typeface="Petrona"/>
                 <a:sym typeface="Petrona"/>
               </a:rPr>
-              <a:t>Flujo de compra en la práctica</a:t>
-            </a:r>
-            <a:endParaRPr sz="2550">
+              <a:t>Flujo</a:t>
+            </a:r>
+            <a:r>
+              <a:rPr lang="en-US" sz="4000" b="1" dirty="0">
+                <a:solidFill>
+                  <a:srgbClr val="FF8AAF"/>
+                </a:solidFill>
+                <a:latin typeface="Petrona"/>
+                <a:ea typeface="Petrona"/>
+                <a:cs typeface="Petrona"/>
+                <a:sym typeface="Petrona"/>
+              </a:rPr>
+              <a:t> de </a:t>
+            </a:r>
+            <a:r>
+              <a:rPr lang="en-US" sz="4000" b="1" dirty="0" err="1">
+                <a:solidFill>
+                  <a:srgbClr val="FF8AAF"/>
+                </a:solidFill>
+                <a:latin typeface="Petrona"/>
+                <a:ea typeface="Petrona"/>
+                <a:cs typeface="Petrona"/>
+                <a:sym typeface="Petrona"/>
+              </a:rPr>
+              <a:t>compra</a:t>
+            </a:r>
+            <a:r>
+              <a:rPr lang="en-US" sz="4000" b="1" dirty="0">
+                <a:solidFill>
+                  <a:srgbClr val="FF8AAF"/>
+                </a:solidFill>
+                <a:latin typeface="Petrona"/>
+                <a:ea typeface="Petrona"/>
+                <a:cs typeface="Petrona"/>
+                <a:sym typeface="Petrona"/>
+              </a:rPr>
+              <a:t> </a:t>
+            </a:r>
+            <a:r>
+              <a:rPr lang="en-US" sz="4000" b="1" dirty="0" err="1">
+                <a:solidFill>
+                  <a:srgbClr val="FF8AAF"/>
+                </a:solidFill>
+                <a:latin typeface="Petrona"/>
+                <a:ea typeface="Petrona"/>
+                <a:cs typeface="Petrona"/>
+                <a:sym typeface="Petrona"/>
+              </a:rPr>
+              <a:t>en</a:t>
+            </a:r>
+            <a:r>
+              <a:rPr lang="en-US" sz="4000" b="1" dirty="0">
+                <a:solidFill>
+                  <a:srgbClr val="FF8AAF"/>
+                </a:solidFill>
+                <a:latin typeface="Petrona"/>
+                <a:ea typeface="Petrona"/>
+                <a:cs typeface="Petrona"/>
+                <a:sym typeface="Petrona"/>
+              </a:rPr>
+              <a:t> la </a:t>
+            </a:r>
+            <a:r>
+              <a:rPr lang="en-US" sz="4000" b="1" dirty="0" err="1">
+                <a:solidFill>
+                  <a:srgbClr val="FF8AAF"/>
+                </a:solidFill>
+                <a:latin typeface="Petrona"/>
+                <a:ea typeface="Petrona"/>
+                <a:cs typeface="Petrona"/>
+                <a:sym typeface="Petrona"/>
+              </a:rPr>
+              <a:t>práctica</a:t>
+            </a:r>
+            <a:endParaRPr sz="4000" dirty="0">
               <a:solidFill>
                 <a:schemeClr val="dk1"/>
               </a:solidFill>
@@ -5947,7 +6106,7 @@
         </p:nvSpPr>
         <p:spPr>
           <a:xfrm>
-            <a:off x="8029308" y="4664098"/>
+            <a:off x="7428174" y="5553092"/>
             <a:ext cx="2567700" cy="321000"/>
           </a:xfrm>
           <a:prstGeom prst="rect">
@@ -5959,12 +6118,12 @@
           </a:ln>
         </p:spPr>
         <p:txBody>
-          <a:bodyPr anchorCtr="0" anchor="t" bIns="0" lIns="0" spcFirstLastPara="1" rIns="0" wrap="square" tIns="0">
+          <a:bodyPr spcFirstLastPara="1" wrap="square" lIns="0" tIns="0" rIns="0" bIns="0" anchor="t" anchorCtr="0">
             <a:noAutofit/>
           </a:bodyPr>
           <a:lstStyle/>
           <a:p>
-            <a:pPr indent="0" lvl="0" marL="0" marR="0" rtl="0" algn="ctr">
+            <a:pPr marL="0" marR="0" lvl="0" indent="0" algn="ctr" rtl="0">
               <a:lnSpc>
                 <a:spcPct val="104000"/>
               </a:lnSpc>
@@ -5982,7 +6141,7 @@
               <a:buNone/>
             </a:pPr>
             <a:r>
-              <a:rPr b="1" lang="en-US" sz="2000">
+              <a:rPr lang="en-US" sz="3200" b="1" dirty="0" err="1">
                 <a:solidFill>
                   <a:srgbClr val="FFFFFF"/>
                 </a:solidFill>
@@ -5993,7 +6152,7 @@
               </a:rPr>
               <a:t>Catálogo</a:t>
             </a:r>
-            <a:endParaRPr sz="2000">
+            <a:endParaRPr sz="3200" dirty="0">
               <a:solidFill>
                 <a:schemeClr val="dk1"/>
               </a:solidFill>
@@ -6013,7 +6172,7 @@
         </p:nvSpPr>
         <p:spPr>
           <a:xfrm>
-            <a:off x="2057558" y="4664092"/>
+            <a:off x="1729950" y="5553092"/>
             <a:ext cx="2567700" cy="321000"/>
           </a:xfrm>
           <a:prstGeom prst="rect">
@@ -6025,12 +6184,12 @@
           </a:ln>
         </p:spPr>
         <p:txBody>
-          <a:bodyPr anchorCtr="0" anchor="t" bIns="0" lIns="0" spcFirstLastPara="1" rIns="0" wrap="square" tIns="0">
+          <a:bodyPr spcFirstLastPara="1" wrap="square" lIns="0" tIns="0" rIns="0" bIns="0" anchor="t" anchorCtr="0">
             <a:noAutofit/>
           </a:bodyPr>
           <a:lstStyle/>
           <a:p>
-            <a:pPr indent="0" lvl="0" marL="0" marR="0" rtl="0" algn="ctr">
+            <a:pPr marL="0" marR="0" lvl="0" indent="0" algn="ctr" rtl="0">
               <a:lnSpc>
                 <a:spcPct val="104000"/>
               </a:lnSpc>
@@ -6048,7 +6207,7 @@
               <a:buNone/>
             </a:pPr>
             <a:r>
-              <a:rPr b="1" lang="en-US" sz="2000">
+              <a:rPr lang="en-US" sz="3200" b="1" dirty="0">
                 <a:solidFill>
                   <a:srgbClr val="FFFFFF"/>
                 </a:solidFill>
@@ -6059,7 +6218,7 @@
               </a:rPr>
               <a:t>Home</a:t>
             </a:r>
-            <a:endParaRPr sz="2000">
+            <a:endParaRPr sz="3200" dirty="0">
               <a:solidFill>
                 <a:schemeClr val="dk1"/>
               </a:solidFill>
@@ -6073,7 +6232,7 @@
       </p:sp>
       <p:pic>
         <p:nvPicPr>
-          <p:cNvPr id="69" name="Google Shape;69;p4"/>
+          <p:cNvPr id="71" name="Google Shape;71;p4"/>
           <p:cNvPicPr preferRelativeResize="0"/>
           <p:nvPr/>
         </p:nvPicPr>
@@ -6087,8 +6246,8 @@
         </p:blipFill>
         <p:spPr>
           <a:xfrm>
-            <a:off x="631609" y="1695801"/>
-            <a:ext cx="5419577" cy="2858576"/>
+            <a:off x="11019875" y="6138123"/>
+            <a:ext cx="1172114" cy="719881"/>
           </a:xfrm>
           <a:prstGeom prst="rect">
             <a:avLst/>
@@ -6101,58 +6260,62 @@
       </p:pic>
       <p:pic>
         <p:nvPicPr>
-          <p:cNvPr id="70" name="Google Shape;70;p4"/>
-          <p:cNvPicPr preferRelativeResize="0"/>
+          <p:cNvPr id="3" name="Imagen 2">
+            <a:extLst>
+              <a:ext uri="{FF2B5EF4-FFF2-40B4-BE49-F238E27FC236}">
+                <a16:creationId xmlns:a16="http://schemas.microsoft.com/office/drawing/2014/main" id="{C2829CFD-2C14-103C-CDC7-7AEF793524EB}"/>
+              </a:ext>
+            </a:extLst>
+          </p:cNvPr>
+          <p:cNvPicPr>
+            <a:picLocks noChangeAspect="1"/>
+          </p:cNvPicPr>
           <p:nvPr/>
         </p:nvPicPr>
         <p:blipFill>
-          <a:blip r:embed="rId4">
-            <a:alphaModFix/>
-          </a:blip>
+          <a:blip r:embed="rId4"/>
           <a:stretch>
             <a:fillRect/>
           </a:stretch>
         </p:blipFill>
         <p:spPr>
           <a:xfrm>
-            <a:off x="6273136" y="1990628"/>
-            <a:ext cx="5836013" cy="2268911"/>
-          </a:xfrm>
-          <a:prstGeom prst="rect">
-            <a:avLst/>
-          </a:prstGeom>
-          <a:noFill/>
-          <a:ln>
-            <a:noFill/>
-          </a:ln>
+            <a:off x="373295" y="1900987"/>
+            <a:ext cx="5281010" cy="3414364"/>
+          </a:xfrm>
+          <a:prstGeom prst="rect">
+            <a:avLst/>
+          </a:prstGeom>
         </p:spPr>
       </p:pic>
       <p:pic>
         <p:nvPicPr>
-          <p:cNvPr id="71" name="Google Shape;71;p4"/>
-          <p:cNvPicPr preferRelativeResize="0"/>
+          <p:cNvPr id="5" name="Imagen 4">
+            <a:extLst>
+              <a:ext uri="{FF2B5EF4-FFF2-40B4-BE49-F238E27FC236}">
+                <a16:creationId xmlns:a16="http://schemas.microsoft.com/office/drawing/2014/main" id="{834018F4-C011-A0F9-44DC-F063F8362FB4}"/>
+              </a:ext>
+            </a:extLst>
+          </p:cNvPr>
+          <p:cNvPicPr>
+            <a:picLocks noChangeAspect="1"/>
+          </p:cNvPicPr>
           <p:nvPr/>
         </p:nvPicPr>
         <p:blipFill>
-          <a:blip r:embed="rId5">
-            <a:alphaModFix/>
-          </a:blip>
+          <a:blip r:embed="rId5"/>
           <a:stretch>
             <a:fillRect/>
           </a:stretch>
         </p:blipFill>
         <p:spPr>
           <a:xfrm>
-            <a:off x="11019875" y="6138123"/>
-            <a:ext cx="1172114" cy="719881"/>
-          </a:xfrm>
-          <a:prstGeom prst="rect">
-            <a:avLst/>
-          </a:prstGeom>
-          <a:noFill/>
-          <a:ln>
-            <a:noFill/>
-          </a:ln>
+            <a:off x="6040868" y="1900987"/>
+            <a:ext cx="5342311" cy="3414364"/>
+          </a:xfrm>
+          <a:prstGeom prst="rect">
+            <a:avLst/>
+          </a:prstGeom>
         </p:spPr>
       </p:pic>
     </p:spTree>
@@ -6164,11 +6327,11 @@
 </file>
 
 <file path=ppt/slides/slide5.xml><?xml version="1.0" encoding="utf-8"?>
-<p:sld xmlns:a="http://schemas.openxmlformats.org/drawingml/2006/main" xmlns:r="http://schemas.openxmlformats.org/officeDocument/2006/relationships" xmlns:mc="http://schemas.openxmlformats.org/markup-compatibility/2006" xmlns:mv="urn:schemas-microsoft-com:mac:vml" xmlns:p="http://schemas.openxmlformats.org/presentationml/2006/main" xmlns:c="http://schemas.openxmlformats.org/drawingml/2006/chart" xmlns:dgm="http://schemas.openxmlformats.org/drawingml/2006/diagram" xmlns:o="urn:schemas-microsoft-com:office:office" xmlns:v="urn:schemas-microsoft-com:vml" xmlns:pvml="urn:schemas-microsoft-com:office:powerpoint" xmlns:com="http://schemas.openxmlformats.org/drawingml/2006/compatibility" xmlns:p14="http://schemas.microsoft.com/office/powerpoint/2010/main" xmlns:p15="http://schemas.microsoft.com/office/powerpoint/2012/main" xmlns:ahyp="http://schemas.microsoft.com/office/drawing/2018/hyperlinkcolor">
+<p:sld xmlns:a="http://schemas.openxmlformats.org/drawingml/2006/main" xmlns:r="http://schemas.openxmlformats.org/officeDocument/2006/relationships" xmlns:p="http://schemas.openxmlformats.org/presentationml/2006/main">
   <p:cSld>
     <p:spTree>
       <p:nvGrpSpPr>
-        <p:cNvPr id="76" name="Shape 76"/>
+        <p:cNvPr id="1" name="Shape 76"/>
         <p:cNvGrpSpPr/>
         <p:nvPr/>
       </p:nvGrpSpPr>
@@ -6200,12 +6363,12 @@
           </a:ln>
         </p:spPr>
         <p:txBody>
-          <a:bodyPr anchorCtr="0" anchor="t" bIns="0" lIns="0" spcFirstLastPara="1" rIns="0" wrap="square" tIns="0">
+          <a:bodyPr spcFirstLastPara="1" wrap="square" lIns="0" tIns="0" rIns="0" bIns="0" anchor="t" anchorCtr="0">
             <a:noAutofit/>
           </a:bodyPr>
           <a:lstStyle/>
           <a:p>
-            <a:pPr indent="0" lvl="0" marL="0" marR="0" rtl="0" algn="ctr">
+            <a:pPr marL="0" marR="0" lvl="0" indent="0" algn="ctr" rtl="0">
               <a:lnSpc>
                 <a:spcPct val="104000"/>
               </a:lnSpc>
@@ -6223,7 +6386,7 @@
               <a:buNone/>
             </a:pPr>
             <a:r>
-              <a:rPr b="1" lang="en-US" sz="2550">
+              <a:rPr lang="en-US" sz="2550" b="1">
                 <a:solidFill>
                   <a:srgbClr val="FF8AAF"/>
                 </a:solidFill>
@@ -6254,7 +6417,7 @@
         </p:nvSpPr>
         <p:spPr>
           <a:xfrm>
-            <a:off x="7760958" y="4399241"/>
+            <a:off x="7800235" y="5190264"/>
             <a:ext cx="2567700" cy="321000"/>
           </a:xfrm>
           <a:prstGeom prst="rect">
@@ -6266,12 +6429,12 @@
           </a:ln>
         </p:spPr>
         <p:txBody>
-          <a:bodyPr anchorCtr="0" anchor="t" bIns="0" lIns="0" spcFirstLastPara="1" rIns="0" wrap="square" tIns="0">
+          <a:bodyPr spcFirstLastPara="1" wrap="square" lIns="0" tIns="0" rIns="0" bIns="0" anchor="t" anchorCtr="0">
             <a:noAutofit/>
           </a:bodyPr>
           <a:lstStyle/>
           <a:p>
-            <a:pPr indent="0" lvl="0" marL="0" marR="0" rtl="0" algn="ctr">
+            <a:pPr marL="0" marR="0" lvl="0" indent="0" algn="ctr" rtl="0">
               <a:lnSpc>
                 <a:spcPct val="104000"/>
               </a:lnSpc>
@@ -6289,7 +6452,7 @@
               <a:buNone/>
             </a:pPr>
             <a:r>
-              <a:rPr b="1" lang="en-US" sz="2000">
+              <a:rPr lang="en-US" sz="3200" b="1" dirty="0" err="1">
                 <a:solidFill>
                   <a:srgbClr val="FFFFFF"/>
                 </a:solidFill>
@@ -6300,7 +6463,7 @@
               </a:rPr>
               <a:t>Carrito</a:t>
             </a:r>
-            <a:endParaRPr sz="2000">
+            <a:endParaRPr sz="2000" dirty="0">
               <a:solidFill>
                 <a:schemeClr val="dk1"/>
               </a:solidFill>
@@ -6320,7 +6483,7 @@
         </p:nvSpPr>
         <p:spPr>
           <a:xfrm>
-            <a:off x="1807133" y="4399260"/>
+            <a:off x="1824067" y="5190264"/>
             <a:ext cx="2567700" cy="321000"/>
           </a:xfrm>
           <a:prstGeom prst="rect">
@@ -6332,12 +6495,12 @@
           </a:ln>
         </p:spPr>
         <p:txBody>
-          <a:bodyPr anchorCtr="0" anchor="t" bIns="0" lIns="0" spcFirstLastPara="1" rIns="0" wrap="square" tIns="0">
+          <a:bodyPr spcFirstLastPara="1" wrap="square" lIns="0" tIns="0" rIns="0" bIns="0" anchor="t" anchorCtr="0">
             <a:noAutofit/>
           </a:bodyPr>
           <a:lstStyle/>
           <a:p>
-            <a:pPr indent="0" lvl="0" marL="0" marR="0" rtl="0" algn="ctr">
+            <a:pPr marL="0" marR="0" lvl="0" indent="0" algn="ctr" rtl="0">
               <a:lnSpc>
                 <a:spcPct val="104000"/>
               </a:lnSpc>
@@ -6355,7 +6518,7 @@
               <a:buNone/>
             </a:pPr>
             <a:r>
-              <a:rPr b="1" lang="en-US" sz="2000">
+              <a:rPr lang="en-US" sz="3200" b="1" dirty="0" err="1">
                 <a:solidFill>
                   <a:srgbClr val="FFFFFF"/>
                 </a:solidFill>
@@ -6366,7 +6529,7 @@
               </a:rPr>
               <a:t>Ficha</a:t>
             </a:r>
-            <a:endParaRPr sz="2000">
+            <a:endParaRPr sz="3200" dirty="0">
               <a:solidFill>
                 <a:schemeClr val="dk1"/>
               </a:solidFill>
@@ -6398,12 +6561,12 @@
           </a:ln>
         </p:spPr>
         <p:txBody>
-          <a:bodyPr anchorCtr="0" anchor="t" bIns="0" lIns="0" spcFirstLastPara="1" rIns="0" wrap="square" tIns="0">
+          <a:bodyPr spcFirstLastPara="1" wrap="square" lIns="0" tIns="0" rIns="0" bIns="0" anchor="t" anchorCtr="0">
             <a:noAutofit/>
           </a:bodyPr>
           <a:lstStyle/>
           <a:p>
-            <a:pPr indent="0" lvl="0" marL="0" marR="0" rtl="0" algn="l">
+            <a:pPr marL="0" marR="0" lvl="0" indent="0" algn="l" rtl="0">
               <a:lnSpc>
                 <a:spcPct val="110000"/>
               </a:lnSpc>
@@ -6421,7 +6584,7 @@
               <a:buNone/>
             </a:pPr>
             <a:r>
-              <a:rPr lang="en-US" sz="950">
+              <a:rPr lang="en-US" sz="950" dirty="0" err="1">
                 <a:solidFill>
                   <a:srgbClr val="E0D6DE"/>
                 </a:solidFill>
@@ -6430,9 +6593,429 @@
                 <a:cs typeface="Inter"/>
                 <a:sym typeface="Inter"/>
               </a:rPr>
-              <a:t>Desde el home se entra al catálogo, se filtra por categoría, se abre la ficha técnica de un producto con su marca, precio y stock, y desde ahí se agrega al carrito, donde se calcula automáticamente el subtotal, el IVA y el total.</a:t>
-            </a:r>
-            <a:endParaRPr sz="950">
+              <a:t>Desde</a:t>
+            </a:r>
+            <a:r>
+              <a:rPr lang="en-US" sz="950" dirty="0">
+                <a:solidFill>
+                  <a:srgbClr val="E0D6DE"/>
+                </a:solidFill>
+                <a:latin typeface="Inter"/>
+                <a:ea typeface="Inter"/>
+                <a:cs typeface="Inter"/>
+                <a:sym typeface="Inter"/>
+              </a:rPr>
+              <a:t> el home se </a:t>
+            </a:r>
+            <a:r>
+              <a:rPr lang="en-US" sz="950" dirty="0" err="1">
+                <a:solidFill>
+                  <a:srgbClr val="E0D6DE"/>
+                </a:solidFill>
+                <a:latin typeface="Inter"/>
+                <a:ea typeface="Inter"/>
+                <a:cs typeface="Inter"/>
+                <a:sym typeface="Inter"/>
+              </a:rPr>
+              <a:t>entra</a:t>
+            </a:r>
+            <a:r>
+              <a:rPr lang="en-US" sz="950" dirty="0">
+                <a:solidFill>
+                  <a:srgbClr val="E0D6DE"/>
+                </a:solidFill>
+                <a:latin typeface="Inter"/>
+                <a:ea typeface="Inter"/>
+                <a:cs typeface="Inter"/>
+                <a:sym typeface="Inter"/>
+              </a:rPr>
+              <a:t> al </a:t>
+            </a:r>
+            <a:r>
+              <a:rPr lang="en-US" sz="950" dirty="0" err="1">
+                <a:solidFill>
+                  <a:srgbClr val="E0D6DE"/>
+                </a:solidFill>
+                <a:latin typeface="Inter"/>
+                <a:ea typeface="Inter"/>
+                <a:cs typeface="Inter"/>
+                <a:sym typeface="Inter"/>
+              </a:rPr>
+              <a:t>catálogo</a:t>
+            </a:r>
+            <a:r>
+              <a:rPr lang="en-US" sz="950" dirty="0">
+                <a:solidFill>
+                  <a:srgbClr val="E0D6DE"/>
+                </a:solidFill>
+                <a:latin typeface="Inter"/>
+                <a:ea typeface="Inter"/>
+                <a:cs typeface="Inter"/>
+                <a:sym typeface="Inter"/>
+              </a:rPr>
+              <a:t>, se filtra </a:t>
+            </a:r>
+            <a:r>
+              <a:rPr lang="en-US" sz="950" dirty="0" err="1">
+                <a:solidFill>
+                  <a:srgbClr val="E0D6DE"/>
+                </a:solidFill>
+                <a:latin typeface="Inter"/>
+                <a:ea typeface="Inter"/>
+                <a:cs typeface="Inter"/>
+                <a:sym typeface="Inter"/>
+              </a:rPr>
+              <a:t>por</a:t>
+            </a:r>
+            <a:r>
+              <a:rPr lang="en-US" sz="950" dirty="0">
+                <a:solidFill>
+                  <a:srgbClr val="E0D6DE"/>
+                </a:solidFill>
+                <a:latin typeface="Inter"/>
+                <a:ea typeface="Inter"/>
+                <a:cs typeface="Inter"/>
+                <a:sym typeface="Inter"/>
+              </a:rPr>
+              <a:t> </a:t>
+            </a:r>
+            <a:r>
+              <a:rPr lang="en-US" sz="950" dirty="0" err="1">
+                <a:solidFill>
+                  <a:srgbClr val="E0D6DE"/>
+                </a:solidFill>
+                <a:latin typeface="Inter"/>
+                <a:ea typeface="Inter"/>
+                <a:cs typeface="Inter"/>
+                <a:sym typeface="Inter"/>
+              </a:rPr>
+              <a:t>categoría</a:t>
+            </a:r>
+            <a:r>
+              <a:rPr lang="en-US" sz="950" dirty="0">
+                <a:solidFill>
+                  <a:srgbClr val="E0D6DE"/>
+                </a:solidFill>
+                <a:latin typeface="Inter"/>
+                <a:ea typeface="Inter"/>
+                <a:cs typeface="Inter"/>
+                <a:sym typeface="Inter"/>
+              </a:rPr>
+              <a:t>, se </a:t>
+            </a:r>
+            <a:r>
+              <a:rPr lang="en-US" sz="950" dirty="0" err="1">
+                <a:solidFill>
+                  <a:srgbClr val="E0D6DE"/>
+                </a:solidFill>
+                <a:latin typeface="Inter"/>
+                <a:ea typeface="Inter"/>
+                <a:cs typeface="Inter"/>
+                <a:sym typeface="Inter"/>
+              </a:rPr>
+              <a:t>abre</a:t>
+            </a:r>
+            <a:r>
+              <a:rPr lang="en-US" sz="950" dirty="0">
+                <a:solidFill>
+                  <a:srgbClr val="E0D6DE"/>
+                </a:solidFill>
+                <a:latin typeface="Inter"/>
+                <a:ea typeface="Inter"/>
+                <a:cs typeface="Inter"/>
+                <a:sym typeface="Inter"/>
+              </a:rPr>
+              <a:t> la </a:t>
+            </a:r>
+            <a:r>
+              <a:rPr lang="en-US" sz="950" dirty="0" err="1">
+                <a:solidFill>
+                  <a:srgbClr val="E0D6DE"/>
+                </a:solidFill>
+                <a:latin typeface="Inter"/>
+                <a:ea typeface="Inter"/>
+                <a:cs typeface="Inter"/>
+                <a:sym typeface="Inter"/>
+              </a:rPr>
+              <a:t>ficha</a:t>
+            </a:r>
+            <a:r>
+              <a:rPr lang="en-US" sz="950" dirty="0">
+                <a:solidFill>
+                  <a:srgbClr val="E0D6DE"/>
+                </a:solidFill>
+                <a:latin typeface="Inter"/>
+                <a:ea typeface="Inter"/>
+                <a:cs typeface="Inter"/>
+                <a:sym typeface="Inter"/>
+              </a:rPr>
+              <a:t> </a:t>
+            </a:r>
+            <a:r>
+              <a:rPr lang="en-US" sz="950" dirty="0" err="1">
+                <a:solidFill>
+                  <a:srgbClr val="E0D6DE"/>
+                </a:solidFill>
+                <a:latin typeface="Inter"/>
+                <a:ea typeface="Inter"/>
+                <a:cs typeface="Inter"/>
+                <a:sym typeface="Inter"/>
+              </a:rPr>
+              <a:t>técnica</a:t>
+            </a:r>
+            <a:r>
+              <a:rPr lang="en-US" sz="950" dirty="0">
+                <a:solidFill>
+                  <a:srgbClr val="E0D6DE"/>
+                </a:solidFill>
+                <a:latin typeface="Inter"/>
+                <a:ea typeface="Inter"/>
+                <a:cs typeface="Inter"/>
+                <a:sym typeface="Inter"/>
+              </a:rPr>
+              <a:t> de un </a:t>
+            </a:r>
+            <a:r>
+              <a:rPr lang="en-US" sz="950" dirty="0" err="1">
+                <a:solidFill>
+                  <a:srgbClr val="E0D6DE"/>
+                </a:solidFill>
+                <a:latin typeface="Inter"/>
+                <a:ea typeface="Inter"/>
+                <a:cs typeface="Inter"/>
+                <a:sym typeface="Inter"/>
+              </a:rPr>
+              <a:t>producto</a:t>
+            </a:r>
+            <a:r>
+              <a:rPr lang="en-US" sz="950" dirty="0">
+                <a:solidFill>
+                  <a:srgbClr val="E0D6DE"/>
+                </a:solidFill>
+                <a:latin typeface="Inter"/>
+                <a:ea typeface="Inter"/>
+                <a:cs typeface="Inter"/>
+                <a:sym typeface="Inter"/>
+              </a:rPr>
+              <a:t> con </a:t>
+            </a:r>
+            <a:r>
+              <a:rPr lang="en-US" sz="950" dirty="0" err="1">
+                <a:solidFill>
+                  <a:srgbClr val="E0D6DE"/>
+                </a:solidFill>
+                <a:latin typeface="Inter"/>
+                <a:ea typeface="Inter"/>
+                <a:cs typeface="Inter"/>
+                <a:sym typeface="Inter"/>
+              </a:rPr>
+              <a:t>su</a:t>
+            </a:r>
+            <a:r>
+              <a:rPr lang="en-US" sz="950" dirty="0">
+                <a:solidFill>
+                  <a:srgbClr val="E0D6DE"/>
+                </a:solidFill>
+                <a:latin typeface="Inter"/>
+                <a:ea typeface="Inter"/>
+                <a:cs typeface="Inter"/>
+                <a:sym typeface="Inter"/>
+              </a:rPr>
+              <a:t> </a:t>
+            </a:r>
+            <a:r>
+              <a:rPr lang="en-US" sz="950" dirty="0" err="1">
+                <a:solidFill>
+                  <a:srgbClr val="E0D6DE"/>
+                </a:solidFill>
+                <a:latin typeface="Inter"/>
+                <a:ea typeface="Inter"/>
+                <a:cs typeface="Inter"/>
+                <a:sym typeface="Inter"/>
+              </a:rPr>
+              <a:t>marca</a:t>
+            </a:r>
+            <a:r>
+              <a:rPr lang="en-US" sz="950" dirty="0">
+                <a:solidFill>
+                  <a:srgbClr val="E0D6DE"/>
+                </a:solidFill>
+                <a:latin typeface="Inter"/>
+                <a:ea typeface="Inter"/>
+                <a:cs typeface="Inter"/>
+                <a:sym typeface="Inter"/>
+              </a:rPr>
+              <a:t>, </a:t>
+            </a:r>
+            <a:r>
+              <a:rPr lang="en-US" sz="950" dirty="0" err="1">
+                <a:solidFill>
+                  <a:srgbClr val="E0D6DE"/>
+                </a:solidFill>
+                <a:latin typeface="Inter"/>
+                <a:ea typeface="Inter"/>
+                <a:cs typeface="Inter"/>
+                <a:sym typeface="Inter"/>
+              </a:rPr>
+              <a:t>precio</a:t>
+            </a:r>
+            <a:r>
+              <a:rPr lang="en-US" sz="950" dirty="0">
+                <a:solidFill>
+                  <a:srgbClr val="E0D6DE"/>
+                </a:solidFill>
+                <a:latin typeface="Inter"/>
+                <a:ea typeface="Inter"/>
+                <a:cs typeface="Inter"/>
+                <a:sym typeface="Inter"/>
+              </a:rPr>
+              <a:t> y stock, y </a:t>
+            </a:r>
+            <a:r>
+              <a:rPr lang="en-US" sz="950" dirty="0" err="1">
+                <a:solidFill>
+                  <a:srgbClr val="E0D6DE"/>
+                </a:solidFill>
+                <a:latin typeface="Inter"/>
+                <a:ea typeface="Inter"/>
+                <a:cs typeface="Inter"/>
+                <a:sym typeface="Inter"/>
+              </a:rPr>
+              <a:t>desde</a:t>
+            </a:r>
+            <a:r>
+              <a:rPr lang="en-US" sz="950" dirty="0">
+                <a:solidFill>
+                  <a:srgbClr val="E0D6DE"/>
+                </a:solidFill>
+                <a:latin typeface="Inter"/>
+                <a:ea typeface="Inter"/>
+                <a:cs typeface="Inter"/>
+                <a:sym typeface="Inter"/>
+              </a:rPr>
+              <a:t> ahí se </a:t>
+            </a:r>
+            <a:r>
+              <a:rPr lang="en-US" sz="950" dirty="0" err="1">
+                <a:solidFill>
+                  <a:srgbClr val="E0D6DE"/>
+                </a:solidFill>
+                <a:latin typeface="Inter"/>
+                <a:ea typeface="Inter"/>
+                <a:cs typeface="Inter"/>
+                <a:sym typeface="Inter"/>
+              </a:rPr>
+              <a:t>agrega</a:t>
+            </a:r>
+            <a:r>
+              <a:rPr lang="en-US" sz="950" dirty="0">
+                <a:solidFill>
+                  <a:srgbClr val="E0D6DE"/>
+                </a:solidFill>
+                <a:latin typeface="Inter"/>
+                <a:ea typeface="Inter"/>
+                <a:cs typeface="Inter"/>
+                <a:sym typeface="Inter"/>
+              </a:rPr>
+              <a:t> al </a:t>
+            </a:r>
+            <a:r>
+              <a:rPr lang="en-US" sz="950" dirty="0" err="1">
+                <a:solidFill>
+                  <a:srgbClr val="E0D6DE"/>
+                </a:solidFill>
+                <a:latin typeface="Inter"/>
+                <a:ea typeface="Inter"/>
+                <a:cs typeface="Inter"/>
+                <a:sym typeface="Inter"/>
+              </a:rPr>
+              <a:t>carrito</a:t>
+            </a:r>
+            <a:r>
+              <a:rPr lang="en-US" sz="950" dirty="0">
+                <a:solidFill>
+                  <a:srgbClr val="E0D6DE"/>
+                </a:solidFill>
+                <a:latin typeface="Inter"/>
+                <a:ea typeface="Inter"/>
+                <a:cs typeface="Inter"/>
+                <a:sym typeface="Inter"/>
+              </a:rPr>
+              <a:t>, </a:t>
+            </a:r>
+            <a:r>
+              <a:rPr lang="en-US" sz="950" dirty="0" err="1">
+                <a:solidFill>
+                  <a:srgbClr val="E0D6DE"/>
+                </a:solidFill>
+                <a:latin typeface="Inter"/>
+                <a:ea typeface="Inter"/>
+                <a:cs typeface="Inter"/>
+                <a:sym typeface="Inter"/>
+              </a:rPr>
+              <a:t>donde</a:t>
+            </a:r>
+            <a:r>
+              <a:rPr lang="en-US" sz="950" dirty="0">
+                <a:solidFill>
+                  <a:srgbClr val="E0D6DE"/>
+                </a:solidFill>
+                <a:latin typeface="Inter"/>
+                <a:ea typeface="Inter"/>
+                <a:cs typeface="Inter"/>
+                <a:sym typeface="Inter"/>
+              </a:rPr>
+              <a:t> se </a:t>
+            </a:r>
+            <a:r>
+              <a:rPr lang="en-US" sz="950" dirty="0" err="1">
+                <a:solidFill>
+                  <a:srgbClr val="E0D6DE"/>
+                </a:solidFill>
+                <a:latin typeface="Inter"/>
+                <a:ea typeface="Inter"/>
+                <a:cs typeface="Inter"/>
+                <a:sym typeface="Inter"/>
+              </a:rPr>
+              <a:t>calcula</a:t>
+            </a:r>
+            <a:r>
+              <a:rPr lang="en-US" sz="950" dirty="0">
+                <a:solidFill>
+                  <a:srgbClr val="E0D6DE"/>
+                </a:solidFill>
+                <a:latin typeface="Inter"/>
+                <a:ea typeface="Inter"/>
+                <a:cs typeface="Inter"/>
+                <a:sym typeface="Inter"/>
+              </a:rPr>
+              <a:t> </a:t>
+            </a:r>
+            <a:r>
+              <a:rPr lang="en-US" sz="950" dirty="0" err="1">
+                <a:solidFill>
+                  <a:srgbClr val="E0D6DE"/>
+                </a:solidFill>
+                <a:latin typeface="Inter"/>
+                <a:ea typeface="Inter"/>
+                <a:cs typeface="Inter"/>
+                <a:sym typeface="Inter"/>
+              </a:rPr>
+              <a:t>automáticamente</a:t>
+            </a:r>
+            <a:r>
+              <a:rPr lang="en-US" sz="950" dirty="0">
+                <a:solidFill>
+                  <a:srgbClr val="E0D6DE"/>
+                </a:solidFill>
+                <a:latin typeface="Inter"/>
+                <a:ea typeface="Inter"/>
+                <a:cs typeface="Inter"/>
+                <a:sym typeface="Inter"/>
+              </a:rPr>
+              <a:t> el subtotal, el IVA y el total.</a:t>
+            </a:r>
+            <a:endParaRPr sz="950" dirty="0">
               <a:solidFill>
                 <a:schemeClr val="dk1"/>
               </a:solidFill>
@@ -6446,7 +7029,7 @@
       </p:sp>
       <p:pic>
         <p:nvPicPr>
-          <p:cNvPr id="81" name="Google Shape;81;g3fa6aa0c82d_0_1" title="Gemini_Generated_Image_jys8ygjys8ygjys8.jpg"/>
+          <p:cNvPr id="83" name="Google Shape;83;g3fa6aa0c82d_0_1"/>
           <p:cNvPicPr preferRelativeResize="0"/>
           <p:nvPr/>
         </p:nvPicPr>
@@ -6460,8 +7043,8 @@
         </p:blipFill>
         <p:spPr>
           <a:xfrm>
-            <a:off x="735875" y="1460866"/>
-            <a:ext cx="4839793" cy="2625493"/>
+            <a:off x="10982325" y="6115060"/>
+            <a:ext cx="1209675" cy="742950"/>
           </a:xfrm>
           <a:prstGeom prst="rect">
             <a:avLst/>
@@ -6474,58 +7057,62 @@
       </p:pic>
       <p:pic>
         <p:nvPicPr>
-          <p:cNvPr id="82" name="Google Shape;82;g3fa6aa0c82d_0_1"/>
-          <p:cNvPicPr preferRelativeResize="0"/>
+          <p:cNvPr id="3" name="Imagen 2">
+            <a:extLst>
+              <a:ext uri="{FF2B5EF4-FFF2-40B4-BE49-F238E27FC236}">
+                <a16:creationId xmlns:a16="http://schemas.microsoft.com/office/drawing/2014/main" id="{2B956242-4F04-1B28-F757-C9DE5C459973}"/>
+              </a:ext>
+            </a:extLst>
+          </p:cNvPr>
+          <p:cNvPicPr>
+            <a:picLocks noChangeAspect="1"/>
+          </p:cNvPicPr>
           <p:nvPr/>
         </p:nvPicPr>
         <p:blipFill>
-          <a:blip r:embed="rId4">
-            <a:alphaModFix/>
-          </a:blip>
+          <a:blip r:embed="rId4"/>
           <a:stretch>
             <a:fillRect/>
           </a:stretch>
         </p:blipFill>
         <p:spPr>
           <a:xfrm>
-            <a:off x="6505838" y="1460875"/>
-            <a:ext cx="5077926" cy="2625476"/>
-          </a:xfrm>
-          <a:prstGeom prst="rect">
-            <a:avLst/>
-          </a:prstGeom>
-          <a:noFill/>
-          <a:ln>
-            <a:noFill/>
-          </a:ln>
+            <a:off x="278035" y="1646481"/>
+            <a:ext cx="5615253" cy="3294979"/>
+          </a:xfrm>
+          <a:prstGeom prst="rect">
+            <a:avLst/>
+          </a:prstGeom>
         </p:spPr>
       </p:pic>
       <p:pic>
         <p:nvPicPr>
-          <p:cNvPr id="83" name="Google Shape;83;g3fa6aa0c82d_0_1"/>
-          <p:cNvPicPr preferRelativeResize="0"/>
+          <p:cNvPr id="5" name="Imagen 4">
+            <a:extLst>
+              <a:ext uri="{FF2B5EF4-FFF2-40B4-BE49-F238E27FC236}">
+                <a16:creationId xmlns:a16="http://schemas.microsoft.com/office/drawing/2014/main" id="{E41B05BC-EF69-A516-58C7-61C8286A0A09}"/>
+              </a:ext>
+            </a:extLst>
+          </p:cNvPr>
+          <p:cNvPicPr>
+            <a:picLocks noChangeAspect="1"/>
+          </p:cNvPicPr>
           <p:nvPr/>
         </p:nvPicPr>
         <p:blipFill>
-          <a:blip r:embed="rId5">
-            <a:alphaModFix/>
-          </a:blip>
+          <a:blip r:embed="rId5"/>
           <a:stretch>
             <a:fillRect/>
           </a:stretch>
         </p:blipFill>
         <p:spPr>
           <a:xfrm>
-            <a:off x="10982325" y="6115060"/>
-            <a:ext cx="1209675" cy="742950"/>
-          </a:xfrm>
-          <a:prstGeom prst="rect">
-            <a:avLst/>
-          </a:prstGeom>
-          <a:noFill/>
-          <a:ln>
-            <a:noFill/>
-          </a:ln>
+            <a:off x="6095825" y="1646480"/>
+            <a:ext cx="5818140" cy="3294979"/>
+          </a:xfrm>
+          <a:prstGeom prst="rect">
+            <a:avLst/>
+          </a:prstGeom>
         </p:spPr>
       </p:pic>
     </p:spTree>
@@ -6537,11 +7124,11 @@
 </file>
 
 <file path=ppt/slides/slide6.xml><?xml version="1.0" encoding="utf-8"?>
-<p:sld xmlns:a="http://schemas.openxmlformats.org/drawingml/2006/main" xmlns:r="http://schemas.openxmlformats.org/officeDocument/2006/relationships" xmlns:mc="http://schemas.openxmlformats.org/markup-compatibility/2006" xmlns:mv="urn:schemas-microsoft-com:mac:vml" xmlns:p="http://schemas.openxmlformats.org/presentationml/2006/main" xmlns:c="http://schemas.openxmlformats.org/drawingml/2006/chart" xmlns:dgm="http://schemas.openxmlformats.org/drawingml/2006/diagram" xmlns:o="urn:schemas-microsoft-com:office:office" xmlns:v="urn:schemas-microsoft-com:vml" xmlns:pvml="urn:schemas-microsoft-com:office:powerpoint" xmlns:com="http://schemas.openxmlformats.org/drawingml/2006/compatibility" xmlns:p14="http://schemas.microsoft.com/office/powerpoint/2010/main" xmlns:p15="http://schemas.microsoft.com/office/powerpoint/2012/main" xmlns:ahyp="http://schemas.microsoft.com/office/drawing/2018/hyperlinkcolor">
+<p:sld xmlns:a="http://schemas.openxmlformats.org/drawingml/2006/main" xmlns:r="http://schemas.openxmlformats.org/officeDocument/2006/relationships" xmlns:p="http://schemas.openxmlformats.org/presentationml/2006/main">
   <p:cSld>
     <p:spTree>
       <p:nvGrpSpPr>
-        <p:cNvPr id="88" name="Shape 88"/>
+        <p:cNvPr id="1" name="Shape 88"/>
         <p:cNvGrpSpPr/>
         <p:nvPr/>
       </p:nvGrpSpPr>
@@ -6573,12 +7160,12 @@
           </a:ln>
         </p:spPr>
         <p:txBody>
-          <a:bodyPr anchorCtr="0" anchor="t" bIns="0" lIns="0" spcFirstLastPara="1" rIns="0" wrap="square" tIns="0">
+          <a:bodyPr spcFirstLastPara="1" wrap="square" lIns="0" tIns="0" rIns="0" bIns="0" anchor="t" anchorCtr="0">
             <a:noAutofit/>
           </a:bodyPr>
           <a:lstStyle/>
           <a:p>
-            <a:pPr indent="0" lvl="0" marL="0" marR="0" rtl="0" algn="l">
+            <a:pPr marL="0" marR="0" lvl="0" indent="0" algn="l" rtl="0">
               <a:lnSpc>
                 <a:spcPct val="104000"/>
               </a:lnSpc>
@@ -6596,7 +7183,7 @@
               <a:buNone/>
             </a:pPr>
             <a:r>
-              <a:rPr b="1" lang="en-US" sz="3700">
+              <a:rPr lang="en-US" sz="3700" b="1">
                 <a:solidFill>
                   <a:srgbClr val="FF8AAF"/>
                 </a:solidFill>
@@ -6639,12 +7226,12 @@
           </a:ln>
         </p:spPr>
         <p:txBody>
-          <a:bodyPr anchorCtr="0" anchor="t" bIns="0" lIns="0" spcFirstLastPara="1" rIns="0" wrap="square" tIns="0">
+          <a:bodyPr spcFirstLastPara="1" wrap="square" lIns="0" tIns="0" rIns="0" bIns="0" anchor="t" anchorCtr="0">
             <a:normAutofit/>
           </a:bodyPr>
           <a:lstStyle/>
           <a:p>
-            <a:pPr indent="0" lvl="0" marL="0" marR="0" rtl="0" algn="l">
+            <a:pPr marL="0" marR="0" lvl="0" indent="0" algn="l" rtl="0">
               <a:lnSpc>
                 <a:spcPct val="130000"/>
               </a:lnSpc>
@@ -6684,7 +7271,7 @@
             </a:endParaRPr>
           </a:p>
           <a:p>
-            <a:pPr indent="0" lvl="0" marL="0" marR="0" rtl="0" algn="l">
+            <a:pPr marL="0" marR="0" lvl="0" indent="0" algn="l" rtl="0">
               <a:lnSpc>
                 <a:spcPct val="130000"/>
               </a:lnSpc>
@@ -6701,9 +7288,6 @@
               <a:buFont typeface="Inter"/>
               <a:buNone/>
             </a:pPr>
-            <a:r>
-              <a:t/>
-            </a:r>
             <a:endParaRPr>
               <a:solidFill>
                 <a:srgbClr val="E0D6DE"/>
@@ -6715,7 +7299,7 @@
             </a:endParaRPr>
           </a:p>
           <a:p>
-            <a:pPr indent="0" lvl="0" marL="0" marR="0" rtl="0" algn="l">
+            <a:pPr marL="0" marR="0" lvl="0" indent="0" algn="l" rtl="0">
               <a:lnSpc>
                 <a:spcPct val="130000"/>
               </a:lnSpc>
@@ -6755,7 +7339,7 @@
             </a:endParaRPr>
           </a:p>
           <a:p>
-            <a:pPr indent="0" lvl="0" marL="0" marR="0" rtl="0" algn="l">
+            <a:pPr marL="0" marR="0" lvl="0" indent="0" algn="l" rtl="0">
               <a:lnSpc>
                 <a:spcPct val="130000"/>
               </a:lnSpc>
@@ -6772,9 +7356,6 @@
               <a:buFont typeface="Inter"/>
               <a:buNone/>
             </a:pPr>
-            <a:r>
-              <a:t/>
-            </a:r>
             <a:endParaRPr>
               <a:solidFill>
                 <a:srgbClr val="E0D6DE"/>
@@ -6786,7 +7367,7 @@
             </a:endParaRPr>
           </a:p>
           <a:p>
-            <a:pPr indent="0" lvl="0" marL="0" marR="0" rtl="0" algn="l">
+            <a:pPr marL="0" marR="0" lvl="0" indent="0" algn="l" rtl="0">
               <a:lnSpc>
                 <a:spcPct val="130000"/>
               </a:lnSpc>
@@ -6892,11 +7473,11 @@
 </file>
 
 <file path=ppt/slides/slide7.xml><?xml version="1.0" encoding="utf-8"?>
-<p:sld xmlns:a="http://schemas.openxmlformats.org/drawingml/2006/main" xmlns:r="http://schemas.openxmlformats.org/officeDocument/2006/relationships" xmlns:mc="http://schemas.openxmlformats.org/markup-compatibility/2006" xmlns:mv="urn:schemas-microsoft-com:mac:vml" xmlns:p="http://schemas.openxmlformats.org/presentationml/2006/main" xmlns:c="http://schemas.openxmlformats.org/drawingml/2006/chart" xmlns:dgm="http://schemas.openxmlformats.org/drawingml/2006/diagram" xmlns:o="urn:schemas-microsoft-com:office:office" xmlns:v="urn:schemas-microsoft-com:vml" xmlns:pvml="urn:schemas-microsoft-com:office:powerpoint" xmlns:com="http://schemas.openxmlformats.org/drawingml/2006/compatibility" xmlns:p14="http://schemas.microsoft.com/office/powerpoint/2010/main" xmlns:p15="http://schemas.microsoft.com/office/powerpoint/2012/main" xmlns:ahyp="http://schemas.microsoft.com/office/drawing/2018/hyperlinkcolor">
+<p:sld xmlns:a="http://schemas.openxmlformats.org/drawingml/2006/main" xmlns:r="http://schemas.openxmlformats.org/officeDocument/2006/relationships" xmlns:p="http://schemas.openxmlformats.org/presentationml/2006/main">
   <p:cSld>
     <p:spTree>
       <p:nvGrpSpPr>
-        <p:cNvPr id="97" name="Shape 97"/>
+        <p:cNvPr id="1" name="Shape 97"/>
         <p:cNvGrpSpPr/>
         <p:nvPr/>
       </p:nvGrpSpPr>
@@ -6928,12 +7509,12 @@
           </a:ln>
         </p:spPr>
         <p:txBody>
-          <a:bodyPr anchorCtr="0" anchor="t" bIns="0" lIns="0" spcFirstLastPara="1" rIns="0" wrap="square" tIns="0">
+          <a:bodyPr spcFirstLastPara="1" wrap="square" lIns="0" tIns="0" rIns="0" bIns="0" anchor="t" anchorCtr="0">
             <a:noAutofit/>
           </a:bodyPr>
           <a:lstStyle/>
           <a:p>
-            <a:pPr indent="0" lvl="0" marL="0" marR="0" rtl="0" algn="l">
+            <a:pPr marL="0" marR="0" lvl="0" indent="0" algn="l" rtl="0">
               <a:lnSpc>
                 <a:spcPct val="104000"/>
               </a:lnSpc>
@@ -6951,7 +7532,7 @@
               <a:buNone/>
             </a:pPr>
             <a:r>
-              <a:rPr b="1" lang="en-US" sz="3900">
+              <a:rPr lang="en-US" sz="3900" b="1">
                 <a:solidFill>
                   <a:srgbClr val="FF8AAF"/>
                 </a:solidFill>
@@ -6976,7 +7557,7 @@
       </p:sp>
       <p:pic>
         <p:nvPicPr>
-          <p:cNvPr descr="preencoded.png" id="99" name="Google Shape;99;p6"/>
+          <p:cNvPr id="99" name="Google Shape;99;p6" descr="preencoded.png"/>
           <p:cNvPicPr preferRelativeResize="0"/>
           <p:nvPr/>
         </p:nvPicPr>
@@ -6984,7 +7565,7 @@
           <a:blip r:embed="rId3">
             <a:alphaModFix/>
           </a:blip>
-          <a:srcRect b="0" l="0" r="0" t="0"/>
+          <a:srcRect/>
           <a:stretch/>
         </p:blipFill>
         <p:spPr>
@@ -7021,12 +7602,12 @@
           </a:ln>
         </p:spPr>
         <p:txBody>
-          <a:bodyPr anchorCtr="0" anchor="t" bIns="0" lIns="0" spcFirstLastPara="1" rIns="0" wrap="square" tIns="0">
+          <a:bodyPr spcFirstLastPara="1" wrap="square" lIns="0" tIns="0" rIns="0" bIns="0" anchor="t" anchorCtr="0">
             <a:noAutofit/>
           </a:bodyPr>
           <a:lstStyle/>
           <a:p>
-            <a:pPr indent="0" lvl="0" marL="0" marR="0" rtl="0" algn="l">
+            <a:pPr marL="0" marR="0" lvl="0" indent="0" algn="l" rtl="0">
               <a:lnSpc>
                 <a:spcPct val="104000"/>
               </a:lnSpc>
@@ -7044,7 +7625,7 @@
               <a:buNone/>
             </a:pPr>
             <a:r>
-              <a:rPr b="1" lang="en-US" sz="1950">
+              <a:rPr lang="en-US" sz="1950" b="1">
                 <a:solidFill>
                   <a:srgbClr val="E0D6DE"/>
                 </a:solidFill>
@@ -7087,12 +7668,12 @@
           </a:ln>
         </p:spPr>
         <p:txBody>
-          <a:bodyPr anchorCtr="0" anchor="t" bIns="0" lIns="0" spcFirstLastPara="1" rIns="0" wrap="square" tIns="0">
+          <a:bodyPr spcFirstLastPara="1" wrap="square" lIns="0" tIns="0" rIns="0" bIns="0" anchor="t" anchorCtr="0">
             <a:normAutofit/>
           </a:bodyPr>
           <a:lstStyle/>
           <a:p>
-            <a:pPr indent="0" lvl="0" marL="0" marR="0" rtl="0" algn="l">
+            <a:pPr marL="0" marR="0" lvl="0" indent="0" algn="l" rtl="0">
               <a:lnSpc>
                 <a:spcPct val="133000"/>
               </a:lnSpc>
@@ -7150,7 +7731,7 @@
       </p:sp>
       <p:pic>
         <p:nvPicPr>
-          <p:cNvPr descr="preencoded.png" id="102" name="Google Shape;102;p6"/>
+          <p:cNvPr id="102" name="Google Shape;102;p6" descr="preencoded.png"/>
           <p:cNvPicPr preferRelativeResize="0"/>
           <p:nvPr/>
         </p:nvPicPr>
@@ -7158,7 +7739,7 @@
           <a:blip r:embed="rId4">
             <a:alphaModFix/>
           </a:blip>
-          <a:srcRect b="0" l="0" r="0" t="0"/>
+          <a:srcRect/>
           <a:stretch/>
         </p:blipFill>
         <p:spPr>
@@ -7195,12 +7776,12 @@
           </a:ln>
         </p:spPr>
         <p:txBody>
-          <a:bodyPr anchorCtr="0" anchor="t" bIns="0" lIns="0" spcFirstLastPara="1" rIns="0" wrap="square" tIns="0">
+          <a:bodyPr spcFirstLastPara="1" wrap="square" lIns="0" tIns="0" rIns="0" bIns="0" anchor="t" anchorCtr="0">
             <a:noAutofit/>
           </a:bodyPr>
           <a:lstStyle/>
           <a:p>
-            <a:pPr indent="0" lvl="0" marL="0" marR="0" rtl="0" algn="l">
+            <a:pPr marL="0" marR="0" lvl="0" indent="0" algn="l" rtl="0">
               <a:lnSpc>
                 <a:spcPct val="104000"/>
               </a:lnSpc>
@@ -7218,7 +7799,7 @@
               <a:buNone/>
             </a:pPr>
             <a:r>
-              <a:rPr b="1" lang="en-US" sz="1950">
+              <a:rPr lang="en-US" sz="1950" b="1">
                 <a:solidFill>
                   <a:srgbClr val="E0D6DE"/>
                 </a:solidFill>
@@ -7261,12 +7842,12 @@
           </a:ln>
         </p:spPr>
         <p:txBody>
-          <a:bodyPr anchorCtr="0" anchor="t" bIns="0" lIns="0" spcFirstLastPara="1" rIns="0" wrap="square" tIns="0">
+          <a:bodyPr spcFirstLastPara="1" wrap="square" lIns="0" tIns="0" rIns="0" bIns="0" anchor="t" anchorCtr="0">
             <a:normAutofit/>
           </a:bodyPr>
           <a:lstStyle/>
           <a:p>
-            <a:pPr indent="0" lvl="0" marL="0" marR="0" rtl="0" algn="l">
+            <a:pPr marL="0" marR="0" lvl="0" indent="0" algn="l" rtl="0">
               <a:lnSpc>
                 <a:spcPct val="133000"/>
               </a:lnSpc>
@@ -7309,7 +7890,7 @@
       </p:sp>
       <p:pic>
         <p:nvPicPr>
-          <p:cNvPr descr="preencoded.png" id="105" name="Google Shape;105;p6"/>
+          <p:cNvPr id="105" name="Google Shape;105;p6" descr="preencoded.png"/>
           <p:cNvPicPr preferRelativeResize="0"/>
           <p:nvPr/>
         </p:nvPicPr>
@@ -7317,7 +7898,7 @@
           <a:blip r:embed="rId5">
             <a:alphaModFix/>
           </a:blip>
-          <a:srcRect b="0" l="0" r="0" t="0"/>
+          <a:srcRect/>
           <a:stretch/>
         </p:blipFill>
         <p:spPr>
@@ -7354,12 +7935,12 @@
           </a:ln>
         </p:spPr>
         <p:txBody>
-          <a:bodyPr anchorCtr="0" anchor="t" bIns="0" lIns="0" spcFirstLastPara="1" rIns="0" wrap="square" tIns="0">
+          <a:bodyPr spcFirstLastPara="1" wrap="square" lIns="0" tIns="0" rIns="0" bIns="0" anchor="t" anchorCtr="0">
             <a:noAutofit/>
           </a:bodyPr>
           <a:lstStyle/>
           <a:p>
-            <a:pPr indent="0" lvl="0" marL="0" marR="0" rtl="0" algn="l">
+            <a:pPr marL="0" marR="0" lvl="0" indent="0" algn="l" rtl="0">
               <a:lnSpc>
                 <a:spcPct val="104000"/>
               </a:lnSpc>
@@ -7377,7 +7958,7 @@
               <a:buNone/>
             </a:pPr>
             <a:r>
-              <a:rPr b="1" lang="en-US" sz="1950">
+              <a:rPr lang="en-US" sz="1950" b="1">
                 <a:solidFill>
                   <a:srgbClr val="E0D6DE"/>
                 </a:solidFill>
@@ -7420,12 +8001,12 @@
           </a:ln>
         </p:spPr>
         <p:txBody>
-          <a:bodyPr anchorCtr="0" anchor="t" bIns="0" lIns="0" spcFirstLastPara="1" rIns="0" wrap="square" tIns="0">
+          <a:bodyPr spcFirstLastPara="1" wrap="square" lIns="0" tIns="0" rIns="0" bIns="0" anchor="t" anchorCtr="0">
             <a:normAutofit/>
           </a:bodyPr>
           <a:lstStyle/>
           <a:p>
-            <a:pPr indent="0" lvl="0" marL="0" marR="0" rtl="0" algn="l">
+            <a:pPr marL="0" marR="0" lvl="0" indent="0" algn="l" rtl="0">
               <a:lnSpc>
                 <a:spcPct val="133000"/>
               </a:lnSpc>
@@ -7559,11 +8140,11 @@
 </file>
 
 <file path=ppt/slides/slide8.xml><?xml version="1.0" encoding="utf-8"?>
-<p:sld xmlns:a="http://schemas.openxmlformats.org/drawingml/2006/main" xmlns:r="http://schemas.openxmlformats.org/officeDocument/2006/relationships" xmlns:mc="http://schemas.openxmlformats.org/markup-compatibility/2006" xmlns:mv="urn:schemas-microsoft-com:mac:vml" xmlns:p="http://schemas.openxmlformats.org/presentationml/2006/main" xmlns:c="http://schemas.openxmlformats.org/drawingml/2006/chart" xmlns:dgm="http://schemas.openxmlformats.org/drawingml/2006/diagram" xmlns:o="urn:schemas-microsoft-com:office:office" xmlns:v="urn:schemas-microsoft-com:vml" xmlns:pvml="urn:schemas-microsoft-com:office:powerpoint" xmlns:com="http://schemas.openxmlformats.org/drawingml/2006/compatibility" xmlns:p14="http://schemas.microsoft.com/office/powerpoint/2010/main" xmlns:p15="http://schemas.microsoft.com/office/powerpoint/2012/main" xmlns:ahyp="http://schemas.microsoft.com/office/drawing/2018/hyperlinkcolor">
+<p:sld xmlns:a="http://schemas.openxmlformats.org/drawingml/2006/main" xmlns:r="http://schemas.openxmlformats.org/officeDocument/2006/relationships" xmlns:p="http://schemas.openxmlformats.org/presentationml/2006/main">
   <p:cSld>
     <p:spTree>
       <p:nvGrpSpPr>
-        <p:cNvPr id="115" name="Shape 115"/>
+        <p:cNvPr id="1" name="Shape 115"/>
         <p:cNvGrpSpPr/>
         <p:nvPr/>
       </p:nvGrpSpPr>
@@ -7595,12 +8176,12 @@
           </a:ln>
         </p:spPr>
         <p:txBody>
-          <a:bodyPr anchorCtr="0" anchor="t" bIns="0" lIns="0" spcFirstLastPara="1" rIns="0" wrap="square" tIns="0">
+          <a:bodyPr spcFirstLastPara="1" wrap="square" lIns="0" tIns="0" rIns="0" bIns="0" anchor="t" anchorCtr="0">
             <a:noAutofit/>
           </a:bodyPr>
           <a:lstStyle/>
           <a:p>
-            <a:pPr indent="0" lvl="0" marL="0" marR="0" rtl="0" algn="l">
+            <a:pPr marL="0" marR="0" lvl="0" indent="0" algn="l" rtl="0">
               <a:lnSpc>
                 <a:spcPct val="104000"/>
               </a:lnSpc>
@@ -7618,7 +8199,7 @@
               <a:buNone/>
             </a:pPr>
             <a:r>
-              <a:rPr b="1" lang="en-US" sz="3050">
+              <a:rPr lang="en-US" sz="3050" b="1">
                 <a:solidFill>
                   <a:srgbClr val="FF8AAF"/>
                 </a:solidFill>
@@ -7734,11 +8315,11 @@
 </file>
 
 <file path=ppt/slides/slide9.xml><?xml version="1.0" encoding="utf-8"?>
-<p:sld xmlns:a="http://schemas.openxmlformats.org/drawingml/2006/main" xmlns:r="http://schemas.openxmlformats.org/officeDocument/2006/relationships" xmlns:mc="http://schemas.openxmlformats.org/markup-compatibility/2006" xmlns:mv="urn:schemas-microsoft-com:mac:vml" xmlns:p="http://schemas.openxmlformats.org/presentationml/2006/main" xmlns:c="http://schemas.openxmlformats.org/drawingml/2006/chart" xmlns:dgm="http://schemas.openxmlformats.org/drawingml/2006/diagram" xmlns:o="urn:schemas-microsoft-com:office:office" xmlns:v="urn:schemas-microsoft-com:vml" xmlns:pvml="urn:schemas-microsoft-com:office:powerpoint" xmlns:com="http://schemas.openxmlformats.org/drawingml/2006/compatibility" xmlns:p14="http://schemas.microsoft.com/office/powerpoint/2010/main" xmlns:p15="http://schemas.microsoft.com/office/powerpoint/2012/main" xmlns:ahyp="http://schemas.microsoft.com/office/drawing/2018/hyperlinkcolor">
+<p:sld xmlns:a="http://schemas.openxmlformats.org/drawingml/2006/main" xmlns:r="http://schemas.openxmlformats.org/officeDocument/2006/relationships" xmlns:p="http://schemas.openxmlformats.org/presentationml/2006/main">
   <p:cSld>
     <p:spTree>
       <p:nvGrpSpPr>
-        <p:cNvPr id="124" name="Shape 124"/>
+        <p:cNvPr id="1" name="Shape 124"/>
         <p:cNvGrpSpPr/>
         <p:nvPr/>
       </p:nvGrpSpPr>
@@ -7763,7 +8344,7 @@
           </a:xfrm>
           <a:prstGeom prst="roundRect">
             <a:avLst>
-              <a:gd fmla="val 22117" name="adj"/>
+              <a:gd name="adj" fmla="val 22117"/>
             </a:avLst>
           </a:prstGeom>
           <a:solidFill>
@@ -7774,12 +8355,12 @@
           </a:ln>
         </p:spPr>
         <p:txBody>
-          <a:bodyPr anchorCtr="0" anchor="t" bIns="45700" lIns="91425" spcFirstLastPara="1" rIns="91425" wrap="square" tIns="45700">
+          <a:bodyPr spcFirstLastPara="1" wrap="square" lIns="91425" tIns="45700" rIns="91425" bIns="45700" anchor="t" anchorCtr="0">
             <a:noAutofit/>
           </a:bodyPr>
           <a:lstStyle/>
           <a:p>
-            <a:pPr indent="0" lvl="0" marL="0" marR="0" rtl="0" algn="l">
+            <a:pPr marL="0" marR="0" lvl="0" indent="0" algn="l" rtl="0">
               <a:spcBef>
                 <a:spcPts val="0"/>
               </a:spcBef>
@@ -7788,9 +8369,6 @@
               </a:spcAft>
               <a:buNone/>
             </a:pPr>
-            <a:r>
-              <a:t/>
-            </a:r>
             <a:endParaRPr sz="1800">
               <a:solidFill>
                 <a:schemeClr val="dk1"/>
@@ -7823,12 +8401,12 @@
           </a:ln>
         </p:spPr>
         <p:txBody>
-          <a:bodyPr anchorCtr="0" anchor="t" bIns="0" lIns="0" spcFirstLastPara="1" rIns="0" wrap="square" tIns="0">
+          <a:bodyPr spcFirstLastPara="1" wrap="square" lIns="0" tIns="0" rIns="0" bIns="0" anchor="t" anchorCtr="0">
             <a:noAutofit/>
           </a:bodyPr>
           <a:lstStyle/>
           <a:p>
-            <a:pPr indent="0" lvl="0" marL="0" marR="0" rtl="0" algn="l">
+            <a:pPr marL="0" marR="0" lvl="0" indent="0" algn="l" rtl="0">
               <a:lnSpc>
                 <a:spcPct val="96000"/>
               </a:lnSpc>
@@ -7889,12 +8467,12 @@
           </a:ln>
         </p:spPr>
         <p:txBody>
-          <a:bodyPr anchorCtr="0" anchor="t" bIns="0" lIns="0" spcFirstLastPara="1" rIns="0" wrap="square" tIns="0">
+          <a:bodyPr spcFirstLastPara="1" wrap="square" lIns="0" tIns="0" rIns="0" bIns="0" anchor="t" anchorCtr="0">
             <a:noAutofit/>
           </a:bodyPr>
           <a:lstStyle/>
           <a:p>
-            <a:pPr indent="0" lvl="0" marL="0" marR="0" rtl="0" algn="l">
+            <a:pPr marL="0" marR="0" lvl="0" indent="0" algn="l" rtl="0">
               <a:lnSpc>
                 <a:spcPct val="104000"/>
               </a:lnSpc>
@@ -7912,7 +8490,7 @@
               <a:buNone/>
             </a:pPr>
             <a:r>
-              <a:rPr b="1" lang="en-US" sz="3800">
+              <a:rPr lang="en-US" sz="3800" b="1">
                 <a:solidFill>
                   <a:srgbClr val="FF8AAF"/>
                 </a:solidFill>
@@ -7955,12 +8533,12 @@
           </a:ln>
         </p:spPr>
         <p:txBody>
-          <a:bodyPr anchorCtr="0" anchor="t" bIns="0" lIns="0" spcFirstLastPara="1" rIns="0" wrap="square" tIns="0">
+          <a:bodyPr spcFirstLastPara="1" wrap="square" lIns="0" tIns="0" rIns="0" bIns="0" anchor="t" anchorCtr="0">
             <a:normAutofit/>
           </a:bodyPr>
           <a:lstStyle/>
           <a:p>
-            <a:pPr indent="0" lvl="0" marL="0" marR="0" rtl="0" algn="l">
+            <a:pPr marL="0" marR="0" lvl="0" indent="0" algn="l" rtl="0">
               <a:lnSpc>
                 <a:spcPct val="132000"/>
               </a:lnSpc>
@@ -8000,7 +8578,7 @@
             </a:endParaRPr>
           </a:p>
           <a:p>
-            <a:pPr indent="0" lvl="0" marL="0" marR="0" rtl="0" algn="l">
+            <a:pPr marL="0" marR="0" lvl="0" indent="0" algn="l" rtl="0">
               <a:lnSpc>
                 <a:spcPct val="132000"/>
               </a:lnSpc>
@@ -8017,9 +8595,6 @@
               <a:buFont typeface="Inter"/>
               <a:buNone/>
             </a:pPr>
-            <a:r>
-              <a:t/>
-            </a:r>
             <a:endParaRPr sz="1450">
               <a:solidFill>
                 <a:srgbClr val="E0D6DE"/>
@@ -8031,7 +8606,7 @@
             </a:endParaRPr>
           </a:p>
           <a:p>
-            <a:pPr indent="0" lvl="0" marL="0" marR="0" rtl="0" algn="l">
+            <a:pPr marL="0" marR="0" lvl="0" indent="0" algn="l" rtl="0">
               <a:lnSpc>
                 <a:spcPct val="132000"/>
               </a:lnSpc>
@@ -8071,7 +8646,7 @@
             </a:endParaRPr>
           </a:p>
           <a:p>
-            <a:pPr indent="0" lvl="0" marL="0" marR="0" rtl="0" algn="l">
+            <a:pPr marL="0" marR="0" lvl="0" indent="0" algn="l" rtl="0">
               <a:lnSpc>
                 <a:spcPct val="132000"/>
               </a:lnSpc>
@@ -8088,9 +8663,6 @@
               <a:buFont typeface="Inter"/>
               <a:buNone/>
             </a:pPr>
-            <a:r>
-              <a:t/>
-            </a:r>
             <a:endParaRPr sz="1450">
               <a:solidFill>
                 <a:srgbClr val="E0D6DE"/>
@@ -8102,7 +8674,7 @@
             </a:endParaRPr>
           </a:p>
           <a:p>
-            <a:pPr indent="0" lvl="0" marL="0" marR="0" rtl="0" algn="l">
+            <a:pPr marL="0" marR="0" lvl="0" indent="0" algn="l" rtl="0">
               <a:lnSpc>
                 <a:spcPct val="132000"/>
               </a:lnSpc>
@@ -8208,7 +8780,7 @@
 </file>
 
 <file path=ppt/theme/theme1.xml><?xml version="1.0" encoding="utf-8"?>
-<a:theme xmlns:a="http://schemas.openxmlformats.org/drawingml/2006/main" xmlns:r="http://schemas.openxmlformats.org/officeDocument/2006/relationships" name="Office Theme">
+<a:theme xmlns:a="http://schemas.openxmlformats.org/drawingml/2006/main" name="Office Theme">
   <a:themeElements>
     <a:clrScheme name="Office">
       <a:dk1>
@@ -8483,11 +9055,13 @@
       </a:bgFillStyleLst>
     </a:fmtScheme>
   </a:themeElements>
+  <a:objectDefaults/>
+  <a:extraClrSchemeLst/>
 </a:theme>
 </file>
 
 <file path=ppt/theme/theme2.xml><?xml version="1.0" encoding="utf-8"?>
-<a:theme xmlns:a="http://schemas.openxmlformats.org/drawingml/2006/main" xmlns:r="http://schemas.openxmlformats.org/officeDocument/2006/relationships" name="Tema de Office">
+<a:theme xmlns:a="http://schemas.openxmlformats.org/drawingml/2006/main" name="Tema de Office">
   <a:themeElements>
     <a:clrScheme name="Office">
       <a:dk1>
@@ -8762,5 +9336,7 @@
       </a:bgFillStyleLst>
     </a:fmtScheme>
   </a:themeElements>
+  <a:objectDefaults/>
+  <a:extraClrSchemeLst/>
 </a:theme>
 </file>
</xml_diff>